<commit_message>
Remove the hosted play link from the deck
The hosted app is stopped, so slide 11 now leads with the repository and how to run the game locally, and its speaker notes no longer mention the hosted URL.

Co-authored-by: Copilot <223556219+Copilot@users.noreply.github.com>
</commit_message>
<xml_diff>
--- a/docs/luna-gp-deck.pptx
+++ b/docs/luna-gp-deck.pptx
@@ -688,7 +688,7 @@
           <a:p>
             <a:r>
               <a:rPr lang="en-US" dirty="0"/>
-              <a:t>Play the hosted game at luna-gp-45684.azurewebsites.net: it runs on Azure App Service and reaches the model with its managed identity, and the server caps model calls at 20,000 a day. To run your own: Node.js 20+ and, for AI rivals, FOUNDRY_ENDPOINT plus an Azure CLI login with access to the Foundry resource. Without it the game still runs with offline heuristics. P or Esc pauses, M mutes.</a:t>
+              <a:t>The code is at github.com/roryp/racing. To run it: Node.js 20+ and, for AI rivals, FOUNDRY_ENDPOINT plus an Azure CLI login with access to the Foundry resource. Without it the game still runs with offline heuristics. The README also covers hosting it on App Service with a managed identity. P or Esc pauses, M mutes.</a:t>
             </a:r>
             <a:endParaRPr lang="en-US" dirty="0"/>
           </a:p>
@@ -3149,11 +3149,11 @@
         <p:spPr>
           <a:xfrm>
             <a:off x="548640" y="2011680"/>
-            <a:ext cx="3840480" cy="713232"/>
+            <a:ext cx="3840480" cy="905256"/>
           </a:xfrm>
           <a:prstGeom prst="roundRect">
             <a:avLst>
-              <a:gd name="adj" fmla="val 15385"/>
+              <a:gd name="adj" fmla="val 12121"/>
             </a:avLst>
           </a:prstGeom>
           <a:solidFill>
@@ -3170,7 +3170,7 @@
         </p:nvSpPr>
         <p:spPr>
           <a:xfrm>
-            <a:off x="777240" y="2112264"/>
+            <a:off x="777240" y="2203704"/>
             <a:ext cx="3383280" cy="237744"/>
           </a:xfrm>
           <a:prstGeom prst="rect">
@@ -3195,22 +3195,46 @@
                 <a:ea typeface="Segoe UI Semibold" pitchFamily="34" charset="-122"/>
                 <a:cs typeface="Segoe UI Semibold" pitchFamily="34" charset="-120"/>
               </a:rPr>
-              <a:t>PLAY IT NOW</a:t>
+              <a:t>GET THE CODE</a:t>
             </a:r>
             <a:endParaRPr lang="en-US" sz="1050" dirty="0"/>
           </a:p>
         </p:txBody>
       </p:sp>
-      <p:sp>
-        <p:nvSpPr>
-          <p:cNvPr id="14" name="Text 11"/>
-          <p:cNvSpPr/>
-          <p:nvPr/>
-        </p:nvSpPr>
-        <p:spPr>
-          <a:xfrm>
-            <a:off x="777240" y="2359152"/>
-            <a:ext cx="3383280" cy="274320"/>
+      <p:pic>
+        <p:nvPicPr>
+          <p:cNvPr id="14" name="Image 1" descr="GitHub icon">    </p:cNvPr>
+          <p:cNvPicPr>
+            <a:picLocks noChangeAspect="1"/>
+          </p:cNvPicPr>
+          <p:nvPr/>
+        </p:nvPicPr>
+        <p:blipFill>
+          <a:blip r:embed="rId2"/>
+          <a:stretch>
+            <a:fillRect/>
+          </a:stretch>
+        </p:blipFill>
+        <p:spPr>
+          <a:xfrm>
+            <a:off x="777240" y="2478024"/>
+            <a:ext cx="219456" cy="219456"/>
+          </a:xfrm>
+          <a:prstGeom prst="rect">
+            <a:avLst/>
+          </a:prstGeom>
+        </p:spPr>
+      </p:pic>
+      <p:sp>
+        <p:nvSpPr>
+          <p:cNvPr id="15" name="Text 11"/>
+          <p:cNvSpPr/>
+          <p:nvPr/>
+        </p:nvSpPr>
+        <p:spPr>
+          <a:xfrm>
+            <a:off x="1088136" y="2450592"/>
+            <a:ext cx="3072384" cy="274320"/>
           </a:xfrm>
           <a:prstGeom prst="rect">
             <a:avLst/>
@@ -3234,7 +3258,7 @@
                 <a:ea typeface="Segoe UI Semibold" pitchFamily="34" charset="-122"/>
                 <a:cs typeface="Segoe UI Semibold" pitchFamily="34" charset="-120"/>
               </a:rPr>
-              <a:t>luna-gp-45684.azurewebsites.net</a:t>
+              <a:t>github.com/roryp/racing</a:t>
             </a:r>
             <a:endParaRPr lang="en-US" sz="1600" dirty="0"/>
           </a:p>
@@ -3242,8 +3266,8 @@
       </p:sp>
       <p:sp>
         <p:nvSpPr>
-          <p:cNvPr id="15" name="Shape 12">
-            <a:hlinkClick r:id="rId2" tooltip="Play LUNA GP"/>
+          <p:cNvPr id="16" name="Shape 12">
+            <a:hlinkClick r:id="rId3" tooltip="Open the repository"/>
           </p:cNvPr>
           <p:cNvSpPr/>
           <p:nvPr/>
@@ -3251,7 +3275,7 @@
         <p:spPr>
           <a:xfrm>
             <a:off x="548640" y="2011680"/>
-            <a:ext cx="3840480" cy="713232"/>
+            <a:ext cx="3840480" cy="905256"/>
           </a:xfrm>
           <a:prstGeom prst="rect">
             <a:avLst/>
@@ -3266,18 +3290,18 @@
       </p:sp>
       <p:sp>
         <p:nvSpPr>
-          <p:cNvPr id="16" name="Shape 13"/>
-          <p:cNvSpPr/>
-          <p:nvPr/>
-        </p:nvSpPr>
-        <p:spPr>
-          <a:xfrm>
-            <a:off x="548640" y="2862072"/>
-            <a:ext cx="3840480" cy="713232"/>
+          <p:cNvPr id="17" name="Shape 13"/>
+          <p:cNvSpPr/>
+          <p:nvPr/>
+        </p:nvSpPr>
+        <p:spPr>
+          <a:xfrm>
+            <a:off x="548640" y="3063240"/>
+            <a:ext cx="3840480" cy="905256"/>
           </a:xfrm>
           <a:prstGeom prst="roundRect">
             <a:avLst>
-              <a:gd name="adj" fmla="val 15385"/>
+              <a:gd name="adj" fmla="val 12121"/>
             </a:avLst>
           </a:prstGeom>
           <a:solidFill>
@@ -3288,13 +3312,13 @@
       </p:sp>
       <p:sp>
         <p:nvSpPr>
-          <p:cNvPr id="17" name="Text 14"/>
-          <p:cNvSpPr/>
-          <p:nvPr/>
-        </p:nvSpPr>
-        <p:spPr>
-          <a:xfrm>
-            <a:off x="777240" y="2962656"/>
+          <p:cNvPr id="18" name="Text 14"/>
+          <p:cNvSpPr/>
+          <p:nvPr/>
+        </p:nvSpPr>
+        <p:spPr>
+          <a:xfrm>
+            <a:off x="777240" y="3255264"/>
             <a:ext cx="3383280" cy="237744"/>
           </a:xfrm>
           <a:prstGeom prst="rect">
@@ -3319,7 +3343,7 @@
                 <a:ea typeface="Segoe UI Semibold" pitchFamily="34" charset="-122"/>
                 <a:cs typeface="Segoe UI Semibold" pitchFamily="34" charset="-120"/>
               </a:rPr>
-              <a:t>OR RUN YOUR OWN</a:t>
+              <a:t>RUN IT</a:t>
             </a:r>
             <a:endParaRPr lang="en-US" sz="1050" dirty="0"/>
           </a:p>
@@ -3327,13 +3351,13 @@
       </p:sp>
       <p:sp>
         <p:nvSpPr>
-          <p:cNvPr id="18" name="Text 15"/>
-          <p:cNvSpPr/>
-          <p:nvPr/>
-        </p:nvSpPr>
-        <p:spPr>
-          <a:xfrm>
-            <a:off x="777240" y="3209544"/>
+          <p:cNvPr id="19" name="Text 15"/>
+          <p:cNvSpPr/>
+          <p:nvPr/>
+        </p:nvSpPr>
+        <p:spPr>
+          <a:xfrm>
+            <a:off x="777240" y="3502152"/>
             <a:ext cx="3383280" cy="274320"/>
           </a:xfrm>
           <a:prstGeom prst="rect">
@@ -3394,14 +3418,14 @@
       </p:sp>
       <p:sp>
         <p:nvSpPr>
-          <p:cNvPr id="19" name="Text 16"/>
-          <p:cNvSpPr/>
-          <p:nvPr/>
-        </p:nvSpPr>
-        <p:spPr>
-          <a:xfrm>
-            <a:off x="548640" y="3712464"/>
-            <a:ext cx="3840480" cy="411480"/>
+          <p:cNvPr id="20" name="Text 16"/>
+          <p:cNvSpPr/>
+          <p:nvPr/>
+        </p:nvSpPr>
+        <p:spPr>
+          <a:xfrm>
+            <a:off x="548640" y="4114800"/>
+            <a:ext cx="3840480" cy="384048"/>
           </a:xfrm>
           <a:prstGeom prst="rect">
             <a:avLst/>
@@ -3478,7 +3502,7 @@
       </p:sp>
       <p:sp>
         <p:nvSpPr>
-          <p:cNvPr id="20" name="Shape 17"/>
+          <p:cNvPr id="21" name="Shape 17"/>
           <p:cNvSpPr/>
           <p:nvPr/>
         </p:nvSpPr>
@@ -3505,31 +3529,7 @@
       </p:sp>
       <p:pic>
         <p:nvPicPr>
-          <p:cNvPr id="21" name="Image 1" descr="Left arrow key">    </p:cNvPr>
-          <p:cNvPicPr>
-            <a:picLocks noChangeAspect="1"/>
-          </p:cNvPicPr>
-          <p:nvPr/>
-        </p:nvPicPr>
-        <p:blipFill>
-          <a:blip r:embed="rId3"/>
-          <a:stretch>
-            <a:fillRect/>
-          </a:stretch>
-        </p:blipFill>
-        <p:spPr>
-          <a:xfrm>
-            <a:off x="5134356" y="2071116"/>
-            <a:ext cx="155448" cy="155448"/>
-          </a:xfrm>
-          <a:prstGeom prst="rect">
-            <a:avLst/>
-          </a:prstGeom>
-        </p:spPr>
-      </p:pic>
-      <p:pic>
-        <p:nvPicPr>
-          <p:cNvPr id="22" name="Image 2" descr="Right arrow key">    </p:cNvPr>
+          <p:cNvPr id="22" name="Image 2" descr="Left arrow key">    </p:cNvPr>
           <p:cNvPicPr>
             <a:picLocks noChangeAspect="1"/>
           </p:cNvPicPr>
@@ -3543,6 +3543,30 @@
         </p:blipFill>
         <p:spPr>
           <a:xfrm>
+            <a:off x="5134356" y="2071116"/>
+            <a:ext cx="155448" cy="155448"/>
+          </a:xfrm>
+          <a:prstGeom prst="rect">
+            <a:avLst/>
+          </a:prstGeom>
+        </p:spPr>
+      </p:pic>
+      <p:pic>
+        <p:nvPicPr>
+          <p:cNvPr id="23" name="Image 3" descr="Right arrow key">    </p:cNvPr>
+          <p:cNvPicPr>
+            <a:picLocks noChangeAspect="1"/>
+          </p:cNvPicPr>
+          <p:nvPr/>
+        </p:nvPicPr>
+        <p:blipFill>
+          <a:blip r:embed="rId5"/>
+          <a:stretch>
+            <a:fillRect/>
+          </a:stretch>
+        </p:blipFill>
+        <p:spPr>
+          <a:xfrm>
             <a:off x="5362956" y="2071116"/>
             <a:ext cx="155448" cy="155448"/>
           </a:xfrm>
@@ -3553,7 +3577,7 @@
       </p:pic>
       <p:sp>
         <p:nvSpPr>
-          <p:cNvPr id="23" name="Text 18"/>
+          <p:cNvPr id="24" name="Text 18"/>
           <p:cNvSpPr/>
           <p:nvPr/>
         </p:nvSpPr>
@@ -3592,7 +3616,7 @@
       </p:sp>
       <p:sp>
         <p:nvSpPr>
-          <p:cNvPr id="24" name="Shape 19"/>
+          <p:cNvPr id="25" name="Shape 19"/>
           <p:cNvSpPr/>
           <p:nvPr/>
         </p:nvSpPr>
@@ -3619,14 +3643,14 @@
       </p:sp>
       <p:pic>
         <p:nvPicPr>
-          <p:cNvPr id="25" name="Image 3" descr="Up arrow key">    </p:cNvPr>
+          <p:cNvPr id="26" name="Image 4" descr="Up arrow key">    </p:cNvPr>
           <p:cNvPicPr>
             <a:picLocks noChangeAspect="1"/>
           </p:cNvPicPr>
           <p:nvPr/>
         </p:nvPicPr>
         <p:blipFill>
-          <a:blip r:embed="rId5"/>
+          <a:blip r:embed="rId6"/>
           <a:stretch>
             <a:fillRect/>
           </a:stretch>
@@ -3643,7 +3667,7 @@
       </p:pic>
       <p:sp>
         <p:nvSpPr>
-          <p:cNvPr id="26" name="Text 20"/>
+          <p:cNvPr id="27" name="Text 20"/>
           <p:cNvSpPr/>
           <p:nvPr/>
         </p:nvSpPr>
@@ -3682,7 +3706,7 @@
       </p:sp>
       <p:sp>
         <p:nvSpPr>
-          <p:cNvPr id="27" name="Shape 21"/>
+          <p:cNvPr id="28" name="Shape 21"/>
           <p:cNvSpPr/>
           <p:nvPr/>
         </p:nvSpPr>
@@ -3709,14 +3733,14 @@
       </p:sp>
       <p:pic>
         <p:nvPicPr>
-          <p:cNvPr id="28" name="Image 4" descr="Down arrow key">    </p:cNvPr>
+          <p:cNvPr id="29" name="Image 5" descr="Down arrow key">    </p:cNvPr>
           <p:cNvPicPr>
             <a:picLocks noChangeAspect="1"/>
           </p:cNvPicPr>
           <p:nvPr/>
         </p:nvPicPr>
         <p:blipFill>
-          <a:blip r:embed="rId6"/>
+          <a:blip r:embed="rId7"/>
           <a:stretch>
             <a:fillRect/>
           </a:stretch>
@@ -3733,7 +3757,7 @@
       </p:pic>
       <p:sp>
         <p:nvSpPr>
-          <p:cNvPr id="29" name="Text 22"/>
+          <p:cNvPr id="30" name="Text 22"/>
           <p:cNvSpPr/>
           <p:nvPr/>
         </p:nvSpPr>
@@ -3772,7 +3796,7 @@
       </p:sp>
       <p:sp>
         <p:nvSpPr>
-          <p:cNvPr id="30" name="Shape 23"/>
+          <p:cNvPr id="31" name="Shape 23"/>
           <p:cNvSpPr/>
           <p:nvPr/>
         </p:nvSpPr>
@@ -3799,7 +3823,7 @@
       </p:sp>
       <p:sp>
         <p:nvSpPr>
-          <p:cNvPr id="31" name="Text 24"/>
+          <p:cNvPr id="32" name="Text 24"/>
           <p:cNvSpPr/>
           <p:nvPr/>
         </p:nvSpPr>
@@ -3838,7 +3862,7 @@
       </p:sp>
       <p:sp>
         <p:nvSpPr>
-          <p:cNvPr id="32" name="Text 25"/>
+          <p:cNvPr id="33" name="Text 25"/>
           <p:cNvSpPr/>
           <p:nvPr/>
         </p:nvSpPr>
@@ -3877,7 +3901,7 @@
       </p:sp>
       <p:sp>
         <p:nvSpPr>
-          <p:cNvPr id="33" name="Shape 26"/>
+          <p:cNvPr id="34" name="Shape 26"/>
           <p:cNvSpPr/>
           <p:nvPr/>
         </p:nvSpPr>
@@ -3904,7 +3928,7 @@
       </p:sp>
       <p:sp>
         <p:nvSpPr>
-          <p:cNvPr id="34" name="Text 27"/>
+          <p:cNvPr id="35" name="Text 27"/>
           <p:cNvSpPr/>
           <p:nvPr/>
         </p:nvSpPr>
@@ -3943,7 +3967,7 @@
       </p:sp>
       <p:sp>
         <p:nvSpPr>
-          <p:cNvPr id="35" name="Text 28"/>
+          <p:cNvPr id="36" name="Text 28"/>
           <p:cNvSpPr/>
           <p:nvPr/>
         </p:nvSpPr>
@@ -3980,30 +4004,6 @@
           </a:p>
         </p:txBody>
       </p:sp>
-      <p:pic>
-        <p:nvPicPr>
-          <p:cNvPr id="36" name="Image 5" descr="GitHub icon">    </p:cNvPr>
-          <p:cNvPicPr>
-            <a:picLocks noChangeAspect="1"/>
-          </p:cNvPicPr>
-          <p:nvPr/>
-        </p:nvPicPr>
-        <p:blipFill>
-          <a:blip r:embed="rId7"/>
-          <a:stretch>
-            <a:fillRect/>
-          </a:stretch>
-        </p:blipFill>
-        <p:spPr>
-          <a:xfrm>
-            <a:off x="548640" y="4233672"/>
-            <a:ext cx="219456" cy="219456"/>
-          </a:xfrm>
-          <a:prstGeom prst="rect">
-            <a:avLst/>
-          </a:prstGeom>
-        </p:spPr>
-      </p:pic>
       <p:sp>
         <p:nvSpPr>
           <p:cNvPr id="37" name="Text 29"/>
@@ -4012,8 +4012,8 @@
         </p:nvSpPr>
         <p:spPr>
           <a:xfrm>
-            <a:off x="859536" y="4206240"/>
-            <a:ext cx="3529584" cy="274320"/>
+            <a:off x="4937760" y="4114800"/>
+            <a:ext cx="3657600" cy="192024"/>
           </a:xfrm>
           <a:prstGeom prst="rect">
             <a:avLst/>
@@ -4022,77 +4022,14 @@
           <a:ln/>
         </p:spPr>
         <p:txBody>
-          <a:bodyPr wrap="square" lIns="0" tIns="0" rIns="0" bIns="0" rtlCol="0" anchor="ctr"/>
-          <a:lstStyle/>
-          <a:p>
-            <a:pPr indent="0" marL="0">
-              <a:buNone/>
-            </a:pPr>
-            <a:r>
-              <a:rPr lang="en-US" sz="1300" dirty="0">
-                <a:solidFill>
-                  <a:srgbClr val="ECE9F8"/>
-                </a:solidFill>
-                <a:latin typeface="Segoe UI Semibold" pitchFamily="34" charset="0"/>
-                <a:ea typeface="Segoe UI Semibold" pitchFamily="34" charset="-122"/>
-                <a:cs typeface="Segoe UI Semibold" pitchFamily="34" charset="-120"/>
-              </a:rPr>
-              <a:t>github.com/roryp/racing</a:t>
-            </a:r>
-            <a:endParaRPr lang="en-US" sz="1300" dirty="0"/>
-          </a:p>
-        </p:txBody>
-      </p:sp>
-      <p:sp>
-        <p:nvSpPr>
-          <p:cNvPr id="38" name="Shape 30">
-            <a:hlinkClick r:id="rId8" tooltip="Open the repository"/>
-          </p:cNvPr>
-          <p:cNvSpPr/>
-          <p:nvPr/>
-        </p:nvSpPr>
-        <p:spPr>
-          <a:xfrm>
-            <a:off x="548640" y="4206240"/>
-            <a:ext cx="2423160" cy="274320"/>
-          </a:xfrm>
-          <a:prstGeom prst="rect">
-            <a:avLst/>
-          </a:prstGeom>
-          <a:solidFill>
-            <a:srgbClr val="07071A">
-              <a:alpha val="0"/>
-            </a:srgbClr>
-          </a:solidFill>
-          <a:ln/>
-        </p:spPr>
-      </p:sp>
-      <p:sp>
-        <p:nvSpPr>
-          <p:cNvPr id="39" name="Text 31"/>
-          <p:cNvSpPr/>
-          <p:nvPr/>
-        </p:nvSpPr>
-        <p:spPr>
-          <a:xfrm>
-            <a:off x="4937760" y="4206240"/>
-            <a:ext cx="3657600" cy="274320"/>
-          </a:xfrm>
-          <a:prstGeom prst="rect">
-            <a:avLst/>
-          </a:prstGeom>
-          <a:noFill/>
-          <a:ln/>
-        </p:spPr>
-        <p:txBody>
-          <a:bodyPr wrap="square" lIns="0" tIns="0" rIns="0" bIns="0" rtlCol="0" anchor="ctr"/>
-          <a:lstStyle/>
-          <a:p>
-            <a:pPr indent="0" marL="0">
-              <a:buNone/>
-            </a:pPr>
-            <a:r>
-              <a:rPr lang="en-US" sz="1200" dirty="0">
+          <a:bodyPr wrap="square" lIns="0" tIns="0" rIns="0" bIns="0" rtlCol="0" anchor="t"/>
+          <a:lstStyle/>
+          <a:p>
+            <a:pPr indent="0" marL="0">
+              <a:buNone/>
+            </a:pPr>
+            <a:r>
+              <a:rPr lang="en-US" sz="1150" dirty="0">
                 <a:solidFill>
                   <a:srgbClr val="ABA6C8"/>
                 </a:solidFill>
@@ -4102,7 +4039,7 @@
               </a:rPr>
               <a:t>Phones and tablets get touch controls.</a:t>
             </a:r>
-            <a:endParaRPr lang="en-US" sz="1200" dirty="0"/>
+            <a:endParaRPr lang="en-US" sz="1150" dirty="0"/>
           </a:p>
         </p:txBody>
       </p:sp>

</xml_diff>

<commit_message>
Link the live game at aka.ms/racing on the closing slide
Slide 11 again leads with a PLAY IT NOW card, now pointing at the aka.ms/racing short link rather than the App Service host name. The speaker notes use the same link.

Co-authored-by: Copilot <223556219+Copilot@users.noreply.github.com>
</commit_message>
<xml_diff>
--- a/docs/luna-gp-deck.pptx
+++ b/docs/luna-gp-deck.pptx
@@ -688,7 +688,7 @@
           <a:p>
             <a:r>
               <a:rPr lang="en-US" dirty="0"/>
-              <a:t>The code is at github.com/roryp/racing. To run it: Node.js 20+ and, for AI rivals, FOUNDRY_ENDPOINT plus an Azure CLI login with access to the Foundry resource. Without it the game still runs with offline heuristics. The README also covers hosting it on App Service with a managed identity. P or Esc pauses, M mutes.</a:t>
+              <a:t>Play the hosted game at aka.ms/racing: it runs on Azure App Service and reaches the model with its managed identity, and the server caps model calls at 20,000 a day. To run your own: Node.js 20+ and, for AI rivals, FOUNDRY_ENDPOINT plus an Azure CLI login with access to the Foundry resource. Without it the game still runs with offline heuristics. P or Esc pauses, M mutes.</a:t>
             </a:r>
             <a:endParaRPr lang="en-US" dirty="0"/>
           </a:p>
@@ -3149,11 +3149,11 @@
         <p:spPr>
           <a:xfrm>
             <a:off x="548640" y="2011680"/>
-            <a:ext cx="3840480" cy="905256"/>
+            <a:ext cx="3840480" cy="713232"/>
           </a:xfrm>
           <a:prstGeom prst="roundRect">
             <a:avLst>
-              <a:gd name="adj" fmla="val 12121"/>
+              <a:gd name="adj" fmla="val 15385"/>
             </a:avLst>
           </a:prstGeom>
           <a:solidFill>
@@ -3170,7 +3170,7 @@
         </p:nvSpPr>
         <p:spPr>
           <a:xfrm>
-            <a:off x="777240" y="2203704"/>
+            <a:off x="777240" y="2112264"/>
             <a:ext cx="3383280" cy="237744"/>
           </a:xfrm>
           <a:prstGeom prst="rect">
@@ -3195,46 +3195,22 @@
                 <a:ea typeface="Segoe UI Semibold" pitchFamily="34" charset="-122"/>
                 <a:cs typeface="Segoe UI Semibold" pitchFamily="34" charset="-120"/>
               </a:rPr>
-              <a:t>GET THE CODE</a:t>
+              <a:t>PLAY IT NOW</a:t>
             </a:r>
             <a:endParaRPr lang="en-US" sz="1050" dirty="0"/>
           </a:p>
         </p:txBody>
       </p:sp>
-      <p:pic>
-        <p:nvPicPr>
-          <p:cNvPr id="14" name="Image 1" descr="GitHub icon">    </p:cNvPr>
-          <p:cNvPicPr>
-            <a:picLocks noChangeAspect="1"/>
-          </p:cNvPicPr>
-          <p:nvPr/>
-        </p:nvPicPr>
-        <p:blipFill>
-          <a:blip r:embed="rId2"/>
-          <a:stretch>
-            <a:fillRect/>
-          </a:stretch>
-        </p:blipFill>
-        <p:spPr>
-          <a:xfrm>
-            <a:off x="777240" y="2478024"/>
-            <a:ext cx="219456" cy="219456"/>
-          </a:xfrm>
-          <a:prstGeom prst="rect">
-            <a:avLst/>
-          </a:prstGeom>
-        </p:spPr>
-      </p:pic>
-      <p:sp>
-        <p:nvSpPr>
-          <p:cNvPr id="15" name="Text 11"/>
-          <p:cNvSpPr/>
-          <p:nvPr/>
-        </p:nvSpPr>
-        <p:spPr>
-          <a:xfrm>
-            <a:off x="1088136" y="2450592"/>
-            <a:ext cx="3072384" cy="274320"/>
+      <p:sp>
+        <p:nvSpPr>
+          <p:cNvPr id="14" name="Text 11"/>
+          <p:cNvSpPr/>
+          <p:nvPr/>
+        </p:nvSpPr>
+        <p:spPr>
+          <a:xfrm>
+            <a:off x="777240" y="2359152"/>
+            <a:ext cx="3383280" cy="274320"/>
           </a:xfrm>
           <a:prstGeom prst="rect">
             <a:avLst/>
@@ -3258,7 +3234,7 @@
                 <a:ea typeface="Segoe UI Semibold" pitchFamily="34" charset="-122"/>
                 <a:cs typeface="Segoe UI Semibold" pitchFamily="34" charset="-120"/>
               </a:rPr>
-              <a:t>github.com/roryp/racing</a:t>
+              <a:t>aka.ms/racing</a:t>
             </a:r>
             <a:endParaRPr lang="en-US" sz="1600" dirty="0"/>
           </a:p>
@@ -3266,8 +3242,8 @@
       </p:sp>
       <p:sp>
         <p:nvSpPr>
-          <p:cNvPr id="16" name="Shape 12">
-            <a:hlinkClick r:id="rId3" tooltip="Open the repository"/>
+          <p:cNvPr id="15" name="Shape 12">
+            <a:hlinkClick r:id="rId2" tooltip="Play LUNA GP"/>
           </p:cNvPr>
           <p:cNvSpPr/>
           <p:nvPr/>
@@ -3275,7 +3251,7 @@
         <p:spPr>
           <a:xfrm>
             <a:off x="548640" y="2011680"/>
-            <a:ext cx="3840480" cy="905256"/>
+            <a:ext cx="3840480" cy="713232"/>
           </a:xfrm>
           <a:prstGeom prst="rect">
             <a:avLst/>
@@ -3290,18 +3266,18 @@
       </p:sp>
       <p:sp>
         <p:nvSpPr>
-          <p:cNvPr id="17" name="Shape 13"/>
-          <p:cNvSpPr/>
-          <p:nvPr/>
-        </p:nvSpPr>
-        <p:spPr>
-          <a:xfrm>
-            <a:off x="548640" y="3063240"/>
-            <a:ext cx="3840480" cy="905256"/>
+          <p:cNvPr id="16" name="Shape 13"/>
+          <p:cNvSpPr/>
+          <p:nvPr/>
+        </p:nvSpPr>
+        <p:spPr>
+          <a:xfrm>
+            <a:off x="548640" y="2862072"/>
+            <a:ext cx="3840480" cy="713232"/>
           </a:xfrm>
           <a:prstGeom prst="roundRect">
             <a:avLst>
-              <a:gd name="adj" fmla="val 12121"/>
+              <a:gd name="adj" fmla="val 15385"/>
             </a:avLst>
           </a:prstGeom>
           <a:solidFill>
@@ -3312,13 +3288,13 @@
       </p:sp>
       <p:sp>
         <p:nvSpPr>
-          <p:cNvPr id="18" name="Text 14"/>
-          <p:cNvSpPr/>
-          <p:nvPr/>
-        </p:nvSpPr>
-        <p:spPr>
-          <a:xfrm>
-            <a:off x="777240" y="3255264"/>
+          <p:cNvPr id="17" name="Text 14"/>
+          <p:cNvSpPr/>
+          <p:nvPr/>
+        </p:nvSpPr>
+        <p:spPr>
+          <a:xfrm>
+            <a:off x="777240" y="2962656"/>
             <a:ext cx="3383280" cy="237744"/>
           </a:xfrm>
           <a:prstGeom prst="rect">
@@ -3343,7 +3319,7 @@
                 <a:ea typeface="Segoe UI Semibold" pitchFamily="34" charset="-122"/>
                 <a:cs typeface="Segoe UI Semibold" pitchFamily="34" charset="-120"/>
               </a:rPr>
-              <a:t>RUN IT</a:t>
+              <a:t>OR RUN YOUR OWN</a:t>
             </a:r>
             <a:endParaRPr lang="en-US" sz="1050" dirty="0"/>
           </a:p>
@@ -3351,13 +3327,13 @@
       </p:sp>
       <p:sp>
         <p:nvSpPr>
-          <p:cNvPr id="19" name="Text 15"/>
-          <p:cNvSpPr/>
-          <p:nvPr/>
-        </p:nvSpPr>
-        <p:spPr>
-          <a:xfrm>
-            <a:off x="777240" y="3502152"/>
+          <p:cNvPr id="18" name="Text 15"/>
+          <p:cNvSpPr/>
+          <p:nvPr/>
+        </p:nvSpPr>
+        <p:spPr>
+          <a:xfrm>
+            <a:off x="777240" y="3209544"/>
             <a:ext cx="3383280" cy="274320"/>
           </a:xfrm>
           <a:prstGeom prst="rect">
@@ -3418,14 +3394,14 @@
       </p:sp>
       <p:sp>
         <p:nvSpPr>
-          <p:cNvPr id="20" name="Text 16"/>
-          <p:cNvSpPr/>
-          <p:nvPr/>
-        </p:nvSpPr>
-        <p:spPr>
-          <a:xfrm>
-            <a:off x="548640" y="4114800"/>
-            <a:ext cx="3840480" cy="384048"/>
+          <p:cNvPr id="19" name="Text 16"/>
+          <p:cNvSpPr/>
+          <p:nvPr/>
+        </p:nvSpPr>
+        <p:spPr>
+          <a:xfrm>
+            <a:off x="548640" y="3712464"/>
+            <a:ext cx="3840480" cy="411480"/>
           </a:xfrm>
           <a:prstGeom prst="rect">
             <a:avLst/>
@@ -3502,7 +3478,7 @@
       </p:sp>
       <p:sp>
         <p:nvSpPr>
-          <p:cNvPr id="21" name="Shape 17"/>
+          <p:cNvPr id="20" name="Shape 17"/>
           <p:cNvSpPr/>
           <p:nvPr/>
         </p:nvSpPr>
@@ -3529,7 +3505,31 @@
       </p:sp>
       <p:pic>
         <p:nvPicPr>
-          <p:cNvPr id="22" name="Image 2" descr="Left arrow key">    </p:cNvPr>
+          <p:cNvPr id="21" name="Image 1" descr="Left arrow key">    </p:cNvPr>
+          <p:cNvPicPr>
+            <a:picLocks noChangeAspect="1"/>
+          </p:cNvPicPr>
+          <p:nvPr/>
+        </p:nvPicPr>
+        <p:blipFill>
+          <a:blip r:embed="rId3"/>
+          <a:stretch>
+            <a:fillRect/>
+          </a:stretch>
+        </p:blipFill>
+        <p:spPr>
+          <a:xfrm>
+            <a:off x="5134356" y="2071116"/>
+            <a:ext cx="155448" cy="155448"/>
+          </a:xfrm>
+          <a:prstGeom prst="rect">
+            <a:avLst/>
+          </a:prstGeom>
+        </p:spPr>
+      </p:pic>
+      <p:pic>
+        <p:nvPicPr>
+          <p:cNvPr id="22" name="Image 2" descr="Right arrow key">    </p:cNvPr>
           <p:cNvPicPr>
             <a:picLocks noChangeAspect="1"/>
           </p:cNvPicPr>
@@ -3543,30 +3543,6 @@
         </p:blipFill>
         <p:spPr>
           <a:xfrm>
-            <a:off x="5134356" y="2071116"/>
-            <a:ext cx="155448" cy="155448"/>
-          </a:xfrm>
-          <a:prstGeom prst="rect">
-            <a:avLst/>
-          </a:prstGeom>
-        </p:spPr>
-      </p:pic>
-      <p:pic>
-        <p:nvPicPr>
-          <p:cNvPr id="23" name="Image 3" descr="Right arrow key">    </p:cNvPr>
-          <p:cNvPicPr>
-            <a:picLocks noChangeAspect="1"/>
-          </p:cNvPicPr>
-          <p:nvPr/>
-        </p:nvPicPr>
-        <p:blipFill>
-          <a:blip r:embed="rId5"/>
-          <a:stretch>
-            <a:fillRect/>
-          </a:stretch>
-        </p:blipFill>
-        <p:spPr>
-          <a:xfrm>
             <a:off x="5362956" y="2071116"/>
             <a:ext cx="155448" cy="155448"/>
           </a:xfrm>
@@ -3577,7 +3553,7 @@
       </p:pic>
       <p:sp>
         <p:nvSpPr>
-          <p:cNvPr id="24" name="Text 18"/>
+          <p:cNvPr id="23" name="Text 18"/>
           <p:cNvSpPr/>
           <p:nvPr/>
         </p:nvSpPr>
@@ -3616,7 +3592,7 @@
       </p:sp>
       <p:sp>
         <p:nvSpPr>
-          <p:cNvPr id="25" name="Shape 19"/>
+          <p:cNvPr id="24" name="Shape 19"/>
           <p:cNvSpPr/>
           <p:nvPr/>
         </p:nvSpPr>
@@ -3643,14 +3619,14 @@
       </p:sp>
       <p:pic>
         <p:nvPicPr>
-          <p:cNvPr id="26" name="Image 4" descr="Up arrow key">    </p:cNvPr>
+          <p:cNvPr id="25" name="Image 3" descr="Up arrow key">    </p:cNvPr>
           <p:cNvPicPr>
             <a:picLocks noChangeAspect="1"/>
           </p:cNvPicPr>
           <p:nvPr/>
         </p:nvPicPr>
         <p:blipFill>
-          <a:blip r:embed="rId6"/>
+          <a:blip r:embed="rId5"/>
           <a:stretch>
             <a:fillRect/>
           </a:stretch>
@@ -3667,7 +3643,7 @@
       </p:pic>
       <p:sp>
         <p:nvSpPr>
-          <p:cNvPr id="27" name="Text 20"/>
+          <p:cNvPr id="26" name="Text 20"/>
           <p:cNvSpPr/>
           <p:nvPr/>
         </p:nvSpPr>
@@ -3706,7 +3682,7 @@
       </p:sp>
       <p:sp>
         <p:nvSpPr>
-          <p:cNvPr id="28" name="Shape 21"/>
+          <p:cNvPr id="27" name="Shape 21"/>
           <p:cNvSpPr/>
           <p:nvPr/>
         </p:nvSpPr>
@@ -3733,14 +3709,14 @@
       </p:sp>
       <p:pic>
         <p:nvPicPr>
-          <p:cNvPr id="29" name="Image 5" descr="Down arrow key">    </p:cNvPr>
+          <p:cNvPr id="28" name="Image 4" descr="Down arrow key">    </p:cNvPr>
           <p:cNvPicPr>
             <a:picLocks noChangeAspect="1"/>
           </p:cNvPicPr>
           <p:nvPr/>
         </p:nvPicPr>
         <p:blipFill>
-          <a:blip r:embed="rId7"/>
+          <a:blip r:embed="rId6"/>
           <a:stretch>
             <a:fillRect/>
           </a:stretch>
@@ -3757,7 +3733,7 @@
       </p:pic>
       <p:sp>
         <p:nvSpPr>
-          <p:cNvPr id="30" name="Text 22"/>
+          <p:cNvPr id="29" name="Text 22"/>
           <p:cNvSpPr/>
           <p:nvPr/>
         </p:nvSpPr>
@@ -3796,7 +3772,7 @@
       </p:sp>
       <p:sp>
         <p:nvSpPr>
-          <p:cNvPr id="31" name="Shape 23"/>
+          <p:cNvPr id="30" name="Shape 23"/>
           <p:cNvSpPr/>
           <p:nvPr/>
         </p:nvSpPr>
@@ -3823,7 +3799,7 @@
       </p:sp>
       <p:sp>
         <p:nvSpPr>
-          <p:cNvPr id="32" name="Text 24"/>
+          <p:cNvPr id="31" name="Text 24"/>
           <p:cNvSpPr/>
           <p:nvPr/>
         </p:nvSpPr>
@@ -3862,7 +3838,7 @@
       </p:sp>
       <p:sp>
         <p:nvSpPr>
-          <p:cNvPr id="33" name="Text 25"/>
+          <p:cNvPr id="32" name="Text 25"/>
           <p:cNvSpPr/>
           <p:nvPr/>
         </p:nvSpPr>
@@ -3901,7 +3877,7 @@
       </p:sp>
       <p:sp>
         <p:nvSpPr>
-          <p:cNvPr id="34" name="Shape 26"/>
+          <p:cNvPr id="33" name="Shape 26"/>
           <p:cNvSpPr/>
           <p:nvPr/>
         </p:nvSpPr>
@@ -3928,7 +3904,7 @@
       </p:sp>
       <p:sp>
         <p:nvSpPr>
-          <p:cNvPr id="35" name="Text 27"/>
+          <p:cNvPr id="34" name="Text 27"/>
           <p:cNvSpPr/>
           <p:nvPr/>
         </p:nvSpPr>
@@ -3967,7 +3943,7 @@
       </p:sp>
       <p:sp>
         <p:nvSpPr>
-          <p:cNvPr id="36" name="Text 28"/>
+          <p:cNvPr id="35" name="Text 28"/>
           <p:cNvSpPr/>
           <p:nvPr/>
         </p:nvSpPr>
@@ -4004,6 +3980,30 @@
           </a:p>
         </p:txBody>
       </p:sp>
+      <p:pic>
+        <p:nvPicPr>
+          <p:cNvPr id="36" name="Image 5" descr="GitHub icon">    </p:cNvPr>
+          <p:cNvPicPr>
+            <a:picLocks noChangeAspect="1"/>
+          </p:cNvPicPr>
+          <p:nvPr/>
+        </p:nvPicPr>
+        <p:blipFill>
+          <a:blip r:embed="rId7"/>
+          <a:stretch>
+            <a:fillRect/>
+          </a:stretch>
+        </p:blipFill>
+        <p:spPr>
+          <a:xfrm>
+            <a:off x="548640" y="4233672"/>
+            <a:ext cx="219456" cy="219456"/>
+          </a:xfrm>
+          <a:prstGeom prst="rect">
+            <a:avLst/>
+          </a:prstGeom>
+        </p:spPr>
+      </p:pic>
       <p:sp>
         <p:nvSpPr>
           <p:cNvPr id="37" name="Text 29"/>
@@ -4012,8 +4012,8 @@
         </p:nvSpPr>
         <p:spPr>
           <a:xfrm>
-            <a:off x="4937760" y="4114800"/>
-            <a:ext cx="3657600" cy="192024"/>
+            <a:off x="859536" y="4206240"/>
+            <a:ext cx="3529584" cy="274320"/>
           </a:xfrm>
           <a:prstGeom prst="rect">
             <a:avLst/>
@@ -4022,14 +4022,77 @@
           <a:ln/>
         </p:spPr>
         <p:txBody>
-          <a:bodyPr wrap="square" lIns="0" tIns="0" rIns="0" bIns="0" rtlCol="0" anchor="t"/>
-          <a:lstStyle/>
-          <a:p>
-            <a:pPr indent="0" marL="0">
-              <a:buNone/>
-            </a:pPr>
-            <a:r>
-              <a:rPr lang="en-US" sz="1150" dirty="0">
+          <a:bodyPr wrap="square" lIns="0" tIns="0" rIns="0" bIns="0" rtlCol="0" anchor="ctr"/>
+          <a:lstStyle/>
+          <a:p>
+            <a:pPr indent="0" marL="0">
+              <a:buNone/>
+            </a:pPr>
+            <a:r>
+              <a:rPr lang="en-US" sz="1300" dirty="0">
+                <a:solidFill>
+                  <a:srgbClr val="ECE9F8"/>
+                </a:solidFill>
+                <a:latin typeface="Segoe UI Semibold" pitchFamily="34" charset="0"/>
+                <a:ea typeface="Segoe UI Semibold" pitchFamily="34" charset="-122"/>
+                <a:cs typeface="Segoe UI Semibold" pitchFamily="34" charset="-120"/>
+              </a:rPr>
+              <a:t>github.com/roryp/racing</a:t>
+            </a:r>
+            <a:endParaRPr lang="en-US" sz="1300" dirty="0"/>
+          </a:p>
+        </p:txBody>
+      </p:sp>
+      <p:sp>
+        <p:nvSpPr>
+          <p:cNvPr id="38" name="Shape 30">
+            <a:hlinkClick r:id="rId8" tooltip="Open the repository"/>
+          </p:cNvPr>
+          <p:cNvSpPr/>
+          <p:nvPr/>
+        </p:nvSpPr>
+        <p:spPr>
+          <a:xfrm>
+            <a:off x="548640" y="4206240"/>
+            <a:ext cx="2423160" cy="274320"/>
+          </a:xfrm>
+          <a:prstGeom prst="rect">
+            <a:avLst/>
+          </a:prstGeom>
+          <a:solidFill>
+            <a:srgbClr val="07071A">
+              <a:alpha val="0"/>
+            </a:srgbClr>
+          </a:solidFill>
+          <a:ln/>
+        </p:spPr>
+      </p:sp>
+      <p:sp>
+        <p:nvSpPr>
+          <p:cNvPr id="39" name="Text 31"/>
+          <p:cNvSpPr/>
+          <p:nvPr/>
+        </p:nvSpPr>
+        <p:spPr>
+          <a:xfrm>
+            <a:off x="4937760" y="4206240"/>
+            <a:ext cx="3657600" cy="274320"/>
+          </a:xfrm>
+          <a:prstGeom prst="rect">
+            <a:avLst/>
+          </a:prstGeom>
+          <a:noFill/>
+          <a:ln/>
+        </p:spPr>
+        <p:txBody>
+          <a:bodyPr wrap="square" lIns="0" tIns="0" rIns="0" bIns="0" rtlCol="0" anchor="ctr"/>
+          <a:lstStyle/>
+          <a:p>
+            <a:pPr indent="0" marL="0">
+              <a:buNone/>
+            </a:pPr>
+            <a:r>
+              <a:rPr lang="en-US" sz="1200" dirty="0">
                 <a:solidFill>
                   <a:srgbClr val="ABA6C8"/>
                 </a:solidFill>
@@ -4039,7 +4102,7 @@
               </a:rPr>
               <a:t>Phones and tablets get touch controls.</a:t>
             </a:r>
-            <a:endParaRPr lang="en-US" sz="1150" dirty="0"/>
+            <a:endParaRPr lang="en-US" sz="1200" dirty="0"/>
           </a:p>
         </p:txBody>
       </p:sp>

</xml_diff>

<commit_message>
Add a hosting slide to the deck: one App Service, one Node process
Co-authored-by: Copilot <223556219+Copilot@users.noreply.github.com>
</commit_message>
<xml_diff>
--- a/docs/luna-gp-deck.pptx
+++ b/docs/luna-gp-deck.pptx
@@ -13,6 +13,7 @@
     <p:sldId id="261" r:id="rId7"/>
     <p:sldId id="262" r:id="rId8"/>
     <p:sldId id="263" r:id="rId9"/>
+    <p:sldId id="267" r:id="rId18"/>
     <p:sldId id="264" r:id="rId10"/>
     <p:sldId id="265" r:id="rId11"/>
     <p:sldId id="266" r:id="rId12"/>
@@ -623,7 +624,7 @@
           <a:p>
             <a:fld id="{F7021451-1387-4CA6-816F-3879F97B5CBC}" type="slidenum">
               <a:rPr lang="en-US"/>
-              <a:t>10</a:t>
+              <a:t>11</a:t>
             </a:fld>
             <a:endParaRPr lang="en-US"/>
           </a:p>
@@ -711,7 +712,95 @@
           <a:p>
             <a:fld id="{F7021451-1387-4CA6-816F-3879F97B5CBC}" type="slidenum">
               <a:rPr lang="en-US"/>
-              <a:t>11</a:t>
+              <a:t>12</a:t>
+            </a:fld>
+            <a:endParaRPr lang="en-US"/>
+          </a:p>
+        </p:txBody>
+      </p:sp>
+    </p:spTree>
+    <p:extLst>
+      <p:ext uri="{BB962C8B-B14F-4D97-AF65-F5344CB8AC3E}">
+        <p14:creationId xmlns:p14="http://schemas.microsoft.com/office/powerpoint/2010/main" val="1024086991"/>
+      </p:ext>
+    </p:extLst>
+  </p:cSld>
+  <p:clrMapOvr>
+    <a:masterClrMapping/>
+  </p:clrMapOvr>
+</p:notes>
+</file>
+
+<file path=ppt/notesSlides/notesSlide12.xml><?xml version="1.0" encoding="utf-8"?>
+<p:notes xmlns:a="http://schemas.openxmlformats.org/drawingml/2006/main" xmlns:r="http://schemas.openxmlformats.org/officeDocument/2006/relationships" xmlns:p="http://schemas.openxmlformats.org/presentationml/2006/main">
+  <p:cSld>
+    <p:spTree>
+      <p:nvGrpSpPr>
+        <p:cNvPr id="1" name=""/>
+        <p:cNvGrpSpPr/>
+        <p:nvPr/>
+      </p:nvGrpSpPr>
+      <p:grpSpPr>
+        <a:xfrm>
+          <a:off x="0" y="0"/>
+          <a:ext cx="0" cy="0"/>
+          <a:chOff x="0" y="0"/>
+          <a:chExt cx="0" cy="0"/>
+        </a:xfrm>
+      </p:grpSpPr>
+      <p:sp>
+        <p:nvSpPr>
+          <p:cNvPr id="2" name="Slide Image Placeholder 1"/>
+          <p:cNvSpPr>
+            <a:spLocks noGrp="1" noRot="1" noChangeAspect="1"/>
+          </p:cNvSpPr>
+          <p:nvPr>
+            <p:ph type="sldImg"/>
+          </p:nvPr>
+        </p:nvSpPr>
+        <p:spPr/>
+      </p:sp>
+      <p:sp>
+        <p:nvSpPr>
+          <p:cNvPr id="3" name="Notes Placeholder 2"/>
+          <p:cNvSpPr>
+            <a:spLocks noGrp="1"/>
+          </p:cNvSpPr>
+          <p:nvPr>
+            <p:ph type="body" idx="1"/>
+          </p:nvPr>
+        </p:nvSpPr>
+        <p:spPr/>
+        <p:txBody>
+          <a:bodyPr/>
+          <a:lstStyle/>
+          <a:p>
+            <a:r>
+              <a:rPr lang="en-US" dirty="0"/>
+              <a:t>Where everything runs. The whole game runs in the player’s browser: physics at a fixed 60 Hz step, rival driving, crashes and the roadside recovery, laps, positions and canvas rendering. The browser calls the server only when a rival, Race Control or the debrief needs a decision. The server is one Node.js process (node server.js) on a Linux App Service web app (Node 22, P0v3, always on). It serves the static files in public/ and the /api/rival, /api/steward, /api/debrief and /api/duel endpoints: they validate the telemetry, build the state and questions, and call Microsoft-Decision-1 on Foundry with the app’s system-assigned managed identity, so no key ever reaches the browser. It is not a container app: there is no container image, background worker, queue, scheduled job or database. Apart from answering requests, the server only keeps an in-memory daily call counter and logs a usage summary every 30 s. Deploying is a zip of server.js, package.json, lib and public pushed with az webapp deploy.</a:t>
+            </a:r>
+            <a:endParaRPr lang="en-US" dirty="0"/>
+          </a:p>
+        </p:txBody>
+      </p:sp>
+      <p:sp>
+        <p:nvSpPr>
+          <p:cNvPr id="4" name="Slide Number Placeholder 3"/>
+          <p:cNvSpPr>
+            <a:spLocks noGrp="1"/>
+          </p:cNvSpPr>
+          <p:nvPr>
+            <p:ph type="sldNum" sz="quarter" idx="10"/>
+          </p:nvPr>
+        </p:nvSpPr>
+        <p:spPr/>
+        <p:txBody>
+          <a:bodyPr/>
+          <a:lstStyle/>
+          <a:p>
+            <a:fld id="{F7021451-1387-4CA6-816F-3879F97B5CBC}" type="slidenum">
+              <a:rPr lang="en-US"/>
+              <a:t>9</a:t>
             </a:fld>
             <a:endParaRPr lang="en-US"/>
           </a:p>
@@ -1415,7 +1504,7 @@
           <a:p>
             <a:fld id="{F7021451-1387-4CA6-816F-3879F97B5CBC}" type="slidenum">
               <a:rPr lang="en-US"/>
-              <a:t>9</a:t>
+              <a:t>10</a:t>
             </a:fld>
             <a:endParaRPr lang="en-US"/>
           </a:p>
@@ -2031,7 +2120,7 @@
       </p:sp>
       <p:pic>
         <p:nvPicPr>
-          <p:cNvPr id="14" name="Image 0" descr="Moon">    </p:cNvPr>
+          <p:cNvPr id="14" name="Image 0" descr="Moon"/>
           <p:cNvPicPr>
             <a:picLocks noChangeAspect="1"/>
           </p:cNvPicPr>
@@ -2100,7 +2189,7 @@
                 <a:ea typeface="Segoe UI Black" pitchFamily="34" charset="-122"/>
                 <a:cs typeface="Segoe UI Black" pitchFamily="34" charset="-120"/>
               </a:rPr>
-              <a:t> GP</a:t>
+              <a:t xml:space="preserve"> GP</a:t>
             </a:r>
             <a:endParaRPr lang="en-US" sz="7200" dirty="0"/>
           </a:p>
@@ -2139,7 +2228,7 @@
                 <a:ea typeface="Segoe UI" pitchFamily="34" charset="-122"/>
                 <a:cs typeface="Segoe UI" pitchFamily="34" charset="-120"/>
               </a:rPr>
-              <a:t>A night-time arcade racer where every rival thinks with </a:t>
+              <a:t xml:space="preserve">A night-time arcade racer where every rival thinks with </a:t>
             </a:r>
             <a:pPr indent="0" marL="0">
               <a:buNone/>
@@ -2336,7 +2425,7 @@
                 <a:ea typeface="Segoe UI Semibold" pitchFamily="34" charset="-122"/>
                 <a:cs typeface="Segoe UI Semibold" pitchFamily="34" charset="-120"/>
               </a:rPr>
-              <a:t>10 / 11</a:t>
+              <a:t>11 / 12</a:t>
             </a:r>
             <a:endParaRPr lang="en-US" sz="1100" dirty="0"/>
           </a:p>
@@ -2785,7 +2874,7 @@
       </p:sp>
       <p:pic>
         <p:nvPicPr>
-          <p:cNvPr id="15" name="Image 0" descr="Coins icon">    </p:cNvPr>
+          <p:cNvPr id="15" name="Image 0" descr="Coins icon"/>
           <p:cNvPicPr>
             <a:picLocks noChangeAspect="1"/>
           </p:cNvPicPr>
@@ -3079,7 +3168,7 @@
       </p:sp>
       <p:pic>
         <p:nvPicPr>
-          <p:cNvPr id="10" name="Image 0" descr="Moon">    </p:cNvPr>
+          <p:cNvPr id="10" name="Image 0" descr="Moon"/>
           <p:cNvPicPr>
             <a:picLocks noChangeAspect="1"/>
           </p:cNvPicPr>
@@ -3505,7 +3594,7 @@
       </p:sp>
       <p:pic>
         <p:nvPicPr>
-          <p:cNvPr id="21" name="Image 1" descr="Left arrow key">    </p:cNvPr>
+          <p:cNvPr id="21" name="Image 1" descr="Left arrow key"/>
           <p:cNvPicPr>
             <a:picLocks noChangeAspect="1"/>
           </p:cNvPicPr>
@@ -3529,7 +3618,7 @@
       </p:pic>
       <p:pic>
         <p:nvPicPr>
-          <p:cNvPr id="22" name="Image 2" descr="Right arrow key">    </p:cNvPr>
+          <p:cNvPr id="22" name="Image 2" descr="Right arrow key"/>
           <p:cNvPicPr>
             <a:picLocks noChangeAspect="1"/>
           </p:cNvPicPr>
@@ -3619,7 +3708,7 @@
       </p:sp>
       <p:pic>
         <p:nvPicPr>
-          <p:cNvPr id="25" name="Image 3" descr="Up arrow key">    </p:cNvPr>
+          <p:cNvPr id="25" name="Image 3" descr="Up arrow key"/>
           <p:cNvPicPr>
             <a:picLocks noChangeAspect="1"/>
           </p:cNvPicPr>
@@ -3709,7 +3798,7 @@
       </p:sp>
       <p:pic>
         <p:nvPicPr>
-          <p:cNvPr id="28" name="Image 4" descr="Down arrow key">    </p:cNvPr>
+          <p:cNvPr id="28" name="Image 4" descr="Down arrow key"/>
           <p:cNvPicPr>
             <a:picLocks noChangeAspect="1"/>
           </p:cNvPicPr>
@@ -3982,7 +4071,7 @@
       </p:sp>
       <p:pic>
         <p:nvPicPr>
-          <p:cNvPr id="36" name="Image 5" descr="GitHub icon">    </p:cNvPr>
+          <p:cNvPr id="36" name="Image 5" descr="GitHub icon"/>
           <p:cNvPicPr>
             <a:picLocks noChangeAspect="1"/>
           </p:cNvPicPr>
@@ -4101,6 +4190,822 @@
                 <a:cs typeface="Segoe UI" pitchFamily="34" charset="-120"/>
               </a:rPr>
               <a:t>Phones and tablets get touch controls.</a:t>
+            </a:r>
+            <a:endParaRPr lang="en-US" sz="1200" dirty="0"/>
+          </a:p>
+        </p:txBody>
+      </p:sp>
+    </p:spTree>
+  </p:cSld>
+  <p:clrMapOvr>
+    <a:masterClrMapping/>
+  </p:clrMapOvr>
+</p:sld>
+</file>
+
+<file path=ppt/slides/slide12.xml><?xml version="1.0" encoding="utf-8"?>
+<p:sld xmlns:a="http://schemas.openxmlformats.org/drawingml/2006/main" xmlns:r="http://schemas.openxmlformats.org/officeDocument/2006/relationships" xmlns:p="http://schemas.openxmlformats.org/presentationml/2006/main">
+  <p:cSld name="Slide 12">
+    <p:bg>
+      <p:bgPr>
+        <a:solidFill>
+          <a:srgbClr val="07071A"/>
+        </a:solidFill>
+        <a:effectLst/>
+      </p:bgPr>
+    </p:bg>
+    <p:spTree>
+      <p:nvGrpSpPr>
+        <p:cNvPr id="1" name=""/>
+        <p:cNvGrpSpPr/>
+        <p:nvPr/>
+      </p:nvGrpSpPr>
+      <p:grpSpPr>
+        <a:xfrm>
+          <a:off x="0" y="0"/>
+          <a:ext cx="0" cy="0"/>
+          <a:chOff x="0" y="0"/>
+          <a:chExt cx="0" cy="0"/>
+        </a:xfrm>
+      </p:grpSpPr>
+      <p:sp>
+        <p:nvSpPr>
+          <p:cNvPr id="2" name="Shape 2"/>
+          <p:cNvSpPr/>
+          <p:nvPr/>
+        </p:nvSpPr>
+        <p:spPr>
+          <a:xfrm>
+            <a:off x="548640" y="484632"/>
+            <a:ext cx="109728" cy="109728"/>
+          </a:xfrm>
+          <a:prstGeom prst="ellipse">
+            <a:avLst/>
+          </a:prstGeom>
+          <a:solidFill>
+            <a:srgbClr val="FFD166"/>
+          </a:solidFill>
+          <a:ln/>
+        </p:spPr>
+      </p:sp>
+      <p:sp>
+        <p:nvSpPr>
+          <p:cNvPr id="3" name="Text 3"/>
+          <p:cNvSpPr txBox="1"/>
+          <p:nvPr/>
+        </p:nvSpPr>
+        <p:spPr>
+          <a:xfrm>
+            <a:off x="749808" y="393192"/>
+            <a:ext cx="5943600" cy="292608"/>
+          </a:xfrm>
+          <a:prstGeom prst="rect">
+            <a:avLst/>
+          </a:prstGeom>
+          <a:noFill/>
+          <a:ln/>
+        </p:spPr>
+        <p:txBody>
+          <a:bodyPr wrap="square" lIns="0" tIns="0" rIns="0" bIns="0" rtlCol="0" anchor="ctr"/>
+          <a:lstStyle/>
+          <a:p>
+            <a:pPr indent="0" marL="0">
+              <a:buNone/>
+            </a:pPr>
+            <a:r>
+              <a:rPr lang="en-US" sz="1100" spc="300" kern="0" dirty="0">
+                <a:solidFill>
+                  <a:srgbClr val="ABA6C8"/>
+                </a:solidFill>
+                <a:latin typeface="Segoe UI Semibold" pitchFamily="34" charset="0"/>
+                <a:ea typeface="Segoe UI Semibold" pitchFamily="34" charset="-122"/>
+                <a:cs typeface="Segoe UI Semibold" pitchFamily="34" charset="-120"/>
+              </a:rPr>
+              <a:t xml:space="preserve">HOSTING</a:t>
+            </a:r>
+            <a:endParaRPr lang="en-US" sz="1100" dirty="0"/>
+          </a:p>
+        </p:txBody>
+      </p:sp>
+      <p:sp>
+        <p:nvSpPr>
+          <p:cNvPr id="4" name="Text 4"/>
+          <p:cNvSpPr txBox="1"/>
+          <p:nvPr/>
+        </p:nvSpPr>
+        <p:spPr>
+          <a:xfrm>
+            <a:off x="7223760" y="393192"/>
+            <a:ext cx="1371600" cy="292608"/>
+          </a:xfrm>
+          <a:prstGeom prst="rect">
+            <a:avLst/>
+          </a:prstGeom>
+          <a:noFill/>
+          <a:ln/>
+        </p:spPr>
+        <p:txBody>
+          <a:bodyPr wrap="square" lIns="0" tIns="0" rIns="0" bIns="0" rtlCol="0" anchor="ctr"/>
+          <a:lstStyle/>
+          <a:p>
+            <a:pPr algn="r" indent="0" marL="0">
+              <a:buNone/>
+            </a:pPr>
+            <a:r>
+              <a:rPr lang="en-US" sz="1100" dirty="0">
+                <a:solidFill>
+                  <a:srgbClr val="ABA6C8"/>
+                </a:solidFill>
+                <a:latin typeface="Segoe UI Semibold" pitchFamily="34" charset="0"/>
+                <a:ea typeface="Segoe UI Semibold" pitchFamily="34" charset="-122"/>
+                <a:cs typeface="Segoe UI Semibold" pitchFamily="34" charset="-120"/>
+              </a:rPr>
+              <a:t xml:space="preserve">09 / 12</a:t>
+            </a:r>
+            <a:endParaRPr lang="en-US" sz="1100" dirty="0"/>
+          </a:p>
+        </p:txBody>
+      </p:sp>
+      <p:sp>
+        <p:nvSpPr>
+          <p:cNvPr id="5" name="Text 5"/>
+          <p:cNvSpPr txBox="1"/>
+          <p:nvPr/>
+        </p:nvSpPr>
+        <p:spPr>
+          <a:xfrm>
+            <a:off x="548640" y="749808"/>
+            <a:ext cx="8046720" cy="658368"/>
+          </a:xfrm>
+          <a:prstGeom prst="rect">
+            <a:avLst/>
+          </a:prstGeom>
+          <a:noFill/>
+          <a:ln/>
+        </p:spPr>
+        <p:txBody>
+          <a:bodyPr wrap="square" lIns="0" tIns="0" rIns="0" bIns="0" rtlCol="0" anchor="t"/>
+          <a:lstStyle/>
+          <a:p>
+            <a:pPr indent="0" marL="0">
+              <a:buNone/>
+            </a:pPr>
+            <a:r>
+              <a:rPr lang="en-US" sz="3400" i="1" dirty="0">
+                <a:solidFill>
+                  <a:srgbClr val="ECE9F8"/>
+                </a:solidFill>
+                <a:latin typeface="Segoe UI Black" pitchFamily="34" charset="0"/>
+                <a:ea typeface="Segoe UI Black" pitchFamily="34" charset="-122"/>
+                <a:cs typeface="Segoe UI Black" pitchFamily="34" charset="-120"/>
+              </a:rPr>
+              <a:t xml:space="preserve">One web app, one Node process</a:t>
+            </a:r>
+            <a:endParaRPr lang="en-US" sz="3400" dirty="0"/>
+          </a:p>
+        </p:txBody>
+      </p:sp>
+      <p:sp>
+        <p:nvSpPr>
+          <p:cNvPr id="6" name="Text 6"/>
+          <p:cNvSpPr txBox="1"/>
+          <p:nvPr/>
+        </p:nvSpPr>
+        <p:spPr>
+          <a:xfrm>
+            <a:off x="548640" y="1508760"/>
+            <a:ext cx="8046720" cy="320040"/>
+          </a:xfrm>
+          <a:prstGeom prst="rect">
+            <a:avLst/>
+          </a:prstGeom>
+          <a:noFill/>
+          <a:ln/>
+        </p:spPr>
+        <p:txBody>
+          <a:bodyPr wrap="square" lIns="0" tIns="0" rIns="0" bIns="0" rtlCol="0" anchor="t"/>
+          <a:lstStyle/>
+          <a:p>
+            <a:pPr indent="0" marL="0">
+              <a:buNone/>
+            </a:pPr>
+            <a:r>
+              <a:rPr lang="en-US" sz="1600" dirty="0">
+                <a:solidFill>
+                  <a:srgbClr val="ECE9F8"/>
+                </a:solidFill>
+                <a:latin typeface="Segoe UI" pitchFamily="34" charset="0"/>
+                <a:ea typeface="Segoe UI" pitchFamily="34" charset="-122"/>
+                <a:cs typeface="Segoe UI" pitchFamily="34" charset="-120"/>
+              </a:rPr>
+              <a:t xml:space="preserve">The game runs </a:t>
+            </a:r>
+            <a:r>
+              <a:rPr lang="en-US" sz="1600" b="1" dirty="0">
+                <a:solidFill>
+                  <a:srgbClr val="FFD166"/>
+                </a:solidFill>
+                <a:latin typeface="Segoe UI" pitchFamily="34" charset="0"/>
+                <a:ea typeface="Segoe UI" pitchFamily="34" charset="-122"/>
+                <a:cs typeface="Segoe UI" pitchFamily="34" charset="-120"/>
+              </a:rPr>
+              <a:t xml:space="preserve">in the browser</a:t>
+            </a:r>
+            <a:r>
+              <a:rPr lang="en-US" sz="1600" dirty="0">
+                <a:solidFill>
+                  <a:srgbClr val="ECE9F8"/>
+                </a:solidFill>
+                <a:latin typeface="Segoe UI" pitchFamily="34" charset="0"/>
+                <a:ea typeface="Segoe UI" pitchFamily="34" charset="-122"/>
+                <a:cs typeface="Segoe UI" pitchFamily="34" charset="-120"/>
+              </a:rPr>
+              <a:t xml:space="preserve">. The server only serves files and asks the model.</a:t>
+            </a:r>
+            <a:endParaRPr lang="en-US" sz="1600" dirty="0"/>
+          </a:p>
+        </p:txBody>
+      </p:sp>
+      <p:sp>
+        <p:nvSpPr>
+          <p:cNvPr id="7" name="Card 7"/>
+          <p:cNvSpPr/>
+          <p:nvPr/>
+        </p:nvSpPr>
+        <p:spPr>
+          <a:xfrm>
+            <a:off x="548640" y="2148840"/>
+            <a:ext cx="2407920" cy="1874520"/>
+          </a:xfrm>
+          <a:prstGeom prst="roundRect">
+            <a:avLst>
+              <a:gd name="adj" fmla="val 9143"/>
+            </a:avLst>
+          </a:prstGeom>
+          <a:solidFill>
+            <a:srgbClr val="110F2B"/>
+          </a:solidFill>
+          <a:ln/>
+        </p:spPr>
+      </p:sp>
+      <p:pic>
+        <p:nvPicPr>
+          <p:cNvPr id="8" name="Image 8" descr="Monitor icon"/>
+          <p:cNvPicPr>
+            <a:picLocks noChangeAspect="1"/>
+          </p:cNvPicPr>
+          <p:nvPr/>
+        </p:nvPicPr>
+        <p:blipFill>
+          <a:blip r:embed="rId2"/>
+          <a:stretch>
+            <a:fillRect/>
+          </a:stretch>
+        </p:blipFill>
+        <p:spPr>
+          <a:xfrm>
+            <a:off x="777240" y="2377440"/>
+            <a:ext cx="384048" cy="384048"/>
+          </a:xfrm>
+          <a:prstGeom prst="rect">
+            <a:avLst/>
+          </a:prstGeom>
+        </p:spPr>
+      </p:pic>
+      <p:sp>
+        <p:nvSpPr>
+          <p:cNvPr id="9" name="Text 9"/>
+          <p:cNvSpPr txBox="1"/>
+          <p:nvPr/>
+        </p:nvSpPr>
+        <p:spPr>
+          <a:xfrm>
+            <a:off x="1298448" y="2377440"/>
+            <a:ext cx="1429512" cy="384048"/>
+          </a:xfrm>
+          <a:prstGeom prst="rect">
+            <a:avLst/>
+          </a:prstGeom>
+          <a:noFill/>
+          <a:ln/>
+        </p:spPr>
+        <p:txBody>
+          <a:bodyPr wrap="square" lIns="0" tIns="0" rIns="0" bIns="0" rtlCol="0" anchor="ctr"/>
+          <a:lstStyle/>
+          <a:p>
+            <a:pPr indent="0" marL="0">
+              <a:buNone/>
+            </a:pPr>
+            <a:r>
+              <a:rPr lang="en-US" sz="1050" spc="200" kern="0" dirty="0">
+                <a:solidFill>
+                  <a:srgbClr val="ABA6C8"/>
+                </a:solidFill>
+                <a:latin typeface="Segoe UI Semibold" pitchFamily="34" charset="0"/>
+                <a:ea typeface="Segoe UI Semibold" pitchFamily="34" charset="-122"/>
+                <a:cs typeface="Segoe UI Semibold" pitchFamily="34" charset="-120"/>
+              </a:rPr>
+              <a:t xml:space="preserve">BROWSER</a:t>
+            </a:r>
+            <a:endParaRPr lang="en-US" sz="1050" dirty="0"/>
+          </a:p>
+        </p:txBody>
+      </p:sp>
+      <p:sp>
+        <p:nvSpPr>
+          <p:cNvPr id="10" name="Text 10"/>
+          <p:cNvSpPr txBox="1"/>
+          <p:nvPr/>
+        </p:nvSpPr>
+        <p:spPr>
+          <a:xfrm>
+            <a:off x="777240" y="2926080"/>
+            <a:ext cx="1950720" cy="292608"/>
+          </a:xfrm>
+          <a:prstGeom prst="rect">
+            <a:avLst/>
+          </a:prstGeom>
+          <a:noFill/>
+          <a:ln/>
+        </p:spPr>
+        <p:txBody>
+          <a:bodyPr wrap="square" lIns="0" tIns="0" rIns="0" bIns="0" rtlCol="0" anchor="ctr"/>
+          <a:lstStyle/>
+          <a:p>
+            <a:pPr indent="0" marL="0">
+              <a:buNone/>
+            </a:pPr>
+            <a:r>
+              <a:rPr lang="en-US" sz="1400" b="1" dirty="0">
+                <a:solidFill>
+                  <a:srgbClr val="ECE9F8"/>
+                </a:solidFill>
+                <a:latin typeface="Segoe UI" pitchFamily="34" charset="0"/>
+                <a:ea typeface="Segoe UI" pitchFamily="34" charset="-122"/>
+                <a:cs typeface="Segoe UI" pitchFamily="34" charset="-120"/>
+              </a:rPr>
+              <a:t xml:space="preserve">The whole game</a:t>
+            </a:r>
+            <a:endParaRPr lang="en-US" sz="1400" dirty="0"/>
+          </a:p>
+        </p:txBody>
+      </p:sp>
+      <p:sp>
+        <p:nvSpPr>
+          <p:cNvPr id="11" name="Text 11"/>
+          <p:cNvSpPr txBox="1"/>
+          <p:nvPr/>
+        </p:nvSpPr>
+        <p:spPr>
+          <a:xfrm>
+            <a:off x="777240" y="3291840"/>
+            <a:ext cx="1950720" cy="548640"/>
+          </a:xfrm>
+          <a:prstGeom prst="rect">
+            <a:avLst/>
+          </a:prstGeom>
+          <a:noFill/>
+          <a:ln/>
+        </p:spPr>
+        <p:txBody>
+          <a:bodyPr wrap="square" lIns="0" tIns="0" rIns="0" bIns="0" rtlCol="0" anchor="t"/>
+          <a:lstStyle/>
+          <a:p>
+            <a:pPr indent="0" marL="0">
+              <a:buNone/>
+            </a:pPr>
+            <a:r>
+              <a:rPr lang="en-US" sz="1150" dirty="0">
+                <a:solidFill>
+                  <a:srgbClr val="ABA6C8"/>
+                </a:solidFill>
+                <a:latin typeface="Segoe UI" pitchFamily="34" charset="0"/>
+                <a:ea typeface="Segoe UI" pitchFamily="34" charset="-122"/>
+                <a:cs typeface="Segoe UI" pitchFamily="34" charset="-120"/>
+              </a:rPr>
+              <a:t xml:space="preserve">Physics, rival driving, crashes, laps and drawing, 60 times a second.</a:t>
+            </a:r>
+            <a:endParaRPr lang="en-US" sz="1150" dirty="0"/>
+          </a:p>
+        </p:txBody>
+      </p:sp>
+      <p:cxnSp>
+        <p:nvCxnSpPr>
+          <p:cNvPr id="12" name="Arrow 12"/>
+          <p:cNvCxnSpPr/>
+          <p:nvPr/>
+        </p:nvCxnSpPr>
+        <p:spPr>
+          <a:xfrm>
+            <a:off x="3020568" y="3086100"/>
+            <a:ext cx="283464" cy="0"/>
+          </a:xfrm>
+          <a:prstGeom prst="line">
+            <a:avLst/>
+          </a:prstGeom>
+          <a:ln w="22225" cap="rnd">
+            <a:solidFill>
+              <a:srgbClr val="ABA6C8"/>
+            </a:solidFill>
+            <a:headEnd type="triangle" w="med" len="med"/>
+            <a:tailEnd type="triangle" w="med" len="med"/>
+          </a:ln>
+        </p:spPr>
+      </p:cxnSp>
+      <p:sp>
+        <p:nvSpPr>
+          <p:cNvPr id="13" name="Card 13"/>
+          <p:cNvSpPr/>
+          <p:nvPr/>
+        </p:nvSpPr>
+        <p:spPr>
+          <a:xfrm>
+            <a:off x="3368040" y="2148840"/>
+            <a:ext cx="2407920" cy="1874520"/>
+          </a:xfrm>
+          <a:prstGeom prst="roundRect">
+            <a:avLst>
+              <a:gd name="adj" fmla="val 9143"/>
+            </a:avLst>
+          </a:prstGeom>
+          <a:solidFill>
+            <a:srgbClr val="110F2B"/>
+          </a:solidFill>
+          <a:ln/>
+        </p:spPr>
+      </p:sp>
+      <p:pic>
+        <p:nvPicPr>
+          <p:cNvPr id="14" name="Image 14" descr="Server icon"/>
+          <p:cNvPicPr>
+            <a:picLocks noChangeAspect="1"/>
+          </p:cNvPicPr>
+          <p:nvPr/>
+        </p:nvPicPr>
+        <p:blipFill>
+          <a:blip r:embed="rId3"/>
+          <a:stretch>
+            <a:fillRect/>
+          </a:stretch>
+        </p:blipFill>
+        <p:spPr>
+          <a:xfrm>
+            <a:off x="3596640" y="2377440"/>
+            <a:ext cx="384048" cy="384048"/>
+          </a:xfrm>
+          <a:prstGeom prst="rect">
+            <a:avLst/>
+          </a:prstGeom>
+        </p:spPr>
+      </p:pic>
+      <p:sp>
+        <p:nvSpPr>
+          <p:cNvPr id="15" name="Text 15"/>
+          <p:cNvSpPr txBox="1"/>
+          <p:nvPr/>
+        </p:nvSpPr>
+        <p:spPr>
+          <a:xfrm>
+            <a:off x="4117848" y="2377440"/>
+            <a:ext cx="1429512" cy="384048"/>
+          </a:xfrm>
+          <a:prstGeom prst="rect">
+            <a:avLst/>
+          </a:prstGeom>
+          <a:noFill/>
+          <a:ln/>
+        </p:spPr>
+        <p:txBody>
+          <a:bodyPr wrap="square" lIns="0" tIns="0" rIns="0" bIns="0" rtlCol="0" anchor="ctr"/>
+          <a:lstStyle/>
+          <a:p>
+            <a:pPr indent="0" marL="0">
+              <a:buNone/>
+            </a:pPr>
+            <a:r>
+              <a:rPr lang="en-US" sz="1050" spc="200" kern="0" dirty="0">
+                <a:solidFill>
+                  <a:srgbClr val="ABA6C8"/>
+                </a:solidFill>
+                <a:latin typeface="Segoe UI Semibold" pitchFamily="34" charset="0"/>
+                <a:ea typeface="Segoe UI Semibold" pitchFamily="34" charset="-122"/>
+                <a:cs typeface="Segoe UI Semibold" pitchFamily="34" charset="-120"/>
+              </a:rPr>
+              <a:t xml:space="preserve">APP SERVICE</a:t>
+            </a:r>
+            <a:endParaRPr lang="en-US" sz="1050" dirty="0"/>
+          </a:p>
+        </p:txBody>
+      </p:sp>
+      <p:sp>
+        <p:nvSpPr>
+          <p:cNvPr id="16" name="Text 16"/>
+          <p:cNvSpPr txBox="1"/>
+          <p:nvPr/>
+        </p:nvSpPr>
+        <p:spPr>
+          <a:xfrm>
+            <a:off x="3596640" y="2926080"/>
+            <a:ext cx="1950720" cy="292608"/>
+          </a:xfrm>
+          <a:prstGeom prst="rect">
+            <a:avLst/>
+          </a:prstGeom>
+          <a:noFill/>
+          <a:ln/>
+        </p:spPr>
+        <p:txBody>
+          <a:bodyPr wrap="square" lIns="0" tIns="0" rIns="0" bIns="0" rtlCol="0" anchor="ctr"/>
+          <a:lstStyle/>
+          <a:p>
+            <a:pPr indent="0" marL="0">
+              <a:buNone/>
+            </a:pPr>
+            <a:r>
+              <a:rPr lang="en-US" sz="1400" b="1" dirty="0">
+                <a:solidFill>
+                  <a:srgbClr val="ECE9F8"/>
+                </a:solidFill>
+                <a:latin typeface="Consolas" pitchFamily="34" charset="0"/>
+                <a:ea typeface="Consolas" pitchFamily="34" charset="-122"/>
+                <a:cs typeface="Consolas" pitchFamily="34" charset="-120"/>
+              </a:rPr>
+              <a:t xml:space="preserve">node server.js</a:t>
+            </a:r>
+            <a:endParaRPr lang="en-US" sz="1400" dirty="0"/>
+          </a:p>
+        </p:txBody>
+      </p:sp>
+      <p:sp>
+        <p:nvSpPr>
+          <p:cNvPr id="17" name="Text 17"/>
+          <p:cNvSpPr txBox="1"/>
+          <p:nvPr/>
+        </p:nvSpPr>
+        <p:spPr>
+          <a:xfrm>
+            <a:off x="3596640" y="3291840"/>
+            <a:ext cx="1950720" cy="548640"/>
+          </a:xfrm>
+          <a:prstGeom prst="rect">
+            <a:avLst/>
+          </a:prstGeom>
+          <a:noFill/>
+          <a:ln/>
+        </p:spPr>
+        <p:txBody>
+          <a:bodyPr wrap="square" lIns="0" tIns="0" rIns="0" bIns="0" rtlCol="0" anchor="t"/>
+          <a:lstStyle/>
+          <a:p>
+            <a:pPr indent="0" marL="0">
+              <a:buNone/>
+            </a:pPr>
+            <a:r>
+              <a:rPr lang="en-US" sz="1150" dirty="0">
+                <a:solidFill>
+                  <a:srgbClr val="ABA6C8"/>
+                </a:solidFill>
+                <a:latin typeface="Segoe UI" pitchFamily="34" charset="0"/>
+                <a:ea typeface="Segoe UI" pitchFamily="34" charset="-122"/>
+                <a:cs typeface="Segoe UI" pitchFamily="34" charset="-120"/>
+              </a:rPr>
+              <a:t xml:space="preserve">Serves the game files. Its /api endpoints build the questions and call the model.</a:t>
+            </a:r>
+            <a:endParaRPr lang="en-US" sz="1150" dirty="0"/>
+          </a:p>
+        </p:txBody>
+      </p:sp>
+      <p:cxnSp>
+        <p:nvCxnSpPr>
+          <p:cNvPr id="18" name="Arrow 18"/>
+          <p:cNvCxnSpPr/>
+          <p:nvPr/>
+        </p:nvCxnSpPr>
+        <p:spPr>
+          <a:xfrm>
+            <a:off x="5839968" y="3086100"/>
+            <a:ext cx="283464" cy="0"/>
+          </a:xfrm>
+          <a:prstGeom prst="line">
+            <a:avLst/>
+          </a:prstGeom>
+          <a:ln w="22225" cap="rnd">
+            <a:solidFill>
+              <a:srgbClr val="ABA6C8"/>
+            </a:solidFill>
+            <a:headEnd type="triangle" w="med" len="med"/>
+            <a:tailEnd type="triangle" w="med" len="med"/>
+          </a:ln>
+        </p:spPr>
+      </p:cxnSp>
+      <p:sp>
+        <p:nvSpPr>
+          <p:cNvPr id="19" name="Card 19"/>
+          <p:cNvSpPr/>
+          <p:nvPr/>
+        </p:nvSpPr>
+        <p:spPr>
+          <a:xfrm>
+            <a:off x="6187440" y="2148840"/>
+            <a:ext cx="2407920" cy="1874520"/>
+          </a:xfrm>
+          <a:prstGeom prst="roundRect">
+            <a:avLst>
+              <a:gd name="adj" fmla="val 9143"/>
+            </a:avLst>
+          </a:prstGeom>
+          <a:solidFill>
+            <a:srgbClr val="110F2B"/>
+          </a:solidFill>
+          <a:ln/>
+        </p:spPr>
+      </p:sp>
+      <p:pic>
+        <p:nvPicPr>
+          <p:cNvPr id="20" name="Image 20" descr="Brain circuit icon"/>
+          <p:cNvPicPr>
+            <a:picLocks noChangeAspect="1"/>
+          </p:cNvPicPr>
+          <p:nvPr/>
+        </p:nvPicPr>
+        <p:blipFill>
+          <a:blip r:embed="rId4"/>
+          <a:stretch>
+            <a:fillRect/>
+          </a:stretch>
+        </p:blipFill>
+        <p:spPr>
+          <a:xfrm>
+            <a:off x="6416040" y="2377440"/>
+            <a:ext cx="384048" cy="384048"/>
+          </a:xfrm>
+          <a:prstGeom prst="rect">
+            <a:avLst/>
+          </a:prstGeom>
+        </p:spPr>
+      </p:pic>
+      <p:sp>
+        <p:nvSpPr>
+          <p:cNvPr id="21" name="Text 21"/>
+          <p:cNvSpPr txBox="1"/>
+          <p:nvPr/>
+        </p:nvSpPr>
+        <p:spPr>
+          <a:xfrm>
+            <a:off x="6937248" y="2377440"/>
+            <a:ext cx="1429512" cy="384048"/>
+          </a:xfrm>
+          <a:prstGeom prst="rect">
+            <a:avLst/>
+          </a:prstGeom>
+          <a:noFill/>
+          <a:ln/>
+        </p:spPr>
+        <p:txBody>
+          <a:bodyPr wrap="square" lIns="0" tIns="0" rIns="0" bIns="0" rtlCol="0" anchor="ctr"/>
+          <a:lstStyle/>
+          <a:p>
+            <a:pPr indent="0" marL="0">
+              <a:buNone/>
+            </a:pPr>
+            <a:r>
+              <a:rPr lang="en-US" sz="1050" spc="200" kern="0" dirty="0">
+                <a:solidFill>
+                  <a:srgbClr val="ABA6C8"/>
+                </a:solidFill>
+                <a:latin typeface="Segoe UI Semibold" pitchFamily="34" charset="0"/>
+                <a:ea typeface="Segoe UI Semibold" pitchFamily="34" charset="-122"/>
+                <a:cs typeface="Segoe UI Semibold" pitchFamily="34" charset="-120"/>
+              </a:rPr>
+              <a:t xml:space="preserve">FOUNDRY</a:t>
+            </a:r>
+            <a:endParaRPr lang="en-US" sz="1050" dirty="0"/>
+          </a:p>
+        </p:txBody>
+      </p:sp>
+      <p:sp>
+        <p:nvSpPr>
+          <p:cNvPr id="22" name="Text 22"/>
+          <p:cNvSpPr txBox="1"/>
+          <p:nvPr/>
+        </p:nvSpPr>
+        <p:spPr>
+          <a:xfrm>
+            <a:off x="6416040" y="2926080"/>
+            <a:ext cx="1950720" cy="292608"/>
+          </a:xfrm>
+          <a:prstGeom prst="rect">
+            <a:avLst/>
+          </a:prstGeom>
+          <a:noFill/>
+          <a:ln/>
+        </p:spPr>
+        <p:txBody>
+          <a:bodyPr wrap="square" lIns="0" tIns="0" rIns="0" bIns="0" rtlCol="0" anchor="ctr"/>
+          <a:lstStyle/>
+          <a:p>
+            <a:pPr indent="0" marL="0">
+              <a:buNone/>
+            </a:pPr>
+            <a:r>
+              <a:rPr lang="en-US" sz="1400" b="1" dirty="0">
+                <a:solidFill>
+                  <a:srgbClr val="ECE9F8"/>
+                </a:solidFill>
+                <a:latin typeface="Segoe UI" pitchFamily="34" charset="0"/>
+                <a:ea typeface="Segoe UI" pitchFamily="34" charset="-122"/>
+                <a:cs typeface="Segoe UI" pitchFamily="34" charset="-120"/>
+              </a:rPr>
+              <a:t xml:space="preserve">Microsoft-Decision-1</a:t>
+            </a:r>
+            <a:endParaRPr lang="en-US" sz="1400" dirty="0"/>
+          </a:p>
+        </p:txBody>
+      </p:sp>
+      <p:sp>
+        <p:nvSpPr>
+          <p:cNvPr id="23" name="Text 23"/>
+          <p:cNvSpPr txBox="1"/>
+          <p:nvPr/>
+        </p:nvSpPr>
+        <p:spPr>
+          <a:xfrm>
+            <a:off x="6416040" y="3291840"/>
+            <a:ext cx="1950720" cy="548640"/>
+          </a:xfrm>
+          <a:prstGeom prst="rect">
+            <a:avLst/>
+          </a:prstGeom>
+          <a:noFill/>
+          <a:ln/>
+        </p:spPr>
+        <p:txBody>
+          <a:bodyPr wrap="square" lIns="0" tIns="0" rIns="0" bIns="0" rtlCol="0" anchor="t"/>
+          <a:lstStyle/>
+          <a:p>
+            <a:pPr indent="0" marL="0">
+              <a:buNone/>
+            </a:pPr>
+            <a:r>
+              <a:rPr lang="en-US" sz="1150" dirty="0">
+                <a:solidFill>
+                  <a:srgbClr val="ABA6C8"/>
+                </a:solidFill>
+                <a:latin typeface="Segoe UI" pitchFamily="34" charset="0"/>
+                <a:ea typeface="Segoe UI" pitchFamily="34" charset="-122"/>
+                <a:cs typeface="Segoe UI" pitchFamily="34" charset="-120"/>
+              </a:rPr>
+              <a:t xml:space="preserve">Answers rival, steward and debrief questions. Called with the app’s managed identity.</a:t>
+            </a:r>
+            <a:endParaRPr lang="en-US" sz="1150" dirty="0"/>
+          </a:p>
+        </p:txBody>
+      </p:sp>
+      <p:sp>
+        <p:nvSpPr>
+          <p:cNvPr id="24" name="Text 24"/>
+          <p:cNvSpPr txBox="1"/>
+          <p:nvPr/>
+        </p:nvSpPr>
+        <p:spPr>
+          <a:xfrm>
+            <a:off x="548640" y="4297680"/>
+            <a:ext cx="8046720" cy="274320"/>
+          </a:xfrm>
+          <a:prstGeom prst="rect">
+            <a:avLst/>
+          </a:prstGeom>
+          <a:noFill/>
+          <a:ln/>
+        </p:spPr>
+        <p:txBody>
+          <a:bodyPr wrap="square" lIns="0" tIns="0" rIns="0" bIns="0" rtlCol="0" anchor="ctr"/>
+          <a:lstStyle/>
+          <a:p>
+            <a:pPr indent="0" marL="0">
+              <a:buNone/>
+            </a:pPr>
+            <a:r>
+              <a:rPr lang="en-US" sz="1200" b="1" dirty="0">
+                <a:solidFill>
+                  <a:srgbClr val="FFD166"/>
+                </a:solidFill>
+                <a:latin typeface="Segoe UI" pitchFamily="34" charset="0"/>
+                <a:ea typeface="Segoe UI" pitchFamily="34" charset="-122"/>
+                <a:cs typeface="Segoe UI" pitchFamily="34" charset="-120"/>
+              </a:rPr>
+              <a:t xml:space="preserve">Not a container app: </a:t>
+            </a:r>
+            <a:r>
+              <a:rPr lang="en-US" sz="1200" dirty="0">
+                <a:solidFill>
+                  <a:srgbClr val="ABA6C8"/>
+                </a:solidFill>
+                <a:latin typeface="Segoe UI" pitchFamily="34" charset="0"/>
+                <a:ea typeface="Segoe UI" pitchFamily="34" charset="-122"/>
+                <a:cs typeface="Segoe UI" pitchFamily="34" charset="-120"/>
+              </a:rPr>
+              <a:t xml:space="preserve">no image, background workers, queues or database. Deploy is a zip pushed to the web app.</a:t>
             </a:r>
             <a:endParaRPr lang="en-US" sz="1200" dirty="0"/>
           </a:p>
@@ -4230,7 +5135,7 @@
                 <a:ea typeface="Segoe UI Semibold" pitchFamily="34" charset="-122"/>
                 <a:cs typeface="Segoe UI Semibold" pitchFamily="34" charset="-120"/>
               </a:rPr>
-              <a:t>02 / 11</a:t>
+              <a:t>02 / 12</a:t>
             </a:r>
             <a:endParaRPr lang="en-US" sz="1100" dirty="0"/>
           </a:p>
@@ -4316,7 +5221,7 @@
       </p:sp>
       <p:pic>
         <p:nvPicPr>
-          <p:cNvPr id="7" name="Image 0" descr="LUNA GP race start: rival cars with live decision tags (Vega overtake left, Orion defend, Lyra racing line, Nova overtake right), nitro firing, the player's car in front">    </p:cNvPr>
+          <p:cNvPr id="7" name="Image 0" descr="LUNA GP race start: rival cars with live decision tags (Vega overtake left, Orion defend, Lyra racing line, Nova overtake right), nitro firing, the player's car in front"/>
           <p:cNvPicPr>
             <a:picLocks noChangeAspect="1"/>
           </p:cNvPicPr>
@@ -4360,7 +5265,7 @@
       </p:sp>
       <p:pic>
         <p:nvPicPr>
-          <p:cNvPr id="9" name="Image 1" descr="Steering wheel icon">    </p:cNvPr>
+          <p:cNvPr id="9" name="Image 1" descr="Steering wheel icon"/>
           <p:cNvPicPr>
             <a:picLocks noChangeAspect="1"/>
           </p:cNvPicPr>
@@ -4499,7 +5404,7 @@
       </p:sp>
       <p:pic>
         <p:nvPicPr>
-          <p:cNvPr id="13" name="Image 2" descr="Gauge icon">    </p:cNvPr>
+          <p:cNvPr id="13" name="Image 2" descr="Gauge icon"/>
           <p:cNvPicPr>
             <a:picLocks noChangeAspect="1"/>
           </p:cNvPicPr>
@@ -4638,7 +5543,7 @@
       </p:sp>
       <p:pic>
         <p:nvPicPr>
-          <p:cNvPr id="17" name="Image 3" descr="Brain circuit icon">    </p:cNvPr>
+          <p:cNvPr id="17" name="Image 3" descr="Brain circuit icon"/>
           <p:cNvPicPr>
             <a:picLocks noChangeAspect="1"/>
           </p:cNvPicPr>
@@ -4879,7 +5784,7 @@
                 <a:ea typeface="Segoe UI Semibold" pitchFamily="34" charset="-122"/>
                 <a:cs typeface="Segoe UI Semibold" pitchFamily="34" charset="-120"/>
               </a:rPr>
-              <a:t>03 / 11</a:t>
+              <a:t>03 / 12</a:t>
             </a:r>
             <a:endParaRPr lang="en-US" sz="1100" dirty="0"/>
           </a:p>
@@ -4957,7 +5862,7 @@
                 <a:ea typeface="Segoe UI" pitchFamily="34" charset="-122"/>
                 <a:cs typeface="Segoe UI" pitchFamily="34" charset="-120"/>
               </a:rPr>
-              <a:t>Give it a situation and closed questions; it returns a </a:t>
+              <a:t xml:space="preserve">Give it a situation and closed questions; it returns a </a:t>
             </a:r>
             <a:pPr indent="0" marL="0">
               <a:buNone/>
@@ -4985,7 +5890,7 @@
                 <a:ea typeface="Segoe UI" pitchFamily="34" charset="-122"/>
                 <a:cs typeface="Segoe UI" pitchFamily="34" charset="-120"/>
               </a:rPr>
-              <a:t> for every answer option. No prose, no rationale.</a:t>
+              <a:t xml:space="preserve"> for every answer option. No prose, no rationale.</a:t>
             </a:r>
             <a:endParaRPr lang="en-US" sz="1800" dirty="0"/>
           </a:p>
@@ -5399,7 +6304,7 @@
                 <a:ea typeface="Consolas" pitchFamily="34" charset="-122"/>
                 <a:cs typeface="Consolas" pitchFamily="34" charset="-120"/>
               </a:rPr>
-              <a:t> · </a:t>
+              <a:t xml:space="preserve"> · </a:t>
             </a:r>
             <a:pPr indent="0" marL="0">
               <a:buNone/>
@@ -5427,7 +6332,7 @@
                 <a:ea typeface="Consolas" pitchFamily="34" charset="-122"/>
                 <a:cs typeface="Consolas" pitchFamily="34" charset="-120"/>
               </a:rPr>
-              <a:t> · </a:t>
+              <a:t xml:space="preserve"> · </a:t>
             </a:r>
             <a:pPr indent="0" marL="0">
               <a:buNone/>
@@ -5671,7 +6576,7 @@
                 <a:ea typeface="Segoe UI Semibold" pitchFamily="34" charset="-122"/>
                 <a:cs typeface="Segoe UI Semibold" pitchFamily="34" charset="-120"/>
               </a:rPr>
-              <a:t>04 / 11</a:t>
+              <a:t>04 / 12</a:t>
             </a:r>
             <a:endParaRPr lang="en-US" sz="1100" dirty="0"/>
           </a:p>
@@ -7337,7 +8242,7 @@
                 <a:ea typeface="Segoe UI Semibold" pitchFamily="34" charset="-122"/>
                 <a:cs typeface="Segoe UI Semibold" pitchFamily="34" charset="-120"/>
               </a:rPr>
-              <a:t>05 / 11</a:t>
+              <a:t>05 / 12</a:t>
             </a:r>
             <a:endParaRPr lang="en-US" sz="1100" dirty="0"/>
           </a:p>
@@ -7513,7 +8418,7 @@
                 <a:ea typeface="Consolas" pitchFamily="34" charset="-122"/>
                 <a:cs typeface="Consolas" pitchFamily="34" charset="-120"/>
               </a:rPr>
-              <a:t> </a:t>
+              <a:t xml:space="preserve"> </a:t>
             </a:r>
             <a:pPr indent="0" marL="0">
               <a:lnSpc>
@@ -7550,7 +8455,7 @@
                 <a:ea typeface="Consolas" pitchFamily="34" charset="-122"/>
                 <a:cs typeface="Consolas" pitchFamily="34" charset="-120"/>
               </a:rPr>
-              <a:t>  </a:t>
+              <a:t xml:space="preserve">  </a:t>
             </a:r>
             <a:pPr indent="0" marL="0">
               <a:lnSpc>
@@ -7601,7 +8506,7 @@
                 <a:ea typeface="Consolas" pitchFamily="34" charset="-122"/>
                 <a:cs typeface="Consolas" pitchFamily="34" charset="-120"/>
               </a:rPr>
-              <a:t> </a:t>
+              <a:t xml:space="preserve"> </a:t>
             </a:r>
             <a:pPr indent="0" marL="0">
               <a:lnSpc>
@@ -7655,7 +8560,7 @@
                 <a:ea typeface="Consolas" pitchFamily="34" charset="-122"/>
                 <a:cs typeface="Consolas" pitchFamily="34" charset="-120"/>
               </a:rPr>
-              <a:t>  </a:t>
+              <a:t xml:space="preserve">  </a:t>
             </a:r>
             <a:pPr indent="0" marL="0">
               <a:lnSpc>
@@ -7709,7 +8614,7 @@
                 <a:ea typeface="Consolas" pitchFamily="34" charset="-122"/>
                 <a:cs typeface="Consolas" pitchFamily="34" charset="-120"/>
               </a:rPr>
-              <a:t>    </a:t>
+              <a:t xml:space="preserve">    </a:t>
             </a:r>
             <a:pPr indent="0" marL="0">
               <a:lnSpc>
@@ -7861,7 +8766,7 @@
                 <a:ea typeface="Consolas" pitchFamily="34" charset="-122"/>
                 <a:cs typeface="Consolas" pitchFamily="34" charset="-120"/>
               </a:rPr>
-              <a:t> </a:t>
+              <a:t xml:space="preserve"> </a:t>
             </a:r>
             <a:pPr indent="0" marL="0">
               <a:lnSpc>
@@ -7895,7 +8800,7 @@
                 <a:ea typeface="Consolas" pitchFamily="34" charset="-122"/>
                 <a:cs typeface="Consolas" pitchFamily="34" charset="-120"/>
               </a:rPr>
-              <a:t> </a:t>
+              <a:t xml:space="preserve"> </a:t>
             </a:r>
             <a:pPr indent="0" marL="0">
               <a:lnSpc>
@@ -7946,7 +8851,7 @@
                 <a:ea typeface="Consolas" pitchFamily="34" charset="-122"/>
                 <a:cs typeface="Consolas" pitchFamily="34" charset="-120"/>
               </a:rPr>
-              <a:t> </a:t>
+              <a:t xml:space="preserve"> </a:t>
             </a:r>
             <a:pPr indent="0" marL="0">
               <a:lnSpc>
@@ -7997,7 +8902,7 @@
                 <a:ea typeface="Consolas" pitchFamily="34" charset="-122"/>
                 <a:cs typeface="Consolas" pitchFamily="34" charset="-120"/>
               </a:rPr>
-              <a:t> </a:t>
+              <a:t xml:space="preserve"> </a:t>
             </a:r>
             <a:pPr indent="0" marL="0">
               <a:lnSpc>
@@ -8048,7 +8953,7 @@
                 <a:ea typeface="Consolas" pitchFamily="34" charset="-122"/>
                 <a:cs typeface="Consolas" pitchFamily="34" charset="-120"/>
               </a:rPr>
-              <a:t> </a:t>
+              <a:t xml:space="preserve"> </a:t>
             </a:r>
             <a:pPr indent="0" marL="0">
               <a:lnSpc>
@@ -8082,7 +8987,7 @@
                 <a:ea typeface="Consolas" pitchFamily="34" charset="-122"/>
                 <a:cs typeface="Consolas" pitchFamily="34" charset="-120"/>
               </a:rPr>
-              <a:t> </a:t>
+              <a:t xml:space="preserve"> </a:t>
             </a:r>
             <a:pPr indent="0" marL="0">
               <a:lnSpc>
@@ -8138,7 +9043,7 @@
                 <a:ea typeface="Segoe UI" pitchFamily="34" charset="-122"/>
                 <a:cs typeface="Segoe UI" pitchFamily="34" charset="-120"/>
               </a:rPr>
-              <a:t>Game code calls it a </a:t>
+              <a:t xml:space="preserve">Game code calls it a </a:t>
             </a:r>
             <a:pPr indent="0" marL="0">
               <a:buNone/>
@@ -8166,7 +9071,7 @@
                 <a:ea typeface="Segoe UI" pitchFamily="34" charset="-122"/>
                 <a:cs typeface="Segoe UI" pitchFamily="34" charset="-120"/>
               </a:rPr>
-              <a:t>; </a:t>
+              <a:t xml:space="preserve">; </a:t>
             </a:r>
             <a:pPr indent="0" marL="0">
               <a:buNone/>
@@ -8194,7 +9099,7 @@
                 <a:ea typeface="Segoe UI" pitchFamily="34" charset="-122"/>
                 <a:cs typeface="Segoe UI" pitchFamily="34" charset="-120"/>
               </a:rPr>
-              <a:t> maps it to </a:t>
+              <a:t xml:space="preserve"> maps it to </a:t>
             </a:r>
             <a:pPr indent="0" marL="0">
               <a:buNone/>
@@ -8222,7 +9127,7 @@
                 <a:ea typeface="Segoe UI" pitchFamily="34" charset="-122"/>
                 <a:cs typeface="Segoe UI" pitchFamily="34" charset="-120"/>
               </a:rPr>
-              <a:t> on the wire.</a:t>
+              <a:t xml:space="preserve"> on the wire.</a:t>
             </a:r>
             <a:endParaRPr lang="en-US" sz="1050" dirty="0"/>
           </a:p>
@@ -8609,7 +9514,7 @@
                 <a:ea typeface="Segoe UI" pitchFamily="34" charset="-122"/>
                 <a:cs typeface="Segoe UI" pitchFamily="34" charset="-120"/>
               </a:rPr>
-              <a:t>  aggressive · wildcard</a:t>
+              <a:t xml:space="preserve">  aggressive · wildcard</a:t>
             </a:r>
             <a:endParaRPr lang="en-US" sz="1150" dirty="0"/>
           </a:p>
@@ -8740,7 +9645,7 @@
                 <a:ea typeface="Segoe UI" pitchFamily="34" charset="-122"/>
                 <a:cs typeface="Segoe UI" pitchFamily="34" charset="-120"/>
               </a:rPr>
-              <a:t>  defensive</a:t>
+              <a:t xml:space="preserve">  defensive</a:t>
             </a:r>
             <a:endParaRPr lang="en-US" sz="1150" dirty="0"/>
           </a:p>
@@ -8871,7 +9776,7 @@
                 <a:ea typeface="Segoe UI" pitchFamily="34" charset="-122"/>
                 <a:cs typeface="Segoe UI" pitchFamily="34" charset="-120"/>
               </a:rPr>
-              <a:t>  tactical · smooth</a:t>
+              <a:t xml:space="preserve">  tactical · smooth</a:t>
             </a:r>
             <a:endParaRPr lang="en-US" sz="1150" dirty="0"/>
           </a:p>
@@ -9040,7 +9945,7 @@
                 <a:ea typeface="Segoe UI Semibold" pitchFamily="34" charset="-122"/>
                 <a:cs typeface="Segoe UI Semibold" pitchFamily="34" charset="-120"/>
               </a:rPr>
-              <a:t>06 / 11</a:t>
+              <a:t>06 / 12</a:t>
             </a:r>
             <a:endParaRPr lang="en-US" sz="1100" dirty="0"/>
           </a:p>
@@ -11314,7 +12219,7 @@
                 <a:ea typeface="Segoe UI Semibold" pitchFamily="34" charset="-122"/>
                 <a:cs typeface="Segoe UI Semibold" pitchFamily="34" charset="-120"/>
               </a:rPr>
-              <a:t>07 / 11</a:t>
+              <a:t>07 / 12</a:t>
             </a:r>
             <a:endParaRPr lang="en-US" sz="1100" dirty="0"/>
           </a:p>
@@ -11596,7 +12501,7 @@
                 <a:ea typeface="Consolas" pitchFamily="34" charset="-122"/>
                 <a:cs typeface="Consolas" pitchFamily="34" charset="-120"/>
               </a:rPr>
-              <a:t>  </a:t>
+              <a:t xml:space="preserve">  </a:t>
             </a:r>
             <a:pPr indent="0" marL="0">
               <a:lnSpc>
@@ -11647,7 +12552,7 @@
                 <a:ea typeface="Consolas" pitchFamily="34" charset="-122"/>
                 <a:cs typeface="Consolas" pitchFamily="34" charset="-120"/>
               </a:rPr>
-              <a:t> </a:t>
+              <a:t xml:space="preserve"> </a:t>
             </a:r>
             <a:pPr indent="0" marL="0">
               <a:lnSpc>
@@ -11701,7 +12606,7 @@
                 <a:ea typeface="Consolas" pitchFamily="34" charset="-122"/>
                 <a:cs typeface="Consolas" pitchFamily="34" charset="-120"/>
               </a:rPr>
-              <a:t>  </a:t>
+              <a:t xml:space="preserve">  </a:t>
             </a:r>
             <a:pPr indent="0" marL="0">
               <a:lnSpc>
@@ -11752,7 +12657,7 @@
                 <a:ea typeface="Consolas" pitchFamily="34" charset="-122"/>
                 <a:cs typeface="Consolas" pitchFamily="34" charset="-120"/>
               </a:rPr>
-              <a:t> </a:t>
+              <a:t xml:space="preserve"> </a:t>
             </a:r>
             <a:pPr indent="0" marL="0">
               <a:lnSpc>
@@ -11806,7 +12711,7 @@
                 <a:ea typeface="Consolas" pitchFamily="34" charset="-122"/>
                 <a:cs typeface="Consolas" pitchFamily="34" charset="-120"/>
               </a:rPr>
-              <a:t>  </a:t>
+              <a:t xml:space="preserve">  </a:t>
             </a:r>
             <a:pPr indent="0" marL="0">
               <a:lnSpc>
@@ -11857,7 +12762,7 @@
                 <a:ea typeface="Consolas" pitchFamily="34" charset="-122"/>
                 <a:cs typeface="Consolas" pitchFamily="34" charset="-120"/>
               </a:rPr>
-              <a:t> </a:t>
+              <a:t xml:space="preserve"> </a:t>
             </a:r>
             <a:pPr indent="0" marL="0">
               <a:lnSpc>
@@ -11894,7 +12799,7 @@
                 <a:ea typeface="Consolas" pitchFamily="34" charset="-122"/>
                 <a:cs typeface="Consolas" pitchFamily="34" charset="-120"/>
               </a:rPr>
-              <a:t>    </a:t>
+              <a:t xml:space="preserve">    </a:t>
             </a:r>
             <a:pPr indent="0" marL="0">
               <a:lnSpc>
@@ -11945,7 +12850,7 @@
                 <a:ea typeface="Consolas" pitchFamily="34" charset="-122"/>
                 <a:cs typeface="Consolas" pitchFamily="34" charset="-120"/>
               </a:rPr>
-              <a:t> </a:t>
+              <a:t xml:space="preserve"> </a:t>
             </a:r>
             <a:pPr indent="0" marL="0">
               <a:lnSpc>
@@ -11979,7 +12884,7 @@
                 <a:ea typeface="Consolas" pitchFamily="34" charset="-122"/>
                 <a:cs typeface="Consolas" pitchFamily="34" charset="-120"/>
               </a:rPr>
-              <a:t> </a:t>
+              <a:t xml:space="preserve"> </a:t>
             </a:r>
             <a:pPr indent="0" marL="0">
               <a:lnSpc>
@@ -12030,7 +12935,7 @@
                 <a:ea typeface="Consolas" pitchFamily="34" charset="-122"/>
                 <a:cs typeface="Consolas" pitchFamily="34" charset="-120"/>
               </a:rPr>
-              <a:t> </a:t>
+              <a:t xml:space="preserve"> </a:t>
             </a:r>
             <a:pPr indent="0" marL="0">
               <a:lnSpc>
@@ -12081,7 +12986,7 @@
                 <a:ea typeface="Consolas" pitchFamily="34" charset="-122"/>
                 <a:cs typeface="Consolas" pitchFamily="34" charset="-120"/>
               </a:rPr>
-              <a:t> </a:t>
+              <a:t xml:space="preserve"> </a:t>
             </a:r>
             <a:pPr indent="0" marL="0">
               <a:lnSpc>
@@ -12115,7 +13020,7 @@
                 <a:ea typeface="Consolas" pitchFamily="34" charset="-122"/>
                 <a:cs typeface="Consolas" pitchFamily="34" charset="-120"/>
               </a:rPr>
-              <a:t> </a:t>
+              <a:t xml:space="preserve"> </a:t>
             </a:r>
             <a:pPr indent="0" marL="0">
               <a:lnSpc>
@@ -12169,7 +13074,7 @@
                 <a:ea typeface="Consolas" pitchFamily="34" charset="-122"/>
                 <a:cs typeface="Consolas" pitchFamily="34" charset="-120"/>
               </a:rPr>
-              <a:t>    </a:t>
+              <a:t xml:space="preserve">    </a:t>
             </a:r>
             <a:pPr indent="0" marL="0">
               <a:lnSpc>
@@ -12220,7 +13125,7 @@
                 <a:ea typeface="Consolas" pitchFamily="34" charset="-122"/>
                 <a:cs typeface="Consolas" pitchFamily="34" charset="-120"/>
               </a:rPr>
-              <a:t> </a:t>
+              <a:t xml:space="preserve"> </a:t>
             </a:r>
             <a:pPr indent="0" marL="0">
               <a:lnSpc>
@@ -12254,7 +13159,7 @@
                 <a:ea typeface="Consolas" pitchFamily="34" charset="-122"/>
                 <a:cs typeface="Consolas" pitchFamily="34" charset="-120"/>
               </a:rPr>
-              <a:t> </a:t>
+              <a:t xml:space="preserve"> </a:t>
             </a:r>
             <a:pPr indent="0" marL="0">
               <a:lnSpc>
@@ -12305,7 +13210,7 @@
                 <a:ea typeface="Consolas" pitchFamily="34" charset="-122"/>
                 <a:cs typeface="Consolas" pitchFamily="34" charset="-120"/>
               </a:rPr>
-              <a:t> </a:t>
+              <a:t xml:space="preserve"> </a:t>
             </a:r>
             <a:pPr indent="0" marL="0">
               <a:lnSpc>
@@ -12356,7 +13261,7 @@
                 <a:ea typeface="Consolas" pitchFamily="34" charset="-122"/>
                 <a:cs typeface="Consolas" pitchFamily="34" charset="-120"/>
               </a:rPr>
-              <a:t> </a:t>
+              <a:t xml:space="preserve"> </a:t>
             </a:r>
             <a:pPr indent="0" marL="0">
               <a:lnSpc>
@@ -12390,7 +13295,7 @@
                 <a:ea typeface="Consolas" pitchFamily="34" charset="-122"/>
                 <a:cs typeface="Consolas" pitchFamily="34" charset="-120"/>
               </a:rPr>
-              <a:t> </a:t>
+              <a:t xml:space="preserve"> </a:t>
             </a:r>
             <a:pPr indent="0" marL="0">
               <a:lnSpc>
@@ -12444,7 +13349,7 @@
                 <a:ea typeface="Consolas" pitchFamily="34" charset="-122"/>
                 <a:cs typeface="Consolas" pitchFamily="34" charset="-120"/>
               </a:rPr>
-              <a:t>    </a:t>
+              <a:t xml:space="preserve">    </a:t>
             </a:r>
             <a:pPr indent="0" marL="0">
               <a:lnSpc>
@@ -12495,7 +13400,7 @@
                 <a:ea typeface="Consolas" pitchFamily="34" charset="-122"/>
                 <a:cs typeface="Consolas" pitchFamily="34" charset="-120"/>
               </a:rPr>
-              <a:t> </a:t>
+              <a:t xml:space="preserve"> </a:t>
             </a:r>
             <a:pPr indent="0" marL="0">
               <a:lnSpc>
@@ -12529,7 +13434,7 @@
                 <a:ea typeface="Consolas" pitchFamily="34" charset="-122"/>
                 <a:cs typeface="Consolas" pitchFamily="34" charset="-120"/>
               </a:rPr>
-              <a:t> </a:t>
+              <a:t xml:space="preserve"> </a:t>
             </a:r>
             <a:pPr indent="0" marL="0">
               <a:lnSpc>
@@ -12580,7 +13485,7 @@
                 <a:ea typeface="Consolas" pitchFamily="34" charset="-122"/>
                 <a:cs typeface="Consolas" pitchFamily="34" charset="-120"/>
               </a:rPr>
-              <a:t> </a:t>
+              <a:t xml:space="preserve"> </a:t>
             </a:r>
             <a:pPr indent="0" marL="0">
               <a:lnSpc>
@@ -12631,7 +13536,7 @@
                 <a:ea typeface="Consolas" pitchFamily="34" charset="-122"/>
                 <a:cs typeface="Consolas" pitchFamily="34" charset="-120"/>
               </a:rPr>
-              <a:t> </a:t>
+              <a:t xml:space="preserve"> </a:t>
             </a:r>
             <a:pPr indent="0" marL="0">
               <a:lnSpc>
@@ -12665,7 +13570,7 @@
                 <a:ea typeface="Consolas" pitchFamily="34" charset="-122"/>
                 <a:cs typeface="Consolas" pitchFamily="34" charset="-120"/>
               </a:rPr>
-              <a:t> </a:t>
+              <a:t xml:space="preserve"> </a:t>
             </a:r>
             <a:pPr indent="0" marL="0">
               <a:lnSpc>
@@ -12702,7 +13607,7 @@
                 <a:ea typeface="Consolas" pitchFamily="34" charset="-122"/>
                 <a:cs typeface="Consolas" pitchFamily="34" charset="-120"/>
               </a:rPr>
-              <a:t>  </a:t>
+              <a:t xml:space="preserve">  </a:t>
             </a:r>
             <a:pPr indent="0" marL="0">
               <a:lnSpc>
@@ -12821,7 +13726,7 @@
                 <a:ea typeface="Consolas" pitchFamily="34" charset="-122"/>
                 <a:cs typeface="Consolas" pitchFamily="34" charset="-120"/>
               </a:rPr>
-              <a:t>  </a:t>
+              <a:t xml:space="preserve">  </a:t>
             </a:r>
             <a:pPr indent="0" marL="0">
               <a:lnSpc>
@@ -12872,7 +13777,7 @@
                 <a:ea typeface="Consolas" pitchFamily="34" charset="-122"/>
                 <a:cs typeface="Consolas" pitchFamily="34" charset="-120"/>
               </a:rPr>
-              <a:t> </a:t>
+              <a:t xml:space="preserve"> </a:t>
             </a:r>
             <a:pPr indent="0" marL="0">
               <a:lnSpc>
@@ -12926,7 +13831,7 @@
                 <a:ea typeface="Consolas" pitchFamily="34" charset="-122"/>
                 <a:cs typeface="Consolas" pitchFamily="34" charset="-120"/>
               </a:rPr>
-              <a:t>  </a:t>
+              <a:t xml:space="preserve">  </a:t>
             </a:r>
             <a:pPr indent="0" marL="0">
               <a:lnSpc>
@@ -12977,7 +13882,7 @@
                 <a:ea typeface="Consolas" pitchFamily="34" charset="-122"/>
                 <a:cs typeface="Consolas" pitchFamily="34" charset="-120"/>
               </a:rPr>
-              <a:t> </a:t>
+              <a:t xml:space="preserve"> </a:t>
             </a:r>
             <a:pPr indent="0" marL="0">
               <a:lnSpc>
@@ -13014,7 +13919,7 @@
                 <a:ea typeface="Consolas" pitchFamily="34" charset="-122"/>
                 <a:cs typeface="Consolas" pitchFamily="34" charset="-120"/>
               </a:rPr>
-              <a:t>    </a:t>
+              <a:t xml:space="preserve">    </a:t>
             </a:r>
             <a:pPr indent="0" marL="0">
               <a:lnSpc>
@@ -13065,7 +13970,7 @@
                 <a:ea typeface="Consolas" pitchFamily="34" charset="-122"/>
                 <a:cs typeface="Consolas" pitchFamily="34" charset="-120"/>
               </a:rPr>
-              <a:t> </a:t>
+              <a:t xml:space="preserve"> </a:t>
             </a:r>
             <a:pPr indent="0" marL="0">
               <a:lnSpc>
@@ -13099,7 +14004,7 @@
                 <a:ea typeface="Consolas" pitchFamily="34" charset="-122"/>
                 <a:cs typeface="Consolas" pitchFamily="34" charset="-120"/>
               </a:rPr>
-              <a:t> </a:t>
+              <a:t xml:space="preserve"> </a:t>
             </a:r>
             <a:pPr indent="0" marL="0">
               <a:lnSpc>
@@ -13150,7 +14055,7 @@
                 <a:ea typeface="Consolas" pitchFamily="34" charset="-122"/>
                 <a:cs typeface="Consolas" pitchFamily="34" charset="-120"/>
               </a:rPr>
-              <a:t> </a:t>
+              <a:t xml:space="preserve"> </a:t>
             </a:r>
             <a:pPr indent="0" marL="0">
               <a:lnSpc>
@@ -13201,7 +14106,7 @@
                 <a:ea typeface="Consolas" pitchFamily="34" charset="-122"/>
                 <a:cs typeface="Consolas" pitchFamily="34" charset="-120"/>
               </a:rPr>
-              <a:t> </a:t>
+              <a:t xml:space="preserve"> </a:t>
             </a:r>
             <a:pPr indent="0" marL="0">
               <a:lnSpc>
@@ -13235,7 +14140,7 @@
                 <a:ea typeface="Consolas" pitchFamily="34" charset="-122"/>
                 <a:cs typeface="Consolas" pitchFamily="34" charset="-120"/>
               </a:rPr>
-              <a:t> </a:t>
+              <a:t xml:space="preserve"> </a:t>
             </a:r>
             <a:pPr indent="0" marL="0">
               <a:lnSpc>
@@ -13289,7 +14194,7 @@
                 <a:ea typeface="Consolas" pitchFamily="34" charset="-122"/>
                 <a:cs typeface="Consolas" pitchFamily="34" charset="-120"/>
               </a:rPr>
-              <a:t>    </a:t>
+              <a:t xml:space="preserve">    </a:t>
             </a:r>
             <a:pPr indent="0" marL="0">
               <a:lnSpc>
@@ -13340,7 +14245,7 @@
                 <a:ea typeface="Consolas" pitchFamily="34" charset="-122"/>
                 <a:cs typeface="Consolas" pitchFamily="34" charset="-120"/>
               </a:rPr>
-              <a:t> </a:t>
+              <a:t xml:space="preserve"> </a:t>
             </a:r>
             <a:pPr indent="0" marL="0">
               <a:lnSpc>
@@ -13374,7 +14279,7 @@
                 <a:ea typeface="Consolas" pitchFamily="34" charset="-122"/>
                 <a:cs typeface="Consolas" pitchFamily="34" charset="-120"/>
               </a:rPr>
-              <a:t> </a:t>
+              <a:t xml:space="preserve"> </a:t>
             </a:r>
             <a:pPr indent="0" marL="0">
               <a:lnSpc>
@@ -13425,7 +14330,7 @@
                 <a:ea typeface="Consolas" pitchFamily="34" charset="-122"/>
                 <a:cs typeface="Consolas" pitchFamily="34" charset="-120"/>
               </a:rPr>
-              <a:t> </a:t>
+              <a:t xml:space="preserve"> </a:t>
             </a:r>
             <a:pPr indent="0" marL="0">
               <a:lnSpc>
@@ -13476,7 +14381,7 @@
                 <a:ea typeface="Consolas" pitchFamily="34" charset="-122"/>
                 <a:cs typeface="Consolas" pitchFamily="34" charset="-120"/>
               </a:rPr>
-              <a:t> </a:t>
+              <a:t xml:space="preserve"> </a:t>
             </a:r>
             <a:pPr indent="0" marL="0">
               <a:lnSpc>
@@ -13510,7 +14415,7 @@
                 <a:ea typeface="Consolas" pitchFamily="34" charset="-122"/>
                 <a:cs typeface="Consolas" pitchFamily="34" charset="-120"/>
               </a:rPr>
-              <a:t> </a:t>
+              <a:t xml:space="preserve"> </a:t>
             </a:r>
             <a:pPr indent="0" marL="0">
               <a:lnSpc>
@@ -13564,7 +14469,7 @@
                 <a:ea typeface="Consolas" pitchFamily="34" charset="-122"/>
                 <a:cs typeface="Consolas" pitchFamily="34" charset="-120"/>
               </a:rPr>
-              <a:t>    </a:t>
+              <a:t xml:space="preserve">    </a:t>
             </a:r>
             <a:pPr indent="0" marL="0">
               <a:lnSpc>
@@ -13615,7 +14520,7 @@
                 <a:ea typeface="Consolas" pitchFamily="34" charset="-122"/>
                 <a:cs typeface="Consolas" pitchFamily="34" charset="-120"/>
               </a:rPr>
-              <a:t> </a:t>
+              <a:t xml:space="preserve"> </a:t>
             </a:r>
             <a:pPr indent="0" marL="0">
               <a:lnSpc>
@@ -13649,7 +14554,7 @@
                 <a:ea typeface="Consolas" pitchFamily="34" charset="-122"/>
                 <a:cs typeface="Consolas" pitchFamily="34" charset="-120"/>
               </a:rPr>
-              <a:t> </a:t>
+              <a:t xml:space="preserve"> </a:t>
             </a:r>
             <a:pPr indent="0" marL="0">
               <a:lnSpc>
@@ -13700,7 +14605,7 @@
                 <a:ea typeface="Consolas" pitchFamily="34" charset="-122"/>
                 <a:cs typeface="Consolas" pitchFamily="34" charset="-120"/>
               </a:rPr>
-              <a:t> </a:t>
+              <a:t xml:space="preserve"> </a:t>
             </a:r>
             <a:pPr indent="0" marL="0">
               <a:lnSpc>
@@ -13751,7 +14656,7 @@
                 <a:ea typeface="Consolas" pitchFamily="34" charset="-122"/>
                 <a:cs typeface="Consolas" pitchFamily="34" charset="-120"/>
               </a:rPr>
-              <a:t> </a:t>
+              <a:t xml:space="preserve"> </a:t>
             </a:r>
             <a:pPr indent="0" marL="0">
               <a:lnSpc>
@@ -13785,7 +14690,7 @@
                 <a:ea typeface="Consolas" pitchFamily="34" charset="-122"/>
                 <a:cs typeface="Consolas" pitchFamily="34" charset="-120"/>
               </a:rPr>
-              <a:t> </a:t>
+              <a:t xml:space="preserve"> </a:t>
             </a:r>
             <a:pPr indent="0" marL="0">
               <a:lnSpc>
@@ -13822,7 +14727,7 @@
                 <a:ea typeface="Consolas" pitchFamily="34" charset="-122"/>
                 <a:cs typeface="Consolas" pitchFamily="34" charset="-120"/>
               </a:rPr>
-              <a:t>  </a:t>
+              <a:t xml:space="preserve">  </a:t>
             </a:r>
             <a:pPr indent="0" marL="0">
               <a:lnSpc>
@@ -13876,7 +14781,7 @@
                 <a:ea typeface="Consolas" pitchFamily="34" charset="-122"/>
                 <a:cs typeface="Consolas" pitchFamily="34" charset="-120"/>
               </a:rPr>
-              <a:t>  </a:t>
+              <a:t xml:space="preserve">  </a:t>
             </a:r>
             <a:pPr indent="0" marL="0">
               <a:lnSpc>
@@ -13927,7 +14832,7 @@
                 <a:ea typeface="Consolas" pitchFamily="34" charset="-122"/>
                 <a:cs typeface="Consolas" pitchFamily="34" charset="-120"/>
               </a:rPr>
-              <a:t> </a:t>
+              <a:t xml:space="preserve"> </a:t>
             </a:r>
             <a:pPr indent="0" marL="0">
               <a:lnSpc>
@@ -13961,7 +14866,7 @@
                 <a:ea typeface="Consolas" pitchFamily="34" charset="-122"/>
                 <a:cs typeface="Consolas" pitchFamily="34" charset="-120"/>
               </a:rPr>
-              <a:t> </a:t>
+              <a:t xml:space="preserve"> </a:t>
             </a:r>
             <a:pPr indent="0" marL="0">
               <a:lnSpc>
@@ -14012,7 +14917,7 @@
                 <a:ea typeface="Consolas" pitchFamily="34" charset="-122"/>
                 <a:cs typeface="Consolas" pitchFamily="34" charset="-120"/>
               </a:rPr>
-              <a:t> </a:t>
+              <a:t xml:space="preserve"> </a:t>
             </a:r>
             <a:pPr indent="0" marL="0">
               <a:lnSpc>
@@ -14063,7 +14968,7 @@
                 <a:ea typeface="Consolas" pitchFamily="34" charset="-122"/>
                 <a:cs typeface="Consolas" pitchFamily="34" charset="-120"/>
               </a:rPr>
-              <a:t> </a:t>
+              <a:t xml:space="preserve"> </a:t>
             </a:r>
             <a:pPr indent="0" marL="0">
               <a:lnSpc>
@@ -14114,7 +15019,7 @@
                 <a:ea typeface="Consolas" pitchFamily="34" charset="-122"/>
                 <a:cs typeface="Consolas" pitchFamily="34" charset="-120"/>
               </a:rPr>
-              <a:t> </a:t>
+              <a:t xml:space="preserve"> </a:t>
             </a:r>
             <a:pPr indent="0" marL="0">
               <a:lnSpc>
@@ -14148,7 +15053,7 @@
                 <a:ea typeface="Consolas" pitchFamily="34" charset="-122"/>
                 <a:cs typeface="Consolas" pitchFamily="34" charset="-120"/>
               </a:rPr>
-              <a:t> </a:t>
+              <a:t xml:space="preserve"> </a:t>
             </a:r>
             <a:pPr indent="0" marL="0">
               <a:lnSpc>
@@ -14238,7 +15143,7 @@
                 <a:ea typeface="Segoe UI" pitchFamily="34" charset="-122"/>
                 <a:cs typeface="Segoe UI" pitchFamily="34" charset="-120"/>
               </a:rPr>
-              <a:t> is the deployment name.</a:t>
+              <a:t xml:space="preserve"> is the deployment name.</a:t>
             </a:r>
             <a:endParaRPr lang="en-US" sz="1100" dirty="0"/>
           </a:p>
@@ -14291,7 +15196,7 @@
                 <a:ea typeface="Segoe UI" pitchFamily="34" charset="-122"/>
                 <a:cs typeface="Segoe UI" pitchFamily="34" charset="-120"/>
               </a:rPr>
-              <a:t> is the underlying model.</a:t>
+              <a:t xml:space="preserve"> is the underlying model.</a:t>
             </a:r>
             <a:endParaRPr lang="en-US" sz="1100" dirty="0"/>
           </a:p>
@@ -14421,7 +15326,7 @@
                 <a:ea typeface="Segoe UI Semibold" pitchFamily="34" charset="-122"/>
                 <a:cs typeface="Segoe UI Semibold" pitchFamily="34" charset="-120"/>
               </a:rPr>
-              <a:t>08 / 11</a:t>
+              <a:t>08 / 12</a:t>
             </a:r>
             <a:endParaRPr lang="en-US" sz="1100" dirty="0"/>
           </a:p>
@@ -14468,7 +15373,7 @@
       </p:sp>
       <p:pic>
         <p:nvPicPr>
-          <p:cNvPr id="6" name="Image 0" descr="Sequence diagram: the browser posts telemetry to the game server, which calls Microsoft-Decision-1 and returns maneuver, pace and nitro probability; on failure the browser uses a local heuristic. Model round trip median 0.26 to 0.42 s, p90 about 0.55 s; timeouts 4 s in the browser and 8 s to Foundry">    </p:cNvPr>
+          <p:cNvPr id="6" name="Image 0" descr="Sequence diagram: the browser posts telemetry to the game server, which calls Microsoft-Decision-1 and returns maneuver, pace and nitro probability; on failure the browser uses a local heuristic. Model round trip median 0.26 to 0.42 s, p90 about 0.55 s; timeouts 4 s in the browser and 8 s to Foundry"/>
           <p:cNvPicPr>
             <a:picLocks noChangeAspect="1"/>
           </p:cNvPicPr>
@@ -14614,7 +15519,7 @@
                 <a:ea typeface="Segoe UI Semibold" pitchFamily="34" charset="-122"/>
                 <a:cs typeface="Segoe UI Semibold" pitchFamily="34" charset="-120"/>
               </a:rPr>
-              <a:t>09 / 11</a:t>
+              <a:t>10 / 12</a:t>
             </a:r>
             <a:endParaRPr lang="en-US" sz="1100" dirty="0"/>
           </a:p>
@@ -14683,7 +15588,7 @@
       </p:sp>
       <p:pic>
         <p:nvPicPr>
-          <p:cNvPr id="7" name="Image 0" descr="Key icon">    </p:cNvPr>
+          <p:cNvPr id="7" name="Image 0" descr="Key icon"/>
           <p:cNvPicPr>
             <a:picLocks noChangeAspect="1"/>
           </p:cNvPicPr>
@@ -14841,7 +15746,7 @@
       </p:sp>
       <p:pic>
         <p:nvPicPr>
-          <p:cNvPr id="11" name="Image 1" descr="Shield icon">    </p:cNvPr>
+          <p:cNvPr id="11" name="Image 1" descr="Shield icon"/>
           <p:cNvPicPr>
             <a:picLocks noChangeAspect="1"/>
           </p:cNvPicPr>
@@ -14999,7 +15904,7 @@
       </p:sp>
       <p:pic>
         <p:nvPicPr>
-          <p:cNvPr id="15" name="Image 2" descr="Stopwatch icon">    </p:cNvPr>
+          <p:cNvPr id="15" name="Image 2" descr="Stopwatch icon"/>
           <p:cNvPicPr>
             <a:picLocks noChangeAspect="1"/>
           </p:cNvPicPr>
@@ -15157,7 +16062,7 @@
       </p:sp>
       <p:pic>
         <p:nvPicPr>
-          <p:cNvPr id="19" name="Image 3" descr="Unplugged cable icon">    </p:cNvPr>
+          <p:cNvPr id="19" name="Image 3" descr="Unplugged cable icon"/>
           <p:cNvPicPr>
             <a:picLocks noChangeAspect="1"/>
           </p:cNvPicPr>

</xml_diff>

<commit_message>
Remove implementation jargon from slide five
Co-authored-by: Copilot <223556219+Copilot@users.noreply.github.com>
</commit_message>
<xml_diff>
--- a/docs/luna-gp-deck.pptx
+++ b/docs/luna-gp-deck.pptx
@@ -1129,7 +1129,7 @@
           <a:p>
             <a:r>
               <a:rPr lang="en-US" dirty="0"/>
-              <a:t>noul is the yes/no type: the request has only instructions (criteria with true/false definitions are optional; LUNA GP doesn't send them) and the answer is one probability. The model never decides to fire: each rival compares p with its personality threshold (aggressive and wildcard 0.50, defensive 0.60, tactical and smooth 0.65), so the same answer of 0.62 fires three cars and holds two. A boost also needs at least 34% of the tank. The debrief's clean_racer question is a noul too. Internally the game builds OpenAI-style 'predicate' questions and lib/decisions.js maps them to noul.</a:t>
+              <a:t>noul is the yes/no type: the request has only instructions (criteria with true/false definitions are optional; LUNA GP doesn't send them) and the answer is one probability. The model never decides to fire: each rival compares p with its personality threshold (aggressive and wildcard 0.50, defensive 0.60, tactical and smooth 0.65), so the same answer of 0.62 fires three cars and holds two. A boost also needs at least 34% of the tank. The debrief's clean_racer question is a noul too.</a:t>
             </a:r>
             <a:endParaRPr lang="en-US" dirty="0"/>
           </a:p>
@@ -9007,129 +9007,6 @@
               <a:t>}</a:t>
             </a:r>
             <a:endParaRPr lang="en-US" sz="1100" dirty="0"/>
-          </a:p>
-        </p:txBody>
-      </p:sp>
-      <p:sp>
-        <p:nvSpPr>
-          <p:cNvPr id="11" name="Text 9"/>
-          <p:cNvSpPr/>
-          <p:nvPr/>
-        </p:nvSpPr>
-        <p:spPr>
-          <a:xfrm>
-            <a:off x="777240" y="3941064"/>
-            <a:ext cx="3566160" cy="411480"/>
-          </a:xfrm>
-          <a:prstGeom prst="rect">
-            <a:avLst/>
-          </a:prstGeom>
-          <a:noFill/>
-          <a:ln/>
-        </p:spPr>
-        <p:txBody>
-          <a:bodyPr wrap="square" lIns="0" tIns="0" rIns="0" bIns="0" rtlCol="0" anchor="t"/>
-          <a:lstStyle/>
-          <a:p>
-            <a:pPr indent="0" marL="0">
-              <a:buNone/>
-            </a:pPr>
-            <a:r>
-              <a:rPr lang="en-US" sz="1050" dirty="0">
-                <a:solidFill>
-                  <a:srgbClr val="ABA6C8"/>
-                </a:solidFill>
-                <a:latin typeface="Segoe UI" pitchFamily="34" charset="0"/>
-                <a:ea typeface="Segoe UI" pitchFamily="34" charset="-122"/>
-                <a:cs typeface="Segoe UI" pitchFamily="34" charset="-120"/>
-              </a:rPr>
-              <a:t xml:space="preserve">Game code calls it a </a:t>
-            </a:r>
-            <a:pPr indent="0" marL="0">
-              <a:buNone/>
-            </a:pPr>
-            <a:r>
-              <a:rPr lang="en-US" sz="1050" dirty="0">
-                <a:solidFill>
-                  <a:srgbClr val="ECE9F8"/>
-                </a:solidFill>
-                <a:latin typeface="Consolas" pitchFamily="34" charset="0"/>
-                <a:ea typeface="Consolas" pitchFamily="34" charset="-122"/>
-                <a:cs typeface="Consolas" pitchFamily="34" charset="-120"/>
-              </a:rPr>
-              <a:t>predicate</a:t>
-            </a:r>
-            <a:pPr indent="0" marL="0">
-              <a:buNone/>
-            </a:pPr>
-            <a:r>
-              <a:rPr lang="en-US" sz="1050" dirty="0">
-                <a:solidFill>
-                  <a:srgbClr val="ABA6C8"/>
-                </a:solidFill>
-                <a:latin typeface="Segoe UI" pitchFamily="34" charset="0"/>
-                <a:ea typeface="Segoe UI" pitchFamily="34" charset="-122"/>
-                <a:cs typeface="Segoe UI" pitchFamily="34" charset="-120"/>
-              </a:rPr>
-              <a:t xml:space="preserve">; </a:t>
-            </a:r>
-            <a:pPr indent="0" marL="0">
-              <a:buNone/>
-            </a:pPr>
-            <a:r>
-              <a:rPr lang="en-US" sz="1050" dirty="0">
-                <a:solidFill>
-                  <a:srgbClr val="ECE9F8"/>
-                </a:solidFill>
-                <a:latin typeface="Consolas" pitchFamily="34" charset="0"/>
-                <a:ea typeface="Consolas" pitchFamily="34" charset="-122"/>
-                <a:cs typeface="Consolas" pitchFamily="34" charset="-120"/>
-              </a:rPr>
-              <a:t>lib/decisions.js</a:t>
-            </a:r>
-            <a:pPr indent="0" marL="0">
-              <a:buNone/>
-            </a:pPr>
-            <a:r>
-              <a:rPr lang="en-US" sz="1050" dirty="0">
-                <a:solidFill>
-                  <a:srgbClr val="ABA6C8"/>
-                </a:solidFill>
-                <a:latin typeface="Segoe UI" pitchFamily="34" charset="0"/>
-                <a:ea typeface="Segoe UI" pitchFamily="34" charset="-122"/>
-                <a:cs typeface="Segoe UI" pitchFamily="34" charset="-120"/>
-              </a:rPr>
-              <a:t xml:space="preserve"> maps it to </a:t>
-            </a:r>
-            <a:pPr indent="0" marL="0">
-              <a:buNone/>
-            </a:pPr>
-            <a:r>
-              <a:rPr lang="en-US" sz="1050" dirty="0">
-                <a:solidFill>
-                  <a:srgbClr val="ECE9F8"/>
-                </a:solidFill>
-                <a:latin typeface="Consolas" pitchFamily="34" charset="0"/>
-                <a:ea typeface="Consolas" pitchFamily="34" charset="-122"/>
-                <a:cs typeface="Consolas" pitchFamily="34" charset="-120"/>
-              </a:rPr>
-              <a:t>noul</a:t>
-            </a:r>
-            <a:pPr indent="0" marL="0">
-              <a:buNone/>
-            </a:pPr>
-            <a:r>
-              <a:rPr lang="en-US" sz="1050" dirty="0">
-                <a:solidFill>
-                  <a:srgbClr val="ABA6C8"/>
-                </a:solidFill>
-                <a:latin typeface="Segoe UI" pitchFamily="34" charset="0"/>
-                <a:ea typeface="Segoe UI" pitchFamily="34" charset="-122"/>
-                <a:cs typeface="Segoe UI" pitchFamily="34" charset="-120"/>
-              </a:rPr>
-              <a:t xml:space="preserve"> on the wire.</a:t>
-            </a:r>
-            <a:endParaRPr lang="en-US" sz="1050" dirty="0"/>
           </a:p>
         </p:txBody>
       </p:sp>

</xml_diff>

<commit_message>
Replace the moon on the title slide with an in-game race start shot
Co-authored-by: Copilot <223556219+Copilot@users.noreply.github.com>
</commit_message>
<xml_diff>
--- a/docs/luna-gp-deck.pptx
+++ b/docs/luna-gp-deck.pptx
@@ -1854,273 +1854,9 @@
           <a:chExt cx="0" cy="0"/>
         </a:xfrm>
       </p:grpSpPr>
-      <p:sp>
-        <p:nvSpPr>
-          <p:cNvPr id="2" name="Shape 0"/>
-          <p:cNvSpPr/>
-          <p:nvPr/>
-        </p:nvSpPr>
-        <p:spPr>
-          <a:xfrm>
-            <a:off x="685800" y="548640"/>
-            <a:ext cx="36576" cy="36576"/>
-          </a:xfrm>
-          <a:prstGeom prst="ellipse">
-            <a:avLst/>
-          </a:prstGeom>
-          <a:solidFill>
-            <a:srgbClr val="FFFFFF">
-              <a:alpha val="60000"/>
-            </a:srgbClr>
-          </a:solidFill>
-          <a:ln/>
-        </p:spPr>
-      </p:sp>
-      <p:sp>
-        <p:nvSpPr>
-          <p:cNvPr id="3" name="Shape 1"/>
-          <p:cNvSpPr/>
-          <p:nvPr/>
-        </p:nvSpPr>
-        <p:spPr>
-          <a:xfrm>
-            <a:off x="1920240" y="868680"/>
-            <a:ext cx="27432" cy="27432"/>
-          </a:xfrm>
-          <a:prstGeom prst="ellipse">
-            <a:avLst/>
-          </a:prstGeom>
-          <a:solidFill>
-            <a:srgbClr val="FFFFFF">
-              <a:alpha val="45000"/>
-            </a:srgbClr>
-          </a:solidFill>
-          <a:ln/>
-        </p:spPr>
-      </p:sp>
-      <p:sp>
-        <p:nvSpPr>
-          <p:cNvPr id="4" name="Shape 2"/>
-          <p:cNvSpPr/>
-          <p:nvPr/>
-        </p:nvSpPr>
-        <p:spPr>
-          <a:xfrm>
-            <a:off x="3108960" y="566928"/>
-            <a:ext cx="32004" cy="32004"/>
-          </a:xfrm>
-          <a:prstGeom prst="ellipse">
-            <a:avLst/>
-          </a:prstGeom>
-          <a:solidFill>
-            <a:srgbClr val="FFFFFF">
-              <a:alpha val="50000"/>
-            </a:srgbClr>
-          </a:solidFill>
-          <a:ln/>
-        </p:spPr>
-      </p:sp>
-      <p:sp>
-        <p:nvSpPr>
-          <p:cNvPr id="5" name="Shape 3"/>
-          <p:cNvSpPr/>
-          <p:nvPr/>
-        </p:nvSpPr>
-        <p:spPr>
-          <a:xfrm>
-            <a:off x="4206240" y="777240"/>
-            <a:ext cx="27432" cy="27432"/>
-          </a:xfrm>
-          <a:prstGeom prst="ellipse">
-            <a:avLst/>
-          </a:prstGeom>
-          <a:solidFill>
-            <a:srgbClr val="FFFFFF">
-              <a:alpha val="40000"/>
-            </a:srgbClr>
-          </a:solidFill>
-          <a:ln/>
-        </p:spPr>
-      </p:sp>
-      <p:sp>
-        <p:nvSpPr>
-          <p:cNvPr id="6" name="Shape 4"/>
-          <p:cNvSpPr/>
-          <p:nvPr/>
-        </p:nvSpPr>
-        <p:spPr>
-          <a:xfrm>
-            <a:off x="5029200" y="548640"/>
-            <a:ext cx="36576" cy="36576"/>
-          </a:xfrm>
-          <a:prstGeom prst="ellipse">
-            <a:avLst/>
-          </a:prstGeom>
-          <a:solidFill>
-            <a:srgbClr val="FFFFFF">
-              <a:alpha val="55000"/>
-            </a:srgbClr>
-          </a:solidFill>
-          <a:ln/>
-        </p:spPr>
-      </p:sp>
-      <p:sp>
-        <p:nvSpPr>
-          <p:cNvPr id="7" name="Shape 5"/>
-          <p:cNvSpPr/>
-          <p:nvPr/>
-        </p:nvSpPr>
-        <p:spPr>
-          <a:xfrm>
-            <a:off x="8503920" y="594360"/>
-            <a:ext cx="27432" cy="27432"/>
-          </a:xfrm>
-          <a:prstGeom prst="ellipse">
-            <a:avLst/>
-          </a:prstGeom>
-          <a:solidFill>
-            <a:srgbClr val="FFFFFF">
-              <a:alpha val="50000"/>
-            </a:srgbClr>
-          </a:solidFill>
-          <a:ln/>
-        </p:spPr>
-      </p:sp>
-      <p:sp>
-        <p:nvSpPr>
-          <p:cNvPr id="8" name="Shape 6"/>
-          <p:cNvSpPr/>
-          <p:nvPr/>
-        </p:nvSpPr>
-        <p:spPr>
-          <a:xfrm>
-            <a:off x="8595360" y="3611880"/>
-            <a:ext cx="32004" cy="32004"/>
-          </a:xfrm>
-          <a:prstGeom prst="ellipse">
-            <a:avLst/>
-          </a:prstGeom>
-          <a:solidFill>
-            <a:srgbClr val="FFFFFF">
-              <a:alpha val="55000"/>
-            </a:srgbClr>
-          </a:solidFill>
-          <a:ln/>
-        </p:spPr>
-      </p:sp>
-      <p:sp>
-        <p:nvSpPr>
-          <p:cNvPr id="9" name="Shape 7"/>
-          <p:cNvSpPr/>
-          <p:nvPr/>
-        </p:nvSpPr>
-        <p:spPr>
-          <a:xfrm>
-            <a:off x="5577840" y="4160520"/>
-            <a:ext cx="27432" cy="27432"/>
-          </a:xfrm>
-          <a:prstGeom prst="ellipse">
-            <a:avLst/>
-          </a:prstGeom>
-          <a:solidFill>
-            <a:srgbClr val="FFFFFF">
-              <a:alpha val="40000"/>
-            </a:srgbClr>
-          </a:solidFill>
-          <a:ln/>
-        </p:spPr>
-      </p:sp>
-      <p:sp>
-        <p:nvSpPr>
-          <p:cNvPr id="10" name="Shape 8"/>
-          <p:cNvSpPr/>
-          <p:nvPr/>
-        </p:nvSpPr>
-        <p:spPr>
-          <a:xfrm>
-            <a:off x="7863840" y="4526280"/>
-            <a:ext cx="32004" cy="32004"/>
-          </a:xfrm>
-          <a:prstGeom prst="ellipse">
-            <a:avLst/>
-          </a:prstGeom>
-          <a:solidFill>
-            <a:srgbClr val="FFFFFF">
-              <a:alpha val="50000"/>
-            </a:srgbClr>
-          </a:solidFill>
-          <a:ln/>
-        </p:spPr>
-      </p:sp>
-      <p:sp>
-        <p:nvSpPr>
-          <p:cNvPr id="11" name="Shape 9"/>
-          <p:cNvSpPr/>
-          <p:nvPr/>
-        </p:nvSpPr>
-        <p:spPr>
-          <a:xfrm>
-            <a:off x="4480560" y="3977640"/>
-            <a:ext cx="27432" cy="27432"/>
-          </a:xfrm>
-          <a:prstGeom prst="ellipse">
-            <a:avLst/>
-          </a:prstGeom>
-          <a:solidFill>
-            <a:srgbClr val="FFFFFF">
-              <a:alpha val="45000"/>
-            </a:srgbClr>
-          </a:solidFill>
-          <a:ln/>
-        </p:spPr>
-      </p:sp>
-      <p:sp>
-        <p:nvSpPr>
-          <p:cNvPr id="12" name="Shape 10"/>
-          <p:cNvSpPr/>
-          <p:nvPr/>
-        </p:nvSpPr>
-        <p:spPr>
-          <a:xfrm>
-            <a:off x="2651760" y="3840480"/>
-            <a:ext cx="22860" cy="22860"/>
-          </a:xfrm>
-          <a:prstGeom prst="ellipse">
-            <a:avLst/>
-          </a:prstGeom>
-          <a:solidFill>
-            <a:srgbClr val="FFFFFF">
-              <a:alpha val="40000"/>
-            </a:srgbClr>
-          </a:solidFill>
-          <a:ln/>
-        </p:spPr>
-      </p:sp>
-      <p:sp>
-        <p:nvSpPr>
-          <p:cNvPr id="13" name="Shape 11"/>
-          <p:cNvSpPr/>
-          <p:nvPr/>
-        </p:nvSpPr>
-        <p:spPr>
-          <a:xfrm>
-            <a:off x="1097280" y="3794760"/>
-            <a:ext cx="27432" cy="27432"/>
-          </a:xfrm>
-          <a:prstGeom prst="ellipse">
-            <a:avLst/>
-          </a:prstGeom>
-          <a:solidFill>
-            <a:srgbClr val="FFFFFF">
-              <a:alpha val="50000"/>
-            </a:srgbClr>
-          </a:solidFill>
-          <a:ln/>
-        </p:spPr>
-      </p:sp>
       <p:pic>
         <p:nvPicPr>
-          <p:cNvPr id="14" name="Image 0" descr="Moon"/>
+          <p:cNvPr id="14" name="Image 0" descr="LUNA GP race start: the player car lines up under the start gantry with rival cars ahead"/>
           <p:cNvPicPr>
             <a:picLocks noChangeAspect="1"/>
           </p:cNvPicPr>
@@ -2134,12 +1870,19 @@
         </p:blipFill>
         <p:spPr>
           <a:xfrm>
-            <a:off x="4997196" y="379476"/>
-            <a:ext cx="3995928" cy="3995928"/>
-          </a:xfrm>
-          <a:prstGeom prst="rect">
-            <a:avLst/>
-          </a:prstGeom>
+            <a:off x="5394960" y="1183624"/>
+            <a:ext cx="3200400" cy="2776251"/>
+          </a:xfrm>
+          <a:prstGeom prst="roundRect">
+            <a:avLst>
+              <a:gd name="adj" fmla="val 6000"/>
+            </a:avLst>
+          </a:prstGeom>
+          <a:ln w="12700">
+            <a:solidFill>
+              <a:srgbClr val="2A2650"/>
+            </a:solidFill>
+          </a:ln>
         </p:spPr>
       </p:pic>
       <p:sp>
@@ -2151,7 +1894,7 @@
         <p:spPr>
           <a:xfrm>
             <a:off x="548640" y="1280160"/>
-            <a:ext cx="4937760" cy="1188720"/>
+            <a:ext cx="4572000" cy="1188720"/>
           </a:xfrm>
           <a:prstGeom prst="rect">
             <a:avLst/>
@@ -2271,7 +2014,7 @@
         <p:spPr>
           <a:xfrm>
             <a:off x="548640" y="4251960"/>
-            <a:ext cx="4937760" cy="274320"/>
+            <a:ext cx="4572000" cy="274320"/>
           </a:xfrm>
           <a:prstGeom prst="rect">
             <a:avLst/>

</xml_diff>

<commit_message>
Clarify the driver_of_the_day answer space on slide six
Co-authored-by: Copilot <223556219+Copilot@users.noreply.github.com>
</commit_message>
<xml_diff>
--- a/docs/luna-gp-deck.pptx
+++ b/docs/luna-gp-deck.pptx
@@ -1217,7 +1217,7 @@
           <a:p>
             <a:r>
               <a:rPr lang="en-US" dirty="0"/>
-              <a:t>Every model call the game makes. Five rivals ask maneuver/pace/nitro in one request, 0.65 to 1.05 s after their last answer in traffic and 1.4 to 1.8 s otherwise. The pace score sets the target speed: top speed × (0.92 + 0.03 × score), so Flat out (3) aims 1% past the car's nominal top speed; overtakes add 2%, nitro 22% and a slipstream 6%, and corners scale it down. Race Control asks two questions on each contact with the player (at most once every 4 s per rival) and penalizes the responsible driver when the model is at least 60% sure and severity is at least 0.8. The debrief's driver_of_the_day options are generated per race, one per driver. All policies (thresholds, penalties, the speed formula) live in game code, not in the prompt.</a:t>
+              <a:t>Every model call the game makes. Five rivals ask maneuver/pace/nitro in one request, 0.65 to 1.05 s after their last answer in traffic and 1.4 to 1.8 s otherwise. The pace score sets the target speed: top speed × (0.92 + 0.03 × score), so Flat out (3) aims 1% past the car's nominal top speed; overtakes add 2%, nitro 22% and a slipstream 6%, and corners scale it down. Race Control asks two questions on each contact with the player (at most once every 4 s per rival) and penalizes the responsible driver when the model is at least 60% sure and severity is at least 0.8. The debrief's driver_of_the_day picks from the six cars in the race: you and the five rivals. All policies (thresholds, penalties, the speed formula) live in game code, not in the prompt.</a:t>
             </a:r>
             <a:endParaRPr lang="en-US" dirty="0"/>
           </a:p>
@@ -11422,7 +11422,7 @@
                           <a:ea typeface="Segoe UI" pitchFamily="34" charset="-122"/>
                           <a:cs typeface="Segoe UI" pitchFamily="34" charset="-120"/>
                         </a:rPr>
-                        <a:t>one per driver, built at runtime</a:t>
+                        <a:t>you or one of the 5 rivals</a:t>
                       </a:r>
                       <a:endParaRPr lang="en-US" sz="1050" dirty="0">
                         <a:latin typeface="Segoe UI" charset="0"/>

</xml_diff>

<commit_message>
Add coordinated AI-driver swarm to future projects
Co-authored-by: Copilot <223556219+Copilot@users.noreply.github.com>
</commit_message>
<xml_diff>
--- a/docs/luna-gp-deck.pptx
+++ b/docs/luna-gp-deck.pptx
@@ -689,7 +689,7 @@
           <a:p>
             <a:r>
               <a:rPr lang="en-US" dirty="0"/>
-              <a:t>Play the hosted game at aka.ms/racing: it runs on Azure App Service and reaches the model with its managed identity, and the server caps model calls at 20,000 a day. To run your own: Node.js 20+ and, for AI rivals, FOUNDRY_ENDPOINT plus an Azure CLI login with access to the Foundry resource. Without it the game still runs with offline heuristics. P or Esc pauses, M mutes.</a:t>
+              <a:t>Play the hosted game at aka.ms/racing: it runs on Azure App Service and reaches the model with its managed identity, and the server caps model calls at 20,000 a day. To run your own: Node.js 20+ and, for AI rivals, FOUNDRY_ENDPOINT plus an Azure CLI login with access to the Foundry resource. Without it the game still runs with offline heuristics. P or Esc pauses, M mutes. Future project: turn the independent rivals into a coordinated swarm that shares tactics and adapts together.</a:t>
             </a:r>
             <a:endParaRPr lang="en-US" dirty="0"/>
           </a:p>
@@ -3935,6 +3935,67 @@
               <a:t>Phones and tablets get touch controls.</a:t>
             </a:r>
             <a:endParaRPr lang="en-US" sz="1200" dirty="0"/>
+          </a:p>
+        </p:txBody>
+      </p:sp>
+      <p:sp>
+        <p:nvSpPr>
+          <p:cNvPr id="40" name="Text 32"/>
+          <p:cNvSpPr txBox="1"/>
+          <p:nvPr/>
+        </p:nvSpPr>
+        <p:spPr>
+          <a:xfrm>
+            <a:off x="548640" y="1691640"/>
+            <a:ext cx="5900000" cy="292608"/>
+          </a:xfrm>
+          <a:prstGeom prst="rect">
+            <a:avLst/>
+          </a:prstGeom>
+          <a:noFill/>
+          <a:ln/>
+        </p:spPr>
+        <p:txBody>
+          <a:bodyPr wrap="none" lIns="0" tIns="0" rIns="0" bIns="0" rtlCol="0" anchor="ctr"/>
+          <a:lstStyle/>
+          <a:p>
+            <a:pPr indent="0" marL="0">
+              <a:buNone/>
+            </a:pPr>
+            <a:r>
+              <a:rPr lang="en-US" sz="1000" b="1" dirty="0">
+                <a:solidFill>
+                  <a:srgbClr val="FFD166"/>
+                </a:solidFill>
+                <a:latin typeface="Segoe UI Semibold" pitchFamily="34" charset="0"/>
+                <a:ea typeface="Segoe UI Semibold" pitchFamily="34" charset="-122"/>
+                <a:cs typeface="Segoe UI Semibold" pitchFamily="34" charset="-120"/>
+              </a:rPr>
+              <a:t>FUTURE PROJECT</a:t>
+            </a:r>
+            <a:r>
+              <a:rPr lang="en-US" sz="1200" dirty="0">
+                <a:solidFill>
+                  <a:srgbClr val="ABA6C8"/>
+                </a:solidFill>
+                <a:latin typeface="Segoe UI" pitchFamily="34" charset="0"/>
+                <a:ea typeface="Segoe UI" pitchFamily="34" charset="-122"/>
+                <a:cs typeface="Segoe UI" pitchFamily="34" charset="-120"/>
+              </a:rPr>
+              <a:t xml:space="preserve">  ·  </a:t>
+            </a:r>
+            <a:r>
+              <a:rPr lang="en-US" sz="1500" b="1" dirty="0">
+                <a:solidFill>
+                  <a:srgbClr val="ECE9F8"/>
+                </a:solidFill>
+                <a:latin typeface="Segoe UI Semibold" pitchFamily="34" charset="0"/>
+                <a:ea typeface="Segoe UI Semibold" pitchFamily="34" charset="-122"/>
+                <a:cs typeface="Segoe UI Semibold" pitchFamily="34" charset="-120"/>
+              </a:rPr>
+              <a:t>Build a coordinated AI-driver swarm</a:t>
+            </a:r>
+            <a:endParaRPr lang="en-US" sz="1500" dirty="0"/>
           </a:p>
         </p:txBody>
       </p:sp>

</xml_diff>

<commit_message>
Explain rival request snapshots and independent AI calls in deck
Co-authored-by: Copilot <223556219+Copilot@users.noreply.github.com>
</commit_message>
<xml_diff>
--- a/docs/luna-gp-deck.pptx
+++ b/docs/luna-gp-deck.pptx
@@ -11,6 +11,7 @@
     <p:sldId id="259" r:id="rId5"/>
     <p:sldId id="260" r:id="rId6"/>
     <p:sldId id="261" r:id="rId7"/>
+    <p:sldId id="268" r:id="rId19"/>
     <p:sldId id="262" r:id="rId8"/>
     <p:sldId id="263" r:id="rId9"/>
     <p:sldId id="267" r:id="rId18"/>
@@ -624,7 +625,7 @@
           <a:p>
             <a:fld id="{F7021451-1387-4CA6-816F-3879F97B5CBC}" type="slidenum">
               <a:rPr lang="en-US"/>
-              <a:t>11</a:t>
+              <a:t>12</a:t>
             </a:fld>
             <a:endParaRPr lang="en-US"/>
           </a:p>
@@ -712,7 +713,7 @@
           <a:p>
             <a:fld id="{F7021451-1387-4CA6-816F-3879F97B5CBC}" type="slidenum">
               <a:rPr lang="en-US"/>
-              <a:t>12</a:t>
+              <a:t>13</a:t>
             </a:fld>
             <a:endParaRPr lang="en-US"/>
           </a:p>
@@ -800,7 +801,7 @@
           <a:p>
             <a:fld id="{F7021451-1387-4CA6-816F-3879F97B5CBC}" type="slidenum">
               <a:rPr lang="en-US"/>
-              <a:t>9</a:t>
+              <a:t>10</a:t>
             </a:fld>
             <a:endParaRPr lang="en-US"/>
           </a:p>
@@ -812,6 +813,110 @@
         <p14:creationId xmlns:p14="http://schemas.microsoft.com/office/powerpoint/2010/main" val="1024086991"/>
       </p:ext>
     </p:extLst>
+  </p:cSld>
+  <p:clrMapOvr>
+    <a:masterClrMapping/>
+  </p:clrMapOvr>
+</p:notes>
+</file>
+
+<file path=ppt/notesSlides/notesSlide13.xml><?xml version="1.0" encoding="utf-8"?>
+<p:notes xmlns:a="http://schemas.openxmlformats.org/drawingml/2006/main" xmlns:r="http://schemas.openxmlformats.org/officeDocument/2006/relationships" xmlns:p="http://schemas.openxmlformats.org/presentationml/2006/main">
+  <p:cSld>
+    <p:spTree>
+      <p:nvGrpSpPr>
+        <p:cNvPr id="1" name=""/>
+        <p:cNvGrpSpPr/>
+        <p:nvPr/>
+      </p:nvGrpSpPr>
+      <p:grpSpPr>
+        <a:xfrm>
+          <a:off x="0" y="0"/>
+          <a:ext cx="0" cy="0"/>
+          <a:chOff x="0" y="0"/>
+          <a:chExt cx="0" cy="0"/>
+        </a:xfrm>
+      </p:grpSpPr>
+      <p:sp>
+        <p:nvSpPr>
+          <p:cNvPr id="2" name="Slide Image Placeholder 1"/>
+          <p:cNvSpPr>
+            <a:spLocks noGrp="1" noRot="1" noChangeAspect="1"/>
+          </p:cNvSpPr>
+          <p:nvPr>
+            <p:ph type="sldImg"/>
+          </p:nvPr>
+        </p:nvSpPr>
+        <p:spPr/>
+      </p:sp>
+      <p:sp>
+        <p:nvSpPr>
+          <p:cNvPr id="3" name="Notes Placeholder 2"/>
+          <p:cNvSpPr>
+            <a:spLocks noGrp="1"/>
+          </p:cNvSpPr>
+          <p:nvPr>
+            <p:ph type="body" idx="1"/>
+          </p:nvPr>
+        </p:nvSpPr>
+        <p:spPr/>
+        <p:txBody>
+          <a:bodyPr/>
+          <a:lstStyle/>
+          <a:p>
+            <a:r>
+              <a:rPr lang="en-US"/>
+              <a:t>Think of this as a repeated radio check, not a chat conversation. The snapshot and answers on this slide are illustrative, not a captured model reply. The actual exchange is JSON, shown on the next slide.</a:t>
+            </a:r>
+            <a:endParaRPr lang="en-US"/>
+          </a:p>
+          <a:p>
+            <a:r>
+              <a:rPr lang="en-US"/>
+              <a:t>The browser posts telemetry for one rival to /api/rival. It includes driver name, number and personality; lap, position and gaps; speed, top speed, road position, nitro tank and whether the boost is active; upcoming track features and elevation; nearby cars ahead, behind or alongside and their relative speeds. The previous maneuver and its age are included when available. The server validates the data, writes the state as plain text, and adds the same three fixed questions: maneuver, pace and nitro. Personality is part of the model input, not just a rule applied after the answer.</a:t>
+            </a:r>
+            <a:endParaRPr lang="en-US"/>
+          </a:p>
+          <a:p>
+            <a:r>
+              <a:rPr lang="en-US"/>
+              <a:t>The example reply selects overtake_left, scores pace at 2.4 on the 0-to-3 scale, and returns a nitro likelihood of 0.78. Game code steers and sets the speed target. It compares the nitro likelihood with the driver's personality threshold and checks the tank before boosting; aggressive Vega's threshold is 0.50 and a boost needs at least 34% of the tank. The model does not drive the physics directly.</a:t>
+            </a:r>
+            <a:endParaRPr lang="en-US"/>
+          </a:p>
+          <a:p>
+            <a:r>
+              <a:rPr lang="en-US"/>
+              <a:t>There is no messages array, growing chat transcript or persistent model conversation per car. Each call supplies a fresh snapshot, including the last move and its age. Each of the five rivals has its own asynchronous decision loop and at most one outstanding request; requests from different rivals can overlap. After a reply, that rival waits 0.65 to 1.05 seconds in traffic or 1.4 to 1.8 seconds otherwise before asking again. Rivals observe traffic but do not exchange plans or coordinate as a swarm. A coordinated swarm remains a future project on the closing slide.</a:t>
+            </a:r>
+            <a:endParaRPr lang="en-US"/>
+          </a:p>
+        </p:txBody>
+      </p:sp>
+      <p:sp>
+        <p:nvSpPr>
+          <p:cNvPr id="4" name="Slide Number Placeholder 3"/>
+          <p:cNvSpPr>
+            <a:spLocks noGrp="1"/>
+          </p:cNvSpPr>
+          <p:nvPr>
+            <p:ph type="sldNum" sz="quarter" idx="10"/>
+          </p:nvPr>
+        </p:nvSpPr>
+        <p:spPr/>
+        <p:txBody>
+          <a:bodyPr/>
+          <a:lstStyle/>
+          <a:p>
+            <a:fld id="{3FEF4712-8A2B-4CC3-AF43-90CF52B31007}" type="slidenum">
+              <a:rPr lang="en-US"/>
+              <a:t>7</a:t>
+            </a:fld>
+            <a:endParaRPr lang="en-US"/>
+          </a:p>
+        </p:txBody>
+      </p:sp>
+    </p:spTree>
   </p:cSld>
   <p:clrMapOvr>
     <a:masterClrMapping/>
@@ -1129,7 +1234,7 @@
           <a:p>
             <a:r>
               <a:rPr lang="en-US" dirty="0"/>
-              <a:t>noul is the yes/no type: the request has only instructions (criteria with true/false definitions are optional; LUNA GP doesn't send them) and the answer is one probability. The model never decides to fire: each rival compares p with its personality threshold (aggressive and wildcard 0.50, defensive 0.60, tactical and smooth 0.65), so the same answer of 0.62 fires three cars and holds two. A boost also needs at least 34% of the tank. The debrief's clean_racer question is a noul too.</a:t>
+              <a:t>noul is the yes/no type: the request has only instructions (criteria with true/false definitions are optional; LUNA GP doesn't send them) and the answer is one probability. The probability does not fire nitro by itself: each rival compares it with its personality threshold (aggressive and wildcard 0.50, defensive 0.60, tactical and smooth 0.65). This slide compares a hypothetical result of 0.62 against all five thresholds; it is not one answer broadcast to every car. Each rival has its own request and can receive a different probability. A boost also needs at least 34% of the tank. The debrief's clean_racer question is a noul too.</a:t>
             </a:r>
             <a:endParaRPr lang="en-US" dirty="0"/>
           </a:p>
@@ -1217,7 +1322,7 @@
           <a:p>
             <a:r>
               <a:rPr lang="en-US" dirty="0"/>
-              <a:t>Every model call the game makes. Five rivals ask maneuver/pace/nitro in one request, 0.65 to 1.05 s after their last answer in traffic and 1.4 to 1.8 s otherwise. The pace score sets the target speed: top speed × (0.92 + 0.03 × score), so Flat out (3) aims 1% past the car's nominal top speed; overtakes add 2%, nitro 22% and a slipstream 6%, and corners scale it down. Race Control asks two questions on each contact with the player (at most once every 4 s per rival) and penalizes the responsible driver when the model is at least 60% sure and severity is at least 0.8. The debrief's driver_of_the_day picks from the six cars in the race: you and the five rivals. All policies (thresholds, penalties, the speed formula) live in game code, not in the prompt.</a:t>
+              <a:t>Every model call the game makes. Each of the five rivals sends its own request containing maneuver, pace and nitro; these are not five drivers batched into one request. Requests from different rivals can overlap. Each rival asks again 0.65 to 1.05 s after its last answer in traffic and 1.4 to 1.8 s otherwise. Its personality is included in the model input and also selects the game's nitro threshold. The pace score sets the target speed: top speed × (0.92 + 0.03 × score), so Flat out (3) aims 1% past the car's nominal top speed; overtakes add 2%, nitro 22% and a slipstream 6%, and corners scale it down. Race Control asks two questions on each contact with the player (at most once every 4 s per rival) and penalizes the responsible driver when the model is at least 60% sure and severity is at least 0.8. The debrief's driver_of_the_day picks from the six cars in the race: you and the five rivals. All policies (thresholds, penalties, the speed formula) live in game code, not in the prompt.</a:t>
             </a:r>
             <a:endParaRPr lang="en-US" dirty="0"/>
           </a:p>
@@ -1305,7 +1410,7 @@
           <a:p>
             <a:r>
               <a:rPr lang="en-US" dirty="0"/>
-              <a:t>The rival request, as lib/decisions.js sends it, with instructions and criteria omitted. The request's model is the deployment name; the response's model names the underlying model. state is a few lines of plain text the server writes from validated telemetry (personality, lap, gaps, speed, nitro tank, track ahead, neighbours). Each answer also carries its type and a confidence and, for choice and score, a probability per option or level; a noul answer is just its type and the probability. A rival call measured about 630 input tokens and 3 output tokens.</a:t>
+              <a:t>This is an abbreviated JSON example, not a literal complete packet: the ellipses mark omitted fields. The request's model is the configured deployment name; the response's model names the underlying model. state is a few lines of plain text built from validated telemetry, including personality, race position, speed, nitro, road and nearby cars, and the previous maneuver and its age. There is no messages array or growing chat history. All three questions include instructions explaining what to decide. The maneuver question's criteria is an object mapping the six choices to descriptions: racing_line, overtake_left, overtake_right, slipstream, defend and back_off. The pace question's criteria is an ordered list of four descriptions: Conserve, Race, Push and Flat out, indexed 0 to 3. The nitro question uses type noul and instructions, without criteria. The sample answers match the previous slide and are illustrative, not a measured model response. Actual choice and score answers also contain type, confidence and probabilities; a noul answer contains its type and one probability. Usage also includes input tokens. The server compacts the answers and adds timing and token information before returning them to the browser, where game code applies them. A measured rival call used about 630 input tokens and 3 output tokens.</a:t>
             </a:r>
             <a:endParaRPr lang="en-US" dirty="0"/>
           </a:p>
@@ -1328,7 +1433,7 @@
           <a:p>
             <a:fld id="{F7021451-1387-4CA6-816F-3879F97B5CBC}" type="slidenum">
               <a:rPr lang="en-US"/>
-              <a:t>7</a:t>
+              <a:t>8</a:t>
             </a:fld>
             <a:endParaRPr lang="en-US"/>
           </a:p>
@@ -1416,7 +1521,7 @@
           <a:p>
             <a:fld id="{F7021451-1387-4CA6-816F-3879F97B5CBC}" type="slidenum">
               <a:rPr lang="en-US"/>
-              <a:t>8</a:t>
+              <a:t>9</a:t>
             </a:fld>
             <a:endParaRPr lang="en-US"/>
           </a:p>
@@ -1504,7 +1609,7 @@
           <a:p>
             <a:fld id="{F7021451-1387-4CA6-816F-3879F97B5CBC}" type="slidenum">
               <a:rPr lang="en-US"/>
-              <a:t>10</a:t>
+              <a:t>11</a:t>
             </a:fld>
             <a:endParaRPr lang="en-US"/>
           </a:p>
@@ -2168,7 +2273,7 @@
                 <a:ea typeface="Segoe UI Semibold" pitchFamily="34" charset="-122"/>
                 <a:cs typeface="Segoe UI Semibold" pitchFamily="34" charset="-120"/>
               </a:rPr>
-              <a:t>11 / 12</a:t>
+              <a:t>12 / 13</a:t>
             </a:r>
             <a:endParaRPr lang="en-US" sz="1100" dirty="0"/>
           </a:p>
@@ -3204,7 +3309,7 @@
                 <a:ea typeface="Consolas" pitchFamily="34" charset="-122"/>
                 <a:cs typeface="Consolas" pitchFamily="34" charset="-120"/>
               </a:rPr>
-              <a:t>  →  </a:t>
+              <a:t xml:space="preserve">  →  </a:t>
             </a:r>
             <a:pPr indent="0" marL="0">
               <a:buNone/>
@@ -3274,7 +3379,7 @@
                 <a:ea typeface="Segoe UI" pitchFamily="34" charset="-122"/>
                 <a:cs typeface="Segoe UI" pitchFamily="34" charset="-120"/>
               </a:rPr>
-              <a:t>No </a:t>
+              <a:t xml:space="preserve">No </a:t>
             </a:r>
             <a:pPr indent="0" marL="0">
               <a:buNone/>
@@ -4124,7 +4229,7 @@
                 <a:ea typeface="Segoe UI Semibold" pitchFamily="34" charset="-122"/>
                 <a:cs typeface="Segoe UI Semibold" pitchFamily="34" charset="-120"/>
               </a:rPr>
-              <a:t xml:space="preserve">09 / 12</a:t>
+              <a:t xml:space="preserve">10 / 13</a:t>
             </a:r>
             <a:endParaRPr lang="en-US" sz="1100" dirty="0"/>
           </a:p>
@@ -4812,6 +4917,915 @@
               <a:t xml:space="preserve">no image, background workers, queues or database. Deploy is a zip pushed to the web app.</a:t>
             </a:r>
             <a:endParaRPr lang="en-US" sz="1200" dirty="0"/>
+          </a:p>
+        </p:txBody>
+      </p:sp>
+    </p:spTree>
+  </p:cSld>
+  <p:clrMapOvr>
+    <a:masterClrMapping/>
+  </p:clrMapOvr>
+</p:sld>
+</file>
+
+<file path=ppt/slides/slide13.xml><?xml version="1.0" encoding="utf-8"?>
+<p:sld xmlns:a="http://schemas.openxmlformats.org/drawingml/2006/main" xmlns:r="http://schemas.openxmlformats.org/officeDocument/2006/relationships" xmlns:p="http://schemas.openxmlformats.org/presentationml/2006/main">
+  <p:cSld name="A radio check, not a chat">
+    <p:bg>
+      <p:bgPr>
+        <a:solidFill>
+          <a:srgbClr val="07071A"/>
+        </a:solidFill>
+        <a:effectLst/>
+      </p:bgPr>
+    </p:bg>
+    <p:spTree>
+      <p:nvGrpSpPr>
+        <p:cNvPr id="1" name=""/>
+        <p:cNvGrpSpPr/>
+        <p:nvPr/>
+      </p:nvGrpSpPr>
+      <p:grpSpPr>
+        <a:xfrm>
+          <a:off x="0" y="0"/>
+          <a:ext cx="0" cy="0"/>
+          <a:chOff x="0" y="0"/>
+          <a:chExt cx="0" cy="0"/>
+        </a:xfrm>
+      </p:grpSpPr>
+      <p:sp>
+        <p:nvSpPr>
+          <p:cNvPr id="2" name="Header dot"/>
+          <p:cNvSpPr/>
+          <p:nvPr/>
+        </p:nvSpPr>
+        <p:spPr>
+          <a:xfrm>
+            <a:off x="548640" y="484632"/>
+            <a:ext cx="109728" cy="109728"/>
+          </a:xfrm>
+          <a:prstGeom prst="ellipse">
+            <a:avLst/>
+          </a:prstGeom>
+          <a:solidFill>
+            <a:srgbClr val="FFD166"/>
+          </a:solidFill>
+          <a:ln/>
+        </p:spPr>
+      </p:sp>
+      <p:sp>
+        <p:nvSpPr>
+          <p:cNvPr id="3" name="Section label"/>
+          <p:cNvSpPr txBox="1"/>
+          <p:nvPr/>
+        </p:nvSpPr>
+        <p:spPr>
+          <a:xfrm>
+            <a:off x="749808" y="393192"/>
+            <a:ext cx="5943600" cy="292608"/>
+          </a:xfrm>
+          <a:prstGeom prst="rect">
+            <a:avLst/>
+          </a:prstGeom>
+          <a:noFill/>
+          <a:ln/>
+        </p:spPr>
+        <p:txBody>
+          <a:bodyPr wrap="square" lIns="0" tIns="0" rIns="0" bIns="0" anchor="ctr"/>
+          <a:lstStyle/>
+          <a:p>
+            <a:pPr>
+              <a:buNone/>
+            </a:pPr>
+            <a:r>
+              <a:rPr lang="en-US" sz="1100" b="1" spc="300" kern="0">
+                <a:solidFill>
+                  <a:srgbClr val="ABA6C8"/>
+                </a:solidFill>
+                <a:latin typeface="Segoe UI Semibold"/>
+              </a:rPr>
+              <a:t>RIVAL DECISIONS</a:t>
+            </a:r>
+            <a:endParaRPr lang="en-US" sz="1100"/>
+          </a:p>
+        </p:txBody>
+      </p:sp>
+      <p:sp>
+        <p:nvSpPr>
+          <p:cNvPr id="4" name="Slide counter"/>
+          <p:cNvSpPr txBox="1"/>
+          <p:nvPr/>
+        </p:nvSpPr>
+        <p:spPr>
+          <a:xfrm>
+            <a:off x="7223760" y="393192"/>
+            <a:ext cx="1371600" cy="292608"/>
+          </a:xfrm>
+          <a:prstGeom prst="rect">
+            <a:avLst/>
+          </a:prstGeom>
+          <a:noFill/>
+          <a:ln/>
+        </p:spPr>
+        <p:txBody>
+          <a:bodyPr wrap="square" lIns="0" tIns="0" rIns="0" bIns="0" anchor="ctr"/>
+          <a:lstStyle/>
+          <a:p>
+            <a:pPr algn="r">
+              <a:buNone/>
+            </a:pPr>
+            <a:r>
+              <a:rPr lang="en-US" sz="1100">
+                <a:solidFill>
+                  <a:srgbClr val="ABA6C8"/>
+                </a:solidFill>
+                <a:latin typeface="Segoe UI Semibold"/>
+              </a:rPr>
+              <a:t>07 / 13</a:t>
+            </a:r>
+            <a:endParaRPr lang="en-US" sz="1100"/>
+          </a:p>
+        </p:txBody>
+      </p:sp>
+      <p:sp>
+        <p:nvSpPr>
+          <p:cNvPr id="5" name="Slide title"/>
+          <p:cNvSpPr txBox="1"/>
+          <p:nvPr/>
+        </p:nvSpPr>
+        <p:spPr>
+          <a:xfrm>
+            <a:off x="548640" y="749808"/>
+            <a:ext cx="8046720" cy="658368"/>
+          </a:xfrm>
+          <a:prstGeom prst="rect">
+            <a:avLst/>
+          </a:prstGeom>
+          <a:noFill/>
+          <a:ln/>
+        </p:spPr>
+        <p:txBody>
+          <a:bodyPr wrap="square" lIns="0" tIns="0" rIns="0" bIns="0"/>
+          <a:lstStyle/>
+          <a:p>
+            <a:pPr>
+              <a:buNone/>
+            </a:pPr>
+            <a:r>
+              <a:rPr lang="en-US" sz="3400" b="1" i="1">
+                <a:solidFill>
+                  <a:srgbClr val="ECE9F8"/>
+                </a:solidFill>
+                <a:latin typeface="Segoe UI Black"/>
+              </a:rPr>
+              <a:t>A radio check, not a chat</a:t>
+            </a:r>
+            <a:endParaRPr lang="en-US" sz="3400"/>
+          </a:p>
+        </p:txBody>
+      </p:sp>
+      <p:sp>
+        <p:nvSpPr>
+          <p:cNvPr id="6" name="Slide subtitle"/>
+          <p:cNvSpPr txBox="1"/>
+          <p:nvPr/>
+        </p:nvSpPr>
+        <p:spPr>
+          <a:xfrm>
+            <a:off x="548640" y="1417320"/>
+            <a:ext cx="8046720" cy="292608"/>
+          </a:xfrm>
+          <a:prstGeom prst="rect">
+            <a:avLst/>
+          </a:prstGeom>
+          <a:noFill/>
+          <a:ln/>
+        </p:spPr>
+        <p:txBody>
+          <a:bodyPr wrap="square" lIns="0" tIns="0" rIns="0" bIns="0"/>
+          <a:lstStyle/>
+          <a:p>
+            <a:pPr>
+              <a:buNone/>
+            </a:pPr>
+            <a:r>
+              <a:rPr lang="en-US" sz="1450">
+                <a:solidFill>
+                  <a:srgbClr val="ABA6C8"/>
+                </a:solidFill>
+                <a:latin typeface="Segoe UI"/>
+              </a:rPr>
+              <a:t>Illustrative snapshot and reply; each request is about one driver.</a:t>
+            </a:r>
+            <a:endParaRPr lang="en-US" sz="1450"/>
+          </a:p>
+        </p:txBody>
+      </p:sp>
+      <p:sp>
+        <p:nvSpPr>
+          <p:cNvPr id="7" name="Input card"/>
+          <p:cNvSpPr/>
+          <p:nvPr/>
+        </p:nvSpPr>
+        <p:spPr>
+          <a:xfrm>
+            <a:off x="548640" y="1874520"/>
+            <a:ext cx="3886200" cy="2148840"/>
+          </a:xfrm>
+          <a:prstGeom prst="roundRect">
+            <a:avLst>
+              <a:gd name="adj" fmla="val 9143"/>
+            </a:avLst>
+          </a:prstGeom>
+          <a:solidFill>
+            <a:srgbClr val="110F2B"/>
+          </a:solidFill>
+          <a:ln/>
+        </p:spPr>
+      </p:sp>
+      <p:sp>
+        <p:nvSpPr>
+          <p:cNvPr id="8" name="Output card"/>
+          <p:cNvSpPr/>
+          <p:nvPr/>
+        </p:nvSpPr>
+        <p:spPr>
+          <a:xfrm>
+            <a:off x="4800600" y="1874520"/>
+            <a:ext cx="3794760" cy="2148840"/>
+          </a:xfrm>
+          <a:prstGeom prst="roundRect">
+            <a:avLst>
+              <a:gd name="adj" fmla="val 9143"/>
+            </a:avLst>
+          </a:prstGeom>
+          <a:solidFill>
+            <a:srgbClr val="110F2B"/>
+          </a:solidFill>
+          <a:ln/>
+        </p:spPr>
+      </p:sp>
+      <p:cxnSp>
+        <p:nvCxnSpPr>
+          <p:cNvPr id="9" name="Request to reply arrow"/>
+          <p:cNvCxnSpPr/>
+          <p:nvPr/>
+        </p:nvCxnSpPr>
+        <p:spPr>
+          <a:xfrm>
+            <a:off x="4480560" y="2971800"/>
+            <a:ext cx="265176" cy="0"/>
+          </a:xfrm>
+          <a:prstGeom prst="line">
+            <a:avLst/>
+          </a:prstGeom>
+          <a:ln w="22225">
+            <a:solidFill>
+              <a:srgbClr val="ABA6C8"/>
+            </a:solidFill>
+            <a:tailEnd type="triangle" w="med" len="med"/>
+          </a:ln>
+        </p:spPr>
+      </p:cxnSp>
+      <p:sp>
+        <p:nvSpPr>
+          <p:cNvPr id="10" name="Input label"/>
+          <p:cNvSpPr txBox="1"/>
+          <p:nvPr/>
+        </p:nvSpPr>
+        <p:spPr>
+          <a:xfrm>
+            <a:off x="777240" y="2048256"/>
+            <a:ext cx="3429000" cy="219456"/>
+          </a:xfrm>
+          <a:prstGeom prst="rect">
+            <a:avLst/>
+          </a:prstGeom>
+          <a:noFill/>
+          <a:ln/>
+        </p:spPr>
+        <p:txBody>
+          <a:bodyPr wrap="square" lIns="0" tIns="0" rIns="0" bIns="0"/>
+          <a:lstStyle/>
+          <a:p>
+            <a:pPr>
+              <a:buNone/>
+            </a:pPr>
+            <a:r>
+              <a:rPr lang="en-US" sz="1050" b="1" spc="150">
+                <a:solidFill>
+                  <a:srgbClr val="3DD6FF"/>
+                </a:solidFill>
+                <a:latin typeface="Segoe UI Semibold"/>
+              </a:rPr>
+              <a:t>GAME SENDS TO THE MODEL</a:t>
+            </a:r>
+            <a:endParaRPr lang="en-US" sz="1050"/>
+          </a:p>
+        </p:txBody>
+      </p:sp>
+      <p:sp>
+        <p:nvSpPr>
+          <p:cNvPr id="11" name="Output label"/>
+          <p:cNvSpPr txBox="1"/>
+          <p:nvPr/>
+        </p:nvSpPr>
+        <p:spPr>
+          <a:xfrm>
+            <a:off x="5029200" y="2048256"/>
+            <a:ext cx="3337560" cy="219456"/>
+          </a:xfrm>
+          <a:prstGeom prst="rect">
+            <a:avLst/>
+          </a:prstGeom>
+          <a:noFill/>
+          <a:ln/>
+        </p:spPr>
+        <p:txBody>
+          <a:bodyPr wrap="square" lIns="0" tIns="0" rIns="0" bIns="0"/>
+          <a:lstStyle/>
+          <a:p>
+            <a:pPr>
+              <a:buNone/>
+            </a:pPr>
+            <a:r>
+              <a:rPr lang="en-US" sz="1050" b="1" spc="150">
+                <a:solidFill>
+                  <a:srgbClr val="4ADE80"/>
+                </a:solidFill>
+                <a:latin typeface="Segoe UI Semibold"/>
+              </a:rPr>
+              <a:t>MODEL RETURNS TO THE GAME</a:t>
+            </a:r>
+            <a:endParaRPr lang="en-US" sz="1050"/>
+          </a:p>
+        </p:txBody>
+      </p:sp>
+      <p:sp>
+        <p:nvSpPr>
+          <p:cNvPr id="12" name="Driver heading"/>
+          <p:cNvSpPr txBox="1"/>
+          <p:nvPr/>
+        </p:nvSpPr>
+        <p:spPr>
+          <a:xfrm>
+            <a:off x="777240" y="2304288"/>
+            <a:ext cx="3429000" cy="320040"/>
+          </a:xfrm>
+          <a:prstGeom prst="rect">
+            <a:avLst/>
+          </a:prstGeom>
+          <a:noFill/>
+          <a:ln/>
+        </p:spPr>
+        <p:txBody>
+          <a:bodyPr wrap="square" lIns="0" tIns="0" rIns="0" bIns="0"/>
+          <a:lstStyle/>
+          <a:p>
+            <a:pPr>
+              <a:buNone/>
+            </a:pPr>
+            <a:r>
+              <a:rPr lang="en-US" sz="1600" b="1">
+                <a:solidFill>
+                  <a:srgbClr val="ECE9F8"/>
+                </a:solidFill>
+                <a:latin typeface="Segoe UI Semibold"/>
+              </a:rPr>
+              <a:t>Vega (#7), aggressive</a:t>
+            </a:r>
+            <a:endParaRPr lang="en-US" sz="1600"/>
+          </a:p>
+        </p:txBody>
+      </p:sp>
+      <p:sp>
+        <p:nvSpPr>
+          <p:cNvPr id="13" name="Answers heading"/>
+          <p:cNvSpPr txBox="1"/>
+          <p:nvPr/>
+        </p:nvSpPr>
+        <p:spPr>
+          <a:xfrm>
+            <a:off x="5029200" y="2304288"/>
+            <a:ext cx="3337560" cy="320040"/>
+          </a:xfrm>
+          <a:prstGeom prst="rect">
+            <a:avLst/>
+          </a:prstGeom>
+          <a:noFill/>
+          <a:ln/>
+        </p:spPr>
+        <p:txBody>
+          <a:bodyPr wrap="square" lIns="0" tIns="0" rIns="0" bIns="0"/>
+          <a:lstStyle/>
+          <a:p>
+            <a:pPr>
+              <a:buNone/>
+            </a:pPr>
+            <a:r>
+              <a:rPr lang="en-US" sz="1600" b="1">
+                <a:solidFill>
+                  <a:srgbClr val="ECE9F8"/>
+                </a:solidFill>
+                <a:latin typeface="Segoe UI Semibold"/>
+              </a:rPr>
+              <a:t>Three answers</a:t>
+            </a:r>
+            <a:endParaRPr lang="en-US" sz="1600"/>
+          </a:p>
+        </p:txBody>
+      </p:sp>
+      <p:sp>
+        <p:nvSpPr>
+          <p:cNvPr id="14" name="Driver snapshot"/>
+          <p:cNvSpPr txBox="1"/>
+          <p:nvPr/>
+        </p:nvSpPr>
+        <p:spPr>
+          <a:xfrm>
+            <a:off x="777240" y="2688336"/>
+            <a:ext cx="3429000" cy="914400"/>
+          </a:xfrm>
+          <a:prstGeom prst="rect">
+            <a:avLst/>
+          </a:prstGeom>
+          <a:noFill/>
+          <a:ln/>
+        </p:spPr>
+        <p:txBody>
+          <a:bodyPr wrap="square" lIns="0" tIns="0" rIns="0" bIns="0"/>
+          <a:lstStyle/>
+          <a:p>
+            <a:pPr>
+              <a:lnSpc>
+                <a:spcPts val="1700"/>
+              </a:lnSpc>
+              <a:spcAft>
+                <a:spcPts val="0"/>
+              </a:spcAft>
+              <a:buNone/>
+            </a:pPr>
+            <a:r>
+              <a:rPr lang="en-US" sz="1250">
+                <a:solidFill>
+                  <a:srgbClr val="ECE9F8"/>
+                </a:solidFill>
+                <a:latin typeface="Segoe UI"/>
+              </a:rPr>
+              <a:t>Lap 2/3 · P2/6 · 260 km/h</a:t>
+            </a:r>
+            <a:endParaRPr lang="en-US" sz="1250"/>
+          </a:p>
+          <a:p>
+            <a:pPr>
+              <a:lnSpc>
+                <a:spcPts val="1700"/>
+              </a:lnSpc>
+              <a:spcAft>
+                <a:spcPts val="0"/>
+              </a:spcAft>
+              <a:buNone/>
+            </a:pPr>
+            <a:r>
+              <a:rPr lang="en-US" sz="1250">
+                <a:solidFill>
+                  <a:srgbClr val="ECE9F8"/>
+                </a:solidFill>
+                <a:latin typeface="Segoe UI"/>
+              </a:rPr>
+              <a:t>Nitro tank 70% · 300 m of straight road</a:t>
+            </a:r>
+            <a:endParaRPr lang="en-US" sz="1250"/>
+          </a:p>
+          <a:p>
+            <a:pPr>
+              <a:lnSpc>
+                <a:spcPts val="1700"/>
+              </a:lnSpc>
+              <a:spcAft>
+                <a:spcPts val="0"/>
+              </a:spcAft>
+              <a:buNone/>
+            </a:pPr>
+            <a:r>
+              <a:rPr lang="en-US" sz="1250">
+                <a:solidFill>
+                  <a:srgbClr val="ECE9F8"/>
+                </a:solidFill>
+                <a:latin typeface="Segoe UI"/>
+              </a:rPr>
+              <a:t>Player 18 m ahead, 12 km/h slower</a:t>
+            </a:r>
+            <a:endParaRPr lang="en-US" sz="1250"/>
+          </a:p>
+          <a:p>
+            <a:pPr>
+              <a:lnSpc>
+                <a:spcPts val="1700"/>
+              </a:lnSpc>
+              <a:spcAft>
+                <a:spcPts val="0"/>
+              </a:spcAft>
+              <a:buNone/>
+            </a:pPr>
+            <a:r>
+              <a:rPr lang="en-US" sz="1250">
+                <a:solidFill>
+                  <a:srgbClr val="ECE9F8"/>
+                </a:solidFill>
+                <a:latin typeface="Segoe UI"/>
+              </a:rPr>
+              <a:t>Last move: slipstream, 1.2 s ago</a:t>
+            </a:r>
+            <a:endParaRPr lang="en-US" sz="1250"/>
+          </a:p>
+        </p:txBody>
+      </p:sp>
+      <p:sp>
+        <p:nvSpPr>
+          <p:cNvPr id="15" name="Three questions"/>
+          <p:cNvSpPr txBox="1"/>
+          <p:nvPr/>
+        </p:nvSpPr>
+        <p:spPr>
+          <a:xfrm>
+            <a:off x="777240" y="3694176"/>
+            <a:ext cx="3429000" cy="256032"/>
+          </a:xfrm>
+          <a:prstGeom prst="rect">
+            <a:avLst/>
+          </a:prstGeom>
+          <a:noFill/>
+          <a:ln/>
+        </p:spPr>
+        <p:txBody>
+          <a:bodyPr wrap="square" lIns="0" tIns="0" rIns="0" bIns="0"/>
+          <a:lstStyle/>
+          <a:p>
+            <a:pPr>
+              <a:buNone/>
+            </a:pPr>
+            <a:r>
+              <a:rPr lang="en-US" sz="1250" b="1">
+                <a:solidFill>
+                  <a:srgbClr val="FFD166"/>
+                </a:solidFill>
+                <a:latin typeface="Segoe UI Semibold"/>
+              </a:rPr>
+              <a:t>Ask: Which move? How hard? Nitro?</a:t>
+            </a:r>
+            <a:endParaRPr lang="en-US" sz="1250"/>
+          </a:p>
+        </p:txBody>
+      </p:sp>
+      <p:sp>
+        <p:nvSpPr>
+          <p:cNvPr id="16" name="Maneuver key"/>
+          <p:cNvSpPr txBox="1"/>
+          <p:nvPr/>
+        </p:nvSpPr>
+        <p:spPr>
+          <a:xfrm>
+            <a:off x="5029200" y="2706624"/>
+            <a:ext cx="1097280" cy="274320"/>
+          </a:xfrm>
+          <a:prstGeom prst="rect">
+            <a:avLst/>
+          </a:prstGeom>
+          <a:noFill/>
+          <a:ln/>
+        </p:spPr>
+        <p:txBody>
+          <a:bodyPr wrap="square" lIns="0" tIns="0" rIns="0" bIns="0"/>
+          <a:lstStyle/>
+          <a:p>
+            <a:pPr>
+              <a:buNone/>
+            </a:pPr>
+            <a:r>
+              <a:rPr lang="en-US" sz="1200">
+                <a:solidFill>
+                  <a:srgbClr val="ABA6C8"/>
+                </a:solidFill>
+                <a:latin typeface="Consolas"/>
+              </a:rPr>
+              <a:t>maneuver</a:t>
+            </a:r>
+            <a:endParaRPr lang="en-US" sz="1200"/>
+          </a:p>
+        </p:txBody>
+      </p:sp>
+      <p:sp>
+        <p:nvSpPr>
+          <p:cNvPr id="17" name="Maneuver value"/>
+          <p:cNvSpPr txBox="1"/>
+          <p:nvPr/>
+        </p:nvSpPr>
+        <p:spPr>
+          <a:xfrm>
+            <a:off x="6217920" y="2679192"/>
+            <a:ext cx="2148840" cy="320040"/>
+          </a:xfrm>
+          <a:prstGeom prst="rect">
+            <a:avLst/>
+          </a:prstGeom>
+          <a:noFill/>
+          <a:ln/>
+        </p:spPr>
+        <p:txBody>
+          <a:bodyPr wrap="square" lIns="0" tIns="0" rIns="0" bIns="0"/>
+          <a:lstStyle/>
+          <a:p>
+            <a:pPr>
+              <a:buNone/>
+            </a:pPr>
+            <a:r>
+              <a:rPr lang="en-US" sz="1500" b="1">
+                <a:solidFill>
+                  <a:srgbClr val="3DD6FF"/>
+                </a:solidFill>
+                <a:latin typeface="Segoe UI Semibold"/>
+              </a:rPr>
+              <a:t>Overtake left</a:t>
+            </a:r>
+            <a:endParaRPr lang="en-US" sz="1500"/>
+          </a:p>
+        </p:txBody>
+      </p:sp>
+      <p:sp>
+        <p:nvSpPr>
+          <p:cNvPr id="18" name="Pace key"/>
+          <p:cNvSpPr txBox="1"/>
+          <p:nvPr/>
+        </p:nvSpPr>
+        <p:spPr>
+          <a:xfrm>
+            <a:off x="5029200" y="3035808"/>
+            <a:ext cx="1097280" cy="274320"/>
+          </a:xfrm>
+          <a:prstGeom prst="rect">
+            <a:avLst/>
+          </a:prstGeom>
+          <a:noFill/>
+          <a:ln/>
+        </p:spPr>
+        <p:txBody>
+          <a:bodyPr wrap="square" lIns="0" tIns="0" rIns="0" bIns="0"/>
+          <a:lstStyle/>
+          <a:p>
+            <a:pPr>
+              <a:buNone/>
+            </a:pPr>
+            <a:r>
+              <a:rPr lang="en-US" sz="1200">
+                <a:solidFill>
+                  <a:srgbClr val="ABA6C8"/>
+                </a:solidFill>
+                <a:latin typeface="Consolas"/>
+              </a:rPr>
+              <a:t>pace</a:t>
+            </a:r>
+            <a:endParaRPr lang="en-US" sz="1200"/>
+          </a:p>
+        </p:txBody>
+      </p:sp>
+      <p:sp>
+        <p:nvSpPr>
+          <p:cNvPr id="19" name="Pace value"/>
+          <p:cNvSpPr txBox="1"/>
+          <p:nvPr/>
+        </p:nvSpPr>
+        <p:spPr>
+          <a:xfrm>
+            <a:off x="6217920" y="3008376"/>
+            <a:ext cx="2148840" cy="320040"/>
+          </a:xfrm>
+          <a:prstGeom prst="rect">
+            <a:avLst/>
+          </a:prstGeom>
+          <a:noFill/>
+          <a:ln/>
+        </p:spPr>
+        <p:txBody>
+          <a:bodyPr wrap="square" lIns="0" tIns="0" rIns="0" bIns="0"/>
+          <a:lstStyle/>
+          <a:p>
+            <a:pPr>
+              <a:buNone/>
+            </a:pPr>
+            <a:r>
+              <a:rPr lang="en-US" sz="1500" b="1">
+                <a:solidFill>
+                  <a:srgbClr val="3DD6FF"/>
+                </a:solidFill>
+                <a:latin typeface="Segoe UI Semibold"/>
+              </a:rPr>
+              <a:t>2.4 / 3</a:t>
+            </a:r>
+            <a:endParaRPr lang="en-US" sz="1500"/>
+          </a:p>
+        </p:txBody>
+      </p:sp>
+      <p:sp>
+        <p:nvSpPr>
+          <p:cNvPr id="20" name="Nitro key"/>
+          <p:cNvSpPr txBox="1"/>
+          <p:nvPr/>
+        </p:nvSpPr>
+        <p:spPr>
+          <a:xfrm>
+            <a:off x="5029200" y="3364992"/>
+            <a:ext cx="1097280" cy="274320"/>
+          </a:xfrm>
+          <a:prstGeom prst="rect">
+            <a:avLst/>
+          </a:prstGeom>
+          <a:noFill/>
+          <a:ln/>
+        </p:spPr>
+        <p:txBody>
+          <a:bodyPr wrap="square" lIns="0" tIns="0" rIns="0" bIns="0"/>
+          <a:lstStyle/>
+          <a:p>
+            <a:pPr>
+              <a:buNone/>
+            </a:pPr>
+            <a:r>
+              <a:rPr lang="en-US" sz="1200">
+                <a:solidFill>
+                  <a:srgbClr val="ABA6C8"/>
+                </a:solidFill>
+                <a:latin typeface="Consolas"/>
+              </a:rPr>
+              <a:t>nitro</a:t>
+            </a:r>
+            <a:endParaRPr lang="en-US" sz="1200"/>
+          </a:p>
+        </p:txBody>
+      </p:sp>
+      <p:sp>
+        <p:nvSpPr>
+          <p:cNvPr id="21" name="Nitro value"/>
+          <p:cNvSpPr txBox="1"/>
+          <p:nvPr/>
+        </p:nvSpPr>
+        <p:spPr>
+          <a:xfrm>
+            <a:off x="6217920" y="3337560"/>
+            <a:ext cx="2148840" cy="320040"/>
+          </a:xfrm>
+          <a:prstGeom prst="rect">
+            <a:avLst/>
+          </a:prstGeom>
+          <a:noFill/>
+          <a:ln/>
+        </p:spPr>
+        <p:txBody>
+          <a:bodyPr wrap="square" lIns="0" tIns="0" rIns="0" bIns="0"/>
+          <a:lstStyle/>
+          <a:p>
+            <a:pPr>
+              <a:buNone/>
+            </a:pPr>
+            <a:r>
+              <a:rPr lang="en-US" sz="1500" b="1">
+                <a:solidFill>
+                  <a:srgbClr val="3DD6FF"/>
+                </a:solidFill>
+                <a:latin typeface="Segoe UI Semibold"/>
+              </a:rPr>
+              <a:t>0.78 (78%)</a:t>
+            </a:r>
+            <a:endParaRPr lang="en-US" sz="1500"/>
+          </a:p>
+        </p:txBody>
+      </p:sp>
+      <p:sp>
+        <p:nvSpPr>
+          <p:cNvPr id="22" name="Game action"/>
+          <p:cNvSpPr txBox="1"/>
+          <p:nvPr/>
+        </p:nvSpPr>
+        <p:spPr>
+          <a:xfrm>
+            <a:off x="5029200" y="3749040"/>
+            <a:ext cx="3337560" cy="219456"/>
+          </a:xfrm>
+          <a:prstGeom prst="rect">
+            <a:avLst/>
+          </a:prstGeom>
+          <a:noFill/>
+          <a:ln/>
+        </p:spPr>
+        <p:txBody>
+          <a:bodyPr wrap="square" lIns="0" tIns="0" rIns="0" bIns="0"/>
+          <a:lstStyle/>
+          <a:p>
+            <a:pPr>
+              <a:buNone/>
+            </a:pPr>
+            <a:r>
+              <a:rPr lang="en-US" sz="1100">
+                <a:solidFill>
+                  <a:srgbClr val="ABA6C8"/>
+                </a:solidFill>
+                <a:latin typeface="Segoe UI"/>
+              </a:rPr>
+              <a:t>Game checks the boost threshold and tank.</a:t>
+            </a:r>
+            <a:endParaRPr lang="en-US" sz="1100"/>
+          </a:p>
+        </p:txBody>
+      </p:sp>
+      <p:sp>
+        <p:nvSpPr>
+          <p:cNvPr id="23" name="No chat history"/>
+          <p:cNvSpPr txBox="1"/>
+          <p:nvPr/>
+        </p:nvSpPr>
+        <p:spPr>
+          <a:xfrm>
+            <a:off x="548640" y="4206240"/>
+            <a:ext cx="8046720" cy="256032"/>
+          </a:xfrm>
+          <a:prstGeom prst="rect">
+            <a:avLst/>
+          </a:prstGeom>
+          <a:noFill/>
+          <a:ln/>
+        </p:spPr>
+        <p:txBody>
+          <a:bodyPr wrap="square" lIns="0" tIns="0" rIns="0" bIns="0"/>
+          <a:lstStyle/>
+          <a:p>
+            <a:pPr>
+              <a:buNone/>
+            </a:pPr>
+            <a:r>
+              <a:rPr lang="en-US" sz="1200" b="1">
+                <a:solidFill>
+                  <a:srgbClr val="FFD166"/>
+                </a:solidFill>
+                <a:latin typeface="Segoe UI Semibold"/>
+              </a:rPr>
+              <a:t xml:space="preserve">No chat history: </a:t>
+            </a:r>
+            <a:r>
+              <a:rPr lang="en-US" sz="1200">
+                <a:solidFill>
+                  <a:srgbClr val="ECE9F8"/>
+                </a:solidFill>
+                <a:latin typeface="Segoe UI"/>
+              </a:rPr>
+              <a:t>each repeat sends fresh data plus the previous move and its age.</a:t>
+            </a:r>
+            <a:endParaRPr lang="en-US" sz="1200"/>
+          </a:p>
+        </p:txBody>
+      </p:sp>
+      <p:sp>
+        <p:nvSpPr>
+          <p:cNvPr id="24" name="Independent requests"/>
+          <p:cNvSpPr txBox="1"/>
+          <p:nvPr/>
+        </p:nvSpPr>
+        <p:spPr>
+          <a:xfrm>
+            <a:off x="548640" y="4498848"/>
+            <a:ext cx="8046720" cy="182880"/>
+          </a:xfrm>
+          <a:prstGeom prst="rect">
+            <a:avLst/>
+          </a:prstGeom>
+          <a:noFill/>
+          <a:ln/>
+        </p:spPr>
+        <p:txBody>
+          <a:bodyPr wrap="square" lIns="0" tIns="0" rIns="0" bIns="0"/>
+          <a:lstStyle/>
+          <a:p>
+            <a:pPr>
+              <a:buNone/>
+            </a:pPr>
+            <a:r>
+              <a:rPr lang="en-US" sz="1200" b="1">
+                <a:solidFill>
+                  <a:srgbClr val="FFD166"/>
+                </a:solidFill>
+                <a:latin typeface="Segoe UI Semibold"/>
+              </a:rPr>
+              <a:t xml:space="preserve">Five independent drivers: </a:t>
+            </a:r>
+            <a:r>
+              <a:rPr lang="en-US" sz="1200">
+                <a:solidFill>
+                  <a:srgbClr val="ECE9F8"/>
+                </a:solidFill>
+                <a:latin typeface="Segoe UI"/>
+              </a:rPr>
+              <a:t>requests can overlap; rivals do not exchange plans.</a:t>
+            </a:r>
+            <a:endParaRPr lang="en-US" sz="1200"/>
           </a:p>
         </p:txBody>
       </p:sp>
@@ -4939,7 +5953,7 @@
                 <a:ea typeface="Segoe UI Semibold" pitchFamily="34" charset="-122"/>
                 <a:cs typeface="Segoe UI Semibold" pitchFamily="34" charset="-120"/>
               </a:rPr>
-              <a:t>02 / 12</a:t>
+              <a:t>02 / 13</a:t>
             </a:r>
             <a:endParaRPr lang="en-US" sz="1100" dirty="0"/>
           </a:p>
@@ -5588,7 +6602,7 @@
                 <a:ea typeface="Segoe UI Semibold" pitchFamily="34" charset="-122"/>
                 <a:cs typeface="Segoe UI Semibold" pitchFamily="34" charset="-120"/>
               </a:rPr>
-              <a:t>03 / 12</a:t>
+              <a:t>03 / 13</a:t>
             </a:r>
             <a:endParaRPr lang="en-US" sz="1100" dirty="0"/>
           </a:p>
@@ -6380,7 +7394,7 @@
                 <a:ea typeface="Segoe UI Semibold" pitchFamily="34" charset="-122"/>
                 <a:cs typeface="Segoe UI Semibold" pitchFamily="34" charset="-120"/>
               </a:rPr>
-              <a:t>04 / 12</a:t>
+              <a:t>04 / 13</a:t>
             </a:r>
             <a:endParaRPr lang="en-US" sz="1100" dirty="0"/>
           </a:p>
@@ -8046,7 +9060,7 @@
                 <a:ea typeface="Segoe UI Semibold" pitchFamily="34" charset="-122"/>
                 <a:cs typeface="Segoe UI Semibold" pitchFamily="34" charset="-120"/>
               </a:rPr>
-              <a:t>05 / 12</a:t>
+              <a:t>05 / 13</a:t>
             </a:r>
             <a:endParaRPr lang="en-US" sz="1100" dirty="0"/>
           </a:p>
@@ -9626,7 +10640,7 @@
                 <a:ea typeface="Segoe UI Semibold" pitchFamily="34" charset="-122"/>
                 <a:cs typeface="Segoe UI Semibold" pitchFamily="34" charset="-120"/>
               </a:rPr>
-              <a:t>06 / 12</a:t>
+              <a:t>06 / 13</a:t>
             </a:r>
             <a:endParaRPr lang="en-US" sz="1100" dirty="0"/>
           </a:p>
@@ -11786,12 +12800,13 @@
 
 <file path=ppt/slides/slide7.xml><?xml version="1.0" encoding="utf-8"?>
 <p:sld xmlns:a="http://schemas.openxmlformats.org/drawingml/2006/main" xmlns:r="http://schemas.openxmlformats.org/officeDocument/2006/relationships" xmlns:p="http://schemas.openxmlformats.org/presentationml/2006/main">
-  <p:cSld name="Slide 7">
+  <p:cSld name="One request, three answers">
     <p:bg>
       <p:bgPr>
         <a:solidFill>
           <a:srgbClr val="07071A"/>
         </a:solidFill>
+        <a:effectLst/>
       </p:bgPr>
     </p:bg>
     <p:spTree>
@@ -11810,7 +12825,7 @@
       </p:grpSpPr>
       <p:sp>
         <p:nvSpPr>
-          <p:cNvPr id="2" name="Shape 0"/>
+          <p:cNvPr id="2" name="Header dot"/>
           <p:cNvSpPr/>
           <p:nvPr/>
         </p:nvSpPr>
@@ -11830,8 +12845,8 @@
       </p:sp>
       <p:sp>
         <p:nvSpPr>
-          <p:cNvPr id="3" name="Text 1"/>
-          <p:cNvSpPr/>
+          <p:cNvPr id="3" name="Section label"/>
+          <p:cNvSpPr txBox="1"/>
           <p:nvPr/>
         </p:nvSpPr>
         <p:spPr>
@@ -11846,31 +12861,29 @@
           <a:ln/>
         </p:spPr>
         <p:txBody>
-          <a:bodyPr wrap="square" lIns="0" tIns="0" rIns="0" bIns="0" rtlCol="0" anchor="ctr"/>
-          <a:lstStyle/>
-          <a:p>
-            <a:pPr indent="0" marL="0">
-              <a:buNone/>
-            </a:pPr>
-            <a:r>
-              <a:rPr lang="en-US" sz="1100" spc="300" kern="0" dirty="0">
+          <a:bodyPr wrap="square" lIns="0" tIns="0" rIns="0" bIns="0" anchor="ctr"/>
+          <a:lstStyle/>
+          <a:p>
+            <a:pPr>
+              <a:buNone/>
+            </a:pPr>
+            <a:r>
+              <a:rPr lang="en-US" sz="1100" b="1" spc="300" kern="0">
                 <a:solidFill>
                   <a:srgbClr val="ABA6C8"/>
                 </a:solidFill>
-                <a:latin typeface="Segoe UI Semibold" pitchFamily="34" charset="0"/>
-                <a:ea typeface="Segoe UI Semibold" pitchFamily="34" charset="-122"/>
-                <a:cs typeface="Segoe UI Semibold" pitchFamily="34" charset="-120"/>
-              </a:rPr>
-              <a:t>ON THE WIRE</a:t>
-            </a:r>
-            <a:endParaRPr lang="en-US" sz="1100" dirty="0"/>
-          </a:p>
-        </p:txBody>
-      </p:sp>
-      <p:sp>
-        <p:nvSpPr>
-          <p:cNvPr id="4" name="Text 2"/>
-          <p:cNvSpPr/>
+                <a:latin typeface="Segoe UI Semibold"/>
+              </a:rPr>
+              <a:t>THE JSON EXCHANGE</a:t>
+            </a:r>
+            <a:endParaRPr lang="en-US" sz="1100"/>
+          </a:p>
+        </p:txBody>
+      </p:sp>
+      <p:sp>
+        <p:nvSpPr>
+          <p:cNvPr id="4" name="Slide counter"/>
+          <p:cNvSpPr txBox="1"/>
           <p:nvPr/>
         </p:nvSpPr>
         <p:spPr>
@@ -11885,31 +12898,29 @@
           <a:ln/>
         </p:spPr>
         <p:txBody>
-          <a:bodyPr wrap="square" lIns="0" tIns="0" rIns="0" bIns="0" rtlCol="0" anchor="ctr"/>
-          <a:lstStyle/>
-          <a:p>
-            <a:pPr algn="r" indent="0" marL="0">
-              <a:buNone/>
-            </a:pPr>
-            <a:r>
-              <a:rPr lang="en-US" sz="1100" dirty="0">
+          <a:bodyPr wrap="square" lIns="0" tIns="0" rIns="0" bIns="0" anchor="ctr"/>
+          <a:lstStyle/>
+          <a:p>
+            <a:pPr algn="r">
+              <a:buNone/>
+            </a:pPr>
+            <a:r>
+              <a:rPr lang="en-US" sz="1100">
                 <a:solidFill>
                   <a:srgbClr val="ABA6C8"/>
                 </a:solidFill>
-                <a:latin typeface="Segoe UI Semibold" pitchFamily="34" charset="0"/>
-                <a:ea typeface="Segoe UI Semibold" pitchFamily="34" charset="-122"/>
-                <a:cs typeface="Segoe UI Semibold" pitchFamily="34" charset="-120"/>
-              </a:rPr>
-              <a:t>07 / 12</a:t>
-            </a:r>
-            <a:endParaRPr lang="en-US" sz="1100" dirty="0"/>
-          </a:p>
-        </p:txBody>
-      </p:sp>
-      <p:sp>
-        <p:nvSpPr>
-          <p:cNvPr id="5" name="Text 3"/>
-          <p:cNvSpPr/>
+                <a:latin typeface="Segoe UI Semibold"/>
+              </a:rPr>
+              <a:t>08 / 13</a:t>
+            </a:r>
+            <a:endParaRPr lang="en-US" sz="1100"/>
+          </a:p>
+        </p:txBody>
+      </p:sp>
+      <p:sp>
+        <p:nvSpPr>
+          <p:cNvPr id="5" name="Slide title"/>
+          <p:cNvSpPr txBox="1"/>
           <p:nvPr/>
         </p:nvSpPr>
         <p:spPr>
@@ -11924,36 +12935,34 @@
           <a:ln/>
         </p:spPr>
         <p:txBody>
-          <a:bodyPr wrap="square" lIns="0" tIns="0" rIns="0" bIns="0" rtlCol="0" anchor="t"/>
-          <a:lstStyle/>
-          <a:p>
-            <a:pPr indent="0" marL="0">
-              <a:buNone/>
-            </a:pPr>
-            <a:r>
-              <a:rPr lang="en-US" sz="3400" i="1" dirty="0">
+          <a:bodyPr wrap="square" lIns="0" tIns="0" rIns="0" bIns="0"/>
+          <a:lstStyle/>
+          <a:p>
+            <a:pPr>
+              <a:buNone/>
+            </a:pPr>
+            <a:r>
+              <a:rPr lang="en-US" sz="3400" b="1" i="1">
                 <a:solidFill>
                   <a:srgbClr val="ECE9F8"/>
                 </a:solidFill>
-                <a:latin typeface="Segoe UI Black" pitchFamily="34" charset="0"/>
-                <a:ea typeface="Segoe UI Black" pitchFamily="34" charset="-122"/>
-                <a:cs typeface="Segoe UI Black" pitchFamily="34" charset="-120"/>
+                <a:latin typeface="Segoe UI Black"/>
               </a:rPr>
               <a:t>One request, three answers</a:t>
             </a:r>
-            <a:endParaRPr lang="en-US" sz="3400" dirty="0"/>
-          </a:p>
-        </p:txBody>
-      </p:sp>
-      <p:sp>
-        <p:nvSpPr>
-          <p:cNvPr id="6" name="Text 4"/>
-          <p:cNvSpPr/>
-          <p:nvPr/>
-        </p:nvSpPr>
-        <p:spPr>
-          <a:xfrm>
-            <a:off x="548640" y="1325880"/>
+            <a:endParaRPr lang="en-US" sz="3400"/>
+          </a:p>
+        </p:txBody>
+      </p:sp>
+      <p:sp>
+        <p:nvSpPr>
+          <p:cNvPr id="6" name="Slide subtitle"/>
+          <p:cNvSpPr txBox="1"/>
+          <p:nvPr/>
+        </p:nvSpPr>
+        <p:spPr>
+          <a:xfrm>
+            <a:off x="548640" y="1417320"/>
             <a:ext cx="8046720" cy="320040"/>
           </a:xfrm>
           <a:prstGeom prst="rect">
@@ -11963,41 +12972,39 @@
           <a:ln/>
         </p:spPr>
         <p:txBody>
-          <a:bodyPr wrap="square" lIns="0" tIns="0" rIns="0" bIns="0" rtlCol="0" anchor="ctr"/>
-          <a:lstStyle/>
-          <a:p>
-            <a:pPr indent="0" marL="0">
-              <a:buNone/>
-            </a:pPr>
-            <a:r>
-              <a:rPr lang="en-US" sz="1400" dirty="0">
+          <a:bodyPr wrap="square" lIns="0" tIns="0" rIns="0" bIns="0"/>
+          <a:lstStyle/>
+          <a:p>
+            <a:pPr>
+              <a:buNone/>
+            </a:pPr>
+            <a:r>
+              <a:rPr lang="en-US" sz="1450">
                 <a:solidFill>
                   <a:srgbClr val="ABA6C8"/>
                 </a:solidFill>
-                <a:latin typeface="Segoe UI" pitchFamily="34" charset="0"/>
-                <a:ea typeface="Segoe UI" pitchFamily="34" charset="-122"/>
-                <a:cs typeface="Segoe UI" pitchFamily="34" charset="-120"/>
-              </a:rPr>
-              <a:t>Questions are keyed by name, and the answers come back under the same names.</a:t>
-            </a:r>
-            <a:endParaRPr lang="en-US" sz="1400" dirty="0"/>
-          </a:p>
-        </p:txBody>
-      </p:sp>
-      <p:sp>
-        <p:nvSpPr>
-          <p:cNvPr id="7" name="Shape 5"/>
+                <a:latin typeface="Segoe UI"/>
+              </a:rPr>
+              <a:t>Abbreviated JSON: one driver's situation in, three named answers out.</a:t>
+            </a:r>
+            <a:endParaRPr lang="en-US" sz="1450"/>
+          </a:p>
+        </p:txBody>
+      </p:sp>
+      <p:sp>
+        <p:nvSpPr>
+          <p:cNvPr id="7" name="Request card"/>
           <p:cNvSpPr/>
           <p:nvPr/>
         </p:nvSpPr>
         <p:spPr>
           <a:xfrm>
             <a:off x="548640" y="1874520"/>
-            <a:ext cx="3474720" cy="2651760"/>
+            <a:ext cx="3794760" cy="2651760"/>
           </a:xfrm>
           <a:prstGeom prst="roundRect">
             <a:avLst>
-              <a:gd name="adj" fmla="val 4138"/>
+              <a:gd name="adj" fmla="val 9143"/>
             </a:avLst>
           </a:prstGeom>
           <a:solidFill>
@@ -12008,18 +13015,18 @@
       </p:sp>
       <p:sp>
         <p:nvSpPr>
-          <p:cNvPr id="8" name="Shape 6"/>
-          <p:cNvSpPr/>
-          <p:nvPr/>
-        </p:nvSpPr>
-        <p:spPr>
-          <a:xfrm>
-            <a:off x="4297680" y="1874520"/>
-            <a:ext cx="4297680" cy="2651760"/>
+          <p:cNvPr id="8" name="Response card"/>
+          <p:cNvSpPr/>
+          <p:nvPr/>
+        </p:nvSpPr>
+        <p:spPr>
+          <a:xfrm>
+            <a:off x="4663440" y="1874520"/>
+            <a:ext cx="3931920" cy="2651760"/>
           </a:xfrm>
           <a:prstGeom prst="roundRect">
             <a:avLst>
-              <a:gd name="adj" fmla="val 4138"/>
+              <a:gd name="adj" fmla="val 9143"/>
             </a:avLst>
           </a:prstGeom>
           <a:solidFill>
@@ -12030,8 +13037,8 @@
       </p:sp>
       <p:sp>
         <p:nvSpPr>
-          <p:cNvPr id="9" name="Text 7"/>
-          <p:cNvSpPr/>
+          <p:cNvPr id="9" name="Request label"/>
+          <p:cNvSpPr txBox="1"/>
           <p:nvPr/>
         </p:nvSpPr>
         <p:spPr>
@@ -12046,36 +13053,34 @@
           <a:ln/>
         </p:spPr>
         <p:txBody>
-          <a:bodyPr wrap="square" lIns="0" tIns="0" rIns="0" bIns="0" rtlCol="0" anchor="ctr"/>
-          <a:lstStyle/>
-          <a:p>
-            <a:pPr indent="0" marL="0">
-              <a:buNone/>
-            </a:pPr>
-            <a:r>
-              <a:rPr lang="en-US" sz="1050" spc="200" kern="0" dirty="0">
+          <a:bodyPr wrap="square" lIns="0" tIns="0" rIns="0" bIns="0"/>
+          <a:lstStyle/>
+          <a:p>
+            <a:pPr>
+              <a:buNone/>
+            </a:pPr>
+            <a:r>
+              <a:rPr lang="en-US" sz="1050" b="1" spc="200">
                 <a:solidFill>
                   <a:srgbClr val="ABA6C8"/>
                 </a:solidFill>
-                <a:latin typeface="Segoe UI Semibold" pitchFamily="34" charset="0"/>
-                <a:ea typeface="Segoe UI Semibold" pitchFamily="34" charset="-122"/>
-                <a:cs typeface="Segoe UI Semibold" pitchFamily="34" charset="-120"/>
+                <a:latin typeface="Segoe UI Semibold"/>
               </a:rPr>
               <a:t>REQUEST</a:t>
             </a:r>
-            <a:endParaRPr lang="en-US" sz="1050" dirty="0"/>
-          </a:p>
-        </p:txBody>
-      </p:sp>
-      <p:sp>
-        <p:nvSpPr>
-          <p:cNvPr id="10" name="Text 8"/>
-          <p:cNvSpPr/>
-          <p:nvPr/>
-        </p:nvSpPr>
-        <p:spPr>
-          <a:xfrm>
-            <a:off x="4526280" y="2039112"/>
+            <a:endParaRPr lang="en-US" sz="1050"/>
+          </a:p>
+        </p:txBody>
+      </p:sp>
+      <p:sp>
+        <p:nvSpPr>
+          <p:cNvPr id="10" name="Response label"/>
+          <p:cNvSpPr txBox="1"/>
+          <p:nvPr/>
+        </p:nvSpPr>
+        <p:spPr>
+          <a:xfrm>
+            <a:off x="4892040" y="2039112"/>
             <a:ext cx="1828800" cy="237744"/>
           </a:xfrm>
           <a:prstGeom prst="rect">
@@ -12085,2801 +13090,647 @@
           <a:ln/>
         </p:spPr>
         <p:txBody>
-          <a:bodyPr wrap="square" lIns="0" tIns="0" rIns="0" bIns="0" rtlCol="0" anchor="ctr"/>
-          <a:lstStyle/>
-          <a:p>
-            <a:pPr indent="0" marL="0">
-              <a:buNone/>
-            </a:pPr>
-            <a:r>
-              <a:rPr lang="en-US" sz="1050" spc="200" kern="0" dirty="0">
+          <a:bodyPr wrap="square" lIns="0" tIns="0" rIns="0" bIns="0"/>
+          <a:lstStyle/>
+          <a:p>
+            <a:pPr>
+              <a:buNone/>
+            </a:pPr>
+            <a:r>
+              <a:rPr lang="en-US" sz="1050" b="1" spc="200">
                 <a:solidFill>
                   <a:srgbClr val="ABA6C8"/>
                 </a:solidFill>
-                <a:latin typeface="Segoe UI Semibold" pitchFamily="34" charset="0"/>
-                <a:ea typeface="Segoe UI Semibold" pitchFamily="34" charset="-122"/>
-                <a:cs typeface="Segoe UI Semibold" pitchFamily="34" charset="-120"/>
+                <a:latin typeface="Segoe UI Semibold"/>
               </a:rPr>
               <a:t>RESPONSE</a:t>
             </a:r>
-            <a:endParaRPr lang="en-US" sz="1050" dirty="0"/>
-          </a:p>
-        </p:txBody>
-      </p:sp>
-      <p:sp>
-        <p:nvSpPr>
-          <p:cNvPr id="11" name="Text 9"/>
-          <p:cNvSpPr/>
-          <p:nvPr/>
-        </p:nvSpPr>
-        <p:spPr>
-          <a:xfrm>
-            <a:off x="777240" y="2350008"/>
-            <a:ext cx="3063240" cy="1691640"/>
-          </a:xfrm>
-          <a:prstGeom prst="rect">
-            <a:avLst/>
-          </a:prstGeom>
-          <a:noFill/>
-          <a:ln/>
-        </p:spPr>
-        <p:txBody>
-          <a:bodyPr wrap="square" lIns="0" tIns="0" rIns="0" bIns="0" rtlCol="0" anchor="t"/>
-          <a:lstStyle/>
-          <a:p>
-            <a:pPr indent="0" marL="0">
+            <a:endParaRPr lang="en-US" sz="1050"/>
+          </a:p>
+        </p:txBody>
+      </p:sp>
+      <p:sp>
+        <p:nvSpPr>
+          <p:cNvPr id="11" name="Request JSON"/>
+          <p:cNvSpPr txBox="1"/>
+          <p:nvPr/>
+        </p:nvSpPr>
+        <p:spPr>
+          <a:xfrm>
+            <a:off x="777240" y="2322576"/>
+            <a:ext cx="3337560" cy="1764792"/>
+          </a:xfrm>
+          <a:prstGeom prst="rect">
+            <a:avLst/>
+          </a:prstGeom>
+          <a:noFill/>
+          <a:ln/>
+        </p:spPr>
+        <p:txBody>
+          <a:bodyPr wrap="square" lIns="0" tIns="0" rIns="0" bIns="0"/>
+          <a:lstStyle/>
+          <a:p>
+            <a:pPr>
               <a:lnSpc>
-                <a:spcPct val="100000"/>
+                <a:spcPts val="1150"/>
               </a:lnSpc>
               <a:buNone/>
             </a:pPr>
             <a:r>
-              <a:rPr lang="en-US" sz="1050" dirty="0">
+              <a:rPr lang="en-US" sz="1050">
                 <a:solidFill>
                   <a:srgbClr val="3DD6FF"/>
                 </a:solidFill>
-                <a:latin typeface="Consolas" pitchFamily="34" charset="0"/>
-                <a:ea typeface="Consolas" pitchFamily="34" charset="-122"/>
-                <a:cs typeface="Consolas" pitchFamily="34" charset="-120"/>
+                <a:latin typeface="Consolas"/>
               </a:rPr>
               <a:t>POST …/providers/microsoft/v1/systemone</a:t>
             </a:r>
-            <a:endParaRPr lang="en-US" sz="1050" dirty="0"/>
-          </a:p>
-          <a:p>
-            <a:pPr indent="0" marL="0">
+            <a:endParaRPr sz="1050"/>
+          </a:p>
+          <a:p>
+            <a:pPr>
               <a:lnSpc>
-                <a:spcPct val="100000"/>
+                <a:spcPts val="1150"/>
               </a:lnSpc>
               <a:buNone/>
             </a:pPr>
             <a:r>
-              <a:rPr lang="en-US" sz="1050" dirty="0">
+              <a:rPr lang="en-US" sz="1050">
                 <a:solidFill>
                   <a:srgbClr val="ABA6C8"/>
                 </a:solidFill>
-                <a:latin typeface="Consolas" pitchFamily="34" charset="0"/>
-                <a:ea typeface="Consolas" pitchFamily="34" charset="-122"/>
-                <a:cs typeface="Consolas" pitchFamily="34" charset="-120"/>
+                <a:latin typeface="Consolas"/>
               </a:rPr>
               <a:t>{</a:t>
             </a:r>
-            <a:endParaRPr lang="en-US" sz="1050" dirty="0"/>
-          </a:p>
-          <a:p>
-            <a:pPr indent="0" marL="0">
+            <a:endParaRPr sz="1050"/>
+          </a:p>
+          <a:p>
+            <a:pPr>
               <a:lnSpc>
-                <a:spcPct val="100000"/>
+                <a:spcPts val="1150"/>
               </a:lnSpc>
               <a:buNone/>
             </a:pPr>
             <a:r>
-              <a:rPr lang="en-US" sz="1050" dirty="0">
+              <a:rPr lang="en-US" sz="1050">
+                <a:solidFill>
+                  <a:srgbClr val="ECE9F8"/>
+                </a:solidFill>
+                <a:latin typeface="Consolas"/>
+              </a:rPr>
+              <a:t xml:space="preserve">  "model": </a:t>
+            </a:r>
+            <a:r>
+              <a:rPr lang="en-US" sz="1050">
+                <a:solidFill>
+                  <a:srgbClr val="FFD166"/>
+                </a:solidFill>
+                <a:latin typeface="Consolas"/>
+              </a:rPr>
+              <a:t>"&lt;deployment-name&gt;",</a:t>
+            </a:r>
+            <a:endParaRPr sz="1050"/>
+          </a:p>
+          <a:p>
+            <a:pPr>
+              <a:lnSpc>
+                <a:spcPts val="1150"/>
+              </a:lnSpc>
+              <a:buNone/>
+            </a:pPr>
+            <a:r>
+              <a:rPr lang="en-US" sz="1050">
+                <a:solidFill>
+                  <a:srgbClr val="ECE9F8"/>
+                </a:solidFill>
+                <a:latin typeface="Consolas"/>
+              </a:rPr>
+              <a:t xml:space="preserve">  "state": </a:t>
+            </a:r>
+            <a:r>
+              <a:rPr lang="en-US" sz="1050">
+                <a:solidFill>
+                  <a:srgbClr val="FFD166"/>
+                </a:solidFill>
+                <a:latin typeface="Consolas"/>
+              </a:rPr>
+              <a:t>"&lt;Vega's snapshot&gt;",</a:t>
+            </a:r>
+            <a:endParaRPr sz="1050"/>
+          </a:p>
+          <a:p>
+            <a:pPr>
+              <a:lnSpc>
+                <a:spcPts val="1150"/>
+              </a:lnSpc>
+              <a:buNone/>
+            </a:pPr>
+            <a:r>
+              <a:rPr lang="en-US" sz="1050">
+                <a:solidFill>
+                  <a:srgbClr val="ECE9F8"/>
+                </a:solidFill>
+                <a:latin typeface="Consolas"/>
+              </a:rPr>
+              <a:t xml:space="preserve">  "questions": {</a:t>
+            </a:r>
+            <a:endParaRPr sz="1050"/>
+          </a:p>
+          <a:p>
+            <a:pPr>
+              <a:lnSpc>
+                <a:spcPts val="1150"/>
+              </a:lnSpc>
+              <a:buNone/>
+            </a:pPr>
+            <a:r>
+              <a:rPr lang="en-US" sz="1050">
+                <a:solidFill>
+                  <a:srgbClr val="ECE9F8"/>
+                </a:solidFill>
+                <a:latin typeface="Consolas"/>
+              </a:rPr>
+              <a:t xml:space="preserve">    "maneuver": { "type": </a:t>
+            </a:r>
+            <a:r>
+              <a:rPr lang="en-US" sz="1050">
+                <a:solidFill>
+                  <a:srgbClr val="FFD166"/>
+                </a:solidFill>
+                <a:latin typeface="Consolas"/>
+              </a:rPr>
+              <a:t xml:space="preserve">"choice", … },</a:t>
+            </a:r>
+            <a:endParaRPr sz="1050"/>
+          </a:p>
+          <a:p>
+            <a:pPr>
+              <a:lnSpc>
+                <a:spcPts val="1150"/>
+              </a:lnSpc>
+              <a:buNone/>
+            </a:pPr>
+            <a:r>
+              <a:rPr lang="en-US" sz="1050">
+                <a:solidFill>
+                  <a:srgbClr val="ECE9F8"/>
+                </a:solidFill>
+                <a:latin typeface="Consolas"/>
+              </a:rPr>
+              <a:t xml:space="preserve">    "pace": { "type": </a:t>
+            </a:r>
+            <a:r>
+              <a:rPr lang="en-US" sz="1050">
+                <a:solidFill>
+                  <a:srgbClr val="FFD166"/>
+                </a:solidFill>
+                <a:latin typeface="Consolas"/>
+              </a:rPr>
+              <a:t>"score", … },</a:t>
+            </a:r>
+            <a:endParaRPr sz="1050"/>
+          </a:p>
+          <a:p>
+            <a:pPr>
+              <a:lnSpc>
+                <a:spcPts val="1150"/>
+              </a:lnSpc>
+              <a:buNone/>
+            </a:pPr>
+            <a:r>
+              <a:rPr lang="en-US" sz="1050">
+                <a:solidFill>
+                  <a:srgbClr val="ECE9F8"/>
+                </a:solidFill>
+                <a:latin typeface="Consolas"/>
+              </a:rPr>
+              <a:t xml:space="preserve">    "nitro": { "type": </a:t>
+            </a:r>
+            <a:r>
+              <a:rPr lang="en-US" sz="1050">
+                <a:solidFill>
+                  <a:srgbClr val="FFD166"/>
+                </a:solidFill>
+                <a:latin typeface="Consolas"/>
+              </a:rPr>
+              <a:t>"noul", … }</a:t>
+            </a:r>
+            <a:endParaRPr sz="1050"/>
+          </a:p>
+          <a:p>
+            <a:pPr>
+              <a:lnSpc>
+                <a:spcPts val="1150"/>
+              </a:lnSpc>
+              <a:buNone/>
+            </a:pPr>
+            <a:r>
+              <a:rPr lang="en-US" sz="1050">
                 <a:solidFill>
                   <a:srgbClr val="ABA6C8"/>
                 </a:solidFill>
-                <a:latin typeface="Consolas" pitchFamily="34" charset="0"/>
-                <a:ea typeface="Consolas" pitchFamily="34" charset="-122"/>
-                <a:cs typeface="Consolas" pitchFamily="34" charset="-120"/>
-              </a:rPr>
-              <a:t xml:space="preserve">  </a:t>
-            </a:r>
-            <a:pPr indent="0" marL="0">
+                <a:latin typeface="Consolas"/>
+              </a:rPr>
+              <a:t xml:space="preserve">  }</a:t>
+            </a:r>
+            <a:endParaRPr sz="1050"/>
+          </a:p>
+          <a:p>
+            <a:pPr>
               <a:lnSpc>
-                <a:spcPct val="100000"/>
+                <a:spcPts val="1150"/>
               </a:lnSpc>
               <a:buNone/>
             </a:pPr>
             <a:r>
-              <a:rPr lang="en-US" sz="1050" dirty="0">
+              <a:rPr lang="en-US" sz="1050">
+                <a:solidFill>
+                  <a:srgbClr val="ABA6C8"/>
+                </a:solidFill>
+                <a:latin typeface="Consolas"/>
+              </a:rPr>
+              <a:t>}</a:t>
+            </a:r>
+            <a:endParaRPr sz="1050"/>
+          </a:p>
+        </p:txBody>
+      </p:sp>
+      <p:sp>
+        <p:nvSpPr>
+          <p:cNvPr id="12" name="Response JSON"/>
+          <p:cNvSpPr txBox="1"/>
+          <p:nvPr/>
+        </p:nvSpPr>
+        <p:spPr>
+          <a:xfrm>
+            <a:off x="4892040" y="2322576"/>
+            <a:ext cx="3474720" cy="1874520"/>
+          </a:xfrm>
+          <a:prstGeom prst="rect">
+            <a:avLst/>
+          </a:prstGeom>
+          <a:noFill/>
+          <a:ln/>
+        </p:spPr>
+        <p:txBody>
+          <a:bodyPr wrap="square" lIns="0" tIns="0" rIns="0" bIns="0"/>
+          <a:lstStyle/>
+          <a:p>
+            <a:pPr>
+              <a:lnSpc>
+                <a:spcPts val="1150"/>
+              </a:lnSpc>
+              <a:buNone/>
+            </a:pPr>
+            <a:r>
+              <a:rPr lang="en-US" sz="1050">
+                <a:solidFill>
+                  <a:srgbClr val="4ADE80"/>
+                </a:solidFill>
+                <a:latin typeface="Consolas"/>
+              </a:rPr>
+              <a:t>200 OK</a:t>
+            </a:r>
+            <a:endParaRPr sz="1050"/>
+          </a:p>
+          <a:p>
+            <a:pPr>
+              <a:lnSpc>
+                <a:spcPts val="1150"/>
+              </a:lnSpc>
+              <a:buNone/>
+            </a:pPr>
+            <a:r>
+              <a:rPr lang="en-US" sz="1050">
+                <a:solidFill>
+                  <a:srgbClr val="ABA6C8"/>
+                </a:solidFill>
+                <a:latin typeface="Consolas"/>
+              </a:rPr>
+              <a:t>{</a:t>
+            </a:r>
+            <a:endParaRPr sz="1050"/>
+          </a:p>
+          <a:p>
+            <a:pPr>
+              <a:lnSpc>
+                <a:spcPts val="1150"/>
+              </a:lnSpc>
+              <a:buNone/>
+            </a:pPr>
+            <a:r>
+              <a:rPr lang="en-US" sz="1050">
                 <a:solidFill>
                   <a:srgbClr val="ECE9F8"/>
                 </a:solidFill>
-                <a:latin typeface="Consolas" pitchFamily="34" charset="0"/>
-                <a:ea typeface="Consolas" pitchFamily="34" charset="-122"/>
-                <a:cs typeface="Consolas" pitchFamily="34" charset="-120"/>
-              </a:rPr>
-              <a:t>"model"</a:t>
-            </a:r>
-            <a:pPr indent="0" marL="0">
+                <a:latin typeface="Consolas"/>
+              </a:rPr>
+              <a:t xml:space="preserve">  "model": </a:t>
+            </a:r>
+            <a:r>
+              <a:rPr lang="en-US" sz="1050">
+                <a:solidFill>
+                  <a:srgbClr val="FFD166"/>
+                </a:solidFill>
+                <a:latin typeface="Consolas"/>
+              </a:rPr>
+              <a:t>"microsoft-decision-1",</a:t>
+            </a:r>
+            <a:endParaRPr sz="1050"/>
+          </a:p>
+          <a:p>
+            <a:pPr>
               <a:lnSpc>
-                <a:spcPct val="100000"/>
+                <a:spcPts val="1150"/>
               </a:lnSpc>
               <a:buNone/>
             </a:pPr>
             <a:r>
-              <a:rPr lang="en-US" sz="1050" dirty="0">
+              <a:rPr lang="en-US" sz="1050">
+                <a:solidFill>
+                  <a:srgbClr val="ECE9F8"/>
+                </a:solidFill>
+                <a:latin typeface="Consolas"/>
+              </a:rPr>
+              <a:t xml:space="preserve">  "answers": {</a:t>
+            </a:r>
+            <a:endParaRPr sz="1050"/>
+          </a:p>
+          <a:p>
+            <a:pPr>
+              <a:lnSpc>
+                <a:spcPts val="1150"/>
+              </a:lnSpc>
+              <a:buNone/>
+            </a:pPr>
+            <a:r>
+              <a:rPr lang="en-US" sz="1050">
+                <a:solidFill>
+                  <a:srgbClr val="ECE9F8"/>
+                </a:solidFill>
+                <a:latin typeface="Consolas"/>
+              </a:rPr>
+              <a:t xml:space="preserve">    "maneuver": {</a:t>
+            </a:r>
+            <a:endParaRPr sz="1050"/>
+          </a:p>
+          <a:p>
+            <a:pPr>
+              <a:lnSpc>
+                <a:spcPts val="1150"/>
+              </a:lnSpc>
+              <a:buNone/>
+            </a:pPr>
+            <a:r>
+              <a:rPr lang="en-US" sz="1050">
+                <a:solidFill>
+                  <a:srgbClr val="ECE9F8"/>
+                </a:solidFill>
+                <a:latin typeface="Consolas"/>
+              </a:rPr>
+              <a:t xml:space="preserve">      "choice": </a:t>
+            </a:r>
+            <a:r>
+              <a:rPr lang="en-US" sz="1050">
+                <a:solidFill>
+                  <a:srgbClr val="FFD166"/>
+                </a:solidFill>
+                <a:latin typeface="Consolas"/>
+              </a:rPr>
+              <a:t>"overtake_left", …</a:t>
+            </a:r>
+            <a:endParaRPr sz="1050"/>
+          </a:p>
+          <a:p>
+            <a:pPr>
+              <a:lnSpc>
+                <a:spcPts val="1150"/>
+              </a:lnSpc>
+              <a:buNone/>
+            </a:pPr>
+            <a:r>
+              <a:rPr lang="en-US" sz="1050">
                 <a:solidFill>
                   <a:srgbClr val="ABA6C8"/>
                 </a:solidFill>
-                <a:latin typeface="Consolas" pitchFamily="34" charset="0"/>
-                <a:ea typeface="Consolas" pitchFamily="34" charset="-122"/>
-                <a:cs typeface="Consolas" pitchFamily="34" charset="-120"/>
-              </a:rPr>
-              <a:t>:</a:t>
-            </a:r>
-            <a:pPr indent="0" marL="0">
+                <a:latin typeface="Consolas"/>
+              </a:rPr>
+              <a:t xml:space="preserve">    },</a:t>
+            </a:r>
+            <a:endParaRPr sz="1050"/>
+          </a:p>
+          <a:p>
+            <a:pPr>
               <a:lnSpc>
-                <a:spcPct val="100000"/>
+                <a:spcPts val="1150"/>
               </a:lnSpc>
               <a:buNone/>
             </a:pPr>
             <a:r>
-              <a:rPr lang="en-US" sz="1050" dirty="0">
+              <a:rPr lang="en-US" sz="1050">
+                <a:solidFill>
+                  <a:srgbClr val="ECE9F8"/>
+                </a:solidFill>
+                <a:latin typeface="Consolas"/>
+              </a:rPr>
+              <a:t xml:space="preserve">    "pace": { "score": </a:t>
+            </a:r>
+            <a:r>
+              <a:rPr lang="en-US" sz="1050">
+                <a:solidFill>
+                  <a:srgbClr val="3DD6FF"/>
+                </a:solidFill>
+                <a:latin typeface="Consolas"/>
+              </a:rPr>
+              <a:t>2.4, … },</a:t>
+            </a:r>
+            <a:endParaRPr sz="1050"/>
+          </a:p>
+          <a:p>
+            <a:pPr>
+              <a:lnSpc>
+                <a:spcPts val="1150"/>
+              </a:lnSpc>
+              <a:buNone/>
+            </a:pPr>
+            <a:r>
+              <a:rPr lang="en-US" sz="1050">
+                <a:solidFill>
+                  <a:srgbClr val="ECE9F8"/>
+                </a:solidFill>
+                <a:latin typeface="Consolas"/>
+              </a:rPr>
+              <a:t xml:space="preserve">    "nitro": { "noul": </a:t>
+            </a:r>
+            <a:r>
+              <a:rPr lang="en-US" sz="1050">
+                <a:solidFill>
+                  <a:srgbClr val="3DD6FF"/>
+                </a:solidFill>
+                <a:latin typeface="Consolas"/>
+              </a:rPr>
+              <a:t>0.78, … }</a:t>
+            </a:r>
+            <a:endParaRPr sz="1050"/>
+          </a:p>
+          <a:p>
+            <a:pPr>
+              <a:lnSpc>
+                <a:spcPts val="1150"/>
+              </a:lnSpc>
+              <a:buNone/>
+            </a:pPr>
+            <a:r>
+              <a:rPr lang="en-US" sz="1050">
                 <a:solidFill>
                   <a:srgbClr val="ABA6C8"/>
                 </a:solidFill>
-                <a:latin typeface="Consolas" pitchFamily="34" charset="0"/>
-                <a:ea typeface="Consolas" pitchFamily="34" charset="-122"/>
-                <a:cs typeface="Consolas" pitchFamily="34" charset="-120"/>
-              </a:rPr>
-              <a:t xml:space="preserve"> </a:t>
-            </a:r>
-            <a:pPr indent="0" marL="0">
+                <a:latin typeface="Consolas"/>
+              </a:rPr>
+              <a:t xml:space="preserve">  },</a:t>
+            </a:r>
+            <a:endParaRPr sz="1050"/>
+          </a:p>
+          <a:p>
+            <a:pPr>
               <a:lnSpc>
-                <a:spcPct val="100000"/>
+                <a:spcPts val="1150"/>
               </a:lnSpc>
               <a:buNone/>
             </a:pPr>
             <a:r>
-              <a:rPr lang="en-US" sz="1050" dirty="0">
-                <a:solidFill>
-                  <a:srgbClr val="FFD166"/>
-                </a:solidFill>
-                <a:latin typeface="Consolas" pitchFamily="34" charset="0"/>
-                <a:ea typeface="Consolas" pitchFamily="34" charset="-122"/>
-                <a:cs typeface="Consolas" pitchFamily="34" charset="-120"/>
-              </a:rPr>
-              <a:t>"decision-1-dz"</a:t>
-            </a:r>
-            <a:pPr indent="0" marL="0">
+              <a:rPr lang="en-US" sz="1050">
+                <a:solidFill>
+                  <a:srgbClr val="ECE9F8"/>
+                </a:solidFill>
+                <a:latin typeface="Consolas"/>
+              </a:rPr>
+              <a:t xml:space="preserve">  "usage": { "output_tokens": </a:t>
+            </a:r>
+            <a:r>
+              <a:rPr lang="en-US" sz="1050">
+                <a:solidFill>
+                  <a:srgbClr val="3DD6FF"/>
+                </a:solidFill>
+                <a:latin typeface="Consolas"/>
+              </a:rPr>
+              <a:t>3, … }</a:t>
+            </a:r>
+            <a:endParaRPr sz="1050"/>
+          </a:p>
+          <a:p>
+            <a:pPr>
               <a:lnSpc>
-                <a:spcPct val="100000"/>
+                <a:spcPts val="1150"/>
               </a:lnSpc>
               <a:buNone/>
             </a:pPr>
             <a:r>
-              <a:rPr lang="en-US" sz="1050" dirty="0">
+              <a:rPr lang="en-US" sz="1050">
                 <a:solidFill>
                   <a:srgbClr val="ABA6C8"/>
                 </a:solidFill>
-                <a:latin typeface="Consolas" pitchFamily="34" charset="0"/>
-                <a:ea typeface="Consolas" pitchFamily="34" charset="-122"/>
-                <a:cs typeface="Consolas" pitchFamily="34" charset="-120"/>
-              </a:rPr>
-              <a:t>,</a:t>
-            </a:r>
-            <a:endParaRPr lang="en-US" sz="1050" dirty="0"/>
-          </a:p>
-          <a:p>
-            <a:pPr indent="0" marL="0">
+                <a:latin typeface="Consolas"/>
+              </a:rPr>
+              <a:t>}</a:t>
+            </a:r>
+            <a:endParaRPr sz="1050"/>
+          </a:p>
+        </p:txBody>
+      </p:sp>
+      <p:sp>
+        <p:nvSpPr>
+          <p:cNvPr id="13" name="Omitted request fields"/>
+          <p:cNvSpPr txBox="1"/>
+          <p:nvPr/>
+        </p:nvSpPr>
+        <p:spPr>
+          <a:xfrm>
+            <a:off x="777240" y="4050792"/>
+            <a:ext cx="3337560" cy="365760"/>
+          </a:xfrm>
+          <a:prstGeom prst="rect">
+            <a:avLst/>
+          </a:prstGeom>
+          <a:noFill/>
+          <a:ln/>
+        </p:spPr>
+        <p:txBody>
+          <a:bodyPr wrap="square" lIns="0" tIns="0" rIns="0" bIns="0"/>
+          <a:lstStyle/>
+          <a:p>
+            <a:pPr>
               <a:lnSpc>
-                <a:spcPct val="100000"/>
+                <a:spcPts val="1200"/>
               </a:lnSpc>
               <a:buNone/>
             </a:pPr>
             <a:r>
-              <a:rPr lang="en-US" sz="1050" dirty="0">
+              <a:rPr lang="en-US" sz="1050">
                 <a:solidFill>
                   <a:srgbClr val="ABA6C8"/>
                 </a:solidFill>
-                <a:latin typeface="Consolas" pitchFamily="34" charset="0"/>
-                <a:ea typeface="Consolas" pitchFamily="34" charset="-122"/>
-                <a:cs typeface="Consolas" pitchFamily="34" charset="-120"/>
-              </a:rPr>
-              <a:t xml:space="preserve">  </a:t>
-            </a:r>
-            <a:pPr indent="0" marL="0">
+                <a:latin typeface="Segoe UI"/>
+              </a:rPr>
+              <a:t>All three include instructions.</a:t>
+            </a:r>
+            <a:endParaRPr sz="1050"/>
+          </a:p>
+          <a:p>
+            <a:pPr>
               <a:lnSpc>
-                <a:spcPct val="100000"/>
+                <a:spcPts val="1200"/>
               </a:lnSpc>
               <a:buNone/>
             </a:pPr>
             <a:r>
-              <a:rPr lang="en-US" sz="1050" dirty="0">
-                <a:solidFill>
-                  <a:srgbClr val="ECE9F8"/>
-                </a:solidFill>
-                <a:latin typeface="Consolas" pitchFamily="34" charset="0"/>
-                <a:ea typeface="Consolas" pitchFamily="34" charset="-122"/>
-                <a:cs typeface="Consolas" pitchFamily="34" charset="-120"/>
-              </a:rPr>
-              <a:t>"state"</a:t>
-            </a:r>
-            <a:pPr indent="0" marL="0">
-              <a:lnSpc>
-                <a:spcPct val="100000"/>
-              </a:lnSpc>
-              <a:buNone/>
-            </a:pPr>
-            <a:r>
-              <a:rPr lang="en-US" sz="1050" dirty="0">
+              <a:rPr lang="en-US" sz="1050">
                 <a:solidFill>
                   <a:srgbClr val="ABA6C8"/>
                 </a:solidFill>
-                <a:latin typeface="Consolas" pitchFamily="34" charset="0"/>
-                <a:ea typeface="Consolas" pitchFamily="34" charset="-122"/>
-                <a:cs typeface="Consolas" pitchFamily="34" charset="-120"/>
-              </a:rPr>
-              <a:t>:</a:t>
-            </a:r>
-            <a:pPr indent="0" marL="0">
-              <a:lnSpc>
-                <a:spcPct val="100000"/>
-              </a:lnSpc>
-              <a:buNone/>
-            </a:pPr>
-            <a:r>
-              <a:rPr lang="en-US" sz="1050" dirty="0">
+                <a:latin typeface="Segoe UI"/>
+              </a:rPr>
+              <a:t>Choice and score add criteria (options).</a:t>
+            </a:r>
+            <a:endParaRPr sz="1050"/>
+          </a:p>
+        </p:txBody>
+      </p:sp>
+      <p:sp>
+        <p:nvSpPr>
+          <p:cNvPr id="14" name="Illustrative response caveat"/>
+          <p:cNvSpPr txBox="1"/>
+          <p:nvPr/>
+        </p:nvSpPr>
+        <p:spPr>
+          <a:xfrm>
+            <a:off x="4892040" y="4261104"/>
+            <a:ext cx="3474720" cy="182880"/>
+          </a:xfrm>
+          <a:prstGeom prst="rect">
+            <a:avLst/>
+          </a:prstGeom>
+          <a:noFill/>
+          <a:ln/>
+        </p:spPr>
+        <p:txBody>
+          <a:bodyPr wrap="square" lIns="0" tIns="0" rIns="0" bIns="0"/>
+          <a:lstStyle/>
+          <a:p>
+            <a:pPr>
+              <a:buNone/>
+            </a:pPr>
+            <a:r>
+              <a:rPr lang="en-US" sz="1050">
                 <a:solidFill>
                   <a:srgbClr val="ABA6C8"/>
                 </a:solidFill>
-                <a:latin typeface="Consolas" pitchFamily="34" charset="0"/>
-                <a:ea typeface="Consolas" pitchFamily="34" charset="-122"/>
-                <a:cs typeface="Consolas" pitchFamily="34" charset="-120"/>
-              </a:rPr>
-              <a:t xml:space="preserve"> </a:t>
-            </a:r>
-            <a:pPr indent="0" marL="0">
-              <a:lnSpc>
-                <a:spcPct val="100000"/>
-              </a:lnSpc>
-              <a:buNone/>
-            </a:pPr>
-            <a:r>
-              <a:rPr lang="en-US" sz="1050" dirty="0">
-                <a:solidFill>
-                  <a:srgbClr val="FFD166"/>
-                </a:solidFill>
-                <a:latin typeface="Consolas" pitchFamily="34" charset="0"/>
-                <a:ea typeface="Consolas" pitchFamily="34" charset="-122"/>
-                <a:cs typeface="Consolas" pitchFamily="34" charset="-120"/>
-              </a:rPr>
-              <a:t>"&lt;race situation text&gt;"</a:t>
-            </a:r>
-            <a:pPr indent="0" marL="0">
-              <a:lnSpc>
-                <a:spcPct val="100000"/>
-              </a:lnSpc>
-              <a:buNone/>
-            </a:pPr>
-            <a:r>
-              <a:rPr lang="en-US" sz="1050" dirty="0">
-                <a:solidFill>
-                  <a:srgbClr val="ABA6C8"/>
-                </a:solidFill>
-                <a:latin typeface="Consolas" pitchFamily="34" charset="0"/>
-                <a:ea typeface="Consolas" pitchFamily="34" charset="-122"/>
-                <a:cs typeface="Consolas" pitchFamily="34" charset="-120"/>
-              </a:rPr>
-              <a:t>,</a:t>
-            </a:r>
-            <a:endParaRPr lang="en-US" sz="1050" dirty="0"/>
-          </a:p>
-          <a:p>
-            <a:pPr indent="0" marL="0">
-              <a:lnSpc>
-                <a:spcPct val="100000"/>
-              </a:lnSpc>
-              <a:buNone/>
-            </a:pPr>
-            <a:r>
-              <a:rPr lang="en-US" sz="1050" dirty="0">
-                <a:solidFill>
-                  <a:srgbClr val="ABA6C8"/>
-                </a:solidFill>
-                <a:latin typeface="Consolas" pitchFamily="34" charset="0"/>
-                <a:ea typeface="Consolas" pitchFamily="34" charset="-122"/>
-                <a:cs typeface="Consolas" pitchFamily="34" charset="-120"/>
-              </a:rPr>
-              <a:t xml:space="preserve">  </a:t>
-            </a:r>
-            <a:pPr indent="0" marL="0">
-              <a:lnSpc>
-                <a:spcPct val="100000"/>
-              </a:lnSpc>
-              <a:buNone/>
-            </a:pPr>
-            <a:r>
-              <a:rPr lang="en-US" sz="1050" dirty="0">
-                <a:solidFill>
-                  <a:srgbClr val="ECE9F8"/>
-                </a:solidFill>
-                <a:latin typeface="Consolas" pitchFamily="34" charset="0"/>
-                <a:ea typeface="Consolas" pitchFamily="34" charset="-122"/>
-                <a:cs typeface="Consolas" pitchFamily="34" charset="-120"/>
-              </a:rPr>
-              <a:t>"questions"</a:t>
-            </a:r>
-            <a:pPr indent="0" marL="0">
-              <a:lnSpc>
-                <a:spcPct val="100000"/>
-              </a:lnSpc>
-              <a:buNone/>
-            </a:pPr>
-            <a:r>
-              <a:rPr lang="en-US" sz="1050" dirty="0">
-                <a:solidFill>
-                  <a:srgbClr val="ABA6C8"/>
-                </a:solidFill>
-                <a:latin typeface="Consolas" pitchFamily="34" charset="0"/>
-                <a:ea typeface="Consolas" pitchFamily="34" charset="-122"/>
-                <a:cs typeface="Consolas" pitchFamily="34" charset="-120"/>
-              </a:rPr>
-              <a:t>:</a:t>
-            </a:r>
-            <a:pPr indent="0" marL="0">
-              <a:lnSpc>
-                <a:spcPct val="100000"/>
-              </a:lnSpc>
-              <a:buNone/>
-            </a:pPr>
-            <a:r>
-              <a:rPr lang="en-US" sz="1050" dirty="0">
-                <a:solidFill>
-                  <a:srgbClr val="ABA6C8"/>
-                </a:solidFill>
-                <a:latin typeface="Consolas" pitchFamily="34" charset="0"/>
-                <a:ea typeface="Consolas" pitchFamily="34" charset="-122"/>
-                <a:cs typeface="Consolas" pitchFamily="34" charset="-120"/>
-              </a:rPr>
-              <a:t xml:space="preserve"> </a:t>
-            </a:r>
-            <a:pPr indent="0" marL="0">
-              <a:lnSpc>
-                <a:spcPct val="100000"/>
-              </a:lnSpc>
-              <a:buNone/>
-            </a:pPr>
-            <a:r>
-              <a:rPr lang="en-US" sz="1050" dirty="0">
-                <a:solidFill>
-                  <a:srgbClr val="ABA6C8"/>
-                </a:solidFill>
-                <a:latin typeface="Consolas" pitchFamily="34" charset="0"/>
-                <a:ea typeface="Consolas" pitchFamily="34" charset="-122"/>
-                <a:cs typeface="Consolas" pitchFamily="34" charset="-120"/>
-              </a:rPr>
-              <a:t>{</a:t>
-            </a:r>
-            <a:endParaRPr lang="en-US" sz="1050" dirty="0"/>
-          </a:p>
-          <a:p>
-            <a:pPr indent="0" marL="0">
-              <a:lnSpc>
-                <a:spcPct val="100000"/>
-              </a:lnSpc>
-              <a:buNone/>
-            </a:pPr>
-            <a:r>
-              <a:rPr lang="en-US" sz="1050" dirty="0">
-                <a:solidFill>
-                  <a:srgbClr val="ABA6C8"/>
-                </a:solidFill>
-                <a:latin typeface="Consolas" pitchFamily="34" charset="0"/>
-                <a:ea typeface="Consolas" pitchFamily="34" charset="-122"/>
-                <a:cs typeface="Consolas" pitchFamily="34" charset="-120"/>
-              </a:rPr>
-              <a:t xml:space="preserve">    </a:t>
-            </a:r>
-            <a:pPr indent="0" marL="0">
-              <a:lnSpc>
-                <a:spcPct val="100000"/>
-              </a:lnSpc>
-              <a:buNone/>
-            </a:pPr>
-            <a:r>
-              <a:rPr lang="en-US" sz="1050" dirty="0">
-                <a:solidFill>
-                  <a:srgbClr val="ECE9F8"/>
-                </a:solidFill>
-                <a:latin typeface="Consolas" pitchFamily="34" charset="0"/>
-                <a:ea typeface="Consolas" pitchFamily="34" charset="-122"/>
-                <a:cs typeface="Consolas" pitchFamily="34" charset="-120"/>
-              </a:rPr>
-              <a:t>"maneuver"</a:t>
-            </a:r>
-            <a:pPr indent="0" marL="0">
-              <a:lnSpc>
-                <a:spcPct val="100000"/>
-              </a:lnSpc>
-              <a:buNone/>
-            </a:pPr>
-            <a:r>
-              <a:rPr lang="en-US" sz="1050" dirty="0">
-                <a:solidFill>
-                  <a:srgbClr val="ABA6C8"/>
-                </a:solidFill>
-                <a:latin typeface="Consolas" pitchFamily="34" charset="0"/>
-                <a:ea typeface="Consolas" pitchFamily="34" charset="-122"/>
-                <a:cs typeface="Consolas" pitchFamily="34" charset="-120"/>
-              </a:rPr>
-              <a:t>:</a:t>
-            </a:r>
-            <a:pPr indent="0" marL="0">
-              <a:lnSpc>
-                <a:spcPct val="100000"/>
-              </a:lnSpc>
-              <a:buNone/>
-            </a:pPr>
-            <a:r>
-              <a:rPr lang="en-US" sz="1050" dirty="0">
-                <a:solidFill>
-                  <a:srgbClr val="ABA6C8"/>
-                </a:solidFill>
-                <a:latin typeface="Consolas" pitchFamily="34" charset="0"/>
-                <a:ea typeface="Consolas" pitchFamily="34" charset="-122"/>
-                <a:cs typeface="Consolas" pitchFamily="34" charset="-120"/>
-              </a:rPr>
-              <a:t xml:space="preserve"> </a:t>
-            </a:r>
-            <a:pPr indent="0" marL="0">
-              <a:lnSpc>
-                <a:spcPct val="100000"/>
-              </a:lnSpc>
-              <a:buNone/>
-            </a:pPr>
-            <a:r>
-              <a:rPr lang="en-US" sz="1050" dirty="0">
-                <a:solidFill>
-                  <a:srgbClr val="ABA6C8"/>
-                </a:solidFill>
-                <a:latin typeface="Consolas" pitchFamily="34" charset="0"/>
-                <a:ea typeface="Consolas" pitchFamily="34" charset="-122"/>
-                <a:cs typeface="Consolas" pitchFamily="34" charset="-120"/>
-              </a:rPr>
-              <a:t>{</a:t>
-            </a:r>
-            <a:pPr indent="0" marL="0">
-              <a:lnSpc>
-                <a:spcPct val="100000"/>
-              </a:lnSpc>
-              <a:buNone/>
-            </a:pPr>
-            <a:r>
-              <a:rPr lang="en-US" sz="1050" dirty="0">
-                <a:solidFill>
-                  <a:srgbClr val="ABA6C8"/>
-                </a:solidFill>
-                <a:latin typeface="Consolas" pitchFamily="34" charset="0"/>
-                <a:ea typeface="Consolas" pitchFamily="34" charset="-122"/>
-                <a:cs typeface="Consolas" pitchFamily="34" charset="-120"/>
-              </a:rPr>
-              <a:t xml:space="preserve"> </a:t>
-            </a:r>
-            <a:pPr indent="0" marL="0">
-              <a:lnSpc>
-                <a:spcPct val="100000"/>
-              </a:lnSpc>
-              <a:buNone/>
-            </a:pPr>
-            <a:r>
-              <a:rPr lang="en-US" sz="1050" dirty="0">
-                <a:solidFill>
-                  <a:srgbClr val="ECE9F8"/>
-                </a:solidFill>
-                <a:latin typeface="Consolas" pitchFamily="34" charset="0"/>
-                <a:ea typeface="Consolas" pitchFamily="34" charset="-122"/>
-                <a:cs typeface="Consolas" pitchFamily="34" charset="-120"/>
-              </a:rPr>
-              <a:t>"type"</a:t>
-            </a:r>
-            <a:pPr indent="0" marL="0">
-              <a:lnSpc>
-                <a:spcPct val="100000"/>
-              </a:lnSpc>
-              <a:buNone/>
-            </a:pPr>
-            <a:r>
-              <a:rPr lang="en-US" sz="1050" dirty="0">
-                <a:solidFill>
-                  <a:srgbClr val="ABA6C8"/>
-                </a:solidFill>
-                <a:latin typeface="Consolas" pitchFamily="34" charset="0"/>
-                <a:ea typeface="Consolas" pitchFamily="34" charset="-122"/>
-                <a:cs typeface="Consolas" pitchFamily="34" charset="-120"/>
-              </a:rPr>
-              <a:t>:</a:t>
-            </a:r>
-            <a:pPr indent="0" marL="0">
-              <a:lnSpc>
-                <a:spcPct val="100000"/>
-              </a:lnSpc>
-              <a:buNone/>
-            </a:pPr>
-            <a:r>
-              <a:rPr lang="en-US" sz="1050" dirty="0">
-                <a:solidFill>
-                  <a:srgbClr val="ABA6C8"/>
-                </a:solidFill>
-                <a:latin typeface="Consolas" pitchFamily="34" charset="0"/>
-                <a:ea typeface="Consolas" pitchFamily="34" charset="-122"/>
-                <a:cs typeface="Consolas" pitchFamily="34" charset="-120"/>
-              </a:rPr>
-              <a:t xml:space="preserve"> </a:t>
-            </a:r>
-            <a:pPr indent="0" marL="0">
-              <a:lnSpc>
-                <a:spcPct val="100000"/>
-              </a:lnSpc>
-              <a:buNone/>
-            </a:pPr>
-            <a:r>
-              <a:rPr lang="en-US" sz="1050" dirty="0">
-                <a:solidFill>
-                  <a:srgbClr val="FFD166"/>
-                </a:solidFill>
-                <a:latin typeface="Consolas" pitchFamily="34" charset="0"/>
-                <a:ea typeface="Consolas" pitchFamily="34" charset="-122"/>
-                <a:cs typeface="Consolas" pitchFamily="34" charset="-120"/>
-              </a:rPr>
-              <a:t>"choice"</a:t>
-            </a:r>
-            <a:pPr indent="0" marL="0">
-              <a:lnSpc>
-                <a:spcPct val="100000"/>
-              </a:lnSpc>
-              <a:buNone/>
-            </a:pPr>
-            <a:r>
-              <a:rPr lang="en-US" sz="1050" dirty="0">
-                <a:solidFill>
-                  <a:srgbClr val="ABA6C8"/>
-                </a:solidFill>
-                <a:latin typeface="Consolas" pitchFamily="34" charset="0"/>
-                <a:ea typeface="Consolas" pitchFamily="34" charset="-122"/>
-                <a:cs typeface="Consolas" pitchFamily="34" charset="-120"/>
-              </a:rPr>
-              <a:t>,</a:t>
-            </a:r>
-            <a:pPr indent="0" marL="0">
-              <a:lnSpc>
-                <a:spcPct val="100000"/>
-              </a:lnSpc>
-              <a:buNone/>
-            </a:pPr>
-            <a:r>
-              <a:rPr lang="en-US" sz="1050" dirty="0">
-                <a:solidFill>
-                  <a:srgbClr val="ABA6C8"/>
-                </a:solidFill>
-                <a:latin typeface="Consolas" pitchFamily="34" charset="0"/>
-                <a:ea typeface="Consolas" pitchFamily="34" charset="-122"/>
-                <a:cs typeface="Consolas" pitchFamily="34" charset="-120"/>
-              </a:rPr>
-              <a:t xml:space="preserve"> </a:t>
-            </a:r>
-            <a:pPr indent="0" marL="0">
-              <a:lnSpc>
-                <a:spcPct val="100000"/>
-              </a:lnSpc>
-              <a:buNone/>
-            </a:pPr>
-            <a:r>
-              <a:rPr lang="en-US" sz="1050" dirty="0">
-                <a:solidFill>
-                  <a:srgbClr val="6C6790"/>
-                </a:solidFill>
-                <a:latin typeface="Consolas" pitchFamily="34" charset="0"/>
-                <a:ea typeface="Consolas" pitchFamily="34" charset="-122"/>
-                <a:cs typeface="Consolas" pitchFamily="34" charset="-120"/>
-              </a:rPr>
-              <a:t>…</a:t>
-            </a:r>
-            <a:pPr indent="0" marL="0">
-              <a:lnSpc>
-                <a:spcPct val="100000"/>
-              </a:lnSpc>
-              <a:buNone/>
-            </a:pPr>
-            <a:r>
-              <a:rPr lang="en-US" sz="1050" dirty="0">
-                <a:solidFill>
-                  <a:srgbClr val="ABA6C8"/>
-                </a:solidFill>
-                <a:latin typeface="Consolas" pitchFamily="34" charset="0"/>
-                <a:ea typeface="Consolas" pitchFamily="34" charset="-122"/>
-                <a:cs typeface="Consolas" pitchFamily="34" charset="-120"/>
-              </a:rPr>
-              <a:t xml:space="preserve"> </a:t>
-            </a:r>
-            <a:pPr indent="0" marL="0">
-              <a:lnSpc>
-                <a:spcPct val="100000"/>
-              </a:lnSpc>
-              <a:buNone/>
-            </a:pPr>
-            <a:r>
-              <a:rPr lang="en-US" sz="1050" dirty="0">
-                <a:solidFill>
-                  <a:srgbClr val="ABA6C8"/>
-                </a:solidFill>
-                <a:latin typeface="Consolas" pitchFamily="34" charset="0"/>
-                <a:ea typeface="Consolas" pitchFamily="34" charset="-122"/>
-                <a:cs typeface="Consolas" pitchFamily="34" charset="-120"/>
-              </a:rPr>
-              <a:t>}</a:t>
-            </a:r>
-            <a:pPr indent="0" marL="0">
-              <a:lnSpc>
-                <a:spcPct val="100000"/>
-              </a:lnSpc>
-              <a:buNone/>
-            </a:pPr>
-            <a:r>
-              <a:rPr lang="en-US" sz="1050" dirty="0">
-                <a:solidFill>
-                  <a:srgbClr val="ABA6C8"/>
-                </a:solidFill>
-                <a:latin typeface="Consolas" pitchFamily="34" charset="0"/>
-                <a:ea typeface="Consolas" pitchFamily="34" charset="-122"/>
-                <a:cs typeface="Consolas" pitchFamily="34" charset="-120"/>
-              </a:rPr>
-              <a:t>,</a:t>
-            </a:r>
-            <a:endParaRPr lang="en-US" sz="1050" dirty="0"/>
-          </a:p>
-          <a:p>
-            <a:pPr indent="0" marL="0">
-              <a:lnSpc>
-                <a:spcPct val="100000"/>
-              </a:lnSpc>
-              <a:buNone/>
-            </a:pPr>
-            <a:r>
-              <a:rPr lang="en-US" sz="1050" dirty="0">
-                <a:solidFill>
-                  <a:srgbClr val="ABA6C8"/>
-                </a:solidFill>
-                <a:latin typeface="Consolas" pitchFamily="34" charset="0"/>
-                <a:ea typeface="Consolas" pitchFamily="34" charset="-122"/>
-                <a:cs typeface="Consolas" pitchFamily="34" charset="-120"/>
-              </a:rPr>
-              <a:t xml:space="preserve">    </a:t>
-            </a:r>
-            <a:pPr indent="0" marL="0">
-              <a:lnSpc>
-                <a:spcPct val="100000"/>
-              </a:lnSpc>
-              <a:buNone/>
-            </a:pPr>
-            <a:r>
-              <a:rPr lang="en-US" sz="1050" dirty="0">
-                <a:solidFill>
-                  <a:srgbClr val="ECE9F8"/>
-                </a:solidFill>
-                <a:latin typeface="Consolas" pitchFamily="34" charset="0"/>
-                <a:ea typeface="Consolas" pitchFamily="34" charset="-122"/>
-                <a:cs typeface="Consolas" pitchFamily="34" charset="-120"/>
-              </a:rPr>
-              <a:t>"pace"</a:t>
-            </a:r>
-            <a:pPr indent="0" marL="0">
-              <a:lnSpc>
-                <a:spcPct val="100000"/>
-              </a:lnSpc>
-              <a:buNone/>
-            </a:pPr>
-            <a:r>
-              <a:rPr lang="en-US" sz="1050" dirty="0">
-                <a:solidFill>
-                  <a:srgbClr val="ABA6C8"/>
-                </a:solidFill>
-                <a:latin typeface="Consolas" pitchFamily="34" charset="0"/>
-                <a:ea typeface="Consolas" pitchFamily="34" charset="-122"/>
-                <a:cs typeface="Consolas" pitchFamily="34" charset="-120"/>
-              </a:rPr>
-              <a:t>:</a:t>
-            </a:r>
-            <a:pPr indent="0" marL="0">
-              <a:lnSpc>
-                <a:spcPct val="100000"/>
-              </a:lnSpc>
-              <a:buNone/>
-            </a:pPr>
-            <a:r>
-              <a:rPr lang="en-US" sz="1050" dirty="0">
-                <a:solidFill>
-                  <a:srgbClr val="ABA6C8"/>
-                </a:solidFill>
-                <a:latin typeface="Consolas" pitchFamily="34" charset="0"/>
-                <a:ea typeface="Consolas" pitchFamily="34" charset="-122"/>
-                <a:cs typeface="Consolas" pitchFamily="34" charset="-120"/>
-              </a:rPr>
-              <a:t xml:space="preserve"> </a:t>
-            </a:r>
-            <a:pPr indent="0" marL="0">
-              <a:lnSpc>
-                <a:spcPct val="100000"/>
-              </a:lnSpc>
-              <a:buNone/>
-            </a:pPr>
-            <a:r>
-              <a:rPr lang="en-US" sz="1050" dirty="0">
-                <a:solidFill>
-                  <a:srgbClr val="ABA6C8"/>
-                </a:solidFill>
-                <a:latin typeface="Consolas" pitchFamily="34" charset="0"/>
-                <a:ea typeface="Consolas" pitchFamily="34" charset="-122"/>
-                <a:cs typeface="Consolas" pitchFamily="34" charset="-120"/>
-              </a:rPr>
-              <a:t>{</a:t>
-            </a:r>
-            <a:pPr indent="0" marL="0">
-              <a:lnSpc>
-                <a:spcPct val="100000"/>
-              </a:lnSpc>
-              <a:buNone/>
-            </a:pPr>
-            <a:r>
-              <a:rPr lang="en-US" sz="1050" dirty="0">
-                <a:solidFill>
-                  <a:srgbClr val="ABA6C8"/>
-                </a:solidFill>
-                <a:latin typeface="Consolas" pitchFamily="34" charset="0"/>
-                <a:ea typeface="Consolas" pitchFamily="34" charset="-122"/>
-                <a:cs typeface="Consolas" pitchFamily="34" charset="-120"/>
-              </a:rPr>
-              <a:t xml:space="preserve"> </a:t>
-            </a:r>
-            <a:pPr indent="0" marL="0">
-              <a:lnSpc>
-                <a:spcPct val="100000"/>
-              </a:lnSpc>
-              <a:buNone/>
-            </a:pPr>
-            <a:r>
-              <a:rPr lang="en-US" sz="1050" dirty="0">
-                <a:solidFill>
-                  <a:srgbClr val="ECE9F8"/>
-                </a:solidFill>
-                <a:latin typeface="Consolas" pitchFamily="34" charset="0"/>
-                <a:ea typeface="Consolas" pitchFamily="34" charset="-122"/>
-                <a:cs typeface="Consolas" pitchFamily="34" charset="-120"/>
-              </a:rPr>
-              <a:t>"type"</a:t>
-            </a:r>
-            <a:pPr indent="0" marL="0">
-              <a:lnSpc>
-                <a:spcPct val="100000"/>
-              </a:lnSpc>
-              <a:buNone/>
-            </a:pPr>
-            <a:r>
-              <a:rPr lang="en-US" sz="1050" dirty="0">
-                <a:solidFill>
-                  <a:srgbClr val="ABA6C8"/>
-                </a:solidFill>
-                <a:latin typeface="Consolas" pitchFamily="34" charset="0"/>
-                <a:ea typeface="Consolas" pitchFamily="34" charset="-122"/>
-                <a:cs typeface="Consolas" pitchFamily="34" charset="-120"/>
-              </a:rPr>
-              <a:t>:</a:t>
-            </a:r>
-            <a:pPr indent="0" marL="0">
-              <a:lnSpc>
-                <a:spcPct val="100000"/>
-              </a:lnSpc>
-              <a:buNone/>
-            </a:pPr>
-            <a:r>
-              <a:rPr lang="en-US" sz="1050" dirty="0">
-                <a:solidFill>
-                  <a:srgbClr val="ABA6C8"/>
-                </a:solidFill>
-                <a:latin typeface="Consolas" pitchFamily="34" charset="0"/>
-                <a:ea typeface="Consolas" pitchFamily="34" charset="-122"/>
-                <a:cs typeface="Consolas" pitchFamily="34" charset="-120"/>
-              </a:rPr>
-              <a:t xml:space="preserve"> </a:t>
-            </a:r>
-            <a:pPr indent="0" marL="0">
-              <a:lnSpc>
-                <a:spcPct val="100000"/>
-              </a:lnSpc>
-              <a:buNone/>
-            </a:pPr>
-            <a:r>
-              <a:rPr lang="en-US" sz="1050" dirty="0">
-                <a:solidFill>
-                  <a:srgbClr val="FFD166"/>
-                </a:solidFill>
-                <a:latin typeface="Consolas" pitchFamily="34" charset="0"/>
-                <a:ea typeface="Consolas" pitchFamily="34" charset="-122"/>
-                <a:cs typeface="Consolas" pitchFamily="34" charset="-120"/>
-              </a:rPr>
-              <a:t>"score"</a:t>
-            </a:r>
-            <a:pPr indent="0" marL="0">
-              <a:lnSpc>
-                <a:spcPct val="100000"/>
-              </a:lnSpc>
-              <a:buNone/>
-            </a:pPr>
-            <a:r>
-              <a:rPr lang="en-US" sz="1050" dirty="0">
-                <a:solidFill>
-                  <a:srgbClr val="ABA6C8"/>
-                </a:solidFill>
-                <a:latin typeface="Consolas" pitchFamily="34" charset="0"/>
-                <a:ea typeface="Consolas" pitchFamily="34" charset="-122"/>
-                <a:cs typeface="Consolas" pitchFamily="34" charset="-120"/>
-              </a:rPr>
-              <a:t>,</a:t>
-            </a:r>
-            <a:pPr indent="0" marL="0">
-              <a:lnSpc>
-                <a:spcPct val="100000"/>
-              </a:lnSpc>
-              <a:buNone/>
-            </a:pPr>
-            <a:r>
-              <a:rPr lang="en-US" sz="1050" dirty="0">
-                <a:solidFill>
-                  <a:srgbClr val="ABA6C8"/>
-                </a:solidFill>
-                <a:latin typeface="Consolas" pitchFamily="34" charset="0"/>
-                <a:ea typeface="Consolas" pitchFamily="34" charset="-122"/>
-                <a:cs typeface="Consolas" pitchFamily="34" charset="-120"/>
-              </a:rPr>
-              <a:t xml:space="preserve"> </a:t>
-            </a:r>
-            <a:pPr indent="0" marL="0">
-              <a:lnSpc>
-                <a:spcPct val="100000"/>
-              </a:lnSpc>
-              <a:buNone/>
-            </a:pPr>
-            <a:r>
-              <a:rPr lang="en-US" sz="1050" dirty="0">
-                <a:solidFill>
-                  <a:srgbClr val="6C6790"/>
-                </a:solidFill>
-                <a:latin typeface="Consolas" pitchFamily="34" charset="0"/>
-                <a:ea typeface="Consolas" pitchFamily="34" charset="-122"/>
-                <a:cs typeface="Consolas" pitchFamily="34" charset="-120"/>
-              </a:rPr>
-              <a:t>…</a:t>
-            </a:r>
-            <a:pPr indent="0" marL="0">
-              <a:lnSpc>
-                <a:spcPct val="100000"/>
-              </a:lnSpc>
-              <a:buNone/>
-            </a:pPr>
-            <a:r>
-              <a:rPr lang="en-US" sz="1050" dirty="0">
-                <a:solidFill>
-                  <a:srgbClr val="ABA6C8"/>
-                </a:solidFill>
-                <a:latin typeface="Consolas" pitchFamily="34" charset="0"/>
-                <a:ea typeface="Consolas" pitchFamily="34" charset="-122"/>
-                <a:cs typeface="Consolas" pitchFamily="34" charset="-120"/>
-              </a:rPr>
-              <a:t xml:space="preserve"> </a:t>
-            </a:r>
-            <a:pPr indent="0" marL="0">
-              <a:lnSpc>
-                <a:spcPct val="100000"/>
-              </a:lnSpc>
-              <a:buNone/>
-            </a:pPr>
-            <a:r>
-              <a:rPr lang="en-US" sz="1050" dirty="0">
-                <a:solidFill>
-                  <a:srgbClr val="ABA6C8"/>
-                </a:solidFill>
-                <a:latin typeface="Consolas" pitchFamily="34" charset="0"/>
-                <a:ea typeface="Consolas" pitchFamily="34" charset="-122"/>
-                <a:cs typeface="Consolas" pitchFamily="34" charset="-120"/>
-              </a:rPr>
-              <a:t>}</a:t>
-            </a:r>
-            <a:pPr indent="0" marL="0">
-              <a:lnSpc>
-                <a:spcPct val="100000"/>
-              </a:lnSpc>
-              <a:buNone/>
-            </a:pPr>
-            <a:r>
-              <a:rPr lang="en-US" sz="1050" dirty="0">
-                <a:solidFill>
-                  <a:srgbClr val="ABA6C8"/>
-                </a:solidFill>
-                <a:latin typeface="Consolas" pitchFamily="34" charset="0"/>
-                <a:ea typeface="Consolas" pitchFamily="34" charset="-122"/>
-                <a:cs typeface="Consolas" pitchFamily="34" charset="-120"/>
-              </a:rPr>
-              <a:t>,</a:t>
-            </a:r>
-            <a:endParaRPr lang="en-US" sz="1050" dirty="0"/>
-          </a:p>
-          <a:p>
-            <a:pPr indent="0" marL="0">
-              <a:lnSpc>
-                <a:spcPct val="100000"/>
-              </a:lnSpc>
-              <a:buNone/>
-            </a:pPr>
-            <a:r>
-              <a:rPr lang="en-US" sz="1050" dirty="0">
-                <a:solidFill>
-                  <a:srgbClr val="ABA6C8"/>
-                </a:solidFill>
-                <a:latin typeface="Consolas" pitchFamily="34" charset="0"/>
-                <a:ea typeface="Consolas" pitchFamily="34" charset="-122"/>
-                <a:cs typeface="Consolas" pitchFamily="34" charset="-120"/>
-              </a:rPr>
-              <a:t xml:space="preserve">    </a:t>
-            </a:r>
-            <a:pPr indent="0" marL="0">
-              <a:lnSpc>
-                <a:spcPct val="100000"/>
-              </a:lnSpc>
-              <a:buNone/>
-            </a:pPr>
-            <a:r>
-              <a:rPr lang="en-US" sz="1050" dirty="0">
-                <a:solidFill>
-                  <a:srgbClr val="ECE9F8"/>
-                </a:solidFill>
-                <a:latin typeface="Consolas" pitchFamily="34" charset="0"/>
-                <a:ea typeface="Consolas" pitchFamily="34" charset="-122"/>
-                <a:cs typeface="Consolas" pitchFamily="34" charset="-120"/>
-              </a:rPr>
-              <a:t>"nitro"</a:t>
-            </a:r>
-            <a:pPr indent="0" marL="0">
-              <a:lnSpc>
-                <a:spcPct val="100000"/>
-              </a:lnSpc>
-              <a:buNone/>
-            </a:pPr>
-            <a:r>
-              <a:rPr lang="en-US" sz="1050" dirty="0">
-                <a:solidFill>
-                  <a:srgbClr val="ABA6C8"/>
-                </a:solidFill>
-                <a:latin typeface="Consolas" pitchFamily="34" charset="0"/>
-                <a:ea typeface="Consolas" pitchFamily="34" charset="-122"/>
-                <a:cs typeface="Consolas" pitchFamily="34" charset="-120"/>
-              </a:rPr>
-              <a:t>:</a:t>
-            </a:r>
-            <a:pPr indent="0" marL="0">
-              <a:lnSpc>
-                <a:spcPct val="100000"/>
-              </a:lnSpc>
-              <a:buNone/>
-            </a:pPr>
-            <a:r>
-              <a:rPr lang="en-US" sz="1050" dirty="0">
-                <a:solidFill>
-                  <a:srgbClr val="ABA6C8"/>
-                </a:solidFill>
-                <a:latin typeface="Consolas" pitchFamily="34" charset="0"/>
-                <a:ea typeface="Consolas" pitchFamily="34" charset="-122"/>
-                <a:cs typeface="Consolas" pitchFamily="34" charset="-120"/>
-              </a:rPr>
-              <a:t xml:space="preserve"> </a:t>
-            </a:r>
-            <a:pPr indent="0" marL="0">
-              <a:lnSpc>
-                <a:spcPct val="100000"/>
-              </a:lnSpc>
-              <a:buNone/>
-            </a:pPr>
-            <a:r>
-              <a:rPr lang="en-US" sz="1050" dirty="0">
-                <a:solidFill>
-                  <a:srgbClr val="ABA6C8"/>
-                </a:solidFill>
-                <a:latin typeface="Consolas" pitchFamily="34" charset="0"/>
-                <a:ea typeface="Consolas" pitchFamily="34" charset="-122"/>
-                <a:cs typeface="Consolas" pitchFamily="34" charset="-120"/>
-              </a:rPr>
-              <a:t>{</a:t>
-            </a:r>
-            <a:pPr indent="0" marL="0">
-              <a:lnSpc>
-                <a:spcPct val="100000"/>
-              </a:lnSpc>
-              <a:buNone/>
-            </a:pPr>
-            <a:r>
-              <a:rPr lang="en-US" sz="1050" dirty="0">
-                <a:solidFill>
-                  <a:srgbClr val="ABA6C8"/>
-                </a:solidFill>
-                <a:latin typeface="Consolas" pitchFamily="34" charset="0"/>
-                <a:ea typeface="Consolas" pitchFamily="34" charset="-122"/>
-                <a:cs typeface="Consolas" pitchFamily="34" charset="-120"/>
-              </a:rPr>
-              <a:t xml:space="preserve"> </a:t>
-            </a:r>
-            <a:pPr indent="0" marL="0">
-              <a:lnSpc>
-                <a:spcPct val="100000"/>
-              </a:lnSpc>
-              <a:buNone/>
-            </a:pPr>
-            <a:r>
-              <a:rPr lang="en-US" sz="1050" dirty="0">
-                <a:solidFill>
-                  <a:srgbClr val="ECE9F8"/>
-                </a:solidFill>
-                <a:latin typeface="Consolas" pitchFamily="34" charset="0"/>
-                <a:ea typeface="Consolas" pitchFamily="34" charset="-122"/>
-                <a:cs typeface="Consolas" pitchFamily="34" charset="-120"/>
-              </a:rPr>
-              <a:t>"type"</a:t>
-            </a:r>
-            <a:pPr indent="0" marL="0">
-              <a:lnSpc>
-                <a:spcPct val="100000"/>
-              </a:lnSpc>
-              <a:buNone/>
-            </a:pPr>
-            <a:r>
-              <a:rPr lang="en-US" sz="1050" dirty="0">
-                <a:solidFill>
-                  <a:srgbClr val="ABA6C8"/>
-                </a:solidFill>
-                <a:latin typeface="Consolas" pitchFamily="34" charset="0"/>
-                <a:ea typeface="Consolas" pitchFamily="34" charset="-122"/>
-                <a:cs typeface="Consolas" pitchFamily="34" charset="-120"/>
-              </a:rPr>
-              <a:t>:</a:t>
-            </a:r>
-            <a:pPr indent="0" marL="0">
-              <a:lnSpc>
-                <a:spcPct val="100000"/>
-              </a:lnSpc>
-              <a:buNone/>
-            </a:pPr>
-            <a:r>
-              <a:rPr lang="en-US" sz="1050" dirty="0">
-                <a:solidFill>
-                  <a:srgbClr val="ABA6C8"/>
-                </a:solidFill>
-                <a:latin typeface="Consolas" pitchFamily="34" charset="0"/>
-                <a:ea typeface="Consolas" pitchFamily="34" charset="-122"/>
-                <a:cs typeface="Consolas" pitchFamily="34" charset="-120"/>
-              </a:rPr>
-              <a:t xml:space="preserve"> </a:t>
-            </a:r>
-            <a:pPr indent="0" marL="0">
-              <a:lnSpc>
-                <a:spcPct val="100000"/>
-              </a:lnSpc>
-              <a:buNone/>
-            </a:pPr>
-            <a:r>
-              <a:rPr lang="en-US" sz="1050" dirty="0">
-                <a:solidFill>
-                  <a:srgbClr val="FFD166"/>
-                </a:solidFill>
-                <a:latin typeface="Consolas" pitchFamily="34" charset="0"/>
-                <a:ea typeface="Consolas" pitchFamily="34" charset="-122"/>
-                <a:cs typeface="Consolas" pitchFamily="34" charset="-120"/>
-              </a:rPr>
-              <a:t>"noul"</a:t>
-            </a:r>
-            <a:pPr indent="0" marL="0">
-              <a:lnSpc>
-                <a:spcPct val="100000"/>
-              </a:lnSpc>
-              <a:buNone/>
-            </a:pPr>
-            <a:r>
-              <a:rPr lang="en-US" sz="1050" dirty="0">
-                <a:solidFill>
-                  <a:srgbClr val="ABA6C8"/>
-                </a:solidFill>
-                <a:latin typeface="Consolas" pitchFamily="34" charset="0"/>
-                <a:ea typeface="Consolas" pitchFamily="34" charset="-122"/>
-                <a:cs typeface="Consolas" pitchFamily="34" charset="-120"/>
-              </a:rPr>
-              <a:t>,</a:t>
-            </a:r>
-            <a:pPr indent="0" marL="0">
-              <a:lnSpc>
-                <a:spcPct val="100000"/>
-              </a:lnSpc>
-              <a:buNone/>
-            </a:pPr>
-            <a:r>
-              <a:rPr lang="en-US" sz="1050" dirty="0">
-                <a:solidFill>
-                  <a:srgbClr val="ABA6C8"/>
-                </a:solidFill>
-                <a:latin typeface="Consolas" pitchFamily="34" charset="0"/>
-                <a:ea typeface="Consolas" pitchFamily="34" charset="-122"/>
-                <a:cs typeface="Consolas" pitchFamily="34" charset="-120"/>
-              </a:rPr>
-              <a:t xml:space="preserve"> </a:t>
-            </a:r>
-            <a:pPr indent="0" marL="0">
-              <a:lnSpc>
-                <a:spcPct val="100000"/>
-              </a:lnSpc>
-              <a:buNone/>
-            </a:pPr>
-            <a:r>
-              <a:rPr lang="en-US" sz="1050" dirty="0">
-                <a:solidFill>
-                  <a:srgbClr val="6C6790"/>
-                </a:solidFill>
-                <a:latin typeface="Consolas" pitchFamily="34" charset="0"/>
-                <a:ea typeface="Consolas" pitchFamily="34" charset="-122"/>
-                <a:cs typeface="Consolas" pitchFamily="34" charset="-120"/>
-              </a:rPr>
-              <a:t>…</a:t>
-            </a:r>
-            <a:pPr indent="0" marL="0">
-              <a:lnSpc>
-                <a:spcPct val="100000"/>
-              </a:lnSpc>
-              <a:buNone/>
-            </a:pPr>
-            <a:r>
-              <a:rPr lang="en-US" sz="1050" dirty="0">
-                <a:solidFill>
-                  <a:srgbClr val="ABA6C8"/>
-                </a:solidFill>
-                <a:latin typeface="Consolas" pitchFamily="34" charset="0"/>
-                <a:ea typeface="Consolas" pitchFamily="34" charset="-122"/>
-                <a:cs typeface="Consolas" pitchFamily="34" charset="-120"/>
-              </a:rPr>
-              <a:t xml:space="preserve"> </a:t>
-            </a:r>
-            <a:pPr indent="0" marL="0">
-              <a:lnSpc>
-                <a:spcPct val="100000"/>
-              </a:lnSpc>
-              <a:buNone/>
-            </a:pPr>
-            <a:r>
-              <a:rPr lang="en-US" sz="1050" dirty="0">
-                <a:solidFill>
-                  <a:srgbClr val="ABA6C8"/>
-                </a:solidFill>
-                <a:latin typeface="Consolas" pitchFamily="34" charset="0"/>
-                <a:ea typeface="Consolas" pitchFamily="34" charset="-122"/>
-                <a:cs typeface="Consolas" pitchFamily="34" charset="-120"/>
-              </a:rPr>
-              <a:t>}</a:t>
-            </a:r>
-            <a:endParaRPr lang="en-US" sz="1050" dirty="0"/>
-          </a:p>
-          <a:p>
-            <a:pPr indent="0" marL="0">
-              <a:lnSpc>
-                <a:spcPct val="100000"/>
-              </a:lnSpc>
-              <a:buNone/>
-            </a:pPr>
-            <a:r>
-              <a:rPr lang="en-US" sz="1050" dirty="0">
-                <a:solidFill>
-                  <a:srgbClr val="ABA6C8"/>
-                </a:solidFill>
-                <a:latin typeface="Consolas" pitchFamily="34" charset="0"/>
-                <a:ea typeface="Consolas" pitchFamily="34" charset="-122"/>
-                <a:cs typeface="Consolas" pitchFamily="34" charset="-120"/>
-              </a:rPr>
-              <a:t xml:space="preserve">  </a:t>
-            </a:r>
-            <a:pPr indent="0" marL="0">
-              <a:lnSpc>
-                <a:spcPct val="100000"/>
-              </a:lnSpc>
-              <a:buNone/>
-            </a:pPr>
-            <a:r>
-              <a:rPr lang="en-US" sz="1050" dirty="0">
-                <a:solidFill>
-                  <a:srgbClr val="ABA6C8"/>
-                </a:solidFill>
-                <a:latin typeface="Consolas" pitchFamily="34" charset="0"/>
-                <a:ea typeface="Consolas" pitchFamily="34" charset="-122"/>
-                <a:cs typeface="Consolas" pitchFamily="34" charset="-120"/>
-              </a:rPr>
-              <a:t>}</a:t>
-            </a:r>
-            <a:endParaRPr lang="en-US" sz="1050" dirty="0"/>
-          </a:p>
-          <a:p>
-            <a:pPr indent="0" marL="0">
-              <a:lnSpc>
-                <a:spcPct val="100000"/>
-              </a:lnSpc>
-              <a:buNone/>
-            </a:pPr>
-            <a:r>
-              <a:rPr lang="en-US" sz="1050" dirty="0">
-                <a:solidFill>
-                  <a:srgbClr val="ABA6C8"/>
-                </a:solidFill>
-                <a:latin typeface="Consolas" pitchFamily="34" charset="0"/>
-                <a:ea typeface="Consolas" pitchFamily="34" charset="-122"/>
-                <a:cs typeface="Consolas" pitchFamily="34" charset="-120"/>
-              </a:rPr>
-              <a:t>}</a:t>
-            </a:r>
-            <a:endParaRPr lang="en-US" sz="1050" dirty="0"/>
-          </a:p>
-        </p:txBody>
-      </p:sp>
-      <p:sp>
-        <p:nvSpPr>
-          <p:cNvPr id="12" name="Text 10"/>
-          <p:cNvSpPr/>
-          <p:nvPr/>
-        </p:nvSpPr>
-        <p:spPr>
-          <a:xfrm>
-            <a:off x="4526280" y="2350008"/>
-            <a:ext cx="3886200" cy="1691640"/>
-          </a:xfrm>
-          <a:prstGeom prst="rect">
-            <a:avLst/>
-          </a:prstGeom>
-          <a:noFill/>
-          <a:ln/>
-        </p:spPr>
-        <p:txBody>
-          <a:bodyPr wrap="square" lIns="0" tIns="0" rIns="0" bIns="0" rtlCol="0" anchor="t"/>
-          <a:lstStyle/>
-          <a:p>
-            <a:pPr indent="0" marL="0">
-              <a:lnSpc>
-                <a:spcPct val="100000"/>
-              </a:lnSpc>
-              <a:buNone/>
-            </a:pPr>
-            <a:r>
-              <a:rPr lang="en-US" sz="1050" dirty="0">
-                <a:solidFill>
-                  <a:srgbClr val="4ADE80"/>
-                </a:solidFill>
-                <a:latin typeface="Consolas" pitchFamily="34" charset="0"/>
-                <a:ea typeface="Consolas" pitchFamily="34" charset="-122"/>
-                <a:cs typeface="Consolas" pitchFamily="34" charset="-120"/>
-              </a:rPr>
-              <a:t>200 OK</a:t>
-            </a:r>
-            <a:endParaRPr lang="en-US" sz="1050" dirty="0"/>
-          </a:p>
-          <a:p>
-            <a:pPr indent="0" marL="0">
-              <a:lnSpc>
-                <a:spcPct val="100000"/>
-              </a:lnSpc>
-              <a:buNone/>
-            </a:pPr>
-            <a:r>
-              <a:rPr lang="en-US" sz="1050" dirty="0">
-                <a:solidFill>
-                  <a:srgbClr val="ABA6C8"/>
-                </a:solidFill>
-                <a:latin typeface="Consolas" pitchFamily="34" charset="0"/>
-                <a:ea typeface="Consolas" pitchFamily="34" charset="-122"/>
-                <a:cs typeface="Consolas" pitchFamily="34" charset="-120"/>
-              </a:rPr>
-              <a:t>{</a:t>
-            </a:r>
-            <a:endParaRPr lang="en-US" sz="1050" dirty="0"/>
-          </a:p>
-          <a:p>
-            <a:pPr indent="0" marL="0">
-              <a:lnSpc>
-                <a:spcPct val="100000"/>
-              </a:lnSpc>
-              <a:buNone/>
-            </a:pPr>
-            <a:r>
-              <a:rPr lang="en-US" sz="1050" dirty="0">
-                <a:solidFill>
-                  <a:srgbClr val="ABA6C8"/>
-                </a:solidFill>
-                <a:latin typeface="Consolas" pitchFamily="34" charset="0"/>
-                <a:ea typeface="Consolas" pitchFamily="34" charset="-122"/>
-                <a:cs typeface="Consolas" pitchFamily="34" charset="-120"/>
-              </a:rPr>
-              <a:t xml:space="preserve">  </a:t>
-            </a:r>
-            <a:pPr indent="0" marL="0">
-              <a:lnSpc>
-                <a:spcPct val="100000"/>
-              </a:lnSpc>
-              <a:buNone/>
-            </a:pPr>
-            <a:r>
-              <a:rPr lang="en-US" sz="1050" dirty="0">
-                <a:solidFill>
-                  <a:srgbClr val="ECE9F8"/>
-                </a:solidFill>
-                <a:latin typeface="Consolas" pitchFamily="34" charset="0"/>
-                <a:ea typeface="Consolas" pitchFamily="34" charset="-122"/>
-                <a:cs typeface="Consolas" pitchFamily="34" charset="-120"/>
-              </a:rPr>
-              <a:t>"model"</a:t>
-            </a:r>
-            <a:pPr indent="0" marL="0">
-              <a:lnSpc>
-                <a:spcPct val="100000"/>
-              </a:lnSpc>
-              <a:buNone/>
-            </a:pPr>
-            <a:r>
-              <a:rPr lang="en-US" sz="1050" dirty="0">
-                <a:solidFill>
-                  <a:srgbClr val="ABA6C8"/>
-                </a:solidFill>
-                <a:latin typeface="Consolas" pitchFamily="34" charset="0"/>
-                <a:ea typeface="Consolas" pitchFamily="34" charset="-122"/>
-                <a:cs typeface="Consolas" pitchFamily="34" charset="-120"/>
-              </a:rPr>
-              <a:t>:</a:t>
-            </a:r>
-            <a:pPr indent="0" marL="0">
-              <a:lnSpc>
-                <a:spcPct val="100000"/>
-              </a:lnSpc>
-              <a:buNone/>
-            </a:pPr>
-            <a:r>
-              <a:rPr lang="en-US" sz="1050" dirty="0">
-                <a:solidFill>
-                  <a:srgbClr val="ABA6C8"/>
-                </a:solidFill>
-                <a:latin typeface="Consolas" pitchFamily="34" charset="0"/>
-                <a:ea typeface="Consolas" pitchFamily="34" charset="-122"/>
-                <a:cs typeface="Consolas" pitchFamily="34" charset="-120"/>
-              </a:rPr>
-              <a:t xml:space="preserve"> </a:t>
-            </a:r>
-            <a:pPr indent="0" marL="0">
-              <a:lnSpc>
-                <a:spcPct val="100000"/>
-              </a:lnSpc>
-              <a:buNone/>
-            </a:pPr>
-            <a:r>
-              <a:rPr lang="en-US" sz="1050" dirty="0">
-                <a:solidFill>
-                  <a:srgbClr val="FFD166"/>
-                </a:solidFill>
-                <a:latin typeface="Consolas" pitchFamily="34" charset="0"/>
-                <a:ea typeface="Consolas" pitchFamily="34" charset="-122"/>
-                <a:cs typeface="Consolas" pitchFamily="34" charset="-120"/>
-              </a:rPr>
-              <a:t>"microsoft-decision-1"</a:t>
-            </a:r>
-            <a:pPr indent="0" marL="0">
-              <a:lnSpc>
-                <a:spcPct val="100000"/>
-              </a:lnSpc>
-              <a:buNone/>
-            </a:pPr>
-            <a:r>
-              <a:rPr lang="en-US" sz="1050" dirty="0">
-                <a:solidFill>
-                  <a:srgbClr val="ABA6C8"/>
-                </a:solidFill>
-                <a:latin typeface="Consolas" pitchFamily="34" charset="0"/>
-                <a:ea typeface="Consolas" pitchFamily="34" charset="-122"/>
-                <a:cs typeface="Consolas" pitchFamily="34" charset="-120"/>
-              </a:rPr>
-              <a:t>,</a:t>
-            </a:r>
-            <a:endParaRPr lang="en-US" sz="1050" dirty="0"/>
-          </a:p>
-          <a:p>
-            <a:pPr indent="0" marL="0">
-              <a:lnSpc>
-                <a:spcPct val="100000"/>
-              </a:lnSpc>
-              <a:buNone/>
-            </a:pPr>
-            <a:r>
-              <a:rPr lang="en-US" sz="1050" dirty="0">
-                <a:solidFill>
-                  <a:srgbClr val="ABA6C8"/>
-                </a:solidFill>
-                <a:latin typeface="Consolas" pitchFamily="34" charset="0"/>
-                <a:ea typeface="Consolas" pitchFamily="34" charset="-122"/>
-                <a:cs typeface="Consolas" pitchFamily="34" charset="-120"/>
-              </a:rPr>
-              <a:t xml:space="preserve">  </a:t>
-            </a:r>
-            <a:pPr indent="0" marL="0">
-              <a:lnSpc>
-                <a:spcPct val="100000"/>
-              </a:lnSpc>
-              <a:buNone/>
-            </a:pPr>
-            <a:r>
-              <a:rPr lang="en-US" sz="1050" dirty="0">
-                <a:solidFill>
-                  <a:srgbClr val="ECE9F8"/>
-                </a:solidFill>
-                <a:latin typeface="Consolas" pitchFamily="34" charset="0"/>
-                <a:ea typeface="Consolas" pitchFamily="34" charset="-122"/>
-                <a:cs typeface="Consolas" pitchFamily="34" charset="-120"/>
-              </a:rPr>
-              <a:t>"answers"</a:t>
-            </a:r>
-            <a:pPr indent="0" marL="0">
-              <a:lnSpc>
-                <a:spcPct val="100000"/>
-              </a:lnSpc>
-              <a:buNone/>
-            </a:pPr>
-            <a:r>
-              <a:rPr lang="en-US" sz="1050" dirty="0">
-                <a:solidFill>
-                  <a:srgbClr val="ABA6C8"/>
-                </a:solidFill>
-                <a:latin typeface="Consolas" pitchFamily="34" charset="0"/>
-                <a:ea typeface="Consolas" pitchFamily="34" charset="-122"/>
-                <a:cs typeface="Consolas" pitchFamily="34" charset="-120"/>
-              </a:rPr>
-              <a:t>:</a:t>
-            </a:r>
-            <a:pPr indent="0" marL="0">
-              <a:lnSpc>
-                <a:spcPct val="100000"/>
-              </a:lnSpc>
-              <a:buNone/>
-            </a:pPr>
-            <a:r>
-              <a:rPr lang="en-US" sz="1050" dirty="0">
-                <a:solidFill>
-                  <a:srgbClr val="ABA6C8"/>
-                </a:solidFill>
-                <a:latin typeface="Consolas" pitchFamily="34" charset="0"/>
-                <a:ea typeface="Consolas" pitchFamily="34" charset="-122"/>
-                <a:cs typeface="Consolas" pitchFamily="34" charset="-120"/>
-              </a:rPr>
-              <a:t xml:space="preserve"> </a:t>
-            </a:r>
-            <a:pPr indent="0" marL="0">
-              <a:lnSpc>
-                <a:spcPct val="100000"/>
-              </a:lnSpc>
-              <a:buNone/>
-            </a:pPr>
-            <a:r>
-              <a:rPr lang="en-US" sz="1050" dirty="0">
-                <a:solidFill>
-                  <a:srgbClr val="ABA6C8"/>
-                </a:solidFill>
-                <a:latin typeface="Consolas" pitchFamily="34" charset="0"/>
-                <a:ea typeface="Consolas" pitchFamily="34" charset="-122"/>
-                <a:cs typeface="Consolas" pitchFamily="34" charset="-120"/>
-              </a:rPr>
-              <a:t>{</a:t>
-            </a:r>
-            <a:endParaRPr lang="en-US" sz="1050" dirty="0"/>
-          </a:p>
-          <a:p>
-            <a:pPr indent="0" marL="0">
-              <a:lnSpc>
-                <a:spcPct val="100000"/>
-              </a:lnSpc>
-              <a:buNone/>
-            </a:pPr>
-            <a:r>
-              <a:rPr lang="en-US" sz="1050" dirty="0">
-                <a:solidFill>
-                  <a:srgbClr val="ABA6C8"/>
-                </a:solidFill>
-                <a:latin typeface="Consolas" pitchFamily="34" charset="0"/>
-                <a:ea typeface="Consolas" pitchFamily="34" charset="-122"/>
-                <a:cs typeface="Consolas" pitchFamily="34" charset="-120"/>
-              </a:rPr>
-              <a:t xml:space="preserve">    </a:t>
-            </a:r>
-            <a:pPr indent="0" marL="0">
-              <a:lnSpc>
-                <a:spcPct val="100000"/>
-              </a:lnSpc>
-              <a:buNone/>
-            </a:pPr>
-            <a:r>
-              <a:rPr lang="en-US" sz="1050" dirty="0">
-                <a:solidFill>
-                  <a:srgbClr val="ECE9F8"/>
-                </a:solidFill>
-                <a:latin typeface="Consolas" pitchFamily="34" charset="0"/>
-                <a:ea typeface="Consolas" pitchFamily="34" charset="-122"/>
-                <a:cs typeface="Consolas" pitchFamily="34" charset="-120"/>
-              </a:rPr>
-              <a:t>"maneuver"</a:t>
-            </a:r>
-            <a:pPr indent="0" marL="0">
-              <a:lnSpc>
-                <a:spcPct val="100000"/>
-              </a:lnSpc>
-              <a:buNone/>
-            </a:pPr>
-            <a:r>
-              <a:rPr lang="en-US" sz="1050" dirty="0">
-                <a:solidFill>
-                  <a:srgbClr val="ABA6C8"/>
-                </a:solidFill>
-                <a:latin typeface="Consolas" pitchFamily="34" charset="0"/>
-                <a:ea typeface="Consolas" pitchFamily="34" charset="-122"/>
-                <a:cs typeface="Consolas" pitchFamily="34" charset="-120"/>
-              </a:rPr>
-              <a:t>:</a:t>
-            </a:r>
-            <a:pPr indent="0" marL="0">
-              <a:lnSpc>
-                <a:spcPct val="100000"/>
-              </a:lnSpc>
-              <a:buNone/>
-            </a:pPr>
-            <a:r>
-              <a:rPr lang="en-US" sz="1050" dirty="0">
-                <a:solidFill>
-                  <a:srgbClr val="ABA6C8"/>
-                </a:solidFill>
-                <a:latin typeface="Consolas" pitchFamily="34" charset="0"/>
-                <a:ea typeface="Consolas" pitchFamily="34" charset="-122"/>
-                <a:cs typeface="Consolas" pitchFamily="34" charset="-120"/>
-              </a:rPr>
-              <a:t xml:space="preserve"> </a:t>
-            </a:r>
-            <a:pPr indent="0" marL="0">
-              <a:lnSpc>
-                <a:spcPct val="100000"/>
-              </a:lnSpc>
-              <a:buNone/>
-            </a:pPr>
-            <a:r>
-              <a:rPr lang="en-US" sz="1050" dirty="0">
-                <a:solidFill>
-                  <a:srgbClr val="ABA6C8"/>
-                </a:solidFill>
-                <a:latin typeface="Consolas" pitchFamily="34" charset="0"/>
-                <a:ea typeface="Consolas" pitchFamily="34" charset="-122"/>
-                <a:cs typeface="Consolas" pitchFamily="34" charset="-120"/>
-              </a:rPr>
-              <a:t>{</a:t>
-            </a:r>
-            <a:pPr indent="0" marL="0">
-              <a:lnSpc>
-                <a:spcPct val="100000"/>
-              </a:lnSpc>
-              <a:buNone/>
-            </a:pPr>
-            <a:r>
-              <a:rPr lang="en-US" sz="1050" dirty="0">
-                <a:solidFill>
-                  <a:srgbClr val="ABA6C8"/>
-                </a:solidFill>
-                <a:latin typeface="Consolas" pitchFamily="34" charset="0"/>
-                <a:ea typeface="Consolas" pitchFamily="34" charset="-122"/>
-                <a:cs typeface="Consolas" pitchFamily="34" charset="-120"/>
-              </a:rPr>
-              <a:t xml:space="preserve"> </a:t>
-            </a:r>
-            <a:pPr indent="0" marL="0">
-              <a:lnSpc>
-                <a:spcPct val="100000"/>
-              </a:lnSpc>
-              <a:buNone/>
-            </a:pPr>
-            <a:r>
-              <a:rPr lang="en-US" sz="1050" dirty="0">
-                <a:solidFill>
-                  <a:srgbClr val="ECE9F8"/>
-                </a:solidFill>
-                <a:latin typeface="Consolas" pitchFamily="34" charset="0"/>
-                <a:ea typeface="Consolas" pitchFamily="34" charset="-122"/>
-                <a:cs typeface="Consolas" pitchFamily="34" charset="-120"/>
-              </a:rPr>
-              <a:t>"choice"</a:t>
-            </a:r>
-            <a:pPr indent="0" marL="0">
-              <a:lnSpc>
-                <a:spcPct val="100000"/>
-              </a:lnSpc>
-              <a:buNone/>
-            </a:pPr>
-            <a:r>
-              <a:rPr lang="en-US" sz="1050" dirty="0">
-                <a:solidFill>
-                  <a:srgbClr val="ABA6C8"/>
-                </a:solidFill>
-                <a:latin typeface="Consolas" pitchFamily="34" charset="0"/>
-                <a:ea typeface="Consolas" pitchFamily="34" charset="-122"/>
-                <a:cs typeface="Consolas" pitchFamily="34" charset="-120"/>
-              </a:rPr>
-              <a:t>:</a:t>
-            </a:r>
-            <a:pPr indent="0" marL="0">
-              <a:lnSpc>
-                <a:spcPct val="100000"/>
-              </a:lnSpc>
-              <a:buNone/>
-            </a:pPr>
-            <a:r>
-              <a:rPr lang="en-US" sz="1050" dirty="0">
-                <a:solidFill>
-                  <a:srgbClr val="ABA6C8"/>
-                </a:solidFill>
-                <a:latin typeface="Consolas" pitchFamily="34" charset="0"/>
-                <a:ea typeface="Consolas" pitchFamily="34" charset="-122"/>
-                <a:cs typeface="Consolas" pitchFamily="34" charset="-120"/>
-              </a:rPr>
-              <a:t xml:space="preserve"> </a:t>
-            </a:r>
-            <a:pPr indent="0" marL="0">
-              <a:lnSpc>
-                <a:spcPct val="100000"/>
-              </a:lnSpc>
-              <a:buNone/>
-            </a:pPr>
-            <a:r>
-              <a:rPr lang="en-US" sz="1050" dirty="0">
-                <a:solidFill>
-                  <a:srgbClr val="FFD166"/>
-                </a:solidFill>
-                <a:latin typeface="Consolas" pitchFamily="34" charset="0"/>
-                <a:ea typeface="Consolas" pitchFamily="34" charset="-122"/>
-                <a:cs typeface="Consolas" pitchFamily="34" charset="-120"/>
-              </a:rPr>
-              <a:t>"…"</a:t>
-            </a:r>
-            <a:pPr indent="0" marL="0">
-              <a:lnSpc>
-                <a:spcPct val="100000"/>
-              </a:lnSpc>
-              <a:buNone/>
-            </a:pPr>
-            <a:r>
-              <a:rPr lang="en-US" sz="1050" dirty="0">
-                <a:solidFill>
-                  <a:srgbClr val="ABA6C8"/>
-                </a:solidFill>
-                <a:latin typeface="Consolas" pitchFamily="34" charset="0"/>
-                <a:ea typeface="Consolas" pitchFamily="34" charset="-122"/>
-                <a:cs typeface="Consolas" pitchFamily="34" charset="-120"/>
-              </a:rPr>
-              <a:t>,</a:t>
-            </a:r>
-            <a:pPr indent="0" marL="0">
-              <a:lnSpc>
-                <a:spcPct val="100000"/>
-              </a:lnSpc>
-              <a:buNone/>
-            </a:pPr>
-            <a:r>
-              <a:rPr lang="en-US" sz="1050" dirty="0">
-                <a:solidFill>
-                  <a:srgbClr val="ABA6C8"/>
-                </a:solidFill>
-                <a:latin typeface="Consolas" pitchFamily="34" charset="0"/>
-                <a:ea typeface="Consolas" pitchFamily="34" charset="-122"/>
-                <a:cs typeface="Consolas" pitchFamily="34" charset="-120"/>
-              </a:rPr>
-              <a:t xml:space="preserve"> </a:t>
-            </a:r>
-            <a:pPr indent="0" marL="0">
-              <a:lnSpc>
-                <a:spcPct val="100000"/>
-              </a:lnSpc>
-              <a:buNone/>
-            </a:pPr>
-            <a:r>
-              <a:rPr lang="en-US" sz="1050" dirty="0">
-                <a:solidFill>
-                  <a:srgbClr val="6C6790"/>
-                </a:solidFill>
-                <a:latin typeface="Consolas" pitchFamily="34" charset="0"/>
-                <a:ea typeface="Consolas" pitchFamily="34" charset="-122"/>
-                <a:cs typeface="Consolas" pitchFamily="34" charset="-120"/>
-              </a:rPr>
-              <a:t>…</a:t>
-            </a:r>
-            <a:pPr indent="0" marL="0">
-              <a:lnSpc>
-                <a:spcPct val="100000"/>
-              </a:lnSpc>
-              <a:buNone/>
-            </a:pPr>
-            <a:r>
-              <a:rPr lang="en-US" sz="1050" dirty="0">
-                <a:solidFill>
-                  <a:srgbClr val="ABA6C8"/>
-                </a:solidFill>
-                <a:latin typeface="Consolas" pitchFamily="34" charset="0"/>
-                <a:ea typeface="Consolas" pitchFamily="34" charset="-122"/>
-                <a:cs typeface="Consolas" pitchFamily="34" charset="-120"/>
-              </a:rPr>
-              <a:t xml:space="preserve"> </a:t>
-            </a:r>
-            <a:pPr indent="0" marL="0">
-              <a:lnSpc>
-                <a:spcPct val="100000"/>
-              </a:lnSpc>
-              <a:buNone/>
-            </a:pPr>
-            <a:r>
-              <a:rPr lang="en-US" sz="1050" dirty="0">
-                <a:solidFill>
-                  <a:srgbClr val="ABA6C8"/>
-                </a:solidFill>
-                <a:latin typeface="Consolas" pitchFamily="34" charset="0"/>
-                <a:ea typeface="Consolas" pitchFamily="34" charset="-122"/>
-                <a:cs typeface="Consolas" pitchFamily="34" charset="-120"/>
-              </a:rPr>
-              <a:t>}</a:t>
-            </a:r>
-            <a:pPr indent="0" marL="0">
-              <a:lnSpc>
-                <a:spcPct val="100000"/>
-              </a:lnSpc>
-              <a:buNone/>
-            </a:pPr>
-            <a:r>
-              <a:rPr lang="en-US" sz="1050" dirty="0">
-                <a:solidFill>
-                  <a:srgbClr val="ABA6C8"/>
-                </a:solidFill>
-                <a:latin typeface="Consolas" pitchFamily="34" charset="0"/>
-                <a:ea typeface="Consolas" pitchFamily="34" charset="-122"/>
-                <a:cs typeface="Consolas" pitchFamily="34" charset="-120"/>
-              </a:rPr>
-              <a:t>,</a:t>
-            </a:r>
-            <a:endParaRPr lang="en-US" sz="1050" dirty="0"/>
-          </a:p>
-          <a:p>
-            <a:pPr indent="0" marL="0">
-              <a:lnSpc>
-                <a:spcPct val="100000"/>
-              </a:lnSpc>
-              <a:buNone/>
-            </a:pPr>
-            <a:r>
-              <a:rPr lang="en-US" sz="1050" dirty="0">
-                <a:solidFill>
-                  <a:srgbClr val="ABA6C8"/>
-                </a:solidFill>
-                <a:latin typeface="Consolas" pitchFamily="34" charset="0"/>
-                <a:ea typeface="Consolas" pitchFamily="34" charset="-122"/>
-                <a:cs typeface="Consolas" pitchFamily="34" charset="-120"/>
-              </a:rPr>
-              <a:t xml:space="preserve">    </a:t>
-            </a:r>
-            <a:pPr indent="0" marL="0">
-              <a:lnSpc>
-                <a:spcPct val="100000"/>
-              </a:lnSpc>
-              <a:buNone/>
-            </a:pPr>
-            <a:r>
-              <a:rPr lang="en-US" sz="1050" dirty="0">
-                <a:solidFill>
-                  <a:srgbClr val="ECE9F8"/>
-                </a:solidFill>
-                <a:latin typeface="Consolas" pitchFamily="34" charset="0"/>
-                <a:ea typeface="Consolas" pitchFamily="34" charset="-122"/>
-                <a:cs typeface="Consolas" pitchFamily="34" charset="-120"/>
-              </a:rPr>
-              <a:t>"pace"</a:t>
-            </a:r>
-            <a:pPr indent="0" marL="0">
-              <a:lnSpc>
-                <a:spcPct val="100000"/>
-              </a:lnSpc>
-              <a:buNone/>
-            </a:pPr>
-            <a:r>
-              <a:rPr lang="en-US" sz="1050" dirty="0">
-                <a:solidFill>
-                  <a:srgbClr val="ABA6C8"/>
-                </a:solidFill>
-                <a:latin typeface="Consolas" pitchFamily="34" charset="0"/>
-                <a:ea typeface="Consolas" pitchFamily="34" charset="-122"/>
-                <a:cs typeface="Consolas" pitchFamily="34" charset="-120"/>
-              </a:rPr>
-              <a:t>:</a:t>
-            </a:r>
-            <a:pPr indent="0" marL="0">
-              <a:lnSpc>
-                <a:spcPct val="100000"/>
-              </a:lnSpc>
-              <a:buNone/>
-            </a:pPr>
-            <a:r>
-              <a:rPr lang="en-US" sz="1050" dirty="0">
-                <a:solidFill>
-                  <a:srgbClr val="ABA6C8"/>
-                </a:solidFill>
-                <a:latin typeface="Consolas" pitchFamily="34" charset="0"/>
-                <a:ea typeface="Consolas" pitchFamily="34" charset="-122"/>
-                <a:cs typeface="Consolas" pitchFamily="34" charset="-120"/>
-              </a:rPr>
-              <a:t xml:space="preserve"> </a:t>
-            </a:r>
-            <a:pPr indent="0" marL="0">
-              <a:lnSpc>
-                <a:spcPct val="100000"/>
-              </a:lnSpc>
-              <a:buNone/>
-            </a:pPr>
-            <a:r>
-              <a:rPr lang="en-US" sz="1050" dirty="0">
-                <a:solidFill>
-                  <a:srgbClr val="ABA6C8"/>
-                </a:solidFill>
-                <a:latin typeface="Consolas" pitchFamily="34" charset="0"/>
-                <a:ea typeface="Consolas" pitchFamily="34" charset="-122"/>
-                <a:cs typeface="Consolas" pitchFamily="34" charset="-120"/>
-              </a:rPr>
-              <a:t>{</a:t>
-            </a:r>
-            <a:pPr indent="0" marL="0">
-              <a:lnSpc>
-                <a:spcPct val="100000"/>
-              </a:lnSpc>
-              <a:buNone/>
-            </a:pPr>
-            <a:r>
-              <a:rPr lang="en-US" sz="1050" dirty="0">
-                <a:solidFill>
-                  <a:srgbClr val="ABA6C8"/>
-                </a:solidFill>
-                <a:latin typeface="Consolas" pitchFamily="34" charset="0"/>
-                <a:ea typeface="Consolas" pitchFamily="34" charset="-122"/>
-                <a:cs typeface="Consolas" pitchFamily="34" charset="-120"/>
-              </a:rPr>
-              <a:t xml:space="preserve"> </a:t>
-            </a:r>
-            <a:pPr indent="0" marL="0">
-              <a:lnSpc>
-                <a:spcPct val="100000"/>
-              </a:lnSpc>
-              <a:buNone/>
-            </a:pPr>
-            <a:r>
-              <a:rPr lang="en-US" sz="1050" dirty="0">
-                <a:solidFill>
-                  <a:srgbClr val="ECE9F8"/>
-                </a:solidFill>
-                <a:latin typeface="Consolas" pitchFamily="34" charset="0"/>
-                <a:ea typeface="Consolas" pitchFamily="34" charset="-122"/>
-                <a:cs typeface="Consolas" pitchFamily="34" charset="-120"/>
-              </a:rPr>
-              <a:t>"score"</a:t>
-            </a:r>
-            <a:pPr indent="0" marL="0">
-              <a:lnSpc>
-                <a:spcPct val="100000"/>
-              </a:lnSpc>
-              <a:buNone/>
-            </a:pPr>
-            <a:r>
-              <a:rPr lang="en-US" sz="1050" dirty="0">
-                <a:solidFill>
-                  <a:srgbClr val="ABA6C8"/>
-                </a:solidFill>
-                <a:latin typeface="Consolas" pitchFamily="34" charset="0"/>
-                <a:ea typeface="Consolas" pitchFamily="34" charset="-122"/>
-                <a:cs typeface="Consolas" pitchFamily="34" charset="-120"/>
-              </a:rPr>
-              <a:t>:</a:t>
-            </a:r>
-            <a:pPr indent="0" marL="0">
-              <a:lnSpc>
-                <a:spcPct val="100000"/>
-              </a:lnSpc>
-              <a:buNone/>
-            </a:pPr>
-            <a:r>
-              <a:rPr lang="en-US" sz="1050" dirty="0">
-                <a:solidFill>
-                  <a:srgbClr val="ABA6C8"/>
-                </a:solidFill>
-                <a:latin typeface="Consolas" pitchFamily="34" charset="0"/>
-                <a:ea typeface="Consolas" pitchFamily="34" charset="-122"/>
-                <a:cs typeface="Consolas" pitchFamily="34" charset="-120"/>
-              </a:rPr>
-              <a:t xml:space="preserve"> </a:t>
-            </a:r>
-            <a:pPr indent="0" marL="0">
-              <a:lnSpc>
-                <a:spcPct val="100000"/>
-              </a:lnSpc>
-              <a:buNone/>
-            </a:pPr>
-            <a:r>
-              <a:rPr lang="en-US" sz="1050" dirty="0">
-                <a:solidFill>
-                  <a:srgbClr val="6C6790"/>
-                </a:solidFill>
-                <a:latin typeface="Consolas" pitchFamily="34" charset="0"/>
-                <a:ea typeface="Consolas" pitchFamily="34" charset="-122"/>
-                <a:cs typeface="Consolas" pitchFamily="34" charset="-120"/>
-              </a:rPr>
-              <a:t>…</a:t>
-            </a:r>
-            <a:pPr indent="0" marL="0">
-              <a:lnSpc>
-                <a:spcPct val="100000"/>
-              </a:lnSpc>
-              <a:buNone/>
-            </a:pPr>
-            <a:r>
-              <a:rPr lang="en-US" sz="1050" dirty="0">
-                <a:solidFill>
-                  <a:srgbClr val="ABA6C8"/>
-                </a:solidFill>
-                <a:latin typeface="Consolas" pitchFamily="34" charset="0"/>
-                <a:ea typeface="Consolas" pitchFamily="34" charset="-122"/>
-                <a:cs typeface="Consolas" pitchFamily="34" charset="-120"/>
-              </a:rPr>
-              <a:t>,</a:t>
-            </a:r>
-            <a:pPr indent="0" marL="0">
-              <a:lnSpc>
-                <a:spcPct val="100000"/>
-              </a:lnSpc>
-              <a:buNone/>
-            </a:pPr>
-            <a:r>
-              <a:rPr lang="en-US" sz="1050" dirty="0">
-                <a:solidFill>
-                  <a:srgbClr val="ABA6C8"/>
-                </a:solidFill>
-                <a:latin typeface="Consolas" pitchFamily="34" charset="0"/>
-                <a:ea typeface="Consolas" pitchFamily="34" charset="-122"/>
-                <a:cs typeface="Consolas" pitchFamily="34" charset="-120"/>
-              </a:rPr>
-              <a:t xml:space="preserve"> </a:t>
-            </a:r>
-            <a:pPr indent="0" marL="0">
-              <a:lnSpc>
-                <a:spcPct val="100000"/>
-              </a:lnSpc>
-              <a:buNone/>
-            </a:pPr>
-            <a:r>
-              <a:rPr lang="en-US" sz="1050" dirty="0">
-                <a:solidFill>
-                  <a:srgbClr val="6C6790"/>
-                </a:solidFill>
-                <a:latin typeface="Consolas" pitchFamily="34" charset="0"/>
-                <a:ea typeface="Consolas" pitchFamily="34" charset="-122"/>
-                <a:cs typeface="Consolas" pitchFamily="34" charset="-120"/>
-              </a:rPr>
-              <a:t>…</a:t>
-            </a:r>
-            <a:pPr indent="0" marL="0">
-              <a:lnSpc>
-                <a:spcPct val="100000"/>
-              </a:lnSpc>
-              <a:buNone/>
-            </a:pPr>
-            <a:r>
-              <a:rPr lang="en-US" sz="1050" dirty="0">
-                <a:solidFill>
-                  <a:srgbClr val="ABA6C8"/>
-                </a:solidFill>
-                <a:latin typeface="Consolas" pitchFamily="34" charset="0"/>
-                <a:ea typeface="Consolas" pitchFamily="34" charset="-122"/>
-                <a:cs typeface="Consolas" pitchFamily="34" charset="-120"/>
-              </a:rPr>
-              <a:t xml:space="preserve"> </a:t>
-            </a:r>
-            <a:pPr indent="0" marL="0">
-              <a:lnSpc>
-                <a:spcPct val="100000"/>
-              </a:lnSpc>
-              <a:buNone/>
-            </a:pPr>
-            <a:r>
-              <a:rPr lang="en-US" sz="1050" dirty="0">
-                <a:solidFill>
-                  <a:srgbClr val="ABA6C8"/>
-                </a:solidFill>
-                <a:latin typeface="Consolas" pitchFamily="34" charset="0"/>
-                <a:ea typeface="Consolas" pitchFamily="34" charset="-122"/>
-                <a:cs typeface="Consolas" pitchFamily="34" charset="-120"/>
-              </a:rPr>
-              <a:t>}</a:t>
-            </a:r>
-            <a:pPr indent="0" marL="0">
-              <a:lnSpc>
-                <a:spcPct val="100000"/>
-              </a:lnSpc>
-              <a:buNone/>
-            </a:pPr>
-            <a:r>
-              <a:rPr lang="en-US" sz="1050" dirty="0">
-                <a:solidFill>
-                  <a:srgbClr val="ABA6C8"/>
-                </a:solidFill>
-                <a:latin typeface="Consolas" pitchFamily="34" charset="0"/>
-                <a:ea typeface="Consolas" pitchFamily="34" charset="-122"/>
-                <a:cs typeface="Consolas" pitchFamily="34" charset="-120"/>
-              </a:rPr>
-              <a:t>,</a:t>
-            </a:r>
-            <a:endParaRPr lang="en-US" sz="1050" dirty="0"/>
-          </a:p>
-          <a:p>
-            <a:pPr indent="0" marL="0">
-              <a:lnSpc>
-                <a:spcPct val="100000"/>
-              </a:lnSpc>
-              <a:buNone/>
-            </a:pPr>
-            <a:r>
-              <a:rPr lang="en-US" sz="1050" dirty="0">
-                <a:solidFill>
-                  <a:srgbClr val="ABA6C8"/>
-                </a:solidFill>
-                <a:latin typeface="Consolas" pitchFamily="34" charset="0"/>
-                <a:ea typeface="Consolas" pitchFamily="34" charset="-122"/>
-                <a:cs typeface="Consolas" pitchFamily="34" charset="-120"/>
-              </a:rPr>
-              <a:t xml:space="preserve">    </a:t>
-            </a:r>
-            <a:pPr indent="0" marL="0">
-              <a:lnSpc>
-                <a:spcPct val="100000"/>
-              </a:lnSpc>
-              <a:buNone/>
-            </a:pPr>
-            <a:r>
-              <a:rPr lang="en-US" sz="1050" dirty="0">
-                <a:solidFill>
-                  <a:srgbClr val="ECE9F8"/>
-                </a:solidFill>
-                <a:latin typeface="Consolas" pitchFamily="34" charset="0"/>
-                <a:ea typeface="Consolas" pitchFamily="34" charset="-122"/>
-                <a:cs typeface="Consolas" pitchFamily="34" charset="-120"/>
-              </a:rPr>
-              <a:t>"nitro"</a:t>
-            </a:r>
-            <a:pPr indent="0" marL="0">
-              <a:lnSpc>
-                <a:spcPct val="100000"/>
-              </a:lnSpc>
-              <a:buNone/>
-            </a:pPr>
-            <a:r>
-              <a:rPr lang="en-US" sz="1050" dirty="0">
-                <a:solidFill>
-                  <a:srgbClr val="ABA6C8"/>
-                </a:solidFill>
-                <a:latin typeface="Consolas" pitchFamily="34" charset="0"/>
-                <a:ea typeface="Consolas" pitchFamily="34" charset="-122"/>
-                <a:cs typeface="Consolas" pitchFamily="34" charset="-120"/>
-              </a:rPr>
-              <a:t>:</a:t>
-            </a:r>
-            <a:pPr indent="0" marL="0">
-              <a:lnSpc>
-                <a:spcPct val="100000"/>
-              </a:lnSpc>
-              <a:buNone/>
-            </a:pPr>
-            <a:r>
-              <a:rPr lang="en-US" sz="1050" dirty="0">
-                <a:solidFill>
-                  <a:srgbClr val="ABA6C8"/>
-                </a:solidFill>
-                <a:latin typeface="Consolas" pitchFamily="34" charset="0"/>
-                <a:ea typeface="Consolas" pitchFamily="34" charset="-122"/>
-                <a:cs typeface="Consolas" pitchFamily="34" charset="-120"/>
-              </a:rPr>
-              <a:t xml:space="preserve"> </a:t>
-            </a:r>
-            <a:pPr indent="0" marL="0">
-              <a:lnSpc>
-                <a:spcPct val="100000"/>
-              </a:lnSpc>
-              <a:buNone/>
-            </a:pPr>
-            <a:r>
-              <a:rPr lang="en-US" sz="1050" dirty="0">
-                <a:solidFill>
-                  <a:srgbClr val="ABA6C8"/>
-                </a:solidFill>
-                <a:latin typeface="Consolas" pitchFamily="34" charset="0"/>
-                <a:ea typeface="Consolas" pitchFamily="34" charset="-122"/>
-                <a:cs typeface="Consolas" pitchFamily="34" charset="-120"/>
-              </a:rPr>
-              <a:t>{</a:t>
-            </a:r>
-            <a:pPr indent="0" marL="0">
-              <a:lnSpc>
-                <a:spcPct val="100000"/>
-              </a:lnSpc>
-              <a:buNone/>
-            </a:pPr>
-            <a:r>
-              <a:rPr lang="en-US" sz="1050" dirty="0">
-                <a:solidFill>
-                  <a:srgbClr val="ABA6C8"/>
-                </a:solidFill>
-                <a:latin typeface="Consolas" pitchFamily="34" charset="0"/>
-                <a:ea typeface="Consolas" pitchFamily="34" charset="-122"/>
-                <a:cs typeface="Consolas" pitchFamily="34" charset="-120"/>
-              </a:rPr>
-              <a:t xml:space="preserve"> </a:t>
-            </a:r>
-            <a:pPr indent="0" marL="0">
-              <a:lnSpc>
-                <a:spcPct val="100000"/>
-              </a:lnSpc>
-              <a:buNone/>
-            </a:pPr>
-            <a:r>
-              <a:rPr lang="en-US" sz="1050" dirty="0">
-                <a:solidFill>
-                  <a:srgbClr val="ECE9F8"/>
-                </a:solidFill>
-                <a:latin typeface="Consolas" pitchFamily="34" charset="0"/>
-                <a:ea typeface="Consolas" pitchFamily="34" charset="-122"/>
-                <a:cs typeface="Consolas" pitchFamily="34" charset="-120"/>
-              </a:rPr>
-              <a:t>"noul"</a:t>
-            </a:r>
-            <a:pPr indent="0" marL="0">
-              <a:lnSpc>
-                <a:spcPct val="100000"/>
-              </a:lnSpc>
-              <a:buNone/>
-            </a:pPr>
-            <a:r>
-              <a:rPr lang="en-US" sz="1050" dirty="0">
-                <a:solidFill>
-                  <a:srgbClr val="ABA6C8"/>
-                </a:solidFill>
-                <a:latin typeface="Consolas" pitchFamily="34" charset="0"/>
-                <a:ea typeface="Consolas" pitchFamily="34" charset="-122"/>
-                <a:cs typeface="Consolas" pitchFamily="34" charset="-120"/>
-              </a:rPr>
-              <a:t>:</a:t>
-            </a:r>
-            <a:pPr indent="0" marL="0">
-              <a:lnSpc>
-                <a:spcPct val="100000"/>
-              </a:lnSpc>
-              <a:buNone/>
-            </a:pPr>
-            <a:r>
-              <a:rPr lang="en-US" sz="1050" dirty="0">
-                <a:solidFill>
-                  <a:srgbClr val="ABA6C8"/>
-                </a:solidFill>
-                <a:latin typeface="Consolas" pitchFamily="34" charset="0"/>
-                <a:ea typeface="Consolas" pitchFamily="34" charset="-122"/>
-                <a:cs typeface="Consolas" pitchFamily="34" charset="-120"/>
-              </a:rPr>
-              <a:t xml:space="preserve"> </a:t>
-            </a:r>
-            <a:pPr indent="0" marL="0">
-              <a:lnSpc>
-                <a:spcPct val="100000"/>
-              </a:lnSpc>
-              <a:buNone/>
-            </a:pPr>
-            <a:r>
-              <a:rPr lang="en-US" sz="1050" dirty="0">
-                <a:solidFill>
-                  <a:srgbClr val="6C6790"/>
-                </a:solidFill>
-                <a:latin typeface="Consolas" pitchFamily="34" charset="0"/>
-                <a:ea typeface="Consolas" pitchFamily="34" charset="-122"/>
-                <a:cs typeface="Consolas" pitchFamily="34" charset="-120"/>
-              </a:rPr>
-              <a:t>…</a:t>
-            </a:r>
-            <a:pPr indent="0" marL="0">
-              <a:lnSpc>
-                <a:spcPct val="100000"/>
-              </a:lnSpc>
-              <a:buNone/>
-            </a:pPr>
-            <a:r>
-              <a:rPr lang="en-US" sz="1050" dirty="0">
-                <a:solidFill>
-                  <a:srgbClr val="ABA6C8"/>
-                </a:solidFill>
-                <a:latin typeface="Consolas" pitchFamily="34" charset="0"/>
-                <a:ea typeface="Consolas" pitchFamily="34" charset="-122"/>
-                <a:cs typeface="Consolas" pitchFamily="34" charset="-120"/>
-              </a:rPr>
-              <a:t>,</a:t>
-            </a:r>
-            <a:pPr indent="0" marL="0">
-              <a:lnSpc>
-                <a:spcPct val="100000"/>
-              </a:lnSpc>
-              <a:buNone/>
-            </a:pPr>
-            <a:r>
-              <a:rPr lang="en-US" sz="1050" dirty="0">
-                <a:solidFill>
-                  <a:srgbClr val="ABA6C8"/>
-                </a:solidFill>
-                <a:latin typeface="Consolas" pitchFamily="34" charset="0"/>
-                <a:ea typeface="Consolas" pitchFamily="34" charset="-122"/>
-                <a:cs typeface="Consolas" pitchFamily="34" charset="-120"/>
-              </a:rPr>
-              <a:t xml:space="preserve"> </a:t>
-            </a:r>
-            <a:pPr indent="0" marL="0">
-              <a:lnSpc>
-                <a:spcPct val="100000"/>
-              </a:lnSpc>
-              <a:buNone/>
-            </a:pPr>
-            <a:r>
-              <a:rPr lang="en-US" sz="1050" dirty="0">
-                <a:solidFill>
-                  <a:srgbClr val="6C6790"/>
-                </a:solidFill>
-                <a:latin typeface="Consolas" pitchFamily="34" charset="0"/>
-                <a:ea typeface="Consolas" pitchFamily="34" charset="-122"/>
-                <a:cs typeface="Consolas" pitchFamily="34" charset="-120"/>
-              </a:rPr>
-              <a:t>…</a:t>
-            </a:r>
-            <a:pPr indent="0" marL="0">
-              <a:lnSpc>
-                <a:spcPct val="100000"/>
-              </a:lnSpc>
-              <a:buNone/>
-            </a:pPr>
-            <a:r>
-              <a:rPr lang="en-US" sz="1050" dirty="0">
-                <a:solidFill>
-                  <a:srgbClr val="ABA6C8"/>
-                </a:solidFill>
-                <a:latin typeface="Consolas" pitchFamily="34" charset="0"/>
-                <a:ea typeface="Consolas" pitchFamily="34" charset="-122"/>
-                <a:cs typeface="Consolas" pitchFamily="34" charset="-120"/>
-              </a:rPr>
-              <a:t xml:space="preserve"> </a:t>
-            </a:r>
-            <a:pPr indent="0" marL="0">
-              <a:lnSpc>
-                <a:spcPct val="100000"/>
-              </a:lnSpc>
-              <a:buNone/>
-            </a:pPr>
-            <a:r>
-              <a:rPr lang="en-US" sz="1050" dirty="0">
-                <a:solidFill>
-                  <a:srgbClr val="ABA6C8"/>
-                </a:solidFill>
-                <a:latin typeface="Consolas" pitchFamily="34" charset="0"/>
-                <a:ea typeface="Consolas" pitchFamily="34" charset="-122"/>
-                <a:cs typeface="Consolas" pitchFamily="34" charset="-120"/>
-              </a:rPr>
-              <a:t>}</a:t>
-            </a:r>
-            <a:endParaRPr lang="en-US" sz="1050" dirty="0"/>
-          </a:p>
-          <a:p>
-            <a:pPr indent="0" marL="0">
-              <a:lnSpc>
-                <a:spcPct val="100000"/>
-              </a:lnSpc>
-              <a:buNone/>
-            </a:pPr>
-            <a:r>
-              <a:rPr lang="en-US" sz="1050" dirty="0">
-                <a:solidFill>
-                  <a:srgbClr val="ABA6C8"/>
-                </a:solidFill>
-                <a:latin typeface="Consolas" pitchFamily="34" charset="0"/>
-                <a:ea typeface="Consolas" pitchFamily="34" charset="-122"/>
-                <a:cs typeface="Consolas" pitchFamily="34" charset="-120"/>
-              </a:rPr>
-              <a:t xml:space="preserve">  </a:t>
-            </a:r>
-            <a:pPr indent="0" marL="0">
-              <a:lnSpc>
-                <a:spcPct val="100000"/>
-              </a:lnSpc>
-              <a:buNone/>
-            </a:pPr>
-            <a:r>
-              <a:rPr lang="en-US" sz="1050" dirty="0">
-                <a:solidFill>
-                  <a:srgbClr val="ABA6C8"/>
-                </a:solidFill>
-                <a:latin typeface="Consolas" pitchFamily="34" charset="0"/>
-                <a:ea typeface="Consolas" pitchFamily="34" charset="-122"/>
-                <a:cs typeface="Consolas" pitchFamily="34" charset="-120"/>
-              </a:rPr>
-              <a:t>}</a:t>
-            </a:r>
-            <a:pPr indent="0" marL="0">
-              <a:lnSpc>
-                <a:spcPct val="100000"/>
-              </a:lnSpc>
-              <a:buNone/>
-            </a:pPr>
-            <a:r>
-              <a:rPr lang="en-US" sz="1050" dirty="0">
-                <a:solidFill>
-                  <a:srgbClr val="ABA6C8"/>
-                </a:solidFill>
-                <a:latin typeface="Consolas" pitchFamily="34" charset="0"/>
-                <a:ea typeface="Consolas" pitchFamily="34" charset="-122"/>
-                <a:cs typeface="Consolas" pitchFamily="34" charset="-120"/>
-              </a:rPr>
-              <a:t>,</a:t>
-            </a:r>
-            <a:endParaRPr lang="en-US" sz="1050" dirty="0"/>
-          </a:p>
-          <a:p>
-            <a:pPr indent="0" marL="0">
-              <a:lnSpc>
-                <a:spcPct val="100000"/>
-              </a:lnSpc>
-              <a:buNone/>
-            </a:pPr>
-            <a:r>
-              <a:rPr lang="en-US" sz="1050" dirty="0">
-                <a:solidFill>
-                  <a:srgbClr val="ABA6C8"/>
-                </a:solidFill>
-                <a:latin typeface="Consolas" pitchFamily="34" charset="0"/>
-                <a:ea typeface="Consolas" pitchFamily="34" charset="-122"/>
-                <a:cs typeface="Consolas" pitchFamily="34" charset="-120"/>
-              </a:rPr>
-              <a:t xml:space="preserve">  </a:t>
-            </a:r>
-            <a:pPr indent="0" marL="0">
-              <a:lnSpc>
-                <a:spcPct val="100000"/>
-              </a:lnSpc>
-              <a:buNone/>
-            </a:pPr>
-            <a:r>
-              <a:rPr lang="en-US" sz="1050" dirty="0">
-                <a:solidFill>
-                  <a:srgbClr val="ECE9F8"/>
-                </a:solidFill>
-                <a:latin typeface="Consolas" pitchFamily="34" charset="0"/>
-                <a:ea typeface="Consolas" pitchFamily="34" charset="-122"/>
-                <a:cs typeface="Consolas" pitchFamily="34" charset="-120"/>
-              </a:rPr>
-              <a:t>"usage"</a:t>
-            </a:r>
-            <a:pPr indent="0" marL="0">
-              <a:lnSpc>
-                <a:spcPct val="100000"/>
-              </a:lnSpc>
-              <a:buNone/>
-            </a:pPr>
-            <a:r>
-              <a:rPr lang="en-US" sz="1050" dirty="0">
-                <a:solidFill>
-                  <a:srgbClr val="ABA6C8"/>
-                </a:solidFill>
-                <a:latin typeface="Consolas" pitchFamily="34" charset="0"/>
-                <a:ea typeface="Consolas" pitchFamily="34" charset="-122"/>
-                <a:cs typeface="Consolas" pitchFamily="34" charset="-120"/>
-              </a:rPr>
-              <a:t>:</a:t>
-            </a:r>
-            <a:pPr indent="0" marL="0">
-              <a:lnSpc>
-                <a:spcPct val="100000"/>
-              </a:lnSpc>
-              <a:buNone/>
-            </a:pPr>
-            <a:r>
-              <a:rPr lang="en-US" sz="1050" dirty="0">
-                <a:solidFill>
-                  <a:srgbClr val="ABA6C8"/>
-                </a:solidFill>
-                <a:latin typeface="Consolas" pitchFamily="34" charset="0"/>
-                <a:ea typeface="Consolas" pitchFamily="34" charset="-122"/>
-                <a:cs typeface="Consolas" pitchFamily="34" charset="-120"/>
-              </a:rPr>
-              <a:t xml:space="preserve"> </a:t>
-            </a:r>
-            <a:pPr indent="0" marL="0">
-              <a:lnSpc>
-                <a:spcPct val="100000"/>
-              </a:lnSpc>
-              <a:buNone/>
-            </a:pPr>
-            <a:r>
-              <a:rPr lang="en-US" sz="1050" dirty="0">
-                <a:solidFill>
-                  <a:srgbClr val="ABA6C8"/>
-                </a:solidFill>
-                <a:latin typeface="Consolas" pitchFamily="34" charset="0"/>
-                <a:ea typeface="Consolas" pitchFamily="34" charset="-122"/>
-                <a:cs typeface="Consolas" pitchFamily="34" charset="-120"/>
-              </a:rPr>
-              <a:t>{</a:t>
-            </a:r>
-            <a:pPr indent="0" marL="0">
-              <a:lnSpc>
-                <a:spcPct val="100000"/>
-              </a:lnSpc>
-              <a:buNone/>
-            </a:pPr>
-            <a:r>
-              <a:rPr lang="en-US" sz="1050" dirty="0">
-                <a:solidFill>
-                  <a:srgbClr val="ABA6C8"/>
-                </a:solidFill>
-                <a:latin typeface="Consolas" pitchFamily="34" charset="0"/>
-                <a:ea typeface="Consolas" pitchFamily="34" charset="-122"/>
-                <a:cs typeface="Consolas" pitchFamily="34" charset="-120"/>
-              </a:rPr>
-              <a:t xml:space="preserve"> </a:t>
-            </a:r>
-            <a:pPr indent="0" marL="0">
-              <a:lnSpc>
-                <a:spcPct val="100000"/>
-              </a:lnSpc>
-              <a:buNone/>
-            </a:pPr>
-            <a:r>
-              <a:rPr lang="en-US" sz="1050" dirty="0">
-                <a:solidFill>
-                  <a:srgbClr val="ECE9F8"/>
-                </a:solidFill>
-                <a:latin typeface="Consolas" pitchFamily="34" charset="0"/>
-                <a:ea typeface="Consolas" pitchFamily="34" charset="-122"/>
-                <a:cs typeface="Consolas" pitchFamily="34" charset="-120"/>
-              </a:rPr>
-              <a:t>"input_tokens"</a:t>
-            </a:r>
-            <a:pPr indent="0" marL="0">
-              <a:lnSpc>
-                <a:spcPct val="100000"/>
-              </a:lnSpc>
-              <a:buNone/>
-            </a:pPr>
-            <a:r>
-              <a:rPr lang="en-US" sz="1050" dirty="0">
-                <a:solidFill>
-                  <a:srgbClr val="ABA6C8"/>
-                </a:solidFill>
-                <a:latin typeface="Consolas" pitchFamily="34" charset="0"/>
-                <a:ea typeface="Consolas" pitchFamily="34" charset="-122"/>
-                <a:cs typeface="Consolas" pitchFamily="34" charset="-120"/>
-              </a:rPr>
-              <a:t>:</a:t>
-            </a:r>
-            <a:pPr indent="0" marL="0">
-              <a:lnSpc>
-                <a:spcPct val="100000"/>
-              </a:lnSpc>
-              <a:buNone/>
-            </a:pPr>
-            <a:r>
-              <a:rPr lang="en-US" sz="1050" dirty="0">
-                <a:solidFill>
-                  <a:srgbClr val="ABA6C8"/>
-                </a:solidFill>
-                <a:latin typeface="Consolas" pitchFamily="34" charset="0"/>
-                <a:ea typeface="Consolas" pitchFamily="34" charset="-122"/>
-                <a:cs typeface="Consolas" pitchFamily="34" charset="-120"/>
-              </a:rPr>
-              <a:t xml:space="preserve"> </a:t>
-            </a:r>
-            <a:pPr indent="0" marL="0">
-              <a:lnSpc>
-                <a:spcPct val="100000"/>
-              </a:lnSpc>
-              <a:buNone/>
-            </a:pPr>
-            <a:r>
-              <a:rPr lang="en-US" sz="1050" dirty="0">
-                <a:solidFill>
-                  <a:srgbClr val="6C6790"/>
-                </a:solidFill>
-                <a:latin typeface="Consolas" pitchFamily="34" charset="0"/>
-                <a:ea typeface="Consolas" pitchFamily="34" charset="-122"/>
-                <a:cs typeface="Consolas" pitchFamily="34" charset="-120"/>
-              </a:rPr>
-              <a:t>…</a:t>
-            </a:r>
-            <a:pPr indent="0" marL="0">
-              <a:lnSpc>
-                <a:spcPct val="100000"/>
-              </a:lnSpc>
-              <a:buNone/>
-            </a:pPr>
-            <a:r>
-              <a:rPr lang="en-US" sz="1050" dirty="0">
-                <a:solidFill>
-                  <a:srgbClr val="ABA6C8"/>
-                </a:solidFill>
-                <a:latin typeface="Consolas" pitchFamily="34" charset="0"/>
-                <a:ea typeface="Consolas" pitchFamily="34" charset="-122"/>
-                <a:cs typeface="Consolas" pitchFamily="34" charset="-120"/>
-              </a:rPr>
-              <a:t>,</a:t>
-            </a:r>
-            <a:pPr indent="0" marL="0">
-              <a:lnSpc>
-                <a:spcPct val="100000"/>
-              </a:lnSpc>
-              <a:buNone/>
-            </a:pPr>
-            <a:r>
-              <a:rPr lang="en-US" sz="1050" dirty="0">
-                <a:solidFill>
-                  <a:srgbClr val="ABA6C8"/>
-                </a:solidFill>
-                <a:latin typeface="Consolas" pitchFamily="34" charset="0"/>
-                <a:ea typeface="Consolas" pitchFamily="34" charset="-122"/>
-                <a:cs typeface="Consolas" pitchFamily="34" charset="-120"/>
-              </a:rPr>
-              <a:t xml:space="preserve"> </a:t>
-            </a:r>
-            <a:pPr indent="0" marL="0">
-              <a:lnSpc>
-                <a:spcPct val="100000"/>
-              </a:lnSpc>
-              <a:buNone/>
-            </a:pPr>
-            <a:r>
-              <a:rPr lang="en-US" sz="1050" dirty="0">
-                <a:solidFill>
-                  <a:srgbClr val="ECE9F8"/>
-                </a:solidFill>
-                <a:latin typeface="Consolas" pitchFamily="34" charset="0"/>
-                <a:ea typeface="Consolas" pitchFamily="34" charset="-122"/>
-                <a:cs typeface="Consolas" pitchFamily="34" charset="-120"/>
-              </a:rPr>
-              <a:t>"output_tokens"</a:t>
-            </a:r>
-            <a:pPr indent="0" marL="0">
-              <a:lnSpc>
-                <a:spcPct val="100000"/>
-              </a:lnSpc>
-              <a:buNone/>
-            </a:pPr>
-            <a:r>
-              <a:rPr lang="en-US" sz="1050" dirty="0">
-                <a:solidFill>
-                  <a:srgbClr val="ABA6C8"/>
-                </a:solidFill>
-                <a:latin typeface="Consolas" pitchFamily="34" charset="0"/>
-                <a:ea typeface="Consolas" pitchFamily="34" charset="-122"/>
-                <a:cs typeface="Consolas" pitchFamily="34" charset="-120"/>
-              </a:rPr>
-              <a:t>:</a:t>
-            </a:r>
-            <a:pPr indent="0" marL="0">
-              <a:lnSpc>
-                <a:spcPct val="100000"/>
-              </a:lnSpc>
-              <a:buNone/>
-            </a:pPr>
-            <a:r>
-              <a:rPr lang="en-US" sz="1050" dirty="0">
-                <a:solidFill>
-                  <a:srgbClr val="ABA6C8"/>
-                </a:solidFill>
-                <a:latin typeface="Consolas" pitchFamily="34" charset="0"/>
-                <a:ea typeface="Consolas" pitchFamily="34" charset="-122"/>
-                <a:cs typeface="Consolas" pitchFamily="34" charset="-120"/>
-              </a:rPr>
-              <a:t xml:space="preserve"> </a:t>
-            </a:r>
-            <a:pPr indent="0" marL="0">
-              <a:lnSpc>
-                <a:spcPct val="100000"/>
-              </a:lnSpc>
-              <a:buNone/>
-            </a:pPr>
-            <a:r>
-              <a:rPr lang="en-US" sz="1050" dirty="0">
-                <a:solidFill>
-                  <a:srgbClr val="3DD6FF"/>
-                </a:solidFill>
-                <a:latin typeface="Consolas" pitchFamily="34" charset="0"/>
-                <a:ea typeface="Consolas" pitchFamily="34" charset="-122"/>
-                <a:cs typeface="Consolas" pitchFamily="34" charset="-120"/>
-              </a:rPr>
-              <a:t>3</a:t>
-            </a:r>
-            <a:pPr indent="0" marL="0">
-              <a:lnSpc>
-                <a:spcPct val="100000"/>
-              </a:lnSpc>
-              <a:buNone/>
-            </a:pPr>
-            <a:r>
-              <a:rPr lang="en-US" sz="1050" dirty="0">
-                <a:solidFill>
-                  <a:srgbClr val="ABA6C8"/>
-                </a:solidFill>
-                <a:latin typeface="Consolas" pitchFamily="34" charset="0"/>
-                <a:ea typeface="Consolas" pitchFamily="34" charset="-122"/>
-                <a:cs typeface="Consolas" pitchFamily="34" charset="-120"/>
-              </a:rPr>
-              <a:t xml:space="preserve"> </a:t>
-            </a:r>
-            <a:pPr indent="0" marL="0">
-              <a:lnSpc>
-                <a:spcPct val="100000"/>
-              </a:lnSpc>
-              <a:buNone/>
-            </a:pPr>
-            <a:r>
-              <a:rPr lang="en-US" sz="1050" dirty="0">
-                <a:solidFill>
-                  <a:srgbClr val="ABA6C8"/>
-                </a:solidFill>
-                <a:latin typeface="Consolas" pitchFamily="34" charset="0"/>
-                <a:ea typeface="Consolas" pitchFamily="34" charset="-122"/>
-                <a:cs typeface="Consolas" pitchFamily="34" charset="-120"/>
-              </a:rPr>
-              <a:t>}</a:t>
-            </a:r>
-            <a:endParaRPr lang="en-US" sz="1050" dirty="0"/>
-          </a:p>
-          <a:p>
-            <a:pPr indent="0" marL="0">
-              <a:lnSpc>
-                <a:spcPct val="100000"/>
-              </a:lnSpc>
-              <a:buNone/>
-            </a:pPr>
-            <a:r>
-              <a:rPr lang="en-US" sz="1050" dirty="0">
-                <a:solidFill>
-                  <a:srgbClr val="ABA6C8"/>
-                </a:solidFill>
-                <a:latin typeface="Consolas" pitchFamily="34" charset="0"/>
-                <a:ea typeface="Consolas" pitchFamily="34" charset="-122"/>
-                <a:cs typeface="Consolas" pitchFamily="34" charset="-120"/>
-              </a:rPr>
-              <a:t>}</a:t>
-            </a:r>
-            <a:endParaRPr lang="en-US" sz="1050" dirty="0"/>
-          </a:p>
-        </p:txBody>
-      </p:sp>
-      <p:sp>
-        <p:nvSpPr>
-          <p:cNvPr id="13" name="Text 11"/>
-          <p:cNvSpPr/>
-          <p:nvPr/>
-        </p:nvSpPr>
-        <p:spPr>
-          <a:xfrm>
-            <a:off x="777240" y="4142232"/>
-            <a:ext cx="3017520" cy="237744"/>
-          </a:xfrm>
-          <a:prstGeom prst="rect">
-            <a:avLst/>
-          </a:prstGeom>
-          <a:noFill/>
-          <a:ln/>
-        </p:spPr>
-        <p:txBody>
-          <a:bodyPr wrap="square" lIns="0" tIns="0" rIns="0" bIns="0" rtlCol="0" anchor="ctr"/>
-          <a:lstStyle/>
-          <a:p>
-            <a:pPr indent="0" marL="0">
-              <a:buNone/>
-            </a:pPr>
-            <a:r>
-              <a:rPr lang="en-US" sz="1100" dirty="0">
-                <a:solidFill>
-                  <a:srgbClr val="ECE9F8"/>
-                </a:solidFill>
-                <a:latin typeface="Consolas" pitchFamily="34" charset="0"/>
-                <a:ea typeface="Consolas" pitchFamily="34" charset="-122"/>
-                <a:cs typeface="Consolas" pitchFamily="34" charset="-120"/>
-              </a:rPr>
-              <a:t>model</a:t>
-            </a:r>
-            <a:pPr indent="0" marL="0">
-              <a:buNone/>
-            </a:pPr>
-            <a:r>
-              <a:rPr lang="en-US" sz="1100" dirty="0">
-                <a:solidFill>
-                  <a:srgbClr val="ABA6C8"/>
-                </a:solidFill>
-                <a:latin typeface="Segoe UI" pitchFamily="34" charset="0"/>
-                <a:ea typeface="Segoe UI" pitchFamily="34" charset="-122"/>
-                <a:cs typeface="Segoe UI" pitchFamily="34" charset="-120"/>
-              </a:rPr>
-              <a:t xml:space="preserve"> is the deployment name.</a:t>
-            </a:r>
-            <a:endParaRPr lang="en-US" sz="1100" dirty="0"/>
-          </a:p>
-        </p:txBody>
-      </p:sp>
-      <p:sp>
-        <p:nvSpPr>
-          <p:cNvPr id="14" name="Text 12"/>
-          <p:cNvSpPr/>
-          <p:nvPr/>
-        </p:nvSpPr>
-        <p:spPr>
-          <a:xfrm>
-            <a:off x="4526280" y="4142232"/>
-            <a:ext cx="3840480" cy="237744"/>
-          </a:xfrm>
-          <a:prstGeom prst="rect">
-            <a:avLst/>
-          </a:prstGeom>
-          <a:noFill/>
-          <a:ln/>
-        </p:spPr>
-        <p:txBody>
-          <a:bodyPr wrap="square" lIns="0" tIns="0" rIns="0" bIns="0" rtlCol="0" anchor="ctr"/>
-          <a:lstStyle/>
-          <a:p>
-            <a:pPr indent="0" marL="0">
-              <a:buNone/>
-            </a:pPr>
-            <a:r>
-              <a:rPr lang="en-US" sz="1100" dirty="0">
-                <a:solidFill>
-                  <a:srgbClr val="ECE9F8"/>
-                </a:solidFill>
-                <a:latin typeface="Consolas" pitchFamily="34" charset="0"/>
-                <a:ea typeface="Consolas" pitchFamily="34" charset="-122"/>
-                <a:cs typeface="Consolas" pitchFamily="34" charset="-120"/>
-              </a:rPr>
-              <a:t>model</a:t>
-            </a:r>
-            <a:pPr indent="0" marL="0">
-              <a:buNone/>
-            </a:pPr>
-            <a:r>
-              <a:rPr lang="en-US" sz="1100" dirty="0">
-                <a:solidFill>
-                  <a:srgbClr val="ABA6C8"/>
-                </a:solidFill>
-                <a:latin typeface="Segoe UI" pitchFamily="34" charset="0"/>
-                <a:ea typeface="Segoe UI" pitchFamily="34" charset="-122"/>
-                <a:cs typeface="Segoe UI" pitchFamily="34" charset="-120"/>
-              </a:rPr>
-              <a:t xml:space="preserve"> is the underlying model.</a:t>
-            </a:r>
-            <a:endParaRPr lang="en-US" sz="1100" dirty="0"/>
+                <a:latin typeface="Segoe UI"/>
+              </a:rPr>
+              <a:t>Illustrative reply; extra fields omitted.</a:t>
+            </a:r>
+            <a:endParaRPr lang="en-US" sz="1050"/>
           </a:p>
         </p:txBody>
       </p:sp>
@@ -15007,7 +13858,7 @@
                 <a:ea typeface="Segoe UI Semibold" pitchFamily="34" charset="-122"/>
                 <a:cs typeface="Segoe UI Semibold" pitchFamily="34" charset="-120"/>
               </a:rPr>
-              <a:t>08 / 12</a:t>
+              <a:t>09 / 13</a:t>
             </a:r>
             <a:endParaRPr lang="en-US" sz="1100" dirty="0"/>
           </a:p>
@@ -15200,7 +14051,7 @@
                 <a:ea typeface="Segoe UI Semibold" pitchFamily="34" charset="-122"/>
                 <a:cs typeface="Segoe UI Semibold" pitchFamily="34" charset="-120"/>
               </a:rPr>
-              <a:t>10 / 12</a:t>
+              <a:t>11 / 13</a:t>
             </a:r>
             <a:endParaRPr lang="en-US" sz="1100" dirty="0"/>
           </a:p>

</xml_diff>

<commit_message>
Update luna-gp presentation deck with new content
</commit_message>
<xml_diff>
--- a/docs/luna-gp-deck.pptx
+++ b/docs/luna-gp-deck.pptx
@@ -5,23 +5,24 @@
     <p:sldMasterId id="2147483648" r:id="rId1"/>
   </p:sldMasterIdLst>
   <p:notesMasterIdLst>
-    <p:notesMasterId r:id="rId16"/>
+    <p:notesMasterId r:id="rId17"/>
   </p:notesMasterIdLst>
   <p:sldIdLst>
     <p:sldId id="256" r:id="rId2"/>
     <p:sldId id="269" r:id="rId3"/>
-    <p:sldId id="257" r:id="rId4"/>
-    <p:sldId id="258" r:id="rId5"/>
-    <p:sldId id="259" r:id="rId6"/>
-    <p:sldId id="260" r:id="rId7"/>
-    <p:sldId id="261" r:id="rId8"/>
-    <p:sldId id="268" r:id="rId9"/>
-    <p:sldId id="262" r:id="rId10"/>
-    <p:sldId id="263" r:id="rId11"/>
-    <p:sldId id="267" r:id="rId12"/>
-    <p:sldId id="264" r:id="rId13"/>
-    <p:sldId id="265" r:id="rId14"/>
-    <p:sldId id="266" r:id="rId15"/>
+    <p:sldId id="270" r:id="rId4"/>
+    <p:sldId id="257" r:id="rId5"/>
+    <p:sldId id="258" r:id="rId6"/>
+    <p:sldId id="259" r:id="rId7"/>
+    <p:sldId id="260" r:id="rId8"/>
+    <p:sldId id="261" r:id="rId9"/>
+    <p:sldId id="268" r:id="rId10"/>
+    <p:sldId id="262" r:id="rId11"/>
+    <p:sldId id="263" r:id="rId12"/>
+    <p:sldId id="267" r:id="rId13"/>
+    <p:sldId id="264" r:id="rId14"/>
+    <p:sldId id="265" r:id="rId15"/>
+    <p:sldId id="266" r:id="rId16"/>
   </p:sldIdLst>
   <p:sldSz cx="9144000" cy="5143500" type="screen16x9"/>
   <p:notesSz cx="5143500" cy="9144000"/>
@@ -405,7 +406,7 @@
           <a:p>
             <a:fld id="{F7021451-1387-4CA6-816F-3879F97B5CBC}" type="slidenum">
               <a:rPr lang="en-US"/>
-              <a:t>11</a:t>
+              <a:t>12</a:t>
             </a:fld>
             <a:endParaRPr lang="en-US"/>
           </a:p>
@@ -492,7 +493,7 @@
           <a:p>
             <a:fld id="{F7021451-1387-4CA6-816F-3879F97B5CBC}" type="slidenum">
               <a:rPr lang="en-US"/>
-              <a:t>12</a:t>
+              <a:t>13</a:t>
             </a:fld>
             <a:endParaRPr lang="en-US"/>
           </a:p>
@@ -579,7 +580,7 @@
           <a:p>
             <a:fld id="{F7021451-1387-4CA6-816F-3879F97B5CBC}" type="slidenum">
               <a:rPr lang="en-US"/>
-              <a:t>13</a:t>
+              <a:t>14</a:t>
             </a:fld>
             <a:endParaRPr lang="en-US"/>
           </a:p>
@@ -666,7 +667,7 @@
           <a:p>
             <a:fld id="{F7021451-1387-4CA6-816F-3879F97B5CBC}" type="slidenum">
               <a:rPr lang="en-US"/>
-              <a:t>14</a:t>
+              <a:t>15</a:t>
             </a:fld>
             <a:endParaRPr lang="en-US"/>
           </a:p>
@@ -753,7 +754,7 @@
           <a:p>
             <a:fld id="{F7021451-1387-4CA6-816F-3879F97B5CBC}" type="slidenum">
               <a:rPr lang="en-US"/>
-              <a:t>3</a:t>
+              <a:t>4</a:t>
             </a:fld>
             <a:endParaRPr lang="en-US"/>
           </a:p>
@@ -840,7 +841,7 @@
           <a:p>
             <a:fld id="{F7021451-1387-4CA6-816F-3879F97B5CBC}" type="slidenum">
               <a:rPr lang="en-US"/>
-              <a:t>4</a:t>
+              <a:t>5</a:t>
             </a:fld>
             <a:endParaRPr lang="en-US"/>
           </a:p>
@@ -927,7 +928,7 @@
           <a:p>
             <a:fld id="{F7021451-1387-4CA6-816F-3879F97B5CBC}" type="slidenum">
               <a:rPr lang="en-US"/>
-              <a:t>5</a:t>
+              <a:t>6</a:t>
             </a:fld>
             <a:endParaRPr lang="en-US"/>
           </a:p>
@@ -1014,7 +1015,7 @@
           <a:p>
             <a:fld id="{F7021451-1387-4CA6-816F-3879F97B5CBC}" type="slidenum">
               <a:rPr lang="en-US"/>
-              <a:t>6</a:t>
+              <a:t>7</a:t>
             </a:fld>
             <a:endParaRPr lang="en-US"/>
           </a:p>
@@ -1101,7 +1102,7 @@
           <a:p>
             <a:fld id="{F7021451-1387-4CA6-816F-3879F97B5CBC}" type="slidenum">
               <a:rPr lang="en-US"/>
-              <a:t>7</a:t>
+              <a:t>8</a:t>
             </a:fld>
             <a:endParaRPr lang="en-US"/>
           </a:p>
@@ -1206,7 +1207,7 @@
           <a:p>
             <a:fld id="{3FEF4712-8A2B-4CC3-AF43-90CF52B31007}" type="slidenum">
               <a:rPr lang="en-US"/>
-              <a:t>8</a:t>
+              <a:t>9</a:t>
             </a:fld>
             <a:endParaRPr lang="en-US"/>
           </a:p>
@@ -1288,7 +1289,7 @@
           <a:p>
             <a:fld id="{F7021451-1387-4CA6-816F-3879F97B5CBC}" type="slidenum">
               <a:rPr lang="en-US"/>
-              <a:t>9</a:t>
+              <a:t>10</a:t>
             </a:fld>
             <a:endParaRPr lang="en-US"/>
           </a:p>
@@ -1375,7 +1376,7 @@
           <a:p>
             <a:fld id="{F7021451-1387-4CA6-816F-3879F97B5CBC}" type="slidenum">
               <a:rPr lang="en-US"/>
-              <a:t>10</a:t>
+              <a:t>11</a:t>
             </a:fld>
             <a:endParaRPr lang="en-US"/>
           </a:p>
@@ -1922,6 +1923,971 @@
 
 <file path=ppt/slides/slide10.xml><?xml version="1.0" encoding="utf-8"?>
 <p:sld xmlns:a="http://schemas.openxmlformats.org/drawingml/2006/main" xmlns:r="http://schemas.openxmlformats.org/officeDocument/2006/relationships" xmlns:p="http://schemas.openxmlformats.org/presentationml/2006/main">
+  <p:cSld name="One request, three answers">
+    <p:bg>
+      <p:bgPr>
+        <a:solidFill>
+          <a:srgbClr val="07071A"/>
+        </a:solidFill>
+        <a:effectLst/>
+      </p:bgPr>
+    </p:bg>
+    <p:spTree>
+      <p:nvGrpSpPr>
+        <p:cNvPr id="1" name=""/>
+        <p:cNvGrpSpPr/>
+        <p:nvPr/>
+      </p:nvGrpSpPr>
+      <p:grpSpPr>
+        <a:xfrm>
+          <a:off x="0" y="0"/>
+          <a:ext cx="0" cy="0"/>
+          <a:chOff x="0" y="0"/>
+          <a:chExt cx="0" cy="0"/>
+        </a:xfrm>
+      </p:grpSpPr>
+      <p:sp>
+        <p:nvSpPr>
+          <p:cNvPr id="2" name="Header dot"/>
+          <p:cNvSpPr/>
+          <p:nvPr/>
+        </p:nvSpPr>
+        <p:spPr>
+          <a:xfrm>
+            <a:off x="548640" y="484632"/>
+            <a:ext cx="109728" cy="109728"/>
+          </a:xfrm>
+          <a:prstGeom prst="ellipse">
+            <a:avLst/>
+          </a:prstGeom>
+          <a:solidFill>
+            <a:srgbClr val="FFD166"/>
+          </a:solidFill>
+          <a:ln/>
+        </p:spPr>
+        <p:txBody>
+          <a:bodyPr/>
+          <a:lstStyle/>
+          <a:p>
+            <a:endParaRPr lang="en-ZA"/>
+          </a:p>
+        </p:txBody>
+      </p:sp>
+      <p:sp>
+        <p:nvSpPr>
+          <p:cNvPr id="3" name="Section label"/>
+          <p:cNvSpPr txBox="1"/>
+          <p:nvPr/>
+        </p:nvSpPr>
+        <p:spPr>
+          <a:xfrm>
+            <a:off x="749808" y="393192"/>
+            <a:ext cx="5943600" cy="292608"/>
+          </a:xfrm>
+          <a:prstGeom prst="rect">
+            <a:avLst/>
+          </a:prstGeom>
+          <a:noFill/>
+          <a:ln/>
+        </p:spPr>
+        <p:txBody>
+          <a:bodyPr wrap="square" lIns="0" tIns="0" rIns="0" bIns="0" anchor="ctr"/>
+          <a:lstStyle/>
+          <a:p>
+            <a:pPr>
+              <a:buNone/>
+            </a:pPr>
+            <a:r>
+              <a:rPr lang="en-US" sz="1100" b="1" kern="0" spc="300">
+                <a:solidFill>
+                  <a:srgbClr val="ABA6C8"/>
+                </a:solidFill>
+                <a:latin typeface="Segoe UI Semibold"/>
+              </a:rPr>
+              <a:t>THE JSON EXCHANGE</a:t>
+            </a:r>
+            <a:endParaRPr lang="en-US" sz="1100"/>
+          </a:p>
+        </p:txBody>
+      </p:sp>
+      <p:sp>
+        <p:nvSpPr>
+          <p:cNvPr id="4" name="Slide counter"/>
+          <p:cNvSpPr txBox="1"/>
+          <p:nvPr/>
+        </p:nvSpPr>
+        <p:spPr>
+          <a:xfrm>
+            <a:off x="7223760" y="393192"/>
+            <a:ext cx="1371600" cy="292608"/>
+          </a:xfrm>
+          <a:prstGeom prst="rect">
+            <a:avLst/>
+          </a:prstGeom>
+          <a:noFill/>
+          <a:ln/>
+        </p:spPr>
+        <p:txBody>
+          <a:bodyPr wrap="square" lIns="0" tIns="0" rIns="0" bIns="0" anchor="ctr"/>
+          <a:lstStyle/>
+          <a:p>
+            <a:pPr algn="r">
+              <a:buNone/>
+            </a:pPr>
+            <a:r>
+              <a:rPr lang="en-US" sz="1100">
+                <a:solidFill>
+                  <a:srgbClr val="ABA6C8"/>
+                </a:solidFill>
+                <a:latin typeface="Segoe UI Semibold"/>
+              </a:rPr>
+              <a:t>08 / 13</a:t>
+            </a:r>
+            <a:endParaRPr lang="en-US" sz="1100"/>
+          </a:p>
+        </p:txBody>
+      </p:sp>
+      <p:sp>
+        <p:nvSpPr>
+          <p:cNvPr id="5" name="Slide title"/>
+          <p:cNvSpPr txBox="1"/>
+          <p:nvPr/>
+        </p:nvSpPr>
+        <p:spPr>
+          <a:xfrm>
+            <a:off x="548640" y="749808"/>
+            <a:ext cx="8046720" cy="658368"/>
+          </a:xfrm>
+          <a:prstGeom prst="rect">
+            <a:avLst/>
+          </a:prstGeom>
+          <a:noFill/>
+          <a:ln/>
+        </p:spPr>
+        <p:txBody>
+          <a:bodyPr wrap="square" lIns="0" tIns="0" rIns="0" bIns="0"/>
+          <a:lstStyle/>
+          <a:p>
+            <a:pPr>
+              <a:buNone/>
+            </a:pPr>
+            <a:r>
+              <a:rPr lang="en-US" sz="3400" b="1" i="1">
+                <a:solidFill>
+                  <a:srgbClr val="ECE9F8"/>
+                </a:solidFill>
+                <a:latin typeface="Segoe UI Black"/>
+              </a:rPr>
+              <a:t>One request, three answers</a:t>
+            </a:r>
+            <a:endParaRPr lang="en-US" sz="3400"/>
+          </a:p>
+        </p:txBody>
+      </p:sp>
+      <p:sp>
+        <p:nvSpPr>
+          <p:cNvPr id="6" name="Slide subtitle"/>
+          <p:cNvSpPr txBox="1"/>
+          <p:nvPr/>
+        </p:nvSpPr>
+        <p:spPr>
+          <a:xfrm>
+            <a:off x="548640" y="1417320"/>
+            <a:ext cx="8046720" cy="320040"/>
+          </a:xfrm>
+          <a:prstGeom prst="rect">
+            <a:avLst/>
+          </a:prstGeom>
+          <a:noFill/>
+          <a:ln/>
+        </p:spPr>
+        <p:txBody>
+          <a:bodyPr wrap="square" lIns="0" tIns="0" rIns="0" bIns="0"/>
+          <a:lstStyle/>
+          <a:p>
+            <a:pPr>
+              <a:buNone/>
+            </a:pPr>
+            <a:r>
+              <a:rPr lang="en-US" sz="1450">
+                <a:solidFill>
+                  <a:srgbClr val="ABA6C8"/>
+                </a:solidFill>
+                <a:latin typeface="Segoe UI"/>
+              </a:rPr>
+              <a:t>Abbreviated JSON: one driver's situation in, three named answers out.</a:t>
+            </a:r>
+            <a:endParaRPr lang="en-US" sz="1450"/>
+          </a:p>
+        </p:txBody>
+      </p:sp>
+      <p:sp>
+        <p:nvSpPr>
+          <p:cNvPr id="7" name="Request card"/>
+          <p:cNvSpPr/>
+          <p:nvPr/>
+        </p:nvSpPr>
+        <p:spPr>
+          <a:xfrm>
+            <a:off x="548640" y="1874520"/>
+            <a:ext cx="3794760" cy="2651760"/>
+          </a:xfrm>
+          <a:prstGeom prst="roundRect">
+            <a:avLst>
+              <a:gd name="adj" fmla="val 9143"/>
+            </a:avLst>
+          </a:prstGeom>
+          <a:solidFill>
+            <a:srgbClr val="110F2B"/>
+          </a:solidFill>
+          <a:ln/>
+        </p:spPr>
+        <p:txBody>
+          <a:bodyPr/>
+          <a:lstStyle/>
+          <a:p>
+            <a:endParaRPr lang="en-ZA"/>
+          </a:p>
+        </p:txBody>
+      </p:sp>
+      <p:sp>
+        <p:nvSpPr>
+          <p:cNvPr id="8" name="Response card"/>
+          <p:cNvSpPr/>
+          <p:nvPr/>
+        </p:nvSpPr>
+        <p:spPr>
+          <a:xfrm>
+            <a:off x="4663440" y="1874520"/>
+            <a:ext cx="3931920" cy="2651760"/>
+          </a:xfrm>
+          <a:prstGeom prst="roundRect">
+            <a:avLst>
+              <a:gd name="adj" fmla="val 9143"/>
+            </a:avLst>
+          </a:prstGeom>
+          <a:solidFill>
+            <a:srgbClr val="110F2B"/>
+          </a:solidFill>
+          <a:ln/>
+        </p:spPr>
+        <p:txBody>
+          <a:bodyPr/>
+          <a:lstStyle/>
+          <a:p>
+            <a:endParaRPr lang="en-ZA"/>
+          </a:p>
+        </p:txBody>
+      </p:sp>
+      <p:sp>
+        <p:nvSpPr>
+          <p:cNvPr id="9" name="Request label"/>
+          <p:cNvSpPr txBox="1"/>
+          <p:nvPr/>
+        </p:nvSpPr>
+        <p:spPr>
+          <a:xfrm>
+            <a:off x="777240" y="2039112"/>
+            <a:ext cx="1828800" cy="237744"/>
+          </a:xfrm>
+          <a:prstGeom prst="rect">
+            <a:avLst/>
+          </a:prstGeom>
+          <a:noFill/>
+          <a:ln/>
+        </p:spPr>
+        <p:txBody>
+          <a:bodyPr wrap="square" lIns="0" tIns="0" rIns="0" bIns="0"/>
+          <a:lstStyle/>
+          <a:p>
+            <a:pPr>
+              <a:buNone/>
+            </a:pPr>
+            <a:r>
+              <a:rPr lang="en-US" sz="1050" b="1" spc="200">
+                <a:solidFill>
+                  <a:srgbClr val="ABA6C8"/>
+                </a:solidFill>
+                <a:latin typeface="Segoe UI Semibold"/>
+              </a:rPr>
+              <a:t>REQUEST</a:t>
+            </a:r>
+            <a:endParaRPr lang="en-US" sz="1050"/>
+          </a:p>
+        </p:txBody>
+      </p:sp>
+      <p:sp>
+        <p:nvSpPr>
+          <p:cNvPr id="10" name="Response label"/>
+          <p:cNvSpPr txBox="1"/>
+          <p:nvPr/>
+        </p:nvSpPr>
+        <p:spPr>
+          <a:xfrm>
+            <a:off x="4892040" y="2039112"/>
+            <a:ext cx="1828800" cy="237744"/>
+          </a:xfrm>
+          <a:prstGeom prst="rect">
+            <a:avLst/>
+          </a:prstGeom>
+          <a:noFill/>
+          <a:ln/>
+        </p:spPr>
+        <p:txBody>
+          <a:bodyPr wrap="square" lIns="0" tIns="0" rIns="0" bIns="0"/>
+          <a:lstStyle/>
+          <a:p>
+            <a:pPr>
+              <a:buNone/>
+            </a:pPr>
+            <a:r>
+              <a:rPr lang="en-US" sz="1050" b="1" spc="200">
+                <a:solidFill>
+                  <a:srgbClr val="ABA6C8"/>
+                </a:solidFill>
+                <a:latin typeface="Segoe UI Semibold"/>
+              </a:rPr>
+              <a:t>RESPONSE</a:t>
+            </a:r>
+            <a:endParaRPr lang="en-US" sz="1050"/>
+          </a:p>
+        </p:txBody>
+      </p:sp>
+      <p:sp>
+        <p:nvSpPr>
+          <p:cNvPr id="11" name="Request JSON"/>
+          <p:cNvSpPr txBox="1"/>
+          <p:nvPr/>
+        </p:nvSpPr>
+        <p:spPr>
+          <a:xfrm>
+            <a:off x="777240" y="2322576"/>
+            <a:ext cx="3337560" cy="1764792"/>
+          </a:xfrm>
+          <a:prstGeom prst="rect">
+            <a:avLst/>
+          </a:prstGeom>
+          <a:noFill/>
+          <a:ln/>
+        </p:spPr>
+        <p:txBody>
+          <a:bodyPr wrap="square" lIns="0" tIns="0" rIns="0" bIns="0"/>
+          <a:lstStyle/>
+          <a:p>
+            <a:pPr>
+              <a:lnSpc>
+                <a:spcPts val="1150"/>
+              </a:lnSpc>
+              <a:buNone/>
+            </a:pPr>
+            <a:r>
+              <a:rPr lang="en-US" sz="1050">
+                <a:solidFill>
+                  <a:srgbClr val="3DD6FF"/>
+                </a:solidFill>
+                <a:latin typeface="Consolas"/>
+              </a:rPr>
+              <a:t>POST …/providers/microsoft/v1/systemone</a:t>
+            </a:r>
+            <a:endParaRPr sz="1050"/>
+          </a:p>
+          <a:p>
+            <a:pPr>
+              <a:lnSpc>
+                <a:spcPts val="1150"/>
+              </a:lnSpc>
+              <a:buNone/>
+            </a:pPr>
+            <a:r>
+              <a:rPr lang="en-US" sz="1050">
+                <a:solidFill>
+                  <a:srgbClr val="ABA6C8"/>
+                </a:solidFill>
+                <a:latin typeface="Consolas"/>
+              </a:rPr>
+              <a:t>{</a:t>
+            </a:r>
+            <a:endParaRPr sz="1050"/>
+          </a:p>
+          <a:p>
+            <a:pPr>
+              <a:lnSpc>
+                <a:spcPts val="1150"/>
+              </a:lnSpc>
+              <a:buNone/>
+            </a:pPr>
+            <a:r>
+              <a:rPr lang="en-US" sz="1050">
+                <a:solidFill>
+                  <a:srgbClr val="ECE9F8"/>
+                </a:solidFill>
+                <a:latin typeface="Consolas"/>
+              </a:rPr>
+              <a:t>  "model": </a:t>
+            </a:r>
+            <a:r>
+              <a:rPr lang="en-US" sz="1050">
+                <a:solidFill>
+                  <a:srgbClr val="FFD166"/>
+                </a:solidFill>
+                <a:latin typeface="Consolas"/>
+              </a:rPr>
+              <a:t>"&lt;deployment-name&gt;",</a:t>
+            </a:r>
+            <a:endParaRPr sz="1050"/>
+          </a:p>
+          <a:p>
+            <a:pPr>
+              <a:lnSpc>
+                <a:spcPts val="1150"/>
+              </a:lnSpc>
+              <a:buNone/>
+            </a:pPr>
+            <a:r>
+              <a:rPr lang="en-US" sz="1050">
+                <a:solidFill>
+                  <a:srgbClr val="ECE9F8"/>
+                </a:solidFill>
+                <a:latin typeface="Consolas"/>
+              </a:rPr>
+              <a:t>  "state": </a:t>
+            </a:r>
+            <a:r>
+              <a:rPr lang="en-US" sz="1050">
+                <a:solidFill>
+                  <a:srgbClr val="FFD166"/>
+                </a:solidFill>
+                <a:latin typeface="Consolas"/>
+              </a:rPr>
+              <a:t>"&lt;Vega's snapshot&gt;",</a:t>
+            </a:r>
+            <a:endParaRPr sz="1050"/>
+          </a:p>
+          <a:p>
+            <a:pPr>
+              <a:lnSpc>
+                <a:spcPts val="1150"/>
+              </a:lnSpc>
+              <a:buNone/>
+            </a:pPr>
+            <a:r>
+              <a:rPr lang="en-US" sz="1050">
+                <a:solidFill>
+                  <a:srgbClr val="ECE9F8"/>
+                </a:solidFill>
+                <a:latin typeface="Consolas"/>
+              </a:rPr>
+              <a:t>  "questions": {</a:t>
+            </a:r>
+            <a:endParaRPr sz="1050"/>
+          </a:p>
+          <a:p>
+            <a:pPr>
+              <a:lnSpc>
+                <a:spcPts val="1150"/>
+              </a:lnSpc>
+              <a:buNone/>
+            </a:pPr>
+            <a:r>
+              <a:rPr lang="en-US" sz="1050">
+                <a:solidFill>
+                  <a:srgbClr val="ECE9F8"/>
+                </a:solidFill>
+                <a:latin typeface="Consolas"/>
+              </a:rPr>
+              <a:t>    "maneuver": { "type": </a:t>
+            </a:r>
+            <a:r>
+              <a:rPr lang="en-US" sz="1050">
+                <a:solidFill>
+                  <a:srgbClr val="FFD166"/>
+                </a:solidFill>
+                <a:latin typeface="Consolas"/>
+              </a:rPr>
+              <a:t>"choice", … },</a:t>
+            </a:r>
+            <a:endParaRPr sz="1050"/>
+          </a:p>
+          <a:p>
+            <a:pPr>
+              <a:lnSpc>
+                <a:spcPts val="1150"/>
+              </a:lnSpc>
+              <a:buNone/>
+            </a:pPr>
+            <a:r>
+              <a:rPr lang="en-US" sz="1050">
+                <a:solidFill>
+                  <a:srgbClr val="ECE9F8"/>
+                </a:solidFill>
+                <a:latin typeface="Consolas"/>
+              </a:rPr>
+              <a:t>    "pace": { "type": </a:t>
+            </a:r>
+            <a:r>
+              <a:rPr lang="en-US" sz="1050">
+                <a:solidFill>
+                  <a:srgbClr val="FFD166"/>
+                </a:solidFill>
+                <a:latin typeface="Consolas"/>
+              </a:rPr>
+              <a:t>"score", … },</a:t>
+            </a:r>
+            <a:endParaRPr sz="1050"/>
+          </a:p>
+          <a:p>
+            <a:pPr>
+              <a:lnSpc>
+                <a:spcPts val="1150"/>
+              </a:lnSpc>
+              <a:buNone/>
+            </a:pPr>
+            <a:r>
+              <a:rPr lang="en-US" sz="1050">
+                <a:solidFill>
+                  <a:srgbClr val="ECE9F8"/>
+                </a:solidFill>
+                <a:latin typeface="Consolas"/>
+              </a:rPr>
+              <a:t>    "nitro": { "type": </a:t>
+            </a:r>
+            <a:r>
+              <a:rPr lang="en-US" sz="1050">
+                <a:solidFill>
+                  <a:srgbClr val="FFD166"/>
+                </a:solidFill>
+                <a:latin typeface="Consolas"/>
+              </a:rPr>
+              <a:t>"noul", … }</a:t>
+            </a:r>
+            <a:endParaRPr sz="1050"/>
+          </a:p>
+          <a:p>
+            <a:pPr>
+              <a:lnSpc>
+                <a:spcPts val="1150"/>
+              </a:lnSpc>
+              <a:buNone/>
+            </a:pPr>
+            <a:r>
+              <a:rPr lang="en-US" sz="1050">
+                <a:solidFill>
+                  <a:srgbClr val="ABA6C8"/>
+                </a:solidFill>
+                <a:latin typeface="Consolas"/>
+              </a:rPr>
+              <a:t>  }</a:t>
+            </a:r>
+            <a:endParaRPr sz="1050"/>
+          </a:p>
+          <a:p>
+            <a:pPr>
+              <a:lnSpc>
+                <a:spcPts val="1150"/>
+              </a:lnSpc>
+              <a:buNone/>
+            </a:pPr>
+            <a:r>
+              <a:rPr lang="en-US" sz="1050">
+                <a:solidFill>
+                  <a:srgbClr val="ABA6C8"/>
+                </a:solidFill>
+                <a:latin typeface="Consolas"/>
+              </a:rPr>
+              <a:t>}</a:t>
+            </a:r>
+            <a:endParaRPr sz="1050"/>
+          </a:p>
+        </p:txBody>
+      </p:sp>
+      <p:sp>
+        <p:nvSpPr>
+          <p:cNvPr id="12" name="Response JSON"/>
+          <p:cNvSpPr txBox="1"/>
+          <p:nvPr/>
+        </p:nvSpPr>
+        <p:spPr>
+          <a:xfrm>
+            <a:off x="4892040" y="2322576"/>
+            <a:ext cx="3474720" cy="1874520"/>
+          </a:xfrm>
+          <a:prstGeom prst="rect">
+            <a:avLst/>
+          </a:prstGeom>
+          <a:noFill/>
+          <a:ln/>
+        </p:spPr>
+        <p:txBody>
+          <a:bodyPr wrap="square" lIns="0" tIns="0" rIns="0" bIns="0"/>
+          <a:lstStyle/>
+          <a:p>
+            <a:pPr>
+              <a:lnSpc>
+                <a:spcPts val="1150"/>
+              </a:lnSpc>
+              <a:buNone/>
+            </a:pPr>
+            <a:r>
+              <a:rPr lang="en-US" sz="1050">
+                <a:solidFill>
+                  <a:srgbClr val="4ADE80"/>
+                </a:solidFill>
+                <a:latin typeface="Consolas"/>
+              </a:rPr>
+              <a:t>200 OK</a:t>
+            </a:r>
+            <a:endParaRPr sz="1050"/>
+          </a:p>
+          <a:p>
+            <a:pPr>
+              <a:lnSpc>
+                <a:spcPts val="1150"/>
+              </a:lnSpc>
+              <a:buNone/>
+            </a:pPr>
+            <a:r>
+              <a:rPr lang="en-US" sz="1050">
+                <a:solidFill>
+                  <a:srgbClr val="ABA6C8"/>
+                </a:solidFill>
+                <a:latin typeface="Consolas"/>
+              </a:rPr>
+              <a:t>{</a:t>
+            </a:r>
+            <a:endParaRPr sz="1050"/>
+          </a:p>
+          <a:p>
+            <a:pPr>
+              <a:lnSpc>
+                <a:spcPts val="1150"/>
+              </a:lnSpc>
+              <a:buNone/>
+            </a:pPr>
+            <a:r>
+              <a:rPr lang="en-US" sz="1050">
+                <a:solidFill>
+                  <a:srgbClr val="ECE9F8"/>
+                </a:solidFill>
+                <a:latin typeface="Consolas"/>
+              </a:rPr>
+              <a:t>  "model": </a:t>
+            </a:r>
+            <a:r>
+              <a:rPr lang="en-US" sz="1050">
+                <a:solidFill>
+                  <a:srgbClr val="FFD166"/>
+                </a:solidFill>
+                <a:latin typeface="Consolas"/>
+              </a:rPr>
+              <a:t>"microsoft-decision-1",</a:t>
+            </a:r>
+            <a:endParaRPr sz="1050"/>
+          </a:p>
+          <a:p>
+            <a:pPr>
+              <a:lnSpc>
+                <a:spcPts val="1150"/>
+              </a:lnSpc>
+              <a:buNone/>
+            </a:pPr>
+            <a:r>
+              <a:rPr lang="en-US" sz="1050">
+                <a:solidFill>
+                  <a:srgbClr val="ECE9F8"/>
+                </a:solidFill>
+                <a:latin typeface="Consolas"/>
+              </a:rPr>
+              <a:t>  "answers": {</a:t>
+            </a:r>
+            <a:endParaRPr sz="1050"/>
+          </a:p>
+          <a:p>
+            <a:pPr>
+              <a:lnSpc>
+                <a:spcPts val="1150"/>
+              </a:lnSpc>
+              <a:buNone/>
+            </a:pPr>
+            <a:r>
+              <a:rPr lang="en-US" sz="1050">
+                <a:solidFill>
+                  <a:srgbClr val="ECE9F8"/>
+                </a:solidFill>
+                <a:latin typeface="Consolas"/>
+              </a:rPr>
+              <a:t>    "maneuver": {</a:t>
+            </a:r>
+            <a:endParaRPr sz="1050"/>
+          </a:p>
+          <a:p>
+            <a:pPr>
+              <a:lnSpc>
+                <a:spcPts val="1150"/>
+              </a:lnSpc>
+              <a:buNone/>
+            </a:pPr>
+            <a:r>
+              <a:rPr lang="en-US" sz="1050">
+                <a:solidFill>
+                  <a:srgbClr val="ECE9F8"/>
+                </a:solidFill>
+                <a:latin typeface="Consolas"/>
+              </a:rPr>
+              <a:t>      "choice": </a:t>
+            </a:r>
+            <a:r>
+              <a:rPr lang="en-US" sz="1050">
+                <a:solidFill>
+                  <a:srgbClr val="FFD166"/>
+                </a:solidFill>
+                <a:latin typeface="Consolas"/>
+              </a:rPr>
+              <a:t>"overtake_left", …</a:t>
+            </a:r>
+            <a:endParaRPr sz="1050"/>
+          </a:p>
+          <a:p>
+            <a:pPr>
+              <a:lnSpc>
+                <a:spcPts val="1150"/>
+              </a:lnSpc>
+              <a:buNone/>
+            </a:pPr>
+            <a:r>
+              <a:rPr lang="en-US" sz="1050">
+                <a:solidFill>
+                  <a:srgbClr val="ABA6C8"/>
+                </a:solidFill>
+                <a:latin typeface="Consolas"/>
+              </a:rPr>
+              <a:t>    },</a:t>
+            </a:r>
+            <a:endParaRPr sz="1050"/>
+          </a:p>
+          <a:p>
+            <a:pPr>
+              <a:lnSpc>
+                <a:spcPts val="1150"/>
+              </a:lnSpc>
+              <a:buNone/>
+            </a:pPr>
+            <a:r>
+              <a:rPr lang="en-US" sz="1050">
+                <a:solidFill>
+                  <a:srgbClr val="ECE9F8"/>
+                </a:solidFill>
+                <a:latin typeface="Consolas"/>
+              </a:rPr>
+              <a:t>    "pace": { "score": </a:t>
+            </a:r>
+            <a:r>
+              <a:rPr lang="en-US" sz="1050">
+                <a:solidFill>
+                  <a:srgbClr val="3DD6FF"/>
+                </a:solidFill>
+                <a:latin typeface="Consolas"/>
+              </a:rPr>
+              <a:t>2.4, … },</a:t>
+            </a:r>
+            <a:endParaRPr sz="1050"/>
+          </a:p>
+          <a:p>
+            <a:pPr>
+              <a:lnSpc>
+                <a:spcPts val="1150"/>
+              </a:lnSpc>
+              <a:buNone/>
+            </a:pPr>
+            <a:r>
+              <a:rPr lang="en-US" sz="1050">
+                <a:solidFill>
+                  <a:srgbClr val="ECE9F8"/>
+                </a:solidFill>
+                <a:latin typeface="Consolas"/>
+              </a:rPr>
+              <a:t>    "nitro": { "noul": </a:t>
+            </a:r>
+            <a:r>
+              <a:rPr lang="en-US" sz="1050">
+                <a:solidFill>
+                  <a:srgbClr val="3DD6FF"/>
+                </a:solidFill>
+                <a:latin typeface="Consolas"/>
+              </a:rPr>
+              <a:t>0.78, … }</a:t>
+            </a:r>
+            <a:endParaRPr sz="1050"/>
+          </a:p>
+          <a:p>
+            <a:pPr>
+              <a:lnSpc>
+                <a:spcPts val="1150"/>
+              </a:lnSpc>
+              <a:buNone/>
+            </a:pPr>
+            <a:r>
+              <a:rPr lang="en-US" sz="1050">
+                <a:solidFill>
+                  <a:srgbClr val="ABA6C8"/>
+                </a:solidFill>
+                <a:latin typeface="Consolas"/>
+              </a:rPr>
+              <a:t>  },</a:t>
+            </a:r>
+            <a:endParaRPr sz="1050"/>
+          </a:p>
+          <a:p>
+            <a:pPr>
+              <a:lnSpc>
+                <a:spcPts val="1150"/>
+              </a:lnSpc>
+              <a:buNone/>
+            </a:pPr>
+            <a:r>
+              <a:rPr lang="en-US" sz="1050">
+                <a:solidFill>
+                  <a:srgbClr val="ECE9F8"/>
+                </a:solidFill>
+                <a:latin typeface="Consolas"/>
+              </a:rPr>
+              <a:t>  "usage": { "output_tokens": </a:t>
+            </a:r>
+            <a:r>
+              <a:rPr lang="en-US" sz="1050">
+                <a:solidFill>
+                  <a:srgbClr val="3DD6FF"/>
+                </a:solidFill>
+                <a:latin typeface="Consolas"/>
+              </a:rPr>
+              <a:t>3, … }</a:t>
+            </a:r>
+            <a:endParaRPr sz="1050"/>
+          </a:p>
+          <a:p>
+            <a:pPr>
+              <a:lnSpc>
+                <a:spcPts val="1150"/>
+              </a:lnSpc>
+              <a:buNone/>
+            </a:pPr>
+            <a:r>
+              <a:rPr lang="en-US" sz="1050">
+                <a:solidFill>
+                  <a:srgbClr val="ABA6C8"/>
+                </a:solidFill>
+                <a:latin typeface="Consolas"/>
+              </a:rPr>
+              <a:t>}</a:t>
+            </a:r>
+            <a:endParaRPr sz="1050"/>
+          </a:p>
+        </p:txBody>
+      </p:sp>
+      <p:sp>
+        <p:nvSpPr>
+          <p:cNvPr id="13" name="Omitted request fields"/>
+          <p:cNvSpPr txBox="1"/>
+          <p:nvPr/>
+        </p:nvSpPr>
+        <p:spPr>
+          <a:xfrm>
+            <a:off x="777240" y="4050792"/>
+            <a:ext cx="3337560" cy="365760"/>
+          </a:xfrm>
+          <a:prstGeom prst="rect">
+            <a:avLst/>
+          </a:prstGeom>
+          <a:noFill/>
+          <a:ln/>
+        </p:spPr>
+        <p:txBody>
+          <a:bodyPr wrap="square" lIns="0" tIns="0" rIns="0" bIns="0"/>
+          <a:lstStyle/>
+          <a:p>
+            <a:pPr>
+              <a:lnSpc>
+                <a:spcPts val="1200"/>
+              </a:lnSpc>
+              <a:buNone/>
+            </a:pPr>
+            <a:r>
+              <a:rPr lang="en-US" sz="1050">
+                <a:solidFill>
+                  <a:srgbClr val="ABA6C8"/>
+                </a:solidFill>
+                <a:latin typeface="Segoe UI"/>
+              </a:rPr>
+              <a:t>All three include instructions.</a:t>
+            </a:r>
+            <a:endParaRPr sz="1050"/>
+          </a:p>
+          <a:p>
+            <a:pPr>
+              <a:lnSpc>
+                <a:spcPts val="1200"/>
+              </a:lnSpc>
+              <a:buNone/>
+            </a:pPr>
+            <a:r>
+              <a:rPr lang="en-US" sz="1050">
+                <a:solidFill>
+                  <a:srgbClr val="ABA6C8"/>
+                </a:solidFill>
+                <a:latin typeface="Segoe UI"/>
+              </a:rPr>
+              <a:t>Choice and score add criteria (options).</a:t>
+            </a:r>
+            <a:endParaRPr sz="1050"/>
+          </a:p>
+        </p:txBody>
+      </p:sp>
+      <p:sp>
+        <p:nvSpPr>
+          <p:cNvPr id="14" name="Illustrative response caveat"/>
+          <p:cNvSpPr txBox="1"/>
+          <p:nvPr/>
+        </p:nvSpPr>
+        <p:spPr>
+          <a:xfrm>
+            <a:off x="4892040" y="4261104"/>
+            <a:ext cx="3474720" cy="182880"/>
+          </a:xfrm>
+          <a:prstGeom prst="rect">
+            <a:avLst/>
+          </a:prstGeom>
+          <a:noFill/>
+          <a:ln/>
+        </p:spPr>
+        <p:txBody>
+          <a:bodyPr wrap="square" lIns="0" tIns="0" rIns="0" bIns="0"/>
+          <a:lstStyle/>
+          <a:p>
+            <a:pPr>
+              <a:buNone/>
+            </a:pPr>
+            <a:r>
+              <a:rPr lang="en-US" sz="1050">
+                <a:solidFill>
+                  <a:srgbClr val="ABA6C8"/>
+                </a:solidFill>
+                <a:latin typeface="Segoe UI"/>
+              </a:rPr>
+              <a:t>Illustrative reply; extra fields omitted.</a:t>
+            </a:r>
+            <a:endParaRPr lang="en-US" sz="1050"/>
+          </a:p>
+        </p:txBody>
+      </p:sp>
+    </p:spTree>
+  </p:cSld>
+  <p:clrMapOvr>
+    <a:masterClrMapping/>
+  </p:clrMapOvr>
+</p:sld>
+</file>
+
+<file path=ppt/slides/slide11.xml><?xml version="1.0" encoding="utf-8"?>
+<p:sld xmlns:a="http://schemas.openxmlformats.org/drawingml/2006/main" xmlns:r="http://schemas.openxmlformats.org/officeDocument/2006/relationships" xmlns:p="http://schemas.openxmlformats.org/presentationml/2006/main">
   <p:cSld name="Slide 8">
     <p:bg>
       <p:bgPr>
@@ -2121,7 +3087,7 @@
 </p:sld>
 </file>
 
-<file path=ppt/slides/slide11.xml><?xml version="1.0" encoding="utf-8"?>
+<file path=ppt/slides/slide12.xml><?xml version="1.0" encoding="utf-8"?>
 <p:sld xmlns:a="http://schemas.openxmlformats.org/drawingml/2006/main" xmlns:r="http://schemas.openxmlformats.org/officeDocument/2006/relationships" xmlns:p="http://schemas.openxmlformats.org/presentationml/2006/main">
   <p:cSld name="Slide 12">
     <p:bg>
@@ -2965,7 +3931,7 @@
 </p:sld>
 </file>
 
-<file path=ppt/slides/slide12.xml><?xml version="1.0" encoding="utf-8"?>
+<file path=ppt/slides/slide13.xml><?xml version="1.0" encoding="utf-8"?>
 <p:sld xmlns:a="http://schemas.openxmlformats.org/drawingml/2006/main" xmlns:r="http://schemas.openxmlformats.org/officeDocument/2006/relationships" xmlns:p="http://schemas.openxmlformats.org/presentationml/2006/main">
   <p:cSld name="Slide 9">
     <p:bg>
@@ -3802,7 +4768,7 @@
 </p:sld>
 </file>
 
-<file path=ppt/slides/slide13.xml><?xml version="1.0" encoding="utf-8"?>
+<file path=ppt/slides/slide14.xml><?xml version="1.0" encoding="utf-8"?>
 <p:sld xmlns:a="http://schemas.openxmlformats.org/drawingml/2006/main" xmlns:r="http://schemas.openxmlformats.org/officeDocument/2006/relationships" xmlns:p="http://schemas.openxmlformats.org/presentationml/2006/main">
   <p:cSld name="Slide 10">
     <p:bg>
@@ -4474,7 +5440,7 @@
 </p:sld>
 </file>
 
-<file path=ppt/slides/slide14.xml><?xml version="1.0" encoding="utf-8"?>
+<file path=ppt/slides/slide15.xml><?xml version="1.0" encoding="utf-8"?>
 <p:sld xmlns:a="http://schemas.openxmlformats.org/drawingml/2006/main" xmlns:r="http://schemas.openxmlformats.org/officeDocument/2006/relationships" xmlns:p="http://schemas.openxmlformats.org/presentationml/2006/main">
   <p:cSld name="Slide 11">
     <p:bg>
@@ -5881,7 +6847,7 @@
 </file>
 
 <file path=ppt/slides/slide2.xml><?xml version="1.0" encoding="utf-8"?>
-<p:sld xmlns:a="http://schemas.openxmlformats.org/drawingml/2006/main" xmlns:r="http://schemas.openxmlformats.org/officeDocument/2006/relationships" xmlns:p="http://schemas.openxmlformats.org/presentationml/2006/main">
+<p:sld xmlns:a="http://schemas.openxmlformats.org/drawingml/2006/main" xmlns:r="http://schemas.openxmlformats.org/officeDocument/2006/relationships" xmlns:p="http://schemas.openxmlformats.org/presentationml/2006/main" show="0">
   <p:cSld>
     <p:spTree>
       <p:nvGrpSpPr>
@@ -5942,6 +6908,230 @@
 
 <file path=ppt/slides/slide3.xml><?xml version="1.0" encoding="utf-8"?>
 <p:sld xmlns:a="http://schemas.openxmlformats.org/drawingml/2006/main" xmlns:r="http://schemas.openxmlformats.org/officeDocument/2006/relationships" xmlns:p="http://schemas.openxmlformats.org/presentationml/2006/main">
+  <p:cSld>
+    <p:bg>
+      <p:bgPr>
+        <a:solidFill>
+          <a:schemeClr val="bg1"/>
+        </a:solidFill>
+        <a:effectLst/>
+      </p:bgPr>
+    </p:bg>
+    <p:spTree>
+      <p:nvGrpSpPr>
+        <p:cNvPr id="1" name=""/>
+        <p:cNvGrpSpPr/>
+        <p:nvPr/>
+      </p:nvGrpSpPr>
+      <p:grpSpPr>
+        <a:xfrm>
+          <a:off x="0" y="0"/>
+          <a:ext cx="0" cy="0"/>
+          <a:chOff x="0" y="0"/>
+          <a:chExt cx="0" cy="0"/>
+        </a:xfrm>
+      </p:grpSpPr>
+      <p:sp>
+        <p:nvSpPr>
+          <p:cNvPr id="7" name="Rectangle 6">
+            <a:extLst>
+              <a:ext uri="{FF2B5EF4-FFF2-40B4-BE49-F238E27FC236}">
+                <a16:creationId xmlns:a16="http://schemas.microsoft.com/office/drawing/2014/main" id="{42A4FC2C-047E-45A5-965D-8E1E3BF09BC6}"/>
+              </a:ext>
+              <a:ext uri="{C183D7F6-B498-43B3-948B-1728B52AA6E4}">
+                <adec:decorative xmlns:adec="http://schemas.microsoft.com/office/drawing/2017/decorative" val="1"/>
+              </a:ext>
+            </a:extLst>
+          </p:cNvPr>
+          <p:cNvSpPr>
+            <a:spLocks noGrp="1" noRot="1" noChangeAspect="1" noMove="1" noResize="1" noEditPoints="1" noAdjustHandles="1" noChangeArrowheads="1" noChangeShapeType="1" noTextEdit="1"/>
+          </p:cNvSpPr>
+          <p:nvPr>
+            <p:extLst>
+              <p:ext uri="{386F3935-93C4-4BCD-93E2-E3B085C9AB24}">
+                <p16:designElem xmlns:p16="http://schemas.microsoft.com/office/powerpoint/2015/main" val="1"/>
+              </p:ext>
+            </p:extLst>
+          </p:nvPr>
+        </p:nvSpPr>
+        <p:spPr bwMode="white">
+          <a:xfrm>
+            <a:off x="1143" y="0"/>
+            <a:ext cx="9141714" cy="5143500"/>
+          </a:xfrm>
+          <a:prstGeom prst="rect">
+            <a:avLst/>
+          </a:prstGeom>
+          <a:noFill/>
+          <a:ln>
+            <a:noFill/>
+          </a:ln>
+        </p:spPr>
+        <p:style>
+          <a:lnRef idx="2">
+            <a:schemeClr val="accent1">
+              <a:shade val="50000"/>
+            </a:schemeClr>
+          </a:lnRef>
+          <a:fillRef idx="1">
+            <a:schemeClr val="accent1"/>
+          </a:fillRef>
+          <a:effectRef idx="0">
+            <a:schemeClr val="accent1"/>
+          </a:effectRef>
+          <a:fontRef idx="minor">
+            <a:schemeClr val="lt1"/>
+          </a:fontRef>
+        </p:style>
+        <p:txBody>
+          <a:bodyPr rtlCol="0" anchor="ctr"/>
+          <a:lstStyle>
+            <a:defPPr>
+              <a:defRPr lang="en-US"/>
+            </a:defPPr>
+            <a:lvl1pPr marL="0" algn="l" defTabSz="914400" rtl="0" eaLnBrk="1" latinLnBrk="0" hangingPunct="1">
+              <a:defRPr sz="1800" kern="1200">
+                <a:solidFill>
+                  <a:schemeClr val="lt1"/>
+                </a:solidFill>
+                <a:latin typeface="+mn-lt"/>
+                <a:ea typeface="+mn-ea"/>
+                <a:cs typeface="+mn-cs"/>
+              </a:defRPr>
+            </a:lvl1pPr>
+            <a:lvl2pPr marL="457200" algn="l" defTabSz="914400" rtl="0" eaLnBrk="1" latinLnBrk="0" hangingPunct="1">
+              <a:defRPr sz="1800" kern="1200">
+                <a:solidFill>
+                  <a:schemeClr val="lt1"/>
+                </a:solidFill>
+                <a:latin typeface="+mn-lt"/>
+                <a:ea typeface="+mn-ea"/>
+                <a:cs typeface="+mn-cs"/>
+              </a:defRPr>
+            </a:lvl2pPr>
+            <a:lvl3pPr marL="914400" algn="l" defTabSz="914400" rtl="0" eaLnBrk="1" latinLnBrk="0" hangingPunct="1">
+              <a:defRPr sz="1800" kern="1200">
+                <a:solidFill>
+                  <a:schemeClr val="lt1"/>
+                </a:solidFill>
+                <a:latin typeface="+mn-lt"/>
+                <a:ea typeface="+mn-ea"/>
+                <a:cs typeface="+mn-cs"/>
+              </a:defRPr>
+            </a:lvl3pPr>
+            <a:lvl4pPr marL="1371600" algn="l" defTabSz="914400" rtl="0" eaLnBrk="1" latinLnBrk="0" hangingPunct="1">
+              <a:defRPr sz="1800" kern="1200">
+                <a:solidFill>
+                  <a:schemeClr val="lt1"/>
+                </a:solidFill>
+                <a:latin typeface="+mn-lt"/>
+                <a:ea typeface="+mn-ea"/>
+                <a:cs typeface="+mn-cs"/>
+              </a:defRPr>
+            </a:lvl4pPr>
+            <a:lvl5pPr marL="1828800" algn="l" defTabSz="914400" rtl="0" eaLnBrk="1" latinLnBrk="0" hangingPunct="1">
+              <a:defRPr sz="1800" kern="1200">
+                <a:solidFill>
+                  <a:schemeClr val="lt1"/>
+                </a:solidFill>
+                <a:latin typeface="+mn-lt"/>
+                <a:ea typeface="+mn-ea"/>
+                <a:cs typeface="+mn-cs"/>
+              </a:defRPr>
+            </a:lvl5pPr>
+            <a:lvl6pPr marL="2286000" algn="l" defTabSz="914400" rtl="0" eaLnBrk="1" latinLnBrk="0" hangingPunct="1">
+              <a:defRPr sz="1800" kern="1200">
+                <a:solidFill>
+                  <a:schemeClr val="lt1"/>
+                </a:solidFill>
+                <a:latin typeface="+mn-lt"/>
+                <a:ea typeface="+mn-ea"/>
+                <a:cs typeface="+mn-cs"/>
+              </a:defRPr>
+            </a:lvl6pPr>
+            <a:lvl7pPr marL="2743200" algn="l" defTabSz="914400" rtl="0" eaLnBrk="1" latinLnBrk="0" hangingPunct="1">
+              <a:defRPr sz="1800" kern="1200">
+                <a:solidFill>
+                  <a:schemeClr val="lt1"/>
+                </a:solidFill>
+                <a:latin typeface="+mn-lt"/>
+                <a:ea typeface="+mn-ea"/>
+                <a:cs typeface="+mn-cs"/>
+              </a:defRPr>
+            </a:lvl7pPr>
+            <a:lvl8pPr marL="3200400" algn="l" defTabSz="914400" rtl="0" eaLnBrk="1" latinLnBrk="0" hangingPunct="1">
+              <a:defRPr sz="1800" kern="1200">
+                <a:solidFill>
+                  <a:schemeClr val="lt1"/>
+                </a:solidFill>
+                <a:latin typeface="+mn-lt"/>
+                <a:ea typeface="+mn-ea"/>
+                <a:cs typeface="+mn-cs"/>
+              </a:defRPr>
+            </a:lvl8pPr>
+            <a:lvl9pPr marL="3657600" algn="l" defTabSz="914400" rtl="0" eaLnBrk="1" latinLnBrk="0" hangingPunct="1">
+              <a:defRPr sz="1800" kern="1200">
+                <a:solidFill>
+                  <a:schemeClr val="lt1"/>
+                </a:solidFill>
+                <a:latin typeface="+mn-lt"/>
+                <a:ea typeface="+mn-ea"/>
+                <a:cs typeface="+mn-cs"/>
+              </a:defRPr>
+            </a:lvl9pPr>
+          </a:lstStyle>
+          <a:p>
+            <a:pPr algn="ctr"/>
+            <a:endParaRPr lang="en-US"/>
+          </a:p>
+        </p:txBody>
+      </p:sp>
+      <p:pic>
+        <p:nvPicPr>
+          <p:cNvPr id="2" name="Picture 1" descr="Image preview">
+            <a:extLst>
+              <a:ext uri="{FF2B5EF4-FFF2-40B4-BE49-F238E27FC236}">
+                <a16:creationId xmlns:a16="http://schemas.microsoft.com/office/drawing/2014/main" id="{1EA80197-9483-974C-A334-720D4653C3C1}"/>
+              </a:ext>
+            </a:extLst>
+          </p:cNvPr>
+          <p:cNvPicPr>
+            <a:picLocks noChangeAspect="1"/>
+          </p:cNvPicPr>
+          <p:nvPr/>
+        </p:nvPicPr>
+        <p:blipFill>
+          <a:blip r:embed="rId2"/>
+          <a:srcRect b="19"/>
+          <a:stretch>
+            <a:fillRect/>
+          </a:stretch>
+        </p:blipFill>
+        <p:spPr>
+          <a:xfrm>
+            <a:off x="20" y="961"/>
+            <a:ext cx="9143980" cy="5142539"/>
+          </a:xfrm>
+          <a:prstGeom prst="rect">
+            <a:avLst/>
+          </a:prstGeom>
+        </p:spPr>
+      </p:pic>
+    </p:spTree>
+    <p:extLst>
+      <p:ext uri="{BB962C8B-B14F-4D97-AF65-F5344CB8AC3E}">
+        <p14:creationId xmlns:p14="http://schemas.microsoft.com/office/powerpoint/2010/main" val="1180468926"/>
+      </p:ext>
+    </p:extLst>
+  </p:cSld>
+  <p:clrMapOvr>
+    <a:masterClrMapping/>
+  </p:clrMapOvr>
+</p:sld>
+</file>
+
+<file path=ppt/slides/slide4.xml><?xml version="1.0" encoding="utf-8"?>
+<p:sld xmlns:a="http://schemas.openxmlformats.org/drawingml/2006/main" xmlns:r="http://schemas.openxmlformats.org/officeDocument/2006/relationships" xmlns:p="http://schemas.openxmlformats.org/presentationml/2006/main">
   <p:cSld name="Slide 2">
     <p:bg>
       <p:bgPr>
@@ -6618,7 +7808,7 @@
 </p:sld>
 </file>
 
-<file path=ppt/slides/slide4.xml><?xml version="1.0" encoding="utf-8"?>
+<file path=ppt/slides/slide5.xml><?xml version="1.0" encoding="utf-8"?>
 <p:sld xmlns:a="http://schemas.openxmlformats.org/drawingml/2006/main" xmlns:r="http://schemas.openxmlformats.org/officeDocument/2006/relationships" xmlns:p="http://schemas.openxmlformats.org/presentationml/2006/main">
   <p:cSld name="Slide 3">
     <p:bg>
@@ -7435,7 +8625,7 @@
 </p:sld>
 </file>
 
-<file path=ppt/slides/slide5.xml><?xml version="1.0" encoding="utf-8"?>
+<file path=ppt/slides/slide6.xml><?xml version="1.0" encoding="utf-8"?>
 <p:sld xmlns:a="http://schemas.openxmlformats.org/drawingml/2006/main" xmlns:r="http://schemas.openxmlformats.org/officeDocument/2006/relationships" xmlns:p="http://schemas.openxmlformats.org/presentationml/2006/main">
   <p:cSld name="Slide 4">
     <p:bg>
@@ -9235,7 +10425,7 @@
 </p:sld>
 </file>
 
-<file path=ppt/slides/slide6.xml><?xml version="1.0" encoding="utf-8"?>
+<file path=ppt/slides/slide7.xml><?xml version="1.0" encoding="utf-8"?>
 <p:sld xmlns:a="http://schemas.openxmlformats.org/drawingml/2006/main" xmlns:r="http://schemas.openxmlformats.org/officeDocument/2006/relationships" xmlns:p="http://schemas.openxmlformats.org/presentationml/2006/main">
   <p:cSld name="Slide 5">
     <p:bg>
@@ -10584,7 +11774,7 @@
 </p:sld>
 </file>
 
-<file path=ppt/slides/slide7.xml><?xml version="1.0" encoding="utf-8"?>
+<file path=ppt/slides/slide8.xml><?xml version="1.0" encoding="utf-8"?>
 <p:sld xmlns:a="http://schemas.openxmlformats.org/drawingml/2006/main" xmlns:r="http://schemas.openxmlformats.org/officeDocument/2006/relationships" xmlns:p="http://schemas.openxmlformats.org/presentationml/2006/main">
   <p:cSld name="Slide 6">
     <p:bg>
@@ -13186,7 +14376,7 @@
 </p:sld>
 </file>
 
-<file path=ppt/slides/slide8.xml><?xml version="1.0" encoding="utf-8"?>
+<file path=ppt/slides/slide9.xml><?xml version="1.0" encoding="utf-8"?>
 <p:sld xmlns:a="http://schemas.openxmlformats.org/drawingml/2006/main" xmlns:r="http://schemas.openxmlformats.org/officeDocument/2006/relationships" xmlns:p="http://schemas.openxmlformats.org/presentationml/2006/main">
   <p:cSld name="A radio check, not a chat">
     <p:bg>
@@ -14105,971 +15295,6 @@
               <a:t>requests can overlap; rivals do not exchange plans.</a:t>
             </a:r>
             <a:endParaRPr lang="en-US" sz="1200"/>
-          </a:p>
-        </p:txBody>
-      </p:sp>
-    </p:spTree>
-  </p:cSld>
-  <p:clrMapOvr>
-    <a:masterClrMapping/>
-  </p:clrMapOvr>
-</p:sld>
-</file>
-
-<file path=ppt/slides/slide9.xml><?xml version="1.0" encoding="utf-8"?>
-<p:sld xmlns:a="http://schemas.openxmlformats.org/drawingml/2006/main" xmlns:r="http://schemas.openxmlformats.org/officeDocument/2006/relationships" xmlns:p="http://schemas.openxmlformats.org/presentationml/2006/main">
-  <p:cSld name="One request, three answers">
-    <p:bg>
-      <p:bgPr>
-        <a:solidFill>
-          <a:srgbClr val="07071A"/>
-        </a:solidFill>
-        <a:effectLst/>
-      </p:bgPr>
-    </p:bg>
-    <p:spTree>
-      <p:nvGrpSpPr>
-        <p:cNvPr id="1" name=""/>
-        <p:cNvGrpSpPr/>
-        <p:nvPr/>
-      </p:nvGrpSpPr>
-      <p:grpSpPr>
-        <a:xfrm>
-          <a:off x="0" y="0"/>
-          <a:ext cx="0" cy="0"/>
-          <a:chOff x="0" y="0"/>
-          <a:chExt cx="0" cy="0"/>
-        </a:xfrm>
-      </p:grpSpPr>
-      <p:sp>
-        <p:nvSpPr>
-          <p:cNvPr id="2" name="Header dot"/>
-          <p:cNvSpPr/>
-          <p:nvPr/>
-        </p:nvSpPr>
-        <p:spPr>
-          <a:xfrm>
-            <a:off x="548640" y="484632"/>
-            <a:ext cx="109728" cy="109728"/>
-          </a:xfrm>
-          <a:prstGeom prst="ellipse">
-            <a:avLst/>
-          </a:prstGeom>
-          <a:solidFill>
-            <a:srgbClr val="FFD166"/>
-          </a:solidFill>
-          <a:ln/>
-        </p:spPr>
-        <p:txBody>
-          <a:bodyPr/>
-          <a:lstStyle/>
-          <a:p>
-            <a:endParaRPr lang="en-ZA"/>
-          </a:p>
-        </p:txBody>
-      </p:sp>
-      <p:sp>
-        <p:nvSpPr>
-          <p:cNvPr id="3" name="Section label"/>
-          <p:cNvSpPr txBox="1"/>
-          <p:nvPr/>
-        </p:nvSpPr>
-        <p:spPr>
-          <a:xfrm>
-            <a:off x="749808" y="393192"/>
-            <a:ext cx="5943600" cy="292608"/>
-          </a:xfrm>
-          <a:prstGeom prst="rect">
-            <a:avLst/>
-          </a:prstGeom>
-          <a:noFill/>
-          <a:ln/>
-        </p:spPr>
-        <p:txBody>
-          <a:bodyPr wrap="square" lIns="0" tIns="0" rIns="0" bIns="0" anchor="ctr"/>
-          <a:lstStyle/>
-          <a:p>
-            <a:pPr>
-              <a:buNone/>
-            </a:pPr>
-            <a:r>
-              <a:rPr lang="en-US" sz="1100" b="1" kern="0" spc="300">
-                <a:solidFill>
-                  <a:srgbClr val="ABA6C8"/>
-                </a:solidFill>
-                <a:latin typeface="Segoe UI Semibold"/>
-              </a:rPr>
-              <a:t>THE JSON EXCHANGE</a:t>
-            </a:r>
-            <a:endParaRPr lang="en-US" sz="1100"/>
-          </a:p>
-        </p:txBody>
-      </p:sp>
-      <p:sp>
-        <p:nvSpPr>
-          <p:cNvPr id="4" name="Slide counter"/>
-          <p:cNvSpPr txBox="1"/>
-          <p:nvPr/>
-        </p:nvSpPr>
-        <p:spPr>
-          <a:xfrm>
-            <a:off x="7223760" y="393192"/>
-            <a:ext cx="1371600" cy="292608"/>
-          </a:xfrm>
-          <a:prstGeom prst="rect">
-            <a:avLst/>
-          </a:prstGeom>
-          <a:noFill/>
-          <a:ln/>
-        </p:spPr>
-        <p:txBody>
-          <a:bodyPr wrap="square" lIns="0" tIns="0" rIns="0" bIns="0" anchor="ctr"/>
-          <a:lstStyle/>
-          <a:p>
-            <a:pPr algn="r">
-              <a:buNone/>
-            </a:pPr>
-            <a:r>
-              <a:rPr lang="en-US" sz="1100">
-                <a:solidFill>
-                  <a:srgbClr val="ABA6C8"/>
-                </a:solidFill>
-                <a:latin typeface="Segoe UI Semibold"/>
-              </a:rPr>
-              <a:t>08 / 13</a:t>
-            </a:r>
-            <a:endParaRPr lang="en-US" sz="1100"/>
-          </a:p>
-        </p:txBody>
-      </p:sp>
-      <p:sp>
-        <p:nvSpPr>
-          <p:cNvPr id="5" name="Slide title"/>
-          <p:cNvSpPr txBox="1"/>
-          <p:nvPr/>
-        </p:nvSpPr>
-        <p:spPr>
-          <a:xfrm>
-            <a:off x="548640" y="749808"/>
-            <a:ext cx="8046720" cy="658368"/>
-          </a:xfrm>
-          <a:prstGeom prst="rect">
-            <a:avLst/>
-          </a:prstGeom>
-          <a:noFill/>
-          <a:ln/>
-        </p:spPr>
-        <p:txBody>
-          <a:bodyPr wrap="square" lIns="0" tIns="0" rIns="0" bIns="0"/>
-          <a:lstStyle/>
-          <a:p>
-            <a:pPr>
-              <a:buNone/>
-            </a:pPr>
-            <a:r>
-              <a:rPr lang="en-US" sz="3400" b="1" i="1">
-                <a:solidFill>
-                  <a:srgbClr val="ECE9F8"/>
-                </a:solidFill>
-                <a:latin typeface="Segoe UI Black"/>
-              </a:rPr>
-              <a:t>One request, three answers</a:t>
-            </a:r>
-            <a:endParaRPr lang="en-US" sz="3400"/>
-          </a:p>
-        </p:txBody>
-      </p:sp>
-      <p:sp>
-        <p:nvSpPr>
-          <p:cNvPr id="6" name="Slide subtitle"/>
-          <p:cNvSpPr txBox="1"/>
-          <p:nvPr/>
-        </p:nvSpPr>
-        <p:spPr>
-          <a:xfrm>
-            <a:off x="548640" y="1417320"/>
-            <a:ext cx="8046720" cy="320040"/>
-          </a:xfrm>
-          <a:prstGeom prst="rect">
-            <a:avLst/>
-          </a:prstGeom>
-          <a:noFill/>
-          <a:ln/>
-        </p:spPr>
-        <p:txBody>
-          <a:bodyPr wrap="square" lIns="0" tIns="0" rIns="0" bIns="0"/>
-          <a:lstStyle/>
-          <a:p>
-            <a:pPr>
-              <a:buNone/>
-            </a:pPr>
-            <a:r>
-              <a:rPr lang="en-US" sz="1450">
-                <a:solidFill>
-                  <a:srgbClr val="ABA6C8"/>
-                </a:solidFill>
-                <a:latin typeface="Segoe UI"/>
-              </a:rPr>
-              <a:t>Abbreviated JSON: one driver's situation in, three named answers out.</a:t>
-            </a:r>
-            <a:endParaRPr lang="en-US" sz="1450"/>
-          </a:p>
-        </p:txBody>
-      </p:sp>
-      <p:sp>
-        <p:nvSpPr>
-          <p:cNvPr id="7" name="Request card"/>
-          <p:cNvSpPr/>
-          <p:nvPr/>
-        </p:nvSpPr>
-        <p:spPr>
-          <a:xfrm>
-            <a:off x="548640" y="1874520"/>
-            <a:ext cx="3794760" cy="2651760"/>
-          </a:xfrm>
-          <a:prstGeom prst="roundRect">
-            <a:avLst>
-              <a:gd name="adj" fmla="val 9143"/>
-            </a:avLst>
-          </a:prstGeom>
-          <a:solidFill>
-            <a:srgbClr val="110F2B"/>
-          </a:solidFill>
-          <a:ln/>
-        </p:spPr>
-        <p:txBody>
-          <a:bodyPr/>
-          <a:lstStyle/>
-          <a:p>
-            <a:endParaRPr lang="en-ZA"/>
-          </a:p>
-        </p:txBody>
-      </p:sp>
-      <p:sp>
-        <p:nvSpPr>
-          <p:cNvPr id="8" name="Response card"/>
-          <p:cNvSpPr/>
-          <p:nvPr/>
-        </p:nvSpPr>
-        <p:spPr>
-          <a:xfrm>
-            <a:off x="4663440" y="1874520"/>
-            <a:ext cx="3931920" cy="2651760"/>
-          </a:xfrm>
-          <a:prstGeom prst="roundRect">
-            <a:avLst>
-              <a:gd name="adj" fmla="val 9143"/>
-            </a:avLst>
-          </a:prstGeom>
-          <a:solidFill>
-            <a:srgbClr val="110F2B"/>
-          </a:solidFill>
-          <a:ln/>
-        </p:spPr>
-        <p:txBody>
-          <a:bodyPr/>
-          <a:lstStyle/>
-          <a:p>
-            <a:endParaRPr lang="en-ZA"/>
-          </a:p>
-        </p:txBody>
-      </p:sp>
-      <p:sp>
-        <p:nvSpPr>
-          <p:cNvPr id="9" name="Request label"/>
-          <p:cNvSpPr txBox="1"/>
-          <p:nvPr/>
-        </p:nvSpPr>
-        <p:spPr>
-          <a:xfrm>
-            <a:off x="777240" y="2039112"/>
-            <a:ext cx="1828800" cy="237744"/>
-          </a:xfrm>
-          <a:prstGeom prst="rect">
-            <a:avLst/>
-          </a:prstGeom>
-          <a:noFill/>
-          <a:ln/>
-        </p:spPr>
-        <p:txBody>
-          <a:bodyPr wrap="square" lIns="0" tIns="0" rIns="0" bIns="0"/>
-          <a:lstStyle/>
-          <a:p>
-            <a:pPr>
-              <a:buNone/>
-            </a:pPr>
-            <a:r>
-              <a:rPr lang="en-US" sz="1050" b="1" spc="200">
-                <a:solidFill>
-                  <a:srgbClr val="ABA6C8"/>
-                </a:solidFill>
-                <a:latin typeface="Segoe UI Semibold"/>
-              </a:rPr>
-              <a:t>REQUEST</a:t>
-            </a:r>
-            <a:endParaRPr lang="en-US" sz="1050"/>
-          </a:p>
-        </p:txBody>
-      </p:sp>
-      <p:sp>
-        <p:nvSpPr>
-          <p:cNvPr id="10" name="Response label"/>
-          <p:cNvSpPr txBox="1"/>
-          <p:nvPr/>
-        </p:nvSpPr>
-        <p:spPr>
-          <a:xfrm>
-            <a:off x="4892040" y="2039112"/>
-            <a:ext cx="1828800" cy="237744"/>
-          </a:xfrm>
-          <a:prstGeom prst="rect">
-            <a:avLst/>
-          </a:prstGeom>
-          <a:noFill/>
-          <a:ln/>
-        </p:spPr>
-        <p:txBody>
-          <a:bodyPr wrap="square" lIns="0" tIns="0" rIns="0" bIns="0"/>
-          <a:lstStyle/>
-          <a:p>
-            <a:pPr>
-              <a:buNone/>
-            </a:pPr>
-            <a:r>
-              <a:rPr lang="en-US" sz="1050" b="1" spc="200">
-                <a:solidFill>
-                  <a:srgbClr val="ABA6C8"/>
-                </a:solidFill>
-                <a:latin typeface="Segoe UI Semibold"/>
-              </a:rPr>
-              <a:t>RESPONSE</a:t>
-            </a:r>
-            <a:endParaRPr lang="en-US" sz="1050"/>
-          </a:p>
-        </p:txBody>
-      </p:sp>
-      <p:sp>
-        <p:nvSpPr>
-          <p:cNvPr id="11" name="Request JSON"/>
-          <p:cNvSpPr txBox="1"/>
-          <p:nvPr/>
-        </p:nvSpPr>
-        <p:spPr>
-          <a:xfrm>
-            <a:off x="777240" y="2322576"/>
-            <a:ext cx="3337560" cy="1764792"/>
-          </a:xfrm>
-          <a:prstGeom prst="rect">
-            <a:avLst/>
-          </a:prstGeom>
-          <a:noFill/>
-          <a:ln/>
-        </p:spPr>
-        <p:txBody>
-          <a:bodyPr wrap="square" lIns="0" tIns="0" rIns="0" bIns="0"/>
-          <a:lstStyle/>
-          <a:p>
-            <a:pPr>
-              <a:lnSpc>
-                <a:spcPts val="1150"/>
-              </a:lnSpc>
-              <a:buNone/>
-            </a:pPr>
-            <a:r>
-              <a:rPr lang="en-US" sz="1050">
-                <a:solidFill>
-                  <a:srgbClr val="3DD6FF"/>
-                </a:solidFill>
-                <a:latin typeface="Consolas"/>
-              </a:rPr>
-              <a:t>POST …/providers/microsoft/v1/systemone</a:t>
-            </a:r>
-            <a:endParaRPr sz="1050"/>
-          </a:p>
-          <a:p>
-            <a:pPr>
-              <a:lnSpc>
-                <a:spcPts val="1150"/>
-              </a:lnSpc>
-              <a:buNone/>
-            </a:pPr>
-            <a:r>
-              <a:rPr lang="en-US" sz="1050">
-                <a:solidFill>
-                  <a:srgbClr val="ABA6C8"/>
-                </a:solidFill>
-                <a:latin typeface="Consolas"/>
-              </a:rPr>
-              <a:t>{</a:t>
-            </a:r>
-            <a:endParaRPr sz="1050"/>
-          </a:p>
-          <a:p>
-            <a:pPr>
-              <a:lnSpc>
-                <a:spcPts val="1150"/>
-              </a:lnSpc>
-              <a:buNone/>
-            </a:pPr>
-            <a:r>
-              <a:rPr lang="en-US" sz="1050">
-                <a:solidFill>
-                  <a:srgbClr val="ECE9F8"/>
-                </a:solidFill>
-                <a:latin typeface="Consolas"/>
-              </a:rPr>
-              <a:t>  "model": </a:t>
-            </a:r>
-            <a:r>
-              <a:rPr lang="en-US" sz="1050">
-                <a:solidFill>
-                  <a:srgbClr val="FFD166"/>
-                </a:solidFill>
-                <a:latin typeface="Consolas"/>
-              </a:rPr>
-              <a:t>"&lt;deployment-name&gt;",</a:t>
-            </a:r>
-            <a:endParaRPr sz="1050"/>
-          </a:p>
-          <a:p>
-            <a:pPr>
-              <a:lnSpc>
-                <a:spcPts val="1150"/>
-              </a:lnSpc>
-              <a:buNone/>
-            </a:pPr>
-            <a:r>
-              <a:rPr lang="en-US" sz="1050">
-                <a:solidFill>
-                  <a:srgbClr val="ECE9F8"/>
-                </a:solidFill>
-                <a:latin typeface="Consolas"/>
-              </a:rPr>
-              <a:t>  "state": </a:t>
-            </a:r>
-            <a:r>
-              <a:rPr lang="en-US" sz="1050">
-                <a:solidFill>
-                  <a:srgbClr val="FFD166"/>
-                </a:solidFill>
-                <a:latin typeface="Consolas"/>
-              </a:rPr>
-              <a:t>"&lt;Vega's snapshot&gt;",</a:t>
-            </a:r>
-            <a:endParaRPr sz="1050"/>
-          </a:p>
-          <a:p>
-            <a:pPr>
-              <a:lnSpc>
-                <a:spcPts val="1150"/>
-              </a:lnSpc>
-              <a:buNone/>
-            </a:pPr>
-            <a:r>
-              <a:rPr lang="en-US" sz="1050">
-                <a:solidFill>
-                  <a:srgbClr val="ECE9F8"/>
-                </a:solidFill>
-                <a:latin typeface="Consolas"/>
-              </a:rPr>
-              <a:t>  "questions": {</a:t>
-            </a:r>
-            <a:endParaRPr sz="1050"/>
-          </a:p>
-          <a:p>
-            <a:pPr>
-              <a:lnSpc>
-                <a:spcPts val="1150"/>
-              </a:lnSpc>
-              <a:buNone/>
-            </a:pPr>
-            <a:r>
-              <a:rPr lang="en-US" sz="1050">
-                <a:solidFill>
-                  <a:srgbClr val="ECE9F8"/>
-                </a:solidFill>
-                <a:latin typeface="Consolas"/>
-              </a:rPr>
-              <a:t>    "maneuver": { "type": </a:t>
-            </a:r>
-            <a:r>
-              <a:rPr lang="en-US" sz="1050">
-                <a:solidFill>
-                  <a:srgbClr val="FFD166"/>
-                </a:solidFill>
-                <a:latin typeface="Consolas"/>
-              </a:rPr>
-              <a:t>"choice", … },</a:t>
-            </a:r>
-            <a:endParaRPr sz="1050"/>
-          </a:p>
-          <a:p>
-            <a:pPr>
-              <a:lnSpc>
-                <a:spcPts val="1150"/>
-              </a:lnSpc>
-              <a:buNone/>
-            </a:pPr>
-            <a:r>
-              <a:rPr lang="en-US" sz="1050">
-                <a:solidFill>
-                  <a:srgbClr val="ECE9F8"/>
-                </a:solidFill>
-                <a:latin typeface="Consolas"/>
-              </a:rPr>
-              <a:t>    "pace": { "type": </a:t>
-            </a:r>
-            <a:r>
-              <a:rPr lang="en-US" sz="1050">
-                <a:solidFill>
-                  <a:srgbClr val="FFD166"/>
-                </a:solidFill>
-                <a:latin typeface="Consolas"/>
-              </a:rPr>
-              <a:t>"score", … },</a:t>
-            </a:r>
-            <a:endParaRPr sz="1050"/>
-          </a:p>
-          <a:p>
-            <a:pPr>
-              <a:lnSpc>
-                <a:spcPts val="1150"/>
-              </a:lnSpc>
-              <a:buNone/>
-            </a:pPr>
-            <a:r>
-              <a:rPr lang="en-US" sz="1050">
-                <a:solidFill>
-                  <a:srgbClr val="ECE9F8"/>
-                </a:solidFill>
-                <a:latin typeface="Consolas"/>
-              </a:rPr>
-              <a:t>    "nitro": { "type": </a:t>
-            </a:r>
-            <a:r>
-              <a:rPr lang="en-US" sz="1050">
-                <a:solidFill>
-                  <a:srgbClr val="FFD166"/>
-                </a:solidFill>
-                <a:latin typeface="Consolas"/>
-              </a:rPr>
-              <a:t>"noul", … }</a:t>
-            </a:r>
-            <a:endParaRPr sz="1050"/>
-          </a:p>
-          <a:p>
-            <a:pPr>
-              <a:lnSpc>
-                <a:spcPts val="1150"/>
-              </a:lnSpc>
-              <a:buNone/>
-            </a:pPr>
-            <a:r>
-              <a:rPr lang="en-US" sz="1050">
-                <a:solidFill>
-                  <a:srgbClr val="ABA6C8"/>
-                </a:solidFill>
-                <a:latin typeface="Consolas"/>
-              </a:rPr>
-              <a:t>  }</a:t>
-            </a:r>
-            <a:endParaRPr sz="1050"/>
-          </a:p>
-          <a:p>
-            <a:pPr>
-              <a:lnSpc>
-                <a:spcPts val="1150"/>
-              </a:lnSpc>
-              <a:buNone/>
-            </a:pPr>
-            <a:r>
-              <a:rPr lang="en-US" sz="1050">
-                <a:solidFill>
-                  <a:srgbClr val="ABA6C8"/>
-                </a:solidFill>
-                <a:latin typeface="Consolas"/>
-              </a:rPr>
-              <a:t>}</a:t>
-            </a:r>
-            <a:endParaRPr sz="1050"/>
-          </a:p>
-        </p:txBody>
-      </p:sp>
-      <p:sp>
-        <p:nvSpPr>
-          <p:cNvPr id="12" name="Response JSON"/>
-          <p:cNvSpPr txBox="1"/>
-          <p:nvPr/>
-        </p:nvSpPr>
-        <p:spPr>
-          <a:xfrm>
-            <a:off x="4892040" y="2322576"/>
-            <a:ext cx="3474720" cy="1874520"/>
-          </a:xfrm>
-          <a:prstGeom prst="rect">
-            <a:avLst/>
-          </a:prstGeom>
-          <a:noFill/>
-          <a:ln/>
-        </p:spPr>
-        <p:txBody>
-          <a:bodyPr wrap="square" lIns="0" tIns="0" rIns="0" bIns="0"/>
-          <a:lstStyle/>
-          <a:p>
-            <a:pPr>
-              <a:lnSpc>
-                <a:spcPts val="1150"/>
-              </a:lnSpc>
-              <a:buNone/>
-            </a:pPr>
-            <a:r>
-              <a:rPr lang="en-US" sz="1050">
-                <a:solidFill>
-                  <a:srgbClr val="4ADE80"/>
-                </a:solidFill>
-                <a:latin typeface="Consolas"/>
-              </a:rPr>
-              <a:t>200 OK</a:t>
-            </a:r>
-            <a:endParaRPr sz="1050"/>
-          </a:p>
-          <a:p>
-            <a:pPr>
-              <a:lnSpc>
-                <a:spcPts val="1150"/>
-              </a:lnSpc>
-              <a:buNone/>
-            </a:pPr>
-            <a:r>
-              <a:rPr lang="en-US" sz="1050">
-                <a:solidFill>
-                  <a:srgbClr val="ABA6C8"/>
-                </a:solidFill>
-                <a:latin typeface="Consolas"/>
-              </a:rPr>
-              <a:t>{</a:t>
-            </a:r>
-            <a:endParaRPr sz="1050"/>
-          </a:p>
-          <a:p>
-            <a:pPr>
-              <a:lnSpc>
-                <a:spcPts val="1150"/>
-              </a:lnSpc>
-              <a:buNone/>
-            </a:pPr>
-            <a:r>
-              <a:rPr lang="en-US" sz="1050">
-                <a:solidFill>
-                  <a:srgbClr val="ECE9F8"/>
-                </a:solidFill>
-                <a:latin typeface="Consolas"/>
-              </a:rPr>
-              <a:t>  "model": </a:t>
-            </a:r>
-            <a:r>
-              <a:rPr lang="en-US" sz="1050">
-                <a:solidFill>
-                  <a:srgbClr val="FFD166"/>
-                </a:solidFill>
-                <a:latin typeface="Consolas"/>
-              </a:rPr>
-              <a:t>"microsoft-decision-1",</a:t>
-            </a:r>
-            <a:endParaRPr sz="1050"/>
-          </a:p>
-          <a:p>
-            <a:pPr>
-              <a:lnSpc>
-                <a:spcPts val="1150"/>
-              </a:lnSpc>
-              <a:buNone/>
-            </a:pPr>
-            <a:r>
-              <a:rPr lang="en-US" sz="1050">
-                <a:solidFill>
-                  <a:srgbClr val="ECE9F8"/>
-                </a:solidFill>
-                <a:latin typeface="Consolas"/>
-              </a:rPr>
-              <a:t>  "answers": {</a:t>
-            </a:r>
-            <a:endParaRPr sz="1050"/>
-          </a:p>
-          <a:p>
-            <a:pPr>
-              <a:lnSpc>
-                <a:spcPts val="1150"/>
-              </a:lnSpc>
-              <a:buNone/>
-            </a:pPr>
-            <a:r>
-              <a:rPr lang="en-US" sz="1050">
-                <a:solidFill>
-                  <a:srgbClr val="ECE9F8"/>
-                </a:solidFill>
-                <a:latin typeface="Consolas"/>
-              </a:rPr>
-              <a:t>    "maneuver": {</a:t>
-            </a:r>
-            <a:endParaRPr sz="1050"/>
-          </a:p>
-          <a:p>
-            <a:pPr>
-              <a:lnSpc>
-                <a:spcPts val="1150"/>
-              </a:lnSpc>
-              <a:buNone/>
-            </a:pPr>
-            <a:r>
-              <a:rPr lang="en-US" sz="1050">
-                <a:solidFill>
-                  <a:srgbClr val="ECE9F8"/>
-                </a:solidFill>
-                <a:latin typeface="Consolas"/>
-              </a:rPr>
-              <a:t>      "choice": </a:t>
-            </a:r>
-            <a:r>
-              <a:rPr lang="en-US" sz="1050">
-                <a:solidFill>
-                  <a:srgbClr val="FFD166"/>
-                </a:solidFill>
-                <a:latin typeface="Consolas"/>
-              </a:rPr>
-              <a:t>"overtake_left", …</a:t>
-            </a:r>
-            <a:endParaRPr sz="1050"/>
-          </a:p>
-          <a:p>
-            <a:pPr>
-              <a:lnSpc>
-                <a:spcPts val="1150"/>
-              </a:lnSpc>
-              <a:buNone/>
-            </a:pPr>
-            <a:r>
-              <a:rPr lang="en-US" sz="1050">
-                <a:solidFill>
-                  <a:srgbClr val="ABA6C8"/>
-                </a:solidFill>
-                <a:latin typeface="Consolas"/>
-              </a:rPr>
-              <a:t>    },</a:t>
-            </a:r>
-            <a:endParaRPr sz="1050"/>
-          </a:p>
-          <a:p>
-            <a:pPr>
-              <a:lnSpc>
-                <a:spcPts val="1150"/>
-              </a:lnSpc>
-              <a:buNone/>
-            </a:pPr>
-            <a:r>
-              <a:rPr lang="en-US" sz="1050">
-                <a:solidFill>
-                  <a:srgbClr val="ECE9F8"/>
-                </a:solidFill>
-                <a:latin typeface="Consolas"/>
-              </a:rPr>
-              <a:t>    "pace": { "score": </a:t>
-            </a:r>
-            <a:r>
-              <a:rPr lang="en-US" sz="1050">
-                <a:solidFill>
-                  <a:srgbClr val="3DD6FF"/>
-                </a:solidFill>
-                <a:latin typeface="Consolas"/>
-              </a:rPr>
-              <a:t>2.4, … },</a:t>
-            </a:r>
-            <a:endParaRPr sz="1050"/>
-          </a:p>
-          <a:p>
-            <a:pPr>
-              <a:lnSpc>
-                <a:spcPts val="1150"/>
-              </a:lnSpc>
-              <a:buNone/>
-            </a:pPr>
-            <a:r>
-              <a:rPr lang="en-US" sz="1050">
-                <a:solidFill>
-                  <a:srgbClr val="ECE9F8"/>
-                </a:solidFill>
-                <a:latin typeface="Consolas"/>
-              </a:rPr>
-              <a:t>    "nitro": { "noul": </a:t>
-            </a:r>
-            <a:r>
-              <a:rPr lang="en-US" sz="1050">
-                <a:solidFill>
-                  <a:srgbClr val="3DD6FF"/>
-                </a:solidFill>
-                <a:latin typeface="Consolas"/>
-              </a:rPr>
-              <a:t>0.78, … }</a:t>
-            </a:r>
-            <a:endParaRPr sz="1050"/>
-          </a:p>
-          <a:p>
-            <a:pPr>
-              <a:lnSpc>
-                <a:spcPts val="1150"/>
-              </a:lnSpc>
-              <a:buNone/>
-            </a:pPr>
-            <a:r>
-              <a:rPr lang="en-US" sz="1050">
-                <a:solidFill>
-                  <a:srgbClr val="ABA6C8"/>
-                </a:solidFill>
-                <a:latin typeface="Consolas"/>
-              </a:rPr>
-              <a:t>  },</a:t>
-            </a:r>
-            <a:endParaRPr sz="1050"/>
-          </a:p>
-          <a:p>
-            <a:pPr>
-              <a:lnSpc>
-                <a:spcPts val="1150"/>
-              </a:lnSpc>
-              <a:buNone/>
-            </a:pPr>
-            <a:r>
-              <a:rPr lang="en-US" sz="1050">
-                <a:solidFill>
-                  <a:srgbClr val="ECE9F8"/>
-                </a:solidFill>
-                <a:latin typeface="Consolas"/>
-              </a:rPr>
-              <a:t>  "usage": { "output_tokens": </a:t>
-            </a:r>
-            <a:r>
-              <a:rPr lang="en-US" sz="1050">
-                <a:solidFill>
-                  <a:srgbClr val="3DD6FF"/>
-                </a:solidFill>
-                <a:latin typeface="Consolas"/>
-              </a:rPr>
-              <a:t>3, … }</a:t>
-            </a:r>
-            <a:endParaRPr sz="1050"/>
-          </a:p>
-          <a:p>
-            <a:pPr>
-              <a:lnSpc>
-                <a:spcPts val="1150"/>
-              </a:lnSpc>
-              <a:buNone/>
-            </a:pPr>
-            <a:r>
-              <a:rPr lang="en-US" sz="1050">
-                <a:solidFill>
-                  <a:srgbClr val="ABA6C8"/>
-                </a:solidFill>
-                <a:latin typeface="Consolas"/>
-              </a:rPr>
-              <a:t>}</a:t>
-            </a:r>
-            <a:endParaRPr sz="1050"/>
-          </a:p>
-        </p:txBody>
-      </p:sp>
-      <p:sp>
-        <p:nvSpPr>
-          <p:cNvPr id="13" name="Omitted request fields"/>
-          <p:cNvSpPr txBox="1"/>
-          <p:nvPr/>
-        </p:nvSpPr>
-        <p:spPr>
-          <a:xfrm>
-            <a:off x="777240" y="4050792"/>
-            <a:ext cx="3337560" cy="365760"/>
-          </a:xfrm>
-          <a:prstGeom prst="rect">
-            <a:avLst/>
-          </a:prstGeom>
-          <a:noFill/>
-          <a:ln/>
-        </p:spPr>
-        <p:txBody>
-          <a:bodyPr wrap="square" lIns="0" tIns="0" rIns="0" bIns="0"/>
-          <a:lstStyle/>
-          <a:p>
-            <a:pPr>
-              <a:lnSpc>
-                <a:spcPts val="1200"/>
-              </a:lnSpc>
-              <a:buNone/>
-            </a:pPr>
-            <a:r>
-              <a:rPr lang="en-US" sz="1050">
-                <a:solidFill>
-                  <a:srgbClr val="ABA6C8"/>
-                </a:solidFill>
-                <a:latin typeface="Segoe UI"/>
-              </a:rPr>
-              <a:t>All three include instructions.</a:t>
-            </a:r>
-            <a:endParaRPr sz="1050"/>
-          </a:p>
-          <a:p>
-            <a:pPr>
-              <a:lnSpc>
-                <a:spcPts val="1200"/>
-              </a:lnSpc>
-              <a:buNone/>
-            </a:pPr>
-            <a:r>
-              <a:rPr lang="en-US" sz="1050">
-                <a:solidFill>
-                  <a:srgbClr val="ABA6C8"/>
-                </a:solidFill>
-                <a:latin typeface="Segoe UI"/>
-              </a:rPr>
-              <a:t>Choice and score add criteria (options).</a:t>
-            </a:r>
-            <a:endParaRPr sz="1050"/>
-          </a:p>
-        </p:txBody>
-      </p:sp>
-      <p:sp>
-        <p:nvSpPr>
-          <p:cNvPr id="14" name="Illustrative response caveat"/>
-          <p:cNvSpPr txBox="1"/>
-          <p:nvPr/>
-        </p:nvSpPr>
-        <p:spPr>
-          <a:xfrm>
-            <a:off x="4892040" y="4261104"/>
-            <a:ext cx="3474720" cy="182880"/>
-          </a:xfrm>
-          <a:prstGeom prst="rect">
-            <a:avLst/>
-          </a:prstGeom>
-          <a:noFill/>
-          <a:ln/>
-        </p:spPr>
-        <p:txBody>
-          <a:bodyPr wrap="square" lIns="0" tIns="0" rIns="0" bIns="0"/>
-          <a:lstStyle/>
-          <a:p>
-            <a:pPr>
-              <a:buNone/>
-            </a:pPr>
-            <a:r>
-              <a:rPr lang="en-US" sz="1050">
-                <a:solidFill>
-                  <a:srgbClr val="ABA6C8"/>
-                </a:solidFill>
-                <a:latin typeface="Segoe UI"/>
-              </a:rPr>
-              <a:t>Illustrative reply; extra fields omitted.</a:t>
-            </a:r>
-            <a:endParaRPr lang="en-US" sz="1050"/>
           </a:p>
         </p:txBody>
       </p:sp>

</xml_diff>

<commit_message>
Update luna-gp presentation deck with revised content
</commit_message>
<xml_diff>
--- a/docs/luna-gp-deck.pptx
+++ b/docs/luna-gp-deck.pptx
@@ -18,6 +18,7 @@
     <p:sldId id="261" r:id="rId9"/>
     <p:sldId id="268" r:id="rId10"/>
     <p:sldId id="262" r:id="rId11"/>
+    <p:sldId id="271" r:id="rId22"/>
     <p:sldId id="263" r:id="rId12"/>
     <p:sldId id="267" r:id="rId13"/>
     <p:sldId id="264" r:id="rId14"/>
@@ -679,6 +680,159 @@
         <p14:creationId xmlns:p14="http://schemas.microsoft.com/office/powerpoint/2010/main" val="1024086991"/>
       </p:ext>
     </p:extLst>
+  </p:cSld>
+  <p:clrMapOvr>
+    <a:masterClrMapping/>
+  </p:clrMapOvr>
+</p:notes>
+</file>
+
+<file path=ppt/notesSlides/notesSlide14.xml><?xml version="1.0" encoding="utf-8"?>
+<p:notes xmlns:a="http://schemas.openxmlformats.org/drawingml/2006/main" xmlns:r="http://schemas.openxmlformats.org/officeDocument/2006/relationships" xmlns:p="http://schemas.openxmlformats.org/presentationml/2006/main">
+  <p:cSld>
+    <p:spTree>
+      <p:nvGrpSpPr>
+        <p:cNvPr id="1" name=""/>
+        <p:cNvGrpSpPr/>
+        <p:nvPr/>
+      </p:nvGrpSpPr>
+      <p:grpSpPr>
+        <a:xfrm>
+          <a:off x="0" y="0"/>
+          <a:ext cx="0" cy="0"/>
+          <a:chOff x="0" y="0"/>
+          <a:chExt cx="0" cy="0"/>
+        </a:xfrm>
+      </p:grpSpPr>
+      <p:sp>
+        <p:nvSpPr>
+          <p:cNvPr id="2" name="Slide Image Placeholder"/>
+          <p:cNvSpPr>
+            <a:spLocks noGrp="1" noRot="1" noChangeAspect="1"/>
+          </p:cNvSpPr>
+          <p:nvPr>
+            <p:ph type="sldImg"/>
+          </p:nvPr>
+        </p:nvSpPr>
+        <p:spPr/>
+      </p:sp>
+      <p:sp>
+        <p:nvSpPr>
+          <p:cNvPr id="3" name="Speaker notes"/>
+          <p:cNvSpPr>
+            <a:spLocks noGrp="1"/>
+          </p:cNvSpPr>
+          <p:nvPr>
+            <p:ph type="body" idx="1"/>
+          </p:nvPr>
+        </p:nvSpPr>
+        <p:spPr/>
+        <p:txBody>
+          <a:bodyPr/>
+          <a:lstStyle/>
+          <a:p>
+            <a:r>
+              <a:t>A racing line is the path a driver aims to take to carry speed through a corner. A conventional racing line often uses outside entry, an inside apex and outside exit. LUNA GP does not compute that optimized route: racing_line is a simple curve-following heuristic. Positive curvature is a right-hand bend and produces a positive offset, so the target biases toward the INSIDE of the bend, not the opposite side.</a:t>
+            </a:r>
+          </a:p>
+          <a:p>
+            <a:r>
+              <a:t>Provenance: screenshot from the actual LUNA GP game at https://aka.ms/racing, captured on 2026-10-28. This is a controlled in-game setup using the existing debug hook, not a naturally occurring race moment. Lyra is positioned on a right-hand bend with clear road ahead and a slower player behind. The scene was held still while one real POST /api/rival request was made for that pictured car. The response is from Microsoft-Decision-1, not the local fallback. Request and result on the slide are condensed; displayed numbers are rounded. The HUD P3 and 230 km/h belong to the human player/camera, whereas the request's P2 and 268 km/h belong to Lyra (#22).</a:t>
+            </a:r>
+          </a:p>
+          <a:p>
+            <a:r>
+              <a:t>The editable yellow overlay was added only in PowerPoint. It projects the engine's target offset at sampled road positions using the game's own segment projection. It is a target line, not a model-generated polyline or a prediction of the exact vehicle trajectory. The line is interrupted where Lyra's car occludes it. The screenshot itself has no racing-line overlay in normal gameplay.</a:t>
+            </a:r>
+          </a:p>
+          <a:p>
+            <a:r>
+              <a:t>Implementation: Race.driveAi sets targetOffset = clamp(track.avgCurveAhead(car.progress, 40) * 0.12, -0.55, 0.55) for racing_line. Road offsets run from -1 (left edge) to +1 (right edge), with 0 at the centre. Here average curvature is +4, so the target is +0.48. The 40 segments cover about 55.6 metres in the game's distance scale. Each 60 Hz physics step moves the car toward that target by at most (0.25 + speed / MAX_SPEED) * dt. The model chooses the maneuver, pace and nitro probability; it does not steer frame by frame or supply path coordinates.</a:t>
+            </a:r>
+          </a:p>
+          <a:p>
+            <a:r>
+              <a:t>Traffic and pace: an alongside-car guard prevents steering into another car. Overtake, slipstream, defend and back_off temporarily choose different lateral targets. Pace sets topSpeed * (0.92 + 0.03 * score), then cornering, traffic, drafting and nitro modify the speed target. Rivals do not use the player's centrifugal-drift physics. The fixed-step AI controller directly adjusts their lateral offsets.</a:t>
+            </a:r>
+          </a:p>
+          <a:p>
+            <a:r>
+              <a:t>Exact server-built state for this request:</a:t>
+            </a:r>
+          </a:p>
+          <a:p>
+            <a:r>
+              <a:t>Arcade circuit race, 3 laps, 6 cars. Driver under review: Lyra (#22).</a:t>
+            </a:r>
+          </a:p>
+          <a:p>
+            <a:r>
+              <a:t>Personality: Smooth: clean and consistent, sticks to the racing line, only overtakes when it is easy.</a:t>
+            </a:r>
+          </a:p>
+          <a:p>
+            <a:r>
+              <a:t>Race situation: lap 1 of 3; running P2 of 6, 3.4 s behind the leader.</a:t>
+            </a:r>
+          </a:p>
+          <a:p>
+            <a:r>
+              <a:t>Car: 268 km/h (top speed 285 km/h), in the right lane, nitro tank 72%.</a:t>
+            </a:r>
+          </a:p>
+          <a:p>
+            <a:r>
+              <a:t>Track ahead: currently in a medium right-hand corner with 81 m to go, then a 47 m straight, then a gentle left-hand corner (97 m long). The road climbs.</a:t>
+            </a:r>
+          </a:p>
+          <a:p>
+            <a:r>
+              <a:t>Car ahead: none within 150 m.</a:t>
+            </a:r>
+          </a:p>
+          <a:p>
+            <a:r>
+              <a:t>Car behind: the human player, 24 m behind, slightly to the left, 37 km/h slower (dropping back).</a:t>
+            </a:r>
+          </a:p>
+          <a:p>
+            <a:r>
+              <a:t>Typed questions: maneuver (choice: racing_line, overtake_left, overtake_right, slipstream, defend, back_off); pace (score: Conserve, Race, Push, Flat out); nitro (noul). The exact fixed instructions and criteria are built by lib/prompts.js and converted to the Foundry request shape by lib/decisions.js. No conversation history or screenshot is sent with the rival request.</a:t>
+            </a:r>
+          </a:p>
+          <a:p>
+            <a:r>
+              <a:t>Captured result: model microsoft-decision-1; maneuver.choice racing_line; maneuver.probabilities.racing_line 0.9924292785227681 (99.24% on slide); maneuver.confidence 0.9909151342273217 (a different field, not the displayed choice probability). pace.score 1.4615374821905507; nitro.probability 0.09535027692543765; refusals []; latencyMs 358; inputTokens 594. Nitro is held because 0.09535 is below Lyra's 0.65 threshold even though her tank is 72%, above the 34% minimum cost.</a:t>
+            </a:r>
+          </a:p>
+          <a:p>
+            <a:r>
+              <a:t>Sources: public/js/race.js (driveAi, rivalPayload), public/js/track.js (avgCurveAhead), public/js/rivals.js (cadenceMs, apply), public/js/render.js (road projection), public/js/config.js (STEP and nitro thresholds), lib/prompts.js (buildRivalRequest), lib/decisions.js (toFoundryQuestions). Live game: https://aka.ms/racing.</a:t>
+            </a:r>
+          </a:p>
+        </p:txBody>
+      </p:sp>
+      <p:sp>
+        <p:nvSpPr>
+          <p:cNvPr id="4" name="Slide Number Placeholder"/>
+          <p:cNvSpPr/>
+          <p:nvPr>
+            <p:ph type="sldNum" sz="quarter" idx="10"/>
+          </p:nvPr>
+        </p:nvSpPr>
+        <p:spPr/>
+        <p:txBody>
+          <a:bodyPr/>
+          <a:lstStyle/>
+          <a:p>
+            <a:fld id="{F81BD507-B837-4F80-9B61-285A19E1B2C3}" type="slidenum">
+              <a:rPr lang="en-US"/>
+              <a:t>11</a:t>
+            </a:fld>
+          </a:p>
+        </p:txBody>
+      </p:sp>
+    </p:spTree>
   </p:cSld>
   <p:clrMapOvr>
     <a:masterClrMapping/>
@@ -1807,7 +1961,7 @@
                 <a:ea typeface="Segoe UI Black" pitchFamily="34" charset="-122"/>
                 <a:cs typeface="Segoe UI Black" pitchFamily="34" charset="-120"/>
               </a:rPr>
-              <a:t> GP</a:t>
+              <a:t xml:space="preserve"> GP</a:t>
             </a:r>
             <a:endParaRPr lang="en-US" sz="7200" dirty="0"/>
           </a:p>
@@ -1846,7 +2000,7 @@
                 <a:ea typeface="Segoe UI" pitchFamily="34" charset="-122"/>
                 <a:cs typeface="Segoe UI" pitchFamily="34" charset="-120"/>
               </a:rPr>
-              <a:t>A night-time arcade racer where every rival thinks with </a:t>
+              <a:t xml:space="preserve">A night-time arcade racer where every rival thinks with </a:t>
             </a:r>
             <a:r>
               <a:rPr lang="en-US" sz="2000" b="1" dirty="0">
@@ -2041,7 +2195,7 @@
                 </a:solidFill>
                 <a:latin typeface="Segoe UI Semibold"/>
               </a:rPr>
-              <a:t>08 / 13</a:t>
+              <a:t>08 / 14</a:t>
             </a:r>
             <a:endParaRPr lang="en-US" sz="1100"/>
           </a:p>
@@ -2323,7 +2477,7 @@
                 </a:solidFill>
                 <a:latin typeface="Consolas"/>
               </a:rPr>
-              <a:t>  "model": </a:t>
+              <a:t xml:space="preserve">  "model": </a:t>
             </a:r>
             <a:r>
               <a:rPr lang="en-US" sz="1050">
@@ -2350,7 +2504,7 @@
                 </a:solidFill>
                 <a:latin typeface="Consolas"/>
               </a:rPr>
-              <a:t>  "state": </a:t>
+              <a:t xml:space="preserve">  "state": </a:t>
             </a:r>
             <a:r>
               <a:rPr lang="en-US" sz="1050">
@@ -2377,7 +2531,7 @@
                 </a:solidFill>
                 <a:latin typeface="Consolas"/>
               </a:rPr>
-              <a:t>  "questions": {</a:t>
+              <a:t xml:space="preserve">  "questions": {</a:t>
             </a:r>
             <a:endParaRPr sz="1050"/>
           </a:p>
@@ -2395,7 +2549,7 @@
                 </a:solidFill>
                 <a:latin typeface="Consolas"/>
               </a:rPr>
-              <a:t>    "maneuver": { "type": </a:t>
+              <a:t xml:space="preserve">    "maneuver": { "type": </a:t>
             </a:r>
             <a:r>
               <a:rPr lang="en-US" sz="1050">
@@ -2422,7 +2576,7 @@
                 </a:solidFill>
                 <a:latin typeface="Consolas"/>
               </a:rPr>
-              <a:t>    "pace": { "type": </a:t>
+              <a:t xml:space="preserve">    "pace": { "type": </a:t>
             </a:r>
             <a:r>
               <a:rPr lang="en-US" sz="1050">
@@ -2449,7 +2603,7 @@
                 </a:solidFill>
                 <a:latin typeface="Consolas"/>
               </a:rPr>
-              <a:t>    "nitro": { "type": </a:t>
+              <a:t xml:space="preserve">    "nitro": { "type": </a:t>
             </a:r>
             <a:r>
               <a:rPr lang="en-US" sz="1050">
@@ -2476,7 +2630,7 @@
                 </a:solidFill>
                 <a:latin typeface="Consolas"/>
               </a:rPr>
-              <a:t>  }</a:t>
+              <a:t xml:space="preserve">  }</a:t>
             </a:r>
             <a:endParaRPr sz="1050"/>
           </a:p>
@@ -2570,7 +2724,7 @@
                 </a:solidFill>
                 <a:latin typeface="Consolas"/>
               </a:rPr>
-              <a:t>  "model": </a:t>
+              <a:t xml:space="preserve">  "model": </a:t>
             </a:r>
             <a:r>
               <a:rPr lang="en-US" sz="1050">
@@ -2597,7 +2751,7 @@
                 </a:solidFill>
                 <a:latin typeface="Consolas"/>
               </a:rPr>
-              <a:t>  "answers": {</a:t>
+              <a:t xml:space="preserve">  "answers": {</a:t>
             </a:r>
             <a:endParaRPr sz="1050"/>
           </a:p>
@@ -2615,7 +2769,7 @@
                 </a:solidFill>
                 <a:latin typeface="Consolas"/>
               </a:rPr>
-              <a:t>    "maneuver": {</a:t>
+              <a:t xml:space="preserve">    "maneuver": {</a:t>
             </a:r>
             <a:endParaRPr sz="1050"/>
           </a:p>
@@ -2633,7 +2787,7 @@
                 </a:solidFill>
                 <a:latin typeface="Consolas"/>
               </a:rPr>
-              <a:t>      "choice": </a:t>
+              <a:t xml:space="preserve">      "choice": </a:t>
             </a:r>
             <a:r>
               <a:rPr lang="en-US" sz="1050">
@@ -2660,7 +2814,7 @@
                 </a:solidFill>
                 <a:latin typeface="Consolas"/>
               </a:rPr>
-              <a:t>    },</a:t>
+              <a:t xml:space="preserve">    },</a:t>
             </a:r>
             <a:endParaRPr sz="1050"/>
           </a:p>
@@ -2678,7 +2832,7 @@
                 </a:solidFill>
                 <a:latin typeface="Consolas"/>
               </a:rPr>
-              <a:t>    "pace": { "score": </a:t>
+              <a:t xml:space="preserve">    "pace": { "score": </a:t>
             </a:r>
             <a:r>
               <a:rPr lang="en-US" sz="1050">
@@ -2705,7 +2859,7 @@
                 </a:solidFill>
                 <a:latin typeface="Consolas"/>
               </a:rPr>
-              <a:t>    "nitro": { "noul": </a:t>
+              <a:t xml:space="preserve">    "nitro": { "noul": </a:t>
             </a:r>
             <a:r>
               <a:rPr lang="en-US" sz="1050">
@@ -2732,7 +2886,7 @@
                 </a:solidFill>
                 <a:latin typeface="Consolas"/>
               </a:rPr>
-              <a:t>  },</a:t>
+              <a:t xml:space="preserve">  },</a:t>
             </a:r>
             <a:endParaRPr sz="1050"/>
           </a:p>
@@ -2750,7 +2904,7 @@
                 </a:solidFill>
                 <a:latin typeface="Consolas"/>
               </a:rPr>
-              <a:t>  "usage": { "output_tokens": </a:t>
+              <a:t xml:space="preserve">  "usage": { "output_tokens": </a:t>
             </a:r>
             <a:r>
               <a:rPr lang="en-US" sz="1050">
@@ -3010,7 +3164,7 @@
                 <a:ea typeface="Segoe UI Semibold" pitchFamily="34" charset="-122"/>
                 <a:cs typeface="Segoe UI Semibold" pitchFamily="34" charset="-120"/>
               </a:rPr>
-              <a:t>09 / 13</a:t>
+              <a:t>10 / 14</a:t>
             </a:r>
             <a:endParaRPr lang="en-US" sz="1100" dirty="0"/>
           </a:p>
@@ -3211,7 +3365,7 @@
                 <a:ea typeface="Segoe UI Semibold" pitchFamily="34" charset="-122"/>
                 <a:cs typeface="Segoe UI Semibold" pitchFamily="34" charset="-120"/>
               </a:rPr>
-              <a:t>10 / 13</a:t>
+              <a:t>11 / 14</a:t>
             </a:r>
             <a:endParaRPr lang="en-US" sz="1100" dirty="0"/>
           </a:p>
@@ -3289,7 +3443,7 @@
                 <a:ea typeface="Segoe UI" pitchFamily="34" charset="-122"/>
                 <a:cs typeface="Segoe UI" pitchFamily="34" charset="-120"/>
               </a:rPr>
-              <a:t>The game runs </a:t>
+              <a:t xml:space="preserve">The game runs </a:t>
             </a:r>
             <a:r>
               <a:rPr lang="en-US" sz="1600" b="1" dirty="0">
@@ -3906,7 +4060,7 @@
                 <a:ea typeface="Segoe UI" pitchFamily="34" charset="-122"/>
                 <a:cs typeface="Segoe UI" pitchFamily="34" charset="-120"/>
               </a:rPr>
-              <a:t>Not a container app: </a:t>
+              <a:t xml:space="preserve">Not a container app: </a:t>
             </a:r>
             <a:r>
               <a:rPr lang="en-US" sz="1200" dirty="0">
@@ -4055,7 +4209,7 @@
                 <a:ea typeface="Segoe UI Semibold" pitchFamily="34" charset="-122"/>
                 <a:cs typeface="Segoe UI Semibold" pitchFamily="34" charset="-120"/>
               </a:rPr>
-              <a:t>11 / 13</a:t>
+              <a:t>12 / 14</a:t>
             </a:r>
             <a:endParaRPr lang="en-US" sz="1100" dirty="0"/>
           </a:p>
@@ -4892,7 +5046,7 @@
                 <a:ea typeface="Segoe UI Semibold" pitchFamily="34" charset="-122"/>
                 <a:cs typeface="Segoe UI Semibold" pitchFamily="34" charset="-120"/>
               </a:rPr>
-              <a:t>12 / 13</a:t>
+              <a:t>13 / 14</a:t>
             </a:r>
             <a:endParaRPr lang="en-US" sz="1100" dirty="0"/>
           </a:p>
@@ -6835,6 +6989,1072 @@
               <a:t>Build a coordinated AI-driver swarm</a:t>
             </a:r>
             <a:endParaRPr lang="en-US" sz="1500" dirty="0"/>
+          </a:p>
+        </p:txBody>
+      </p:sp>
+    </p:spTree>
+  </p:cSld>
+  <p:clrMapOvr>
+    <a:masterClrMapping/>
+  </p:clrMapOvr>
+</p:sld>
+</file>
+
+<file path=ppt/slides/slide16.xml><?xml version="1.0" encoding="utf-8"?>
+<p:sld xmlns:a="http://schemas.openxmlformats.org/drawingml/2006/main" xmlns:r="http://schemas.openxmlformats.org/officeDocument/2006/relationships" xmlns:p="http://schemas.openxmlformats.org/presentationml/2006/main">
+  <p:cSld name="How rivals follow the line">
+    <p:bg>
+      <p:bgPr>
+        <a:solidFill>
+          <a:srgbClr val="07071A"/>
+        </a:solidFill>
+        <a:effectLst/>
+      </p:bgPr>
+    </p:bg>
+    <p:spTree>
+      <p:nvGrpSpPr>
+        <p:cNvPr id="1" name=""/>
+        <p:cNvGrpSpPr/>
+        <p:nvPr/>
+      </p:nvGrpSpPr>
+      <p:grpSpPr>
+        <a:xfrm>
+          <a:off x="0" y="0"/>
+          <a:ext cx="0" cy="0"/>
+          <a:chOff x="0" y="0"/>
+          <a:chExt cx="0" cy="0"/>
+        </a:xfrm>
+      </p:grpSpPr>
+      <p:sp>
+        <p:nvSpPr>
+          <p:cNvPr id="2" name="Header dot"/>
+          <p:cNvSpPr/>
+          <p:nvPr/>
+        </p:nvSpPr>
+        <p:spPr>
+          <a:xfrm>
+            <a:off x="548640" y="484632"/>
+            <a:ext cx="109728" cy="109728"/>
+          </a:xfrm>
+          <a:prstGeom prst="ellipse">
+            <a:avLst/>
+          </a:prstGeom>
+          <a:solidFill>
+            <a:srgbClr val="FFD166"/>
+          </a:solidFill>
+          <a:ln>
+            <a:noFill/>
+          </a:ln>
+        </p:spPr>
+      </p:sp>
+      <p:sp>
+        <p:nvSpPr>
+          <p:cNvPr id="3" name="Section label"/>
+          <p:cNvSpPr txBox="1"/>
+          <p:nvPr/>
+        </p:nvSpPr>
+        <p:spPr>
+          <a:xfrm>
+            <a:off x="749808" y="393192"/>
+            <a:ext cx="5943600" cy="292608"/>
+          </a:xfrm>
+          <a:prstGeom prst="rect">
+            <a:avLst/>
+          </a:prstGeom>
+          <a:noFill/>
+          <a:ln>
+            <a:noFill/>
+          </a:ln>
+        </p:spPr>
+        <p:txBody>
+          <a:bodyPr wrap="none" lIns="0" tIns="0" rIns="0" bIns="0" anchor="ctr"/>
+          <a:lstStyle/>
+          <a:p>
+            <a:pPr>
+              <a:buNone/>
+            </a:pPr>
+            <a:r>
+              <a:rPr lang="en-US" sz="1100" b="1" spc="300">
+                <a:solidFill>
+                  <a:srgbClr val="ABA6C8"/>
+                </a:solidFill>
+                <a:latin typeface="Segoe UI Semibold"/>
+              </a:rPr>
+              <a:t>RACING LINE</a:t>
+            </a:r>
+          </a:p>
+        </p:txBody>
+      </p:sp>
+      <p:sp>
+        <p:nvSpPr>
+          <p:cNvPr id="4" name="Slide counter"/>
+          <p:cNvSpPr txBox="1"/>
+          <p:nvPr/>
+        </p:nvSpPr>
+        <p:spPr>
+          <a:xfrm>
+            <a:off x="7223760" y="393192"/>
+            <a:ext cx="1371600" cy="292608"/>
+          </a:xfrm>
+          <a:prstGeom prst="rect">
+            <a:avLst/>
+          </a:prstGeom>
+          <a:noFill/>
+          <a:ln>
+            <a:noFill/>
+          </a:ln>
+        </p:spPr>
+        <p:txBody>
+          <a:bodyPr wrap="none" lIns="0" tIns="0" rIns="0" bIns="0" anchor="ctr"/>
+          <a:lstStyle/>
+          <a:p>
+            <a:pPr algn="r">
+              <a:buNone/>
+            </a:pPr>
+            <a:r>
+              <a:rPr lang="en-US" sz="1100">
+                <a:solidFill>
+                  <a:srgbClr val="ABA6C8"/>
+                </a:solidFill>
+                <a:latin typeface="Segoe UI Semibold"/>
+              </a:rPr>
+              <a:t>09 / 14</a:t>
+            </a:r>
+          </a:p>
+        </p:txBody>
+      </p:sp>
+      <p:sp>
+        <p:nvSpPr>
+          <p:cNvPr id="5" name="Slide title"/>
+          <p:cNvSpPr txBox="1"/>
+          <p:nvPr/>
+        </p:nvSpPr>
+        <p:spPr>
+          <a:xfrm>
+            <a:off x="548640" y="731520"/>
+            <a:ext cx="8046720" cy="658368"/>
+          </a:xfrm>
+          <a:prstGeom prst="rect">
+            <a:avLst/>
+          </a:prstGeom>
+          <a:noFill/>
+          <a:ln>
+            <a:noFill/>
+          </a:ln>
+        </p:spPr>
+        <p:txBody>
+          <a:bodyPr wrap="none" lIns="0" tIns="0" rIns="0" bIns="0"/>
+          <a:lstStyle/>
+          <a:p>
+            <a:pPr>
+              <a:buNone/>
+            </a:pPr>
+            <a:r>
+              <a:rPr lang="en-US" sz="3400" b="1" i="1">
+                <a:solidFill>
+                  <a:srgbClr val="ECE9F8"/>
+                </a:solidFill>
+                <a:latin typeface="Segoe UI Black"/>
+              </a:rPr>
+              <a:t>How rivals follow the line</a:t>
+            </a:r>
+          </a:p>
+        </p:txBody>
+      </p:sp>
+      <p:sp>
+        <p:nvSpPr>
+          <p:cNvPr id="6" name="Racing-line approximation"/>
+          <p:cNvSpPr txBox="1"/>
+          <p:nvPr/>
+        </p:nvSpPr>
+        <p:spPr>
+          <a:xfrm>
+            <a:off x="548640" y="1362456"/>
+            <a:ext cx="8046720" cy="274320"/>
+          </a:xfrm>
+          <a:prstGeom prst="rect">
+            <a:avLst/>
+          </a:prstGeom>
+          <a:noFill/>
+          <a:ln>
+            <a:noFill/>
+          </a:ln>
+        </p:spPr>
+        <p:txBody>
+          <a:bodyPr wrap="none" lIns="0" tIns="0" rIns="0" bIns="0"/>
+          <a:lstStyle/>
+          <a:p>
+            <a:pPr>
+              <a:buNone/>
+            </a:pPr>
+            <a:r>
+              <a:rPr lang="en-US" sz="1370">
+                <a:solidFill>
+                  <a:srgbClr val="ABA6C8"/>
+                </a:solidFill>
+                <a:latin typeface="Segoe UI"/>
+              </a:rPr>
+              <a:t>The model selects racing_line; game code computes the target and steers at 60 Hz.</a:t>
+            </a:r>
+          </a:p>
+        </p:txBody>
+      </p:sp>
+      <p:pic>
+        <p:nvPicPr>
+          <p:cNvPr id="7" name="Actual LUNA GP game capture" descr="Controlled scene captured in the actual game: the player is P3 and Lyra, the purple rival labelled LINE, is P2 on a right-hand bend. The matching live model request is for Lyra, not the player."/>
+          <p:cNvPicPr>
+            <a:picLocks noChangeAspect="1"/>
+          </p:cNvPicPr>
+          <p:nvPr/>
+        </p:nvPicPr>
+        <p:blipFill>
+          <a:blip r:embed="rId2"/>
+          <a:stretch>
+            <a:fillRect/>
+          </a:stretch>
+        </p:blipFill>
+        <p:spPr>
+          <a:xfrm>
+            <a:off x="548640" y="1737360"/>
+            <a:ext cx="4480560" cy="2520315"/>
+          </a:xfrm>
+          <a:prstGeom prst="rect">
+            <a:avLst/>
+          </a:prstGeom>
+          <a:ln>
+            <a:noFill/>
+          </a:ln>
+        </p:spPr>
+      </p:pic>
+      <p:sp>
+        <p:nvSpPr>
+          <p:cNvPr id="8" name="Racing-line contrast underlay"/>
+          <p:cNvSpPr/>
+          <p:nvPr/>
+        </p:nvSpPr>
+        <p:spPr>
+          <a:xfrm>
+            <a:off x="548640" y="1737360"/>
+            <a:ext cx="4480560" cy="2520315"/>
+          </a:xfrm>
+          <a:custGeom>
+            <a:avLst/>
+            <a:gdLst/>
+            <a:ahLst/>
+            <a:cxnLst/>
+            <a:rect l="0" t="0" r="r" b="b"/>
+            <a:pathLst>
+              <a:path w="1280" h="720" fill="none">
+                <a:moveTo>
+                  <a:pt x="839" y="536"/>
+                </a:moveTo>
+                <a:lnTo>
+                  <a:pt x="824" y="510"/>
+                </a:lnTo>
+                <a:lnTo>
+                  <a:pt x="812" y="490"/>
+                </a:lnTo>
+                <a:lnTo>
+                  <a:pt x="803" y="473"/>
+                </a:lnTo>
+                <a:lnTo>
+                  <a:pt x="796" y="459"/>
+                </a:lnTo>
+                <a:lnTo>
+                  <a:pt x="791" y="447"/>
+                </a:lnTo>
+                <a:lnTo>
+                  <a:pt x="786" y="437"/>
+                </a:lnTo>
+                <a:lnTo>
+                  <a:pt x="784" y="428"/>
+                </a:lnTo>
+                <a:lnTo>
+                  <a:pt x="781" y="420"/>
+                </a:lnTo>
+                <a:lnTo>
+                  <a:pt x="780" y="414"/>
+                </a:lnTo>
+                <a:lnTo>
+                  <a:pt x="778" y="408"/>
+                </a:lnTo>
+                <a:lnTo>
+                  <a:pt x="779" y="402"/>
+                </a:lnTo>
+                <a:lnTo>
+                  <a:pt x="779" y="397"/>
+                </a:lnTo>
+                <a:lnTo>
+                  <a:pt x="779" y="393"/>
+                </a:lnTo>
+                <a:moveTo>
+                  <a:pt x="826" y="352"/>
+                </a:moveTo>
+                <a:lnTo>
+                  <a:pt x="834" y="349"/>
+                </a:lnTo>
+                <a:lnTo>
+                  <a:pt x="845" y="345"/>
+                </a:lnTo>
+                <a:lnTo>
+                  <a:pt x="857" y="342"/>
+                </a:lnTo>
+                <a:lnTo>
+                  <a:pt x="871" y="339"/>
+                </a:lnTo>
+                <a:lnTo>
+                  <a:pt x="887" y="336"/>
+                </a:lnTo>
+                <a:lnTo>
+                  <a:pt x="908" y="333"/>
+                </a:lnTo>
+                <a:lnTo>
+                  <a:pt x="925" y="331"/>
+                </a:lnTo>
+              </a:path>
+            </a:pathLst>
+          </a:custGeom>
+          <a:noFill/>
+          <a:ln w="66040" cap="rnd">
+            <a:solidFill>
+              <a:srgbClr val="07071A">
+                <a:alpha val="80000"/>
+              </a:srgbClr>
+            </a:solidFill>
+            <a:round/>
+          </a:ln>
+        </p:spPr>
+      </p:sp>
+      <p:sp>
+        <p:nvSpPr>
+          <p:cNvPr id="9" name="Editable racing-line target - near" descr="Projected engine target: offset = clamp(0.12 * avgCurveAhead(position, 40), -0.55, 0.55). These points are sampled from the actual game's projection. Interrupted behind Lyra's car so the overlay does not paint over it."/>
+          <p:cNvSpPr/>
+          <p:nvPr/>
+        </p:nvSpPr>
+        <p:spPr>
+          <a:xfrm>
+            <a:off x="548640" y="1737360"/>
+            <a:ext cx="4480560" cy="2520315"/>
+          </a:xfrm>
+          <a:custGeom>
+            <a:avLst/>
+            <a:gdLst/>
+            <a:ahLst/>
+            <a:cxnLst/>
+            <a:rect l="0" t="0" r="r" b="b"/>
+            <a:pathLst>
+              <a:path w="1280" h="720" fill="none">
+                <a:moveTo>
+                  <a:pt x="839" y="536"/>
+                </a:moveTo>
+                <a:lnTo>
+                  <a:pt x="824" y="510"/>
+                </a:lnTo>
+                <a:lnTo>
+                  <a:pt x="812" y="490"/>
+                </a:lnTo>
+                <a:lnTo>
+                  <a:pt x="803" y="473"/>
+                </a:lnTo>
+                <a:lnTo>
+                  <a:pt x="796" y="459"/>
+                </a:lnTo>
+                <a:lnTo>
+                  <a:pt x="791" y="447"/>
+                </a:lnTo>
+                <a:lnTo>
+                  <a:pt x="786" y="437"/>
+                </a:lnTo>
+                <a:lnTo>
+                  <a:pt x="784" y="428"/>
+                </a:lnTo>
+                <a:lnTo>
+                  <a:pt x="781" y="420"/>
+                </a:lnTo>
+                <a:lnTo>
+                  <a:pt x="780" y="414"/>
+                </a:lnTo>
+                <a:lnTo>
+                  <a:pt x="778" y="408"/>
+                </a:lnTo>
+                <a:lnTo>
+                  <a:pt x="779" y="402"/>
+                </a:lnTo>
+                <a:lnTo>
+                  <a:pt x="779" y="397"/>
+                </a:lnTo>
+                <a:lnTo>
+                  <a:pt x="779" y="393"/>
+                </a:lnTo>
+              </a:path>
+            </a:pathLst>
+          </a:custGeom>
+          <a:noFill/>
+          <a:ln w="33020" cap="rnd">
+            <a:solidFill>
+              <a:srgbClr val="FFD166"/>
+            </a:solidFill>
+            <a:round/>
+          </a:ln>
+        </p:spPr>
+      </p:sp>
+      <p:sp>
+        <p:nvSpPr>
+          <p:cNvPr id="10" name="Editable racing-line target - ahead" descr="The target line continues ahead of Lyra toward the inside of this right-hand bend. An explanatory annotation, not a path returned by the AI."/>
+          <p:cNvSpPr/>
+          <p:nvPr/>
+        </p:nvSpPr>
+        <p:spPr>
+          <a:xfrm>
+            <a:off x="548640" y="1737360"/>
+            <a:ext cx="4480560" cy="2520315"/>
+          </a:xfrm>
+          <a:custGeom>
+            <a:avLst/>
+            <a:gdLst/>
+            <a:ahLst/>
+            <a:cxnLst/>
+            <a:rect l="0" t="0" r="r" b="b"/>
+            <a:pathLst>
+              <a:path w="1280" h="720" fill="none">
+                <a:moveTo>
+                  <a:pt x="826" y="352"/>
+                </a:moveTo>
+                <a:lnTo>
+                  <a:pt x="834" y="349"/>
+                </a:lnTo>
+                <a:lnTo>
+                  <a:pt x="845" y="345"/>
+                </a:lnTo>
+                <a:lnTo>
+                  <a:pt x="857" y="342"/>
+                </a:lnTo>
+                <a:lnTo>
+                  <a:pt x="871" y="339"/>
+                </a:lnTo>
+                <a:lnTo>
+                  <a:pt x="887" y="336"/>
+                </a:lnTo>
+                <a:lnTo>
+                  <a:pt x="908" y="333"/>
+                </a:lnTo>
+                <a:lnTo>
+                  <a:pt x="925" y="331"/>
+                </a:lnTo>
+              </a:path>
+            </a:pathLst>
+          </a:custGeom>
+          <a:noFill/>
+          <a:ln w="21590" cap="rnd">
+            <a:solidFill>
+              <a:srgbClr val="FFD166"/>
+            </a:solidFill>
+            <a:round/>
+            <a:tailEnd type="triangle" w="sm" len="sm"/>
+          </a:ln>
+        </p:spPr>
+      </p:sp>
+      <p:sp>
+        <p:nvSpPr>
+          <p:cNvPr id="11" name="Lyra request-to-screenshot callout"/>
+          <p:cNvSpPr txBox="1"/>
+          <p:nvPr/>
+        </p:nvSpPr>
+        <p:spPr>
+          <a:xfrm>
+            <a:off x="786384" y="2468880"/>
+            <a:ext cx="2651760" cy="274320"/>
+          </a:xfrm>
+          <a:prstGeom prst="roundRect">
+            <a:avLst>
+              <a:gd name="adj" fmla="val 18000"/>
+            </a:avLst>
+          </a:prstGeom>
+          <a:solidFill>
+            <a:srgbClr val="07071A">
+              <a:alpha val="90000"/>
+            </a:srgbClr>
+          </a:solidFill>
+          <a:ln>
+            <a:noFill/>
+          </a:ln>
+        </p:spPr>
+        <p:txBody>
+          <a:bodyPr wrap="none" lIns="91440" tIns="0" rIns="91440" bIns="0" anchor="ctr"/>
+          <a:lstStyle/>
+          <a:p>
+            <a:pPr>
+              <a:buNone/>
+            </a:pPr>
+            <a:r>
+              <a:rPr lang="en-US" sz="1100" b="1">
+                <a:solidFill>
+                  <a:srgbClr val="D7BCFF"/>
+                </a:solidFill>
+                <a:latin typeface="Segoe UI Semibold"/>
+              </a:rPr>
+              <a:t>LYRA #22 / P2 / 268 km/h</a:t>
+            </a:r>
+          </a:p>
+        </p:txBody>
+      </p:sp>
+      <p:sp>
+        <p:nvSpPr>
+          <p:cNvPr id="12" name="Capture provenance"/>
+          <p:cNvSpPr txBox="1"/>
+          <p:nvPr/>
+        </p:nvSpPr>
+        <p:spPr>
+          <a:xfrm>
+            <a:off x="548640" y="4352544"/>
+            <a:ext cx="4480560" cy="201168"/>
+          </a:xfrm>
+          <a:prstGeom prst="rect">
+            <a:avLst/>
+          </a:prstGeom>
+          <a:noFill/>
+          <a:ln>
+            <a:noFill/>
+          </a:ln>
+        </p:spPr>
+        <p:txBody>
+          <a:bodyPr wrap="none" lIns="0" tIns="0" rIns="0" bIns="0"/>
+          <a:lstStyle/>
+          <a:p>
+            <a:pPr>
+              <a:buNone/>
+            </a:pPr>
+            <a:r>
+              <a:rPr lang="en-US" sz="1100">
+                <a:solidFill>
+                  <a:srgbClr val="ABA6C8"/>
+                </a:solidFill>
+                <a:latin typeface="Segoe UI"/>
+              </a:rPr>
+              <a:t>Yellow: engine target. Controlled game capture; overlay added.</a:t>
+            </a:r>
+          </a:p>
+        </p:txBody>
+      </p:sp>
+      <p:sp>
+        <p:nvSpPr>
+          <p:cNvPr id="13" name="How the engine follows the line"/>
+          <p:cNvSpPr txBox="1"/>
+          <p:nvPr/>
+        </p:nvSpPr>
+        <p:spPr>
+          <a:xfrm>
+            <a:off x="548640" y="4544568"/>
+            <a:ext cx="4480560" cy="201168"/>
+          </a:xfrm>
+          <a:prstGeom prst="rect">
+            <a:avLst/>
+          </a:prstGeom>
+          <a:noFill/>
+          <a:ln>
+            <a:noFill/>
+          </a:ln>
+        </p:spPr>
+        <p:txBody>
+          <a:bodyPr wrap="none" lIns="0" tIns="0" rIns="0" bIns="0"/>
+          <a:lstStyle/>
+          <a:p>
+            <a:pPr>
+              <a:buNone/>
+            </a:pPr>
+            <a:r>
+              <a:rPr lang="en-US" sz="1140" b="1">
+                <a:solidFill>
+                  <a:srgbClr val="ECE9F8"/>
+                </a:solidFill>
+                <a:latin typeface="Segoe UI Semibold"/>
+              </a:rPr>
+              <a:t>40-segment lookahead; inside bias, not a full apex line.</a:t>
+            </a:r>
+          </a:p>
+        </p:txBody>
+      </p:sp>
+      <p:sp>
+        <p:nvSpPr>
+          <p:cNvPr id="14" name="Request card"/>
+          <p:cNvSpPr/>
+          <p:nvPr/>
+        </p:nvSpPr>
+        <p:spPr>
+          <a:xfrm>
+            <a:off x="5349240" y="1737360"/>
+            <a:ext cx="3246120" cy="1572768"/>
+          </a:xfrm>
+          <a:prstGeom prst="roundRect">
+            <a:avLst>
+              <a:gd name="adj" fmla="val 14000"/>
+            </a:avLst>
+          </a:prstGeom>
+          <a:solidFill>
+            <a:srgbClr val="110F26"/>
+          </a:solidFill>
+          <a:ln>
+            <a:noFill/>
+          </a:ln>
+        </p:spPr>
+      </p:sp>
+      <p:sp>
+        <p:nvSpPr>
+          <p:cNvPr id="15" name="AI request label"/>
+          <p:cNvSpPr txBox="1"/>
+          <p:nvPr/>
+        </p:nvSpPr>
+        <p:spPr>
+          <a:xfrm>
+            <a:off x="5532120" y="1883664"/>
+            <a:ext cx="2880360" cy="182880"/>
+          </a:xfrm>
+          <a:prstGeom prst="rect">
+            <a:avLst/>
+          </a:prstGeom>
+          <a:noFill/>
+          <a:ln>
+            <a:noFill/>
+          </a:ln>
+        </p:spPr>
+        <p:txBody>
+          <a:bodyPr wrap="none" lIns="0" tIns="0" rIns="0" bIns="0"/>
+          <a:lstStyle/>
+          <a:p>
+            <a:pPr>
+              <a:buNone/>
+            </a:pPr>
+            <a:r>
+              <a:rPr lang="en-US" sz="1050" b="1" spc="80">
+                <a:solidFill>
+                  <a:srgbClr val="3DD6FF"/>
+                </a:solidFill>
+                <a:latin typeface="Segoe UI Semibold"/>
+              </a:rPr>
+              <a:t>AI REQUEST / STATE SUMMARY</a:t>
+            </a:r>
+          </a:p>
+        </p:txBody>
+      </p:sp>
+      <p:sp>
+        <p:nvSpPr>
+          <p:cNvPr id="16" name="Matching Lyra telemetry"/>
+          <p:cNvSpPr txBox="1"/>
+          <p:nvPr/>
+        </p:nvSpPr>
+        <p:spPr>
+          <a:xfrm>
+            <a:off x="5532120" y="2121408"/>
+            <a:ext cx="2880360" cy="694944"/>
+          </a:xfrm>
+          <a:prstGeom prst="rect">
+            <a:avLst/>
+          </a:prstGeom>
+          <a:noFill/>
+          <a:ln>
+            <a:noFill/>
+          </a:ln>
+        </p:spPr>
+        <p:txBody>
+          <a:bodyPr wrap="none" lIns="0" tIns="0" rIns="0" bIns="0"/>
+          <a:lstStyle/>
+          <a:p>
+            <a:pPr>
+              <a:lnSpc>
+                <a:spcPts val="1600"/>
+              </a:lnSpc>
+              <a:buNone/>
+            </a:pPr>
+            <a:r>
+              <a:rPr lang="en-US" sz="1300" b="1">
+                <a:solidFill>
+                  <a:srgbClr val="ECE9F8"/>
+                </a:solidFill>
+                <a:latin typeface="Segoe UI Semibold"/>
+              </a:rPr>
+              <a:t>Lyra #22 / smooth / lap 1/3 / P2</a:t>
+            </a:r>
+          </a:p>
+          <a:p>
+            <a:pPr>
+              <a:lnSpc>
+                <a:spcPts val="1600"/>
+              </a:lnSpc>
+              <a:buNone/>
+            </a:pPr>
+            <a:r>
+              <a:rPr lang="en-US" sz="1300">
+                <a:solidFill>
+                  <a:srgbClr val="ECE9F8"/>
+                </a:solidFill>
+                <a:latin typeface="Segoe UI"/>
+              </a:rPr>
+              <a:t>268 km/h / medium right / uphill</a:t>
+            </a:r>
+          </a:p>
+          <a:p>
+            <a:pPr>
+              <a:lnSpc>
+                <a:spcPts val="1600"/>
+              </a:lnSpc>
+              <a:buNone/>
+            </a:pPr>
+            <a:r>
+              <a:rPr lang="en-US" sz="1300">
+                <a:solidFill>
+                  <a:srgbClr val="ECE9F8"/>
+                </a:solidFill>
+                <a:latin typeface="Segoe UI"/>
+              </a:rPr>
+              <a:t>No car ahead within 150 m</a:t>
+            </a:r>
+          </a:p>
+        </p:txBody>
+      </p:sp>
+      <p:sp>
+        <p:nvSpPr>
+          <p:cNvPr id="17" name="Three typed questions"/>
+          <p:cNvSpPr txBox="1"/>
+          <p:nvPr/>
+        </p:nvSpPr>
+        <p:spPr>
+          <a:xfrm>
+            <a:off x="5532120" y="2852928"/>
+            <a:ext cx="2880360" cy="347472"/>
+          </a:xfrm>
+          <a:prstGeom prst="rect">
+            <a:avLst/>
+          </a:prstGeom>
+          <a:noFill/>
+          <a:ln>
+            <a:noFill/>
+          </a:ln>
+        </p:spPr>
+        <p:txBody>
+          <a:bodyPr wrap="none" lIns="0" tIns="0" rIns="0" bIns="0"/>
+          <a:lstStyle/>
+          <a:p>
+            <a:pPr>
+              <a:lnSpc>
+                <a:spcPts val="1300"/>
+              </a:lnSpc>
+              <a:buNone/>
+            </a:pPr>
+            <a:r>
+              <a:rPr lang="en-US" sz="1130">
+                <a:solidFill>
+                  <a:srgbClr val="3DD6FF"/>
+                </a:solidFill>
+                <a:latin typeface="Consolas"/>
+              </a:rPr>
+              <a:t>maneuver: choice</a:t>
+            </a:r>
+          </a:p>
+          <a:p>
+            <a:pPr>
+              <a:lnSpc>
+                <a:spcPts val="1300"/>
+              </a:lnSpc>
+              <a:buNone/>
+            </a:pPr>
+            <a:r>
+              <a:rPr lang="en-US" sz="1130">
+                <a:solidFill>
+                  <a:srgbClr val="3DD6FF"/>
+                </a:solidFill>
+                <a:latin typeface="Consolas"/>
+              </a:rPr>
+              <a:t xml:space="preserve">pace: score    nitro: noul</a:t>
+            </a:r>
+          </a:p>
+        </p:txBody>
+      </p:sp>
+      <p:sp>
+        <p:nvSpPr>
+          <p:cNvPr id="18" name="Live result card"/>
+          <p:cNvSpPr/>
+          <p:nvPr/>
+        </p:nvSpPr>
+        <p:spPr>
+          <a:xfrm>
+            <a:off x="5349240" y="3493008"/>
+            <a:ext cx="3246120" cy="1188720"/>
+          </a:xfrm>
+          <a:prstGeom prst="roundRect">
+            <a:avLst>
+              <a:gd name="adj" fmla="val 14000"/>
+            </a:avLst>
+          </a:prstGeom>
+          <a:solidFill>
+            <a:srgbClr val="110F26"/>
+          </a:solidFill>
+          <a:ln>
+            <a:noFill/>
+          </a:ln>
+        </p:spPr>
+      </p:sp>
+      <p:sp>
+        <p:nvSpPr>
+          <p:cNvPr id="19" name="Live response label"/>
+          <p:cNvSpPr txBox="1"/>
+          <p:nvPr/>
+        </p:nvSpPr>
+        <p:spPr>
+          <a:xfrm>
+            <a:off x="5532120" y="3639312"/>
+            <a:ext cx="2880360" cy="182880"/>
+          </a:xfrm>
+          <a:prstGeom prst="rect">
+            <a:avLst/>
+          </a:prstGeom>
+          <a:noFill/>
+          <a:ln>
+            <a:noFill/>
+          </a:ln>
+        </p:spPr>
+        <p:txBody>
+          <a:bodyPr wrap="none" lIns="0" tIns="0" rIns="0" bIns="0"/>
+          <a:lstStyle/>
+          <a:p>
+            <a:pPr>
+              <a:buNone/>
+            </a:pPr>
+            <a:r>
+              <a:rPr lang="en-US" sz="1050" b="1" spc="80">
+                <a:solidFill>
+                  <a:srgbClr val="45E89A"/>
+                </a:solidFill>
+                <a:latin typeface="Segoe UI Semibold"/>
+              </a:rPr>
+              <a:t>LIVE RESULT / 358 ms</a:t>
+            </a:r>
+          </a:p>
+        </p:txBody>
+      </p:sp>
+      <p:sp>
+        <p:nvSpPr>
+          <p:cNvPr id="20" name="Chosen maneuver"/>
+          <p:cNvSpPr txBox="1"/>
+          <p:nvPr/>
+        </p:nvSpPr>
+        <p:spPr>
+          <a:xfrm>
+            <a:off x="5532120" y="3904488"/>
+            <a:ext cx="1911096" cy="274320"/>
+          </a:xfrm>
+          <a:prstGeom prst="rect">
+            <a:avLst/>
+          </a:prstGeom>
+          <a:noFill/>
+          <a:ln>
+            <a:noFill/>
+          </a:ln>
+        </p:spPr>
+        <p:txBody>
+          <a:bodyPr wrap="none" lIns="0" tIns="0" rIns="0" bIns="0"/>
+          <a:lstStyle/>
+          <a:p>
+            <a:pPr>
+              <a:buNone/>
+            </a:pPr>
+            <a:r>
+              <a:rPr lang="en-US" sz="1800" b="1">
+                <a:solidFill>
+                  <a:srgbClr val="3DD6FF"/>
+                </a:solidFill>
+                <a:latin typeface="Consolas"/>
+              </a:rPr>
+              <a:t>racing_line</a:t>
+            </a:r>
+          </a:p>
+        </p:txBody>
+      </p:sp>
+      <p:sp>
+        <p:nvSpPr>
+          <p:cNvPr id="21" name="Maneuver probability"/>
+          <p:cNvSpPr txBox="1"/>
+          <p:nvPr/>
+        </p:nvSpPr>
+        <p:spPr>
+          <a:xfrm>
+            <a:off x="7242048" y="3977640"/>
+            <a:ext cx="1170432" cy="182880"/>
+          </a:xfrm>
+          <a:prstGeom prst="rect">
+            <a:avLst/>
+          </a:prstGeom>
+          <a:noFill/>
+          <a:ln>
+            <a:noFill/>
+          </a:ln>
+        </p:spPr>
+        <p:txBody>
+          <a:bodyPr wrap="none" lIns="0" tIns="0" rIns="0" bIns="0"/>
+          <a:lstStyle/>
+          <a:p>
+            <a:pPr algn="r">
+              <a:buNone/>
+            </a:pPr>
+            <a:r>
+              <a:rPr lang="en-US" sz="1050" b="1">
+                <a:solidFill>
+                  <a:srgbClr val="45E89A"/>
+                </a:solidFill>
+                <a:latin typeface="Segoe UI Semibold"/>
+              </a:rPr>
+              <a:t>choice: 99.24%</a:t>
+            </a:r>
+          </a:p>
+        </p:txBody>
+      </p:sp>
+      <p:sp>
+        <p:nvSpPr>
+          <p:cNvPr id="22" name="Pace and nitro results"/>
+          <p:cNvSpPr txBox="1"/>
+          <p:nvPr/>
+        </p:nvSpPr>
+        <p:spPr>
+          <a:xfrm>
+            <a:off x="5532120" y="4187952"/>
+            <a:ext cx="2880360" cy="228600"/>
+          </a:xfrm>
+          <a:prstGeom prst="rect">
+            <a:avLst/>
+          </a:prstGeom>
+          <a:noFill/>
+          <a:ln>
+            <a:noFill/>
+          </a:ln>
+        </p:spPr>
+        <p:txBody>
+          <a:bodyPr wrap="none" lIns="0" tIns="0" rIns="0" bIns="0"/>
+          <a:lstStyle/>
+          <a:p>
+            <a:pPr>
+              <a:buNone/>
+            </a:pPr>
+            <a:r>
+              <a:rPr lang="en-US" sz="1250">
+                <a:solidFill>
+                  <a:srgbClr val="ECE9F8"/>
+                </a:solidFill>
+                <a:latin typeface="Consolas"/>
+              </a:rPr>
+              <a:t xml:space="preserve">pace 1.46 / 3   nitro 0.095</a:t>
+            </a:r>
+          </a:p>
+        </p:txBody>
+      </p:sp>
+      <p:sp>
+        <p:nvSpPr>
+          <p:cNvPr id="23" name="Nitro threshold policy"/>
+          <p:cNvSpPr txBox="1"/>
+          <p:nvPr/>
+        </p:nvSpPr>
+        <p:spPr>
+          <a:xfrm>
+            <a:off x="5532120" y="4425696"/>
+            <a:ext cx="2880360" cy="201168"/>
+          </a:xfrm>
+          <a:prstGeom prst="rect">
+            <a:avLst/>
+          </a:prstGeom>
+          <a:noFill/>
+          <a:ln>
+            <a:noFill/>
+          </a:ln>
+        </p:spPr>
+        <p:txBody>
+          <a:bodyPr wrap="none" lIns="0" tIns="0" rIns="0" bIns="0"/>
+          <a:lstStyle/>
+          <a:p>
+            <a:pPr>
+              <a:buNone/>
+            </a:pPr>
+            <a:r>
+              <a:rPr lang="en-US" sz="1100">
+                <a:solidFill>
+                  <a:srgbClr val="ABA6C8"/>
+                </a:solidFill>
+                <a:latin typeface="Segoe UI"/>
+              </a:rPr>
+              <a:t>No boost: nitro 0.095 &lt; Lyra's 0.65.</a:t>
+            </a:r>
+          </a:p>
+        </p:txBody>
+      </p:sp>
+      <p:sp>
+        <p:nvSpPr>
+          <p:cNvPr id="24" name="Leader identifying Lyra"/>
+          <p:cNvSpPr/>
+          <p:nvPr/>
+        </p:nvSpPr>
+        <p:spPr>
+          <a:xfrm>
+            <a:off x="2980944" y="2743200"/>
+            <a:ext cx="192024" cy="283464"/>
+          </a:xfrm>
+          <a:custGeom>
+            <a:avLst/>
+            <a:gdLst/>
+            <a:ahLst/>
+            <a:cxnLst/>
+            <a:rect l="0" t="0" r="r" b="b"/>
+            <a:pathLst>
+              <a:path w="1000" h="1000" fill="none">
+                <a:moveTo>
+                  <a:pt x="0" y="0"/>
+                </a:moveTo>
+                <a:lnTo>
+                  <a:pt x="1000" y="1000"/>
+                </a:lnTo>
+              </a:path>
+            </a:pathLst>
+          </a:custGeom>
+          <a:noFill/>
+          <a:ln w="16510" cap="rnd">
+            <a:solidFill>
+              <a:srgbClr val="D7BCFF"/>
+            </a:solidFill>
+            <a:tailEnd type="triangle" w="sm" len="sm"/>
+          </a:ln>
+        </p:spPr>
+      </p:sp>
+      <p:sp>
+        <p:nvSpPr>
+          <p:cNvPr id="25" name="Identify the player HUD"/>
+          <p:cNvSpPr txBox="1"/>
+          <p:nvPr/>
+        </p:nvSpPr>
+        <p:spPr>
+          <a:xfrm>
+            <a:off x="1179576" y="1892808"/>
+            <a:ext cx="594360" cy="182880"/>
+          </a:xfrm>
+          <a:prstGeom prst="rect">
+            <a:avLst/>
+          </a:prstGeom>
+          <a:noFill/>
+          <a:ln>
+            <a:noFill/>
+          </a:ln>
+        </p:spPr>
+        <p:txBody>
+          <a:bodyPr wrap="none" lIns="0" tIns="0" rIns="0" bIns="0"/>
+          <a:lstStyle/>
+          <a:p>
+            <a:pPr>
+              <a:buNone/>
+            </a:pPr>
+            <a:r>
+              <a:rPr lang="en-US" sz="950" b="1">
+                <a:solidFill>
+                  <a:srgbClr val="3DD6FF"/>
+                </a:solidFill>
+                <a:latin typeface="Segoe UI Semibold"/>
+              </a:rPr>
+              <a:t>YOU</a:t>
+            </a:r>
           </a:p>
         </p:txBody>
       </p:sp>
@@ -7254,7 +8474,7 @@
                 <a:ea typeface="Segoe UI Semibold" pitchFamily="34" charset="-122"/>
                 <a:cs typeface="Segoe UI Semibold" pitchFamily="34" charset="-120"/>
               </a:rPr>
-              <a:t>02 / 13</a:t>
+              <a:t>02 / 14</a:t>
             </a:r>
             <a:endParaRPr lang="en-US" sz="1100" dirty="0"/>
           </a:p>
@@ -7932,7 +9152,7 @@
                 <a:ea typeface="Segoe UI Semibold" pitchFamily="34" charset="-122"/>
                 <a:cs typeface="Segoe UI Semibold" pitchFamily="34" charset="-120"/>
               </a:rPr>
-              <a:t>03 / 13</a:t>
+              <a:t>03 / 14</a:t>
             </a:r>
             <a:endParaRPr lang="en-US" sz="1100" dirty="0"/>
           </a:p>
@@ -8010,7 +9230,7 @@
                 <a:ea typeface="Segoe UI" pitchFamily="34" charset="-122"/>
                 <a:cs typeface="Segoe UI" pitchFamily="34" charset="-120"/>
               </a:rPr>
-              <a:t>Give it a situation and closed questions; it returns a </a:t>
+              <a:t xml:space="preserve">Give it a situation and closed questions; it returns a </a:t>
             </a:r>
             <a:r>
               <a:rPr lang="en-US" sz="1800" b="1" dirty="0">
@@ -8032,7 +9252,7 @@
                 <a:ea typeface="Segoe UI" pitchFamily="34" charset="-122"/>
                 <a:cs typeface="Segoe UI" pitchFamily="34" charset="-120"/>
               </a:rPr>
-              <a:t> for every answer option. No prose, no rationale.</a:t>
+              <a:t xml:space="preserve"> for every answer option. No prose, no rationale.</a:t>
             </a:r>
             <a:endParaRPr lang="en-US" sz="1800" dirty="0"/>
           </a:p>
@@ -8471,7 +9691,7 @@
                 <a:ea typeface="Consolas" pitchFamily="34" charset="-122"/>
                 <a:cs typeface="Consolas" pitchFamily="34" charset="-120"/>
               </a:rPr>
-              <a:t> · </a:t>
+              <a:t xml:space="preserve"> · </a:t>
             </a:r>
             <a:r>
               <a:rPr lang="en-US" sz="1200" dirty="0">
@@ -8493,7 +9713,7 @@
                 <a:ea typeface="Consolas" pitchFamily="34" charset="-122"/>
                 <a:cs typeface="Consolas" pitchFamily="34" charset="-120"/>
               </a:rPr>
-              <a:t> · </a:t>
+              <a:t xml:space="preserve"> · </a:t>
             </a:r>
             <a:r>
               <a:rPr lang="en-US" sz="1200" dirty="0">
@@ -8749,7 +9969,7 @@
                 <a:ea typeface="Segoe UI Semibold" pitchFamily="34" charset="-122"/>
                 <a:cs typeface="Segoe UI Semibold" pitchFamily="34" charset="-120"/>
               </a:rPr>
-              <a:t>04 / 13</a:t>
+              <a:t>04 / 14</a:t>
             </a:r>
             <a:endParaRPr lang="en-US" sz="1100" dirty="0"/>
           </a:p>
@@ -10549,7 +11769,7 @@
                 <a:ea typeface="Segoe UI Semibold" pitchFamily="34" charset="-122"/>
                 <a:cs typeface="Segoe UI Semibold" pitchFamily="34" charset="-120"/>
               </a:rPr>
-              <a:t>05 / 13</a:t>
+              <a:t>05 / 14</a:t>
             </a:r>
             <a:endParaRPr lang="en-US" sz="1100" dirty="0"/>
           </a:p>
@@ -10729,7 +11949,7 @@
                 <a:ea typeface="Consolas" pitchFamily="34" charset="-122"/>
                 <a:cs typeface="Consolas" pitchFamily="34" charset="-120"/>
               </a:rPr>
-              <a:t>  </a:t>
+              <a:t xml:space="preserve">  </a:t>
             </a:r>
             <a:r>
               <a:rPr lang="en-US" sz="1100" dirty="0">
@@ -10751,7 +11971,7 @@
                 <a:ea typeface="Consolas" pitchFamily="34" charset="-122"/>
                 <a:cs typeface="Consolas" pitchFamily="34" charset="-120"/>
               </a:rPr>
-              <a:t>: </a:t>
+              <a:t xml:space="preserve">: </a:t>
             </a:r>
             <a:r>
               <a:rPr lang="en-US" sz="1100" dirty="0">
@@ -10793,7 +12013,7 @@
                 <a:ea typeface="Consolas" pitchFamily="34" charset="-122"/>
                 <a:cs typeface="Consolas" pitchFamily="34" charset="-120"/>
               </a:rPr>
-              <a:t>  </a:t>
+              <a:t xml:space="preserve">  </a:t>
             </a:r>
             <a:r>
               <a:rPr lang="en-US" sz="1100" dirty="0">
@@ -10835,7 +12055,7 @@
                 <a:ea typeface="Consolas" pitchFamily="34" charset="-122"/>
                 <a:cs typeface="Consolas" pitchFamily="34" charset="-120"/>
               </a:rPr>
-              <a:t>    </a:t>
+              <a:t xml:space="preserve">    </a:t>
             </a:r>
             <a:r>
               <a:rPr lang="en-US" sz="1100" dirty="0">
@@ -10958,7 +12178,7 @@
                 <a:ea typeface="Consolas" pitchFamily="34" charset="-122"/>
                 <a:cs typeface="Consolas" pitchFamily="34" charset="-120"/>
               </a:rPr>
-              <a:t>: { </a:t>
+              <a:t xml:space="preserve">: { </a:t>
             </a:r>
             <a:r>
               <a:rPr lang="en-US" sz="1100" dirty="0">
@@ -10980,7 +12200,7 @@
                 <a:ea typeface="Consolas" pitchFamily="34" charset="-122"/>
                 <a:cs typeface="Consolas" pitchFamily="34" charset="-120"/>
               </a:rPr>
-              <a:t>: </a:t>
+              <a:t xml:space="preserve">: </a:t>
             </a:r>
             <a:r>
               <a:rPr lang="en-US" sz="1100" dirty="0">
@@ -11002,7 +12222,7 @@
                 <a:ea typeface="Consolas" pitchFamily="34" charset="-122"/>
                 <a:cs typeface="Consolas" pitchFamily="34" charset="-120"/>
               </a:rPr>
-              <a:t>, </a:t>
+              <a:t xml:space="preserve">, </a:t>
             </a:r>
             <a:r>
               <a:rPr lang="en-US" sz="1100" dirty="0">
@@ -11024,7 +12244,7 @@
                 <a:ea typeface="Consolas" pitchFamily="34" charset="-122"/>
                 <a:cs typeface="Consolas" pitchFamily="34" charset="-120"/>
               </a:rPr>
-              <a:t>: </a:t>
+              <a:t xml:space="preserve">: </a:t>
             </a:r>
             <a:r>
               <a:rPr lang="en-US" sz="1100" dirty="0">
@@ -11046,7 +12266,7 @@
                 <a:ea typeface="Consolas" pitchFamily="34" charset="-122"/>
                 <a:cs typeface="Consolas" pitchFamily="34" charset="-120"/>
               </a:rPr>
-              <a:t> }</a:t>
+              <a:t xml:space="preserve"> }</a:t>
             </a:r>
             <a:endParaRPr lang="en-US" sz="1100" dirty="0"/>
           </a:p>
@@ -11465,7 +12685,7 @@
                 <a:ea typeface="Segoe UI" pitchFamily="34" charset="-122"/>
                 <a:cs typeface="Segoe UI" pitchFamily="34" charset="-120"/>
               </a:rPr>
-              <a:t>  aggressive · wildcard</a:t>
+              <a:t xml:space="preserve">  aggressive · wildcard</a:t>
             </a:r>
             <a:endParaRPr lang="en-US" sz="1150" dirty="0"/>
           </a:p>
@@ -11593,7 +12813,7 @@
                 <a:ea typeface="Segoe UI" pitchFamily="34" charset="-122"/>
                 <a:cs typeface="Segoe UI" pitchFamily="34" charset="-120"/>
               </a:rPr>
-              <a:t>  defensive</a:t>
+              <a:t xml:space="preserve">  defensive</a:t>
             </a:r>
             <a:endParaRPr lang="en-US" sz="1150" dirty="0"/>
           </a:p>
@@ -11721,7 +12941,7 @@
                 <a:ea typeface="Segoe UI" pitchFamily="34" charset="-122"/>
                 <a:cs typeface="Segoe UI" pitchFamily="34" charset="-120"/>
               </a:rPr>
-              <a:t>  tactical · smooth</a:t>
+              <a:t xml:space="preserve">  tactical · smooth</a:t>
             </a:r>
             <a:endParaRPr lang="en-US" sz="1150" dirty="0"/>
           </a:p>
@@ -11898,7 +13118,7 @@
                 <a:ea typeface="Segoe UI Semibold" pitchFamily="34" charset="-122"/>
                 <a:cs typeface="Segoe UI Semibold" pitchFamily="34" charset="-120"/>
               </a:rPr>
-              <a:t>06 / 13</a:t>
+              <a:t>06 / 14</a:t>
             </a:r>
             <a:endParaRPr lang="en-US" sz="1100" dirty="0"/>
           </a:p>
@@ -14496,7 +15716,7 @@
                 </a:solidFill>
                 <a:latin typeface="Segoe UI Semibold"/>
               </a:rPr>
-              <a:t>07 / 13</a:t>
+              <a:t>07 / 14</a:t>
             </a:r>
             <a:endParaRPr lang="en-US" sz="1100"/>
           </a:p>
@@ -15237,7 +16457,7 @@
                 </a:solidFill>
                 <a:latin typeface="Segoe UI Semibold"/>
               </a:rPr>
-              <a:t>No chat history: </a:t>
+              <a:t xml:space="preserve">No chat history: </a:t>
             </a:r>
             <a:r>
               <a:rPr lang="en-US" sz="1200">
@@ -15283,7 +16503,7 @@
                 </a:solidFill>
                 <a:latin typeface="Segoe UI Semibold"/>
               </a:rPr>
-              <a:t>Five independent drivers: </a:t>
+              <a:t xml:space="preserve">Five independent drivers: </a:t>
             </a:r>
             <a:r>
               <a:rPr lang="en-US" sz="1200">

</xml_diff>